<commit_message>
refine Korean copy and add editorial audit
</commit_message>
<xml_diff>
--- a/GABA_Feed_Business_Model_Speech_Deck_v1.pptx
+++ b/GABA_Feed_Business_Model_Speech_Deck_v1.pptx
@@ -2,31 +2,31 @@
 <file path=ppt/presentation.xml><?xml version="1.0" encoding="utf-8"?>
 <p:presentation xmlns:p="http://schemas.openxmlformats.org/presentationml/2006/main">
   <p:sldMasterIdLst>
-    <p:sldMasterId xmlns:r="http://schemas.openxmlformats.org/officeDocument/2006/relationships" id="2147483648" r:id="R371255853862404b"/>
+    <p:sldMasterId xmlns:r="http://schemas.openxmlformats.org/officeDocument/2006/relationships" id="2147483648" r:id="R0970b38cb1b24455"/>
   </p:sldMasterIdLst>
   <p:notesMasterIdLst>
-    <p:notesMasterId xmlns:r="http://schemas.openxmlformats.org/officeDocument/2006/relationships" r:id="Rea3fefb3544a47ad"/>
+    <p:notesMasterId xmlns:r="http://schemas.openxmlformats.org/officeDocument/2006/relationships" r:id="R2530760c313c44e4"/>
   </p:notesMasterIdLst>
   <p:sldIdLst>
-    <p:sldId xmlns:r="http://schemas.openxmlformats.org/officeDocument/2006/relationships" id="256" r:id="R4c6d75cd88a14334"/>
-    <p:sldId xmlns:r="http://schemas.openxmlformats.org/officeDocument/2006/relationships" id="257" r:id="R58232561aca640be"/>
-    <p:sldId xmlns:r="http://schemas.openxmlformats.org/officeDocument/2006/relationships" id="258" r:id="R305668c19e3946c9"/>
-    <p:sldId xmlns:r="http://schemas.openxmlformats.org/officeDocument/2006/relationships" id="259" r:id="R666e2def4bf2475d"/>
-    <p:sldId xmlns:r="http://schemas.openxmlformats.org/officeDocument/2006/relationships" id="260" r:id="Rf5bf35a2e0224d11"/>
-    <p:sldId xmlns:r="http://schemas.openxmlformats.org/officeDocument/2006/relationships" id="261" r:id="Rec092309f0c84870"/>
-    <p:sldId xmlns:r="http://schemas.openxmlformats.org/officeDocument/2006/relationships" id="262" r:id="R23cde6a75ab04e00"/>
-    <p:sldId xmlns:r="http://schemas.openxmlformats.org/officeDocument/2006/relationships" id="263" r:id="R5011f07214164a0d"/>
-    <p:sldId xmlns:r="http://schemas.openxmlformats.org/officeDocument/2006/relationships" id="264" r:id="R035343cd664940bb"/>
-    <p:sldId xmlns:r="http://schemas.openxmlformats.org/officeDocument/2006/relationships" id="265" r:id="Rdf5cd179a81c4418"/>
-    <p:sldId xmlns:r="http://schemas.openxmlformats.org/officeDocument/2006/relationships" id="266" r:id="Rde17e9d4b7ab46ca"/>
-    <p:sldId xmlns:r="http://schemas.openxmlformats.org/officeDocument/2006/relationships" id="267" r:id="Ra206b9cdd20d4a30"/>
-    <p:sldId xmlns:r="http://schemas.openxmlformats.org/officeDocument/2006/relationships" id="268" r:id="Rfbd6e1c4f1ce4bff"/>
-    <p:sldId xmlns:r="http://schemas.openxmlformats.org/officeDocument/2006/relationships" id="269" r:id="Rf4ebe49cfcba4036"/>
-    <p:sldId xmlns:r="http://schemas.openxmlformats.org/officeDocument/2006/relationships" id="270" r:id="Rea76db1c8f0f4fff"/>
-    <p:sldId xmlns:r="http://schemas.openxmlformats.org/officeDocument/2006/relationships" id="271" r:id="Rd6f68a6c10d14ecf"/>
-    <p:sldId xmlns:r="http://schemas.openxmlformats.org/officeDocument/2006/relationships" id="272" r:id="R309594921cfb4e9f"/>
-    <p:sldId xmlns:r="http://schemas.openxmlformats.org/officeDocument/2006/relationships" id="273" r:id="R9e5c3a15c5d54657"/>
-    <p:sldId xmlns:r="http://schemas.openxmlformats.org/officeDocument/2006/relationships" id="274" r:id="R5c3e59c466a048a6"/>
+    <p:sldId xmlns:r="http://schemas.openxmlformats.org/officeDocument/2006/relationships" id="256" r:id="R89a4d953b05348a6"/>
+    <p:sldId xmlns:r="http://schemas.openxmlformats.org/officeDocument/2006/relationships" id="257" r:id="R61bc09e86d4c456e"/>
+    <p:sldId xmlns:r="http://schemas.openxmlformats.org/officeDocument/2006/relationships" id="258" r:id="R47c2ab4ec6404465"/>
+    <p:sldId xmlns:r="http://schemas.openxmlformats.org/officeDocument/2006/relationships" id="259" r:id="R58851d4bc81f4bee"/>
+    <p:sldId xmlns:r="http://schemas.openxmlformats.org/officeDocument/2006/relationships" id="260" r:id="Rcf4955f38d5448bd"/>
+    <p:sldId xmlns:r="http://schemas.openxmlformats.org/officeDocument/2006/relationships" id="261" r:id="Rea5ccbdcae3c48a0"/>
+    <p:sldId xmlns:r="http://schemas.openxmlformats.org/officeDocument/2006/relationships" id="262" r:id="R80629fbb99104ced"/>
+    <p:sldId xmlns:r="http://schemas.openxmlformats.org/officeDocument/2006/relationships" id="263" r:id="R45b6d3e9ee3c4c80"/>
+    <p:sldId xmlns:r="http://schemas.openxmlformats.org/officeDocument/2006/relationships" id="264" r:id="R462bf99882e14203"/>
+    <p:sldId xmlns:r="http://schemas.openxmlformats.org/officeDocument/2006/relationships" id="265" r:id="R9c42a96959db4535"/>
+    <p:sldId xmlns:r="http://schemas.openxmlformats.org/officeDocument/2006/relationships" id="266" r:id="R68f782dd53c246df"/>
+    <p:sldId xmlns:r="http://schemas.openxmlformats.org/officeDocument/2006/relationships" id="267" r:id="R78fccbce6e394d90"/>
+    <p:sldId xmlns:r="http://schemas.openxmlformats.org/officeDocument/2006/relationships" id="268" r:id="Re764078bf52c4e72"/>
+    <p:sldId xmlns:r="http://schemas.openxmlformats.org/officeDocument/2006/relationships" id="269" r:id="Refc5d1d76e0b49e7"/>
+    <p:sldId xmlns:r="http://schemas.openxmlformats.org/officeDocument/2006/relationships" id="270" r:id="R4ef7658785c341d1"/>
+    <p:sldId xmlns:r="http://schemas.openxmlformats.org/officeDocument/2006/relationships" id="271" r:id="Ra37f4470a4054d88"/>
+    <p:sldId xmlns:r="http://schemas.openxmlformats.org/officeDocument/2006/relationships" id="272" r:id="R95f1a2ca21f4421b"/>
+    <p:sldId xmlns:r="http://schemas.openxmlformats.org/officeDocument/2006/relationships" id="273" r:id="Rb93f557620e145b3"/>
+    <p:sldId xmlns:r="http://schemas.openxmlformats.org/officeDocument/2006/relationships" id="274" r:id="R857d86fc3438493a"/>
   </p:sldIdLst>
   <p:sldSz cx="12192000" cy="6858000"/>
   <p:notesSz cx="6858000" cy="9144000"/>
@@ -460,7 +460,7 @@
           <a:lstStyle xmlns:a="http://schemas.openxmlformats.org/drawingml/2006/main"/>
           <a:p xmlns:a="http://schemas.openxmlformats.org/drawingml/2006/main">
             <a:r>
-              <a:t>첫 문장은 사업의 전부입니다. 재고는 20% 마스터 한 종류만 보유하고, 고객 규격은 주문이 들어온 뒤 OEM에서 완성합니다. 오늘 요청하는 것은 대규모 생산 투자가 아니라 네 가지 증빙을 잠그는 검증입니다.</a:t>
+              <a:t>사업 모델의 핵심은 단순합니다. 20% 마스터 한 종류만 재고로 보유하고, 고객이 주문한 규격은 OEM 공장에서 생산합니다. 오늘 요청드리는 것은 대규모 생산 투자가 아니라 네 가지 핵심 조건을 실제 자료로 확인하는 일입니다.</a:t>
             </a:r>
           </a:p>
           <a:p xmlns:a="http://schemas.openxmlformats.org/drawingml/2006/main">
@@ -635,7 +635,7 @@
           <a:lstStyle xmlns:a="http://schemas.openxmlformats.org/drawingml/2006/main"/>
           <a:p xmlns:a="http://schemas.openxmlformats.org/drawingml/2006/main">
             <a:r>
-              <a:t>단위공헌은 한 단위를 팔 때 판매가에서 제품원가와 직접변동비를 빼고 남는 금액입니다. 원본 산식은 8,760원/kg을 제시하지만, 잠정원가의 하위 비용이 연결되지 않았습니다. 투자자에게는 실현 공헌이 아니라 검증 목표로 표현해야 합니다.</a:t>
+              <a:t>단위당 공헌이익은 판매가에서 제품 원가와 직접 변동비를 뺀 금액입니다. 원본 계산에서는 kg당 8,760원이 남지만, 예상 원가의 세부 항목을 확인하지 못했습니다. 투자자에게는 확정 수익이 아니라 검증해야 할 목표로 설명해야 합니다.</a:t>
             </a:r>
           </a:p>
           <a:p xmlns:a="http://schemas.openxmlformats.org/drawingml/2006/main">
@@ -720,7 +720,7 @@
           <a:lstStyle xmlns:a="http://schemas.openxmlformats.org/drawingml/2006/main"/>
           <a:p xmlns:a="http://schemas.openxmlformats.org/drawingml/2006/main">
             <a:r>
-              <a:t>원본은 매트릭스 투입량 75g/사료t, 제품원가 4,681.8원/kg을 사용합니다. 그러나 제품 활성함량과 제형이 연구 용량에 연결되지 않아 유효용량으로 볼 수 없습니다. 실제 공헌은 용량, OEM 견적, 채널비, 현장비가 잠긴 뒤 다시 계산합니다.</a:t>
+              <a:t>원본은 사료 1톤당 매트릭스 75g과 kg당 제품 원가 4,681.8원을 사용합니다. 그러나 제품의 활성 함량과 제형이 연구의 투여량과 연결되지 않아 유효한 투입량으로 확정할 수 없습니다. 실제 공헌이익은 투입량, OEM 견적, 채널비, 현장비를 확인한 뒤 다시 계산해야 합니다.</a:t>
             </a:r>
           </a:p>
           <a:p xmlns:a="http://schemas.openxmlformats.org/drawingml/2006/main">
@@ -1070,7 +1070,7 @@
           <a:lstStyle xmlns:a="http://schemas.openxmlformats.org/drawingml/2006/main"/>
           <a:p xmlns:a="http://schemas.openxmlformats.org/drawingml/2006/main">
             <a:r>
-              <a:t>스케일 의사결정은 네 게이트가 닫힌 뒤에만 합니다. 규제와 표시 문구는 서면 검토, 제품근거는 제품특이 시험, OEM은 실사와 품질합의서, 상업검증은 유료 PoV와 반복 PO로 확인합니다. QA Agreement는 발주자와 제조자가 시험·변경·일탈·회수 책임을 합의한 문서입니다.</a:t>
+              <a:t>사업 확대는 네 가지 검증을 모두 마친 뒤 결정합니다. 규제와 표시 문구는 서면 검토 결과로, 제품 근거는 해당 제품의 시험 결과로 확인합니다. OEM 조건은 공장 실사와 품질 협약서로, 상업성은 유료 고객 시험과 반복 주문으로 확인합니다. 품질 협약서는 발주자와 제조자가 시험, 변경, 일탈, 회수 책임을 합의한 문서입니다.</a:t>
             </a:r>
           </a:p>
           <a:p xmlns:a="http://schemas.openxmlformats.org/drawingml/2006/main">
@@ -1170,7 +1170,7 @@
           <a:lstStyle xmlns:a="http://schemas.openxmlformats.org/drawingml/2006/main"/>
           <a:p xmlns:a="http://schemas.openxmlformats.org/drawingml/2006/main">
             <a:r>
-              <a:t>첫 30일은 규제경로와 제품정의를 잠급니다. 다음 30일은 시험생산과 고객시험 설계를 끝냅니다. 마지막 30일은 첫 유료 PO와 반복주문 조건을 확보하고, 실제 원가로 GO 또는 NO-GO를 결정합니다. RFI는 잠재 제조사에 정보와 조건을 요청하는 문서입니다.</a:t>
+              <a:t>첫 30일에는 규제 경로와 제품 조건을 확인합니다. 다음 30일에는 시험 생산을 진행하고 고객 시험계획을 확정합니다. 마지막 30일에는 첫 유료 발주서와 반복 주문 조건을 확보한 뒤 실제 원가를 기준으로 계속 추진할지 결정합니다. RFI는 잠재 제조사에 필요한 정보와 조건을 요청하는 문서입니다.</a:t>
             </a:r>
           </a:p>
           <a:p xmlns:a="http://schemas.openxmlformats.org/drawingml/2006/main">
@@ -1265,7 +1265,7 @@
           <a:lstStyle xmlns:a="http://schemas.openxmlformats.org/drawingml/2006/main"/>
           <a:p xmlns:a="http://schemas.openxmlformats.org/drawingml/2006/main">
             <a:r>
-              <a:t>요청은 대규모 설비투자가 아닙니다. 원본 T1 검증예산 4,560만원을 네 증빙의 마일스톤과 연결해 단계적으로 집행하는 것입니다. 어느 한 게이트가 실패하면 멈추고, 모두 통과하면 고객사와 투자자에게 스케일 계획을 다시 제안합니다.</a:t>
+              <a:t>요청드리는 것은 대규모 설비 투자가 아닙니다. 원본에 제시된 4,560만원의 검증 예산을 네 가지 과제의 완료 시점에 맞춰 단계적으로 집행하는 것입니다. 어느 한 과제에서 기준을 충족하지 못하면 멈추고, 모두 확인되면 고객사와 투자자에게 사업 확대 계획을 다시 제안합니다.</a:t>
             </a:r>
           </a:p>
           <a:p xmlns:a="http://schemas.openxmlformats.org/drawingml/2006/main">
@@ -1465,7 +1465,7 @@
           <a:lstStyle xmlns:a="http://schemas.openxmlformats.org/drawingml/2006/main"/>
           <a:p xmlns:a="http://schemas.openxmlformats.org/drawingml/2006/main">
             <a:r>
-              <a:t>현재 준비도는 잠정 41점입니다. 구조는 설계됐지만 품목분류, 제품특이 유효용량, OEM 실견적, 유료 반복주문이 열려 있습니다. 그래서 지금의 단계는 SCALE이 아니라 VALIDATE입니다.</a:t>
+              <a:t>현재 준비도는 41점입니다. 사업 구조는 설계됐지만 품목 분류, 해당 제품의 유효 용량, OEM 실제 견적, 유료 반복 주문은 아직 확인되지 않았습니다. 따라서 지금은 사업 확대보다 검증에 집중해야 합니다.</a:t>
             </a:r>
           </a:p>
           <a:p xmlns:a="http://schemas.openxmlformats.org/drawingml/2006/main">
@@ -1720,7 +1720,7 @@
           <a:lstStyle xmlns:a="http://schemas.openxmlformats.org/drawingml/2006/main"/>
           <a:p xmlns:a="http://schemas.openxmlformats.org/drawingml/2006/main">
             <a:r>
-              <a:t>원본은 배양액 1톤 원가와 산출량을 제시합니다. 그러나 이 정보만으로 20% 마스터 9,240원/kg을 재현할 수는 없습니다. 다음 단계는 건조, 부형제, 시험, 포장, 수율을 한 장의 원가 브리지로 연결하는 것입니다.</a:t>
+              <a:t>원본은 배양액 1톤의 원가와 산출량을 제시합니다. 그러나 이 정보만으로는 20% 마스터의 kg당 원가 9,240원을 다시 계산할 수 없습니다. 건조, 부형제, 시험, 포장, 수율에 드는 비용을 항목별로 확인해야 합니다.</a:t>
             </a:r>
           </a:p>
           <a:p xmlns:a="http://schemas.openxmlformats.org/drawingml/2006/main">
@@ -1890,7 +1890,7 @@
           <a:lstStyle xmlns:a="http://schemas.openxmlformats.org/drawingml/2006/main"/>
           <a:p xmlns:a="http://schemas.openxmlformats.org/drawingml/2006/main">
             <a:r>
-              <a:t>주문 흐름은 규격 잠금, 마스터 출고, OEM 완제품화의 세 단계입니다. 고객의 농도·수량·표시사항이 확정되기 전에는 생산하지 않습니다. 이 통제가 재고경량 모델을 지키는 운영 장치입니다.</a:t>
+              <a:t>주문은 제품 규격 확정, 마스터 출고, OEM 완제품 생산의 세 단계로 처리합니다. 고객의 농도, 수량, 표시 사항이 정해지기 전에는 생산하지 않습니다. 이 원칙이 불필요한 완제품 재고를 막아 줍니다.</a:t>
             </a:r>
           </a:p>
           <a:p xmlns:a="http://schemas.openxmlformats.org/drawingml/2006/main">
@@ -2070,7 +2070,7 @@
           <a:lstStyle xmlns:a="http://schemas.openxmlformats.org/drawingml/2006/main"/>
           <a:p xmlns:a="http://schemas.openxmlformats.org/drawingml/2006/main">
             <a:r>
-              <a:t>세 연구의 방향은 일관되지 않습니다. 2026년 젖소 연구에서는 산유량이 통계적으로 유의하지 않았고 일부 유성분은 유의했습니다. 2023년 한우 연구는 초기 증체에서 신호가 있었지만 도체 지표는 유의하지 않았고, 2025년 넙치 연구는 성장 개선이 유의하지 않았습니다. 따라서 한 축종·한 제형·한 용량의 제품특이 PoV가 필요합니다.</a:t>
+              <a:t>세 연구의 결과는 일관되지 않습니다. 2026년 젖소 연구에서는 산유량 차이가 통계적으로 유의하지 않았고 일부 유성분만 유의했습니다. 2023년 한우 연구는 초기 증체에서 가능성을 보였지만 도체 지표는 유의하지 않았습니다. 2025년 넙치 연구에서도 성장 개선이 확인되지 않았습니다. 따라서 한 축종, 한 제형, 한 용량으로 조건을 좁혀 해당 제품의 고객 시험을 진행해야 합니다.</a:t>
             </a:r>
           </a:p>
           <a:p xmlns:a="http://schemas.openxmlformats.org/drawingml/2006/main">
@@ -2163,7 +2163,7 @@
   </p:cSld>
   <p:clrMap bg1="lt1" tx1="dk1" bg2="lt2" tx2="dk2" accent1="accent1" accent2="accent2" accent3="accent3" accent4="accent4" accent5="accent5" accent6="accent6" hlink="hlink" folHlink="folHlink"/>
   <p:sldLayoutIdLst>
-    <p:sldLayoutId xmlns:r="http://schemas.openxmlformats.org/officeDocument/2006/relationships" id="2147483649" r:id="R1727d855ff494d0b"/>
+    <p:sldLayoutId xmlns:r="http://schemas.openxmlformats.org/officeDocument/2006/relationships" id="2147483649" r:id="Rc01a14ba3ea148cd"/>
   </p:sldLayoutIdLst>
   <p:txStyles>
     <p:titleStyle>
@@ -2938,7 +2938,7 @@
               </a:defRPr>
             </a:pPr>
             <a:r>
-              <a:t>한 SKU로 시작해,</a:t>
+              <a:t>한 가지 재고로 시작해,</a:t>
             </a:r>
           </a:p>
           <a:p xmlns:a="http://schemas.openxmlformats.org/drawingml/2006/main">
@@ -2954,7 +2954,7 @@
               </a:defRPr>
             </a:pPr>
             <a:r>
-              <a:t>주문으로 네 시장을 연다</a:t>
+              <a:t>주문에 맞춰 네 규격을 만든다</a:t>
             </a:r>
           </a:p>
         </p:txBody>
@@ -3000,23 +3000,23 @@
               </a:defRPr>
             </a:pPr>
             <a:r>
-              <a:t>GABA 20% 마스터만 재고 · 5·10·15·20%는 주문 후 OEM</a:t>
-            </a:r>
-          </a:p>
-          <a:p xmlns:a="http://schemas.openxmlformats.org/drawingml/2006/main">
-            <a:pPr algn="l">
-              <a:buNone/>
-              <a:defRPr sz="2400">
-                <a:solidFill>
-                  <a:srgbClr val="000000"/>
-                </a:solidFill>
-                <a:latin typeface="Helvetica Neue"/>
-                <a:ea typeface="Helvetica Neue"/>
-                <a:cs typeface="Helvetica Neue"/>
-              </a:defRPr>
-            </a:pPr>
-            <a:r>
-              <a:t>규제·효능·OEM·반복주문이 잠길 때만 확대</a:t>
+              <a:t>GABA 20% 마스터만 재고 · 5·10·15·20% 제품은 주문 후 OEM 생산</a:t>
+            </a:r>
+          </a:p>
+          <a:p xmlns:a="http://schemas.openxmlformats.org/drawingml/2006/main">
+            <a:pPr algn="l">
+              <a:buNone/>
+              <a:defRPr sz="2400">
+                <a:solidFill>
+                  <a:srgbClr val="000000"/>
+                </a:solidFill>
+                <a:latin typeface="Helvetica Neue"/>
+                <a:ea typeface="Helvetica Neue"/>
+                <a:cs typeface="Helvetica Neue"/>
+              </a:defRPr>
+            </a:pPr>
+            <a:r>
+              <a:t>규제·제품 근거·OEM 조건·반복 주문을 확인한 뒤 확대</a:t>
             </a:r>
           </a:p>
         </p:txBody>
@@ -3062,7 +3062,7 @@
               </a:defRPr>
             </a:pPr>
             <a:r>
-              <a:t>VALIDATION SPEECH DECK · 2026.08</a:t>
+              <a:t>사업 검증 발표자료 · 2026.08</a:t>
             </a:r>
           </a:p>
         </p:txBody>
@@ -3264,7 +3264,7 @@
               </a:defRPr>
             </a:pPr>
             <a:r>
-              <a:t>첫 PoV는 한 축종·한 제형·한 경제효과로 좁힌다</a:t>
+              <a:t>첫 고객 시험은 한 축종·한 제형·한 경제효과에 집중한다</a:t>
             </a:r>
           </a:p>
         </p:txBody>
@@ -3604,39 +3604,39 @@
               </a:defRPr>
             </a:pPr>
             <a:r>
-              <a:t>유료 PoV</a:t>
-            </a:r>
-          </a:p>
-          <a:p xmlns:a="http://schemas.openxmlformats.org/drawingml/2006/main">
-            <a:pPr algn="l">
-              <a:buNone/>
-              <a:defRPr sz="2400">
-                <a:solidFill>
-                  <a:srgbClr val="000000"/>
-                </a:solidFill>
-                <a:latin typeface="Helvetica Neue"/>
-                <a:ea typeface="Helvetica Neue"/>
-                <a:cs typeface="Helvetica Neue"/>
-              </a:defRPr>
-            </a:pPr>
-            <a:r>
-              <a:t>가격·중단기준</a:t>
-            </a:r>
-          </a:p>
-          <a:p xmlns:a="http://schemas.openxmlformats.org/drawingml/2006/main">
-            <a:pPr algn="l">
-              <a:buNone/>
-              <a:defRPr sz="2400">
-                <a:solidFill>
-                  <a:srgbClr val="000000"/>
-                </a:solidFill>
-                <a:latin typeface="Helvetica Neue"/>
-                <a:ea typeface="Helvetica Neue"/>
-                <a:cs typeface="Helvetica Neue"/>
-              </a:defRPr>
-            </a:pPr>
-            <a:r>
-              <a:t>반복 PO 트리거</a:t>
+              <a:t>유료 고객 시험</a:t>
+            </a:r>
+          </a:p>
+          <a:p xmlns:a="http://schemas.openxmlformats.org/drawingml/2006/main">
+            <a:pPr algn="l">
+              <a:buNone/>
+              <a:defRPr sz="2400">
+                <a:solidFill>
+                  <a:srgbClr val="000000"/>
+                </a:solidFill>
+                <a:latin typeface="Helvetica Neue"/>
+                <a:ea typeface="Helvetica Neue"/>
+                <a:cs typeface="Helvetica Neue"/>
+              </a:defRPr>
+            </a:pPr>
+            <a:r>
+              <a:t>가격·중단 기준</a:t>
+            </a:r>
+          </a:p>
+          <a:p xmlns:a="http://schemas.openxmlformats.org/drawingml/2006/main">
+            <a:pPr algn="l">
+              <a:buNone/>
+              <a:defRPr sz="2400">
+                <a:solidFill>
+                  <a:srgbClr val="000000"/>
+                </a:solidFill>
+                <a:latin typeface="Helvetica Neue"/>
+                <a:ea typeface="Helvetica Neue"/>
+                <a:cs typeface="Helvetica Neue"/>
+              </a:defRPr>
+            </a:pPr>
+            <a:r>
+              <a:t>반복 주문 조건</a:t>
             </a:r>
           </a:p>
         </p:txBody>
@@ -3925,7 +3925,7 @@
               </a:defRPr>
             </a:pPr>
             <a:r>
-              <a:t>마스터 공헌 8,760원/kg은 목표—견적이 연결돼야 성립한다</a:t>
+              <a:t>kg당 8,760원의 공헌이익은 실제 견적을 확인해야 성립한다</a:t>
             </a:r>
           </a:p>
         </p:txBody>
@@ -4033,7 +4033,7 @@
               </a:defRPr>
             </a:pPr>
             <a:r>
-              <a:t>단위공헌</a:t>
+              <a:t>단위당 공헌이익</a:t>
             </a:r>
           </a:p>
           <a:p xmlns:a="http://schemas.openxmlformats.org/drawingml/2006/main">
@@ -4095,7 +4095,7 @@
               </a:defRPr>
             </a:pPr>
             <a:r>
-              <a:t>잠정 원가</a:t>
+              <a:t>예상 원가</a:t>
             </a:r>
           </a:p>
           <a:p xmlns:a="http://schemas.openxmlformats.org/drawingml/2006/main">
@@ -4311,7 +4311,7 @@
               </a:defRPr>
             </a:pPr>
             <a:r>
-              <a:t>※ 9,240원/kg은 원본 가정; 원가 브리지 미완성</a:t>
+              <a:t>※ 9,240원/kg은 원본 가정이며 세부 원가는 아직 확인되지 않음</a:t>
             </a:r>
           </a:p>
         </p:txBody>
@@ -4600,7 +4600,7 @@
               </a:defRPr>
             </a:pPr>
             <a:r>
-              <a:t>매트릭스 공헌 4,149원/사료t도 용량과 직접비가 잠겨야 한다</a:t>
+              <a:t>사료 1톤당 4,149원의 공헌이익도 투입량과 직접비 확인이 필요하다</a:t>
             </a:r>
           </a:p>
         </p:txBody>
@@ -4646,23 +4646,23 @@
               </a:defRPr>
             </a:pPr>
             <a:r>
-              <a:t>프로그램 가격</a:t>
-            </a:r>
-          </a:p>
-          <a:p xmlns:a="http://schemas.openxmlformats.org/drawingml/2006/main">
-            <a:pPr algn="l">
-              <a:buNone/>
-              <a:defRPr sz="2400">
-                <a:solidFill>
-                  <a:srgbClr val="000000"/>
-                </a:solidFill>
-                <a:latin typeface="Helvetica Neue"/>
-                <a:ea typeface="Helvetica Neue"/>
-                <a:cs typeface="Helvetica Neue"/>
-              </a:defRPr>
-            </a:pPr>
-            <a:r>
-              <a:t>KRW/사료t</a:t>
+              <a:t>판매가</a:t>
+            </a:r>
+          </a:p>
+          <a:p xmlns:a="http://schemas.openxmlformats.org/drawingml/2006/main">
+            <a:pPr algn="l">
+              <a:buNone/>
+              <a:defRPr sz="2400">
+                <a:solidFill>
+                  <a:srgbClr val="000000"/>
+                </a:solidFill>
+                <a:latin typeface="Helvetica Neue"/>
+                <a:ea typeface="Helvetica Neue"/>
+                <a:cs typeface="Helvetica Neue"/>
+              </a:defRPr>
+            </a:pPr>
+            <a:r>
+              <a:t>KRW/t</a:t>
             </a:r>
           </a:p>
         </p:txBody>
@@ -4708,23 +4708,23 @@
               </a:defRPr>
             </a:pPr>
             <a:r>
-              <a:t>단위공헌</a:t>
-            </a:r>
-          </a:p>
-          <a:p xmlns:a="http://schemas.openxmlformats.org/drawingml/2006/main">
-            <a:pPr algn="l">
-              <a:buNone/>
-              <a:defRPr sz="2400">
-                <a:solidFill>
-                  <a:srgbClr val="000000"/>
-                </a:solidFill>
-                <a:latin typeface="Helvetica Neue"/>
-                <a:ea typeface="Helvetica Neue"/>
-                <a:cs typeface="Helvetica Neue"/>
-              </a:defRPr>
-            </a:pPr>
-            <a:r>
-              <a:t>KRW/사료t</a:t>
+              <a:t>공헌이익</a:t>
+            </a:r>
+          </a:p>
+          <a:p xmlns:a="http://schemas.openxmlformats.org/drawingml/2006/main">
+            <a:pPr algn="l">
+              <a:buNone/>
+              <a:defRPr sz="2400">
+                <a:solidFill>
+                  <a:srgbClr val="000000"/>
+                </a:solidFill>
+                <a:latin typeface="Helvetica Neue"/>
+                <a:ea typeface="Helvetica Neue"/>
+                <a:cs typeface="Helvetica Neue"/>
+              </a:defRPr>
+            </a:pPr>
+            <a:r>
+              <a:t>KRW/t</a:t>
             </a:r>
           </a:p>
         </p:txBody>
@@ -4786,7 +4786,7 @@
               </a:defRPr>
             </a:pPr>
             <a:r>
-              <a:t>KRW/사료t</a:t>
+              <a:t>KRW/t</a:t>
             </a:r>
           </a:p>
         </p:txBody>
@@ -5275,7 +5275,7 @@
               </a:defRPr>
             </a:pPr>
             <a:r>
-              <a:t>18,000원/t 고객가치는 유료 대조군에서만 증명된다</a:t>
+              <a:t>사료 1톤당 고객 가치 18,000원은 유료 비교시험으로 확인해야 한다</a:t>
             </a:r>
           </a:p>
         </p:txBody>
@@ -5661,7 +5661,7 @@
               </a:defRPr>
             </a:pPr>
             <a:r>
-              <a:t>※ B/C=편익/비용 비율 · 현재는 가설, 유료 대조군에서 검증</a:t>
+              <a:t>※ B/C=편익/비용 비율 · 현재는 가설이며 유료 비교시험에서 확인</a:t>
             </a:r>
           </a:p>
         </p:txBody>
@@ -5950,7 +5950,7 @@
               </a:defRPr>
             </a:pPr>
             <a:r>
-              <a:t>첫 반복판매 시나리오는 매출 6.60억, 공헌 3.83억이다</a:t>
+              <a:t>반복 주문 가정대로라면 매출 6.60억원, 공헌이익 3.83억원이다</a:t>
             </a:r>
           </a:p>
         </p:txBody>
@@ -5996,23 +5996,23 @@
               </a:defRPr>
             </a:pPr>
             <a:r>
-              <a:t>20% 마스터 공헌</a:t>
-            </a:r>
-          </a:p>
-          <a:p xmlns:a="http://schemas.openxmlformats.org/drawingml/2006/main">
-            <a:pPr algn="l">
-              <a:buNone/>
-              <a:defRPr sz="2400">
-                <a:solidFill>
-                  <a:srgbClr val="000000"/>
-                </a:solidFill>
-                <a:latin typeface="Helvetica Neue"/>
-                <a:ea typeface="Helvetica Neue"/>
-                <a:cs typeface="Helvetica Neue"/>
-              </a:defRPr>
-            </a:pPr>
-            <a:r>
-              <a:t>20t×8,760원/kg</a:t>
+              <a:t>20% 마스터</a:t>
+            </a:r>
+          </a:p>
+          <a:p xmlns:a="http://schemas.openxmlformats.org/drawingml/2006/main">
+            <a:pPr algn="l">
+              <a:buNone/>
+              <a:defRPr sz="2400">
+                <a:solidFill>
+                  <a:srgbClr val="000000"/>
+                </a:solidFill>
+                <a:latin typeface="Helvetica Neue"/>
+                <a:ea typeface="Helvetica Neue"/>
+                <a:cs typeface="Helvetica Neue"/>
+              </a:defRPr>
+            </a:pPr>
+            <a:r>
+              <a:t>공헌이익</a:t>
             </a:r>
           </a:p>
         </p:txBody>
@@ -6058,23 +6058,23 @@
               </a:defRPr>
             </a:pPr>
             <a:r>
-              <a:t>합계 공헌</a:t>
-            </a:r>
-          </a:p>
-          <a:p xmlns:a="http://schemas.openxmlformats.org/drawingml/2006/main">
-            <a:pPr algn="l">
-              <a:buNone/>
-              <a:defRPr sz="2400">
-                <a:solidFill>
-                  <a:srgbClr val="000000"/>
-                </a:solidFill>
-                <a:latin typeface="Helvetica Neue"/>
-                <a:ea typeface="Helvetica Neue"/>
-                <a:cs typeface="Helvetica Neue"/>
-              </a:defRPr>
-            </a:pPr>
-            <a:r>
-              <a:t>총매출 6.60억원</a:t>
+              <a:t>합계</a:t>
+            </a:r>
+          </a:p>
+          <a:p xmlns:a="http://schemas.openxmlformats.org/drawingml/2006/main">
+            <a:pPr algn="l">
+              <a:buNone/>
+              <a:defRPr sz="2400">
+                <a:solidFill>
+                  <a:srgbClr val="000000"/>
+                </a:solidFill>
+                <a:latin typeface="Helvetica Neue"/>
+                <a:ea typeface="Helvetica Neue"/>
+                <a:cs typeface="Helvetica Neue"/>
+              </a:defRPr>
+            </a:pPr>
+            <a:r>
+              <a:t>공헌이익</a:t>
             </a:r>
           </a:p>
         </p:txBody>
@@ -6120,23 +6120,23 @@
               </a:defRPr>
             </a:pPr>
             <a:r>
-              <a:t>매트릭스 공헌</a:t>
-            </a:r>
-          </a:p>
-          <a:p xmlns:a="http://schemas.openxmlformats.org/drawingml/2006/main">
-            <a:pPr algn="l">
-              <a:buNone/>
-              <a:defRPr sz="2400">
-                <a:solidFill>
-                  <a:srgbClr val="000000"/>
-                </a:solidFill>
-                <a:latin typeface="Helvetica Neue"/>
-                <a:ea typeface="Helvetica Neue"/>
-                <a:cs typeface="Helvetica Neue"/>
-              </a:defRPr>
-            </a:pPr>
-            <a:r>
-              <a:t>5만t×4,149원/사료t</a:t>
+              <a:t>매트릭스</a:t>
+            </a:r>
+          </a:p>
+          <a:p xmlns:a="http://schemas.openxmlformats.org/drawingml/2006/main">
+            <a:pPr algn="l">
+              <a:buNone/>
+              <a:defRPr sz="2400">
+                <a:solidFill>
+                  <a:srgbClr val="000000"/>
+                </a:solidFill>
+                <a:latin typeface="Helvetica Neue"/>
+                <a:ea typeface="Helvetica Neue"/>
+                <a:cs typeface="Helvetica Neue"/>
+              </a:defRPr>
+            </a:pPr>
+            <a:r>
+              <a:t>공헌이익</a:t>
             </a:r>
           </a:p>
         </p:txBody>
@@ -6538,7 +6538,7 @@
               </a:defRPr>
             </a:pPr>
             <a:r>
-              <a:t>첫 반복판매가 사실이면 브리지 능력의 35%를 사용한다</a:t>
+              <a:t>첫 반복 주문 물량은 추정 생산능력의 35%에 해당한다</a:t>
             </a:r>
           </a:p>
         </p:txBody>
@@ -6796,7 +6796,7 @@
               </a:defRPr>
             </a:pPr>
             <a:r>
-              <a:t>브리지 능력</a:t>
+              <a:t>추정 생산능력</a:t>
             </a:r>
           </a:p>
           <a:p xmlns:a="http://schemas.openxmlformats.org/drawingml/2006/main">
@@ -6891,7 +6891,7 @@
         </p:xfrm>
         <a:graphic xmlns:a="http://schemas.openxmlformats.org/drawingml/2006/main">
           <a:graphicData uri="http://schemas.openxmlformats.org/drawingml/2006/chart">
-            <c:chart xmlns:r="http://schemas.openxmlformats.org/officeDocument/2006/relationships" xmlns:c="http://schemas.openxmlformats.org/drawingml/2006/chart" r:id="Rf01bd0f3b84f44f1"/>
+            <c:chart xmlns:r="http://schemas.openxmlformats.org/officeDocument/2006/relationships" xmlns:c="http://schemas.openxmlformats.org/drawingml/2006/chart" r:id="Rc3a332c1e26f4225"/>
           </a:graphicData>
         </a:graphic>
       </p:graphicFrame>
@@ -7092,7 +7092,7 @@
               </a:defRPr>
             </a:pPr>
             <a:r>
-              <a:t>네 게이트 중 하나라도 열려 있으면 SCALE로 가지 않는다</a:t>
+              <a:t>네 가지 중 하나라도 확인되지 않으면 사업을 확대하지 않는다</a:t>
             </a:r>
           </a:p>
         </p:txBody>
@@ -7184,7 +7184,7 @@
               </a:defRPr>
             </a:pPr>
             <a:r>
-              <a:t>미확정이면 STOP</a:t>
+              <a:t>확인 전 외부 홍보 중단</a:t>
             </a:r>
           </a:p>
         </p:txBody>
@@ -7228,7 +7228,7 @@
               </a:defRPr>
             </a:pPr>
             <a:r>
-              <a:t>제품근거</a:t>
+              <a:t>제품 근거</a:t>
             </a:r>
           </a:p>
           <a:p xmlns:a="http://schemas.openxmlformats.org/drawingml/2006/main">
@@ -7276,7 +7276,7 @@
               </a:defRPr>
             </a:pPr>
             <a:r>
-              <a:t>미확정이면 HOLD</a:t>
+              <a:t>확인 전 확대 보류</a:t>
             </a:r>
           </a:p>
         </p:txBody>
@@ -7322,55 +7322,55 @@
               </a:defRPr>
             </a:pPr>
             <a:r>
-              <a:t>OEM·QA</a:t>
-            </a:r>
-          </a:p>
-          <a:p xmlns:a="http://schemas.openxmlformats.org/drawingml/2006/main">
-            <a:pPr algn="l">
-              <a:buNone/>
-              <a:defRPr sz="2400">
-                <a:solidFill>
-                  <a:srgbClr val="000000"/>
-                </a:solidFill>
-                <a:latin typeface="Helvetica Neue"/>
-                <a:ea typeface="Helvetica Neue"/>
-                <a:cs typeface="Helvetica Neue"/>
-              </a:defRPr>
-            </a:pPr>
-            <a:r>
-              <a:t>실견적·MOQ·리드타임</a:t>
-            </a:r>
-          </a:p>
-          <a:p xmlns:a="http://schemas.openxmlformats.org/drawingml/2006/main">
-            <a:pPr algn="l">
-              <a:buNone/>
-              <a:defRPr sz="2400">
-                <a:solidFill>
-                  <a:srgbClr val="000000"/>
-                </a:solidFill>
-                <a:latin typeface="Helvetica Neue"/>
-                <a:ea typeface="Helvetica Neue"/>
-                <a:cs typeface="Helvetica Neue"/>
-              </a:defRPr>
-            </a:pPr>
-            <a:r>
-              <a:t>QA Agreement</a:t>
-            </a:r>
-          </a:p>
-          <a:p xmlns:a="http://schemas.openxmlformats.org/drawingml/2006/main">
-            <a:pPr algn="l">
-              <a:buNone/>
-              <a:defRPr sz="2400">
-                <a:solidFill>
-                  <a:srgbClr val="000000"/>
-                </a:solidFill>
-                <a:latin typeface="Helvetica Neue"/>
-                <a:ea typeface="Helvetica Neue"/>
-                <a:cs typeface="Helvetica Neue"/>
-              </a:defRPr>
-            </a:pPr>
-            <a:r>
-              <a:t>미합의면 HOLD</a:t>
+              <a:t>OEM·품질</a:t>
+            </a:r>
+          </a:p>
+          <a:p xmlns:a="http://schemas.openxmlformats.org/drawingml/2006/main">
+            <a:pPr algn="l">
+              <a:buNone/>
+              <a:defRPr sz="2400">
+                <a:solidFill>
+                  <a:srgbClr val="000000"/>
+                </a:solidFill>
+                <a:latin typeface="Helvetica Neue"/>
+                <a:ea typeface="Helvetica Neue"/>
+                <a:cs typeface="Helvetica Neue"/>
+              </a:defRPr>
+            </a:pPr>
+            <a:r>
+              <a:t>실제 견적·MOQ·납기</a:t>
+            </a:r>
+          </a:p>
+          <a:p xmlns:a="http://schemas.openxmlformats.org/drawingml/2006/main">
+            <a:pPr algn="l">
+              <a:buNone/>
+              <a:defRPr sz="2400">
+                <a:solidFill>
+                  <a:srgbClr val="000000"/>
+                </a:solidFill>
+                <a:latin typeface="Helvetica Neue"/>
+                <a:ea typeface="Helvetica Neue"/>
+                <a:cs typeface="Helvetica Neue"/>
+              </a:defRPr>
+            </a:pPr>
+            <a:r>
+              <a:t>품질 협약서</a:t>
+            </a:r>
+          </a:p>
+          <a:p xmlns:a="http://schemas.openxmlformats.org/drawingml/2006/main">
+            <a:pPr algn="l">
+              <a:buNone/>
+              <a:defRPr sz="2400">
+                <a:solidFill>
+                  <a:srgbClr val="000000"/>
+                </a:solidFill>
+                <a:latin typeface="Helvetica Neue"/>
+                <a:ea typeface="Helvetica Neue"/>
+                <a:cs typeface="Helvetica Neue"/>
+              </a:defRPr>
+            </a:pPr>
+            <a:r>
+              <a:t>합의 전 납기 약속 보류</a:t>
             </a:r>
           </a:p>
         </p:txBody>
@@ -7416,55 +7416,55 @@
               </a:defRPr>
             </a:pPr>
             <a:r>
-              <a:t>상업검증</a:t>
-            </a:r>
-          </a:p>
-          <a:p xmlns:a="http://schemas.openxmlformats.org/drawingml/2006/main">
-            <a:pPr algn="l">
-              <a:buNone/>
-              <a:defRPr sz="2400">
-                <a:solidFill>
-                  <a:srgbClr val="000000"/>
-                </a:solidFill>
-                <a:latin typeface="Helvetica Neue"/>
-                <a:ea typeface="Helvetica Neue"/>
-                <a:cs typeface="Helvetica Neue"/>
-              </a:defRPr>
-            </a:pPr>
-            <a:r>
-              <a:t>유료 PoV 2건</a:t>
-            </a:r>
-          </a:p>
-          <a:p xmlns:a="http://schemas.openxmlformats.org/drawingml/2006/main">
-            <a:pPr algn="l">
-              <a:buNone/>
-              <a:defRPr sz="2400">
-                <a:solidFill>
-                  <a:srgbClr val="000000"/>
-                </a:solidFill>
-                <a:latin typeface="Helvetica Neue"/>
-                <a:ea typeface="Helvetica Neue"/>
-                <a:cs typeface="Helvetica Neue"/>
-              </a:defRPr>
-            </a:pPr>
-            <a:r>
-              <a:t>반복 PO 트리거</a:t>
-            </a:r>
-          </a:p>
-          <a:p xmlns:a="http://schemas.openxmlformats.org/drawingml/2006/main">
-            <a:pPr algn="l">
-              <a:buNone/>
-              <a:defRPr sz="2400">
-                <a:solidFill>
-                  <a:srgbClr val="000000"/>
-                </a:solidFill>
-                <a:latin typeface="Helvetica Neue"/>
-                <a:ea typeface="Helvetica Neue"/>
-                <a:cs typeface="Helvetica Neue"/>
-              </a:defRPr>
-            </a:pPr>
-            <a:r>
-              <a:t>증빙 없으면 STOP</a:t>
+              <a:t>상업성</a:t>
+            </a:r>
+          </a:p>
+          <a:p xmlns:a="http://schemas.openxmlformats.org/drawingml/2006/main">
+            <a:pPr algn="l">
+              <a:buNone/>
+              <a:defRPr sz="2400">
+                <a:solidFill>
+                  <a:srgbClr val="000000"/>
+                </a:solidFill>
+                <a:latin typeface="Helvetica Neue"/>
+                <a:ea typeface="Helvetica Neue"/>
+                <a:cs typeface="Helvetica Neue"/>
+              </a:defRPr>
+            </a:pPr>
+            <a:r>
+              <a:t>유료 고객 시험 2건</a:t>
+            </a:r>
+          </a:p>
+          <a:p xmlns:a="http://schemas.openxmlformats.org/drawingml/2006/main">
+            <a:pPr algn="l">
+              <a:buNone/>
+              <a:defRPr sz="2400">
+                <a:solidFill>
+                  <a:srgbClr val="000000"/>
+                </a:solidFill>
+                <a:latin typeface="Helvetica Neue"/>
+                <a:ea typeface="Helvetica Neue"/>
+                <a:cs typeface="Helvetica Neue"/>
+              </a:defRPr>
+            </a:pPr>
+            <a:r>
+              <a:t>반복 주문 자료</a:t>
+            </a:r>
+          </a:p>
+          <a:p xmlns:a="http://schemas.openxmlformats.org/drawingml/2006/main">
+            <a:pPr algn="l">
+              <a:buNone/>
+              <a:defRPr sz="2400">
+                <a:solidFill>
+                  <a:srgbClr val="000000"/>
+                </a:solidFill>
+                <a:latin typeface="Helvetica Neue"/>
+                <a:ea typeface="Helvetica Neue"/>
+                <a:cs typeface="Helvetica Neue"/>
+              </a:defRPr>
+            </a:pPr>
+            <a:r>
+              <a:t>미확인 시 투자 확대 중단</a:t>
             </a:r>
           </a:p>
         </p:txBody>
@@ -7554,7 +7554,7 @@
                 <a:ea typeface="Arial"/>
                 <a:cs typeface="Arial"/>
               </a:rPr>
-              <a:t>GABA BUSINESS MODEL | 16 | STOP-LOSS GATES</a:t>
+              <a:t>GABA BUSINESS MODEL | 16 | EXPANSION CHECKS</a:t>
             </a:r>
           </a:p>
         </p:txBody>
@@ -7666,7 +7666,7 @@
               </a:defRPr>
             </a:pPr>
             <a:r>
-              <a:t>90일 안에 네 열린 게이트를 유료 PO로 바꾼다</a:t>
+              <a:t>앞으로 90일 동안 네 가지 핵심 검증을 순서대로 마친다</a:t>
             </a:r>
           </a:p>
         </p:txBody>
@@ -7953,7 +7953,7 @@
               </a:defRPr>
             </a:pPr>
             <a:r>
-              <a:t>제품 잠금</a:t>
+              <a:t>제품·공급 조건 확인</a:t>
             </a:r>
           </a:p>
           <a:p xmlns:a="http://schemas.openxmlformats.org/drawingml/2006/main">
@@ -8001,7 +8001,7 @@
               </a:defRPr>
             </a:pPr>
             <a:r>
-              <a:t>유료 PoV 프로토콜</a:t>
+              <a:t>유료 고객 시험계획</a:t>
             </a:r>
           </a:p>
         </p:txBody>
@@ -8047,7 +8047,7 @@
               </a:defRPr>
             </a:pPr>
             <a:r>
-              <a:t>경로 잠금</a:t>
+              <a:t>규제 경로 확인</a:t>
             </a:r>
           </a:p>
           <a:p xmlns:a="http://schemas.openxmlformats.org/drawingml/2006/main">
@@ -8141,55 +8141,55 @@
               </a:defRPr>
             </a:pPr>
             <a:r>
-              <a:t>상업 잠금</a:t>
-            </a:r>
-          </a:p>
-          <a:p xmlns:a="http://schemas.openxmlformats.org/drawingml/2006/main">
-            <a:pPr algn="l">
-              <a:buNone/>
-              <a:defRPr sz="2400">
-                <a:solidFill>
-                  <a:srgbClr val="000000"/>
-                </a:solidFill>
-                <a:latin typeface="Helvetica Neue"/>
-                <a:ea typeface="Helvetica Neue"/>
-                <a:cs typeface="Helvetica Neue"/>
-              </a:defRPr>
-            </a:pPr>
-            <a:r>
-              <a:t>첫 유료 PO</a:t>
-            </a:r>
-          </a:p>
-          <a:p xmlns:a="http://schemas.openxmlformats.org/drawingml/2006/main">
-            <a:pPr algn="l">
-              <a:buNone/>
-              <a:defRPr sz="2400">
-                <a:solidFill>
-                  <a:srgbClr val="000000"/>
-                </a:solidFill>
-                <a:latin typeface="Helvetica Neue"/>
-                <a:ea typeface="Helvetica Neue"/>
-                <a:cs typeface="Helvetica Neue"/>
-              </a:defRPr>
-            </a:pPr>
-            <a:r>
-              <a:t>반복주문 조건</a:t>
-            </a:r>
-          </a:p>
-          <a:p xmlns:a="http://schemas.openxmlformats.org/drawingml/2006/main">
-            <a:pPr algn="l">
-              <a:buNone/>
-              <a:defRPr sz="2400">
-                <a:solidFill>
-                  <a:srgbClr val="000000"/>
-                </a:solidFill>
-                <a:latin typeface="Helvetica Neue"/>
-                <a:ea typeface="Helvetica Neue"/>
-                <a:cs typeface="Helvetica Neue"/>
-              </a:defRPr>
-            </a:pPr>
-            <a:r>
-              <a:t>실제 원가 GO/NO-GO</a:t>
+              <a:t>상업성 확인</a:t>
+            </a:r>
+          </a:p>
+          <a:p xmlns:a="http://schemas.openxmlformats.org/drawingml/2006/main">
+            <a:pPr algn="l">
+              <a:buNone/>
+              <a:defRPr sz="2400">
+                <a:solidFill>
+                  <a:srgbClr val="000000"/>
+                </a:solidFill>
+                <a:latin typeface="Helvetica Neue"/>
+                <a:ea typeface="Helvetica Neue"/>
+                <a:cs typeface="Helvetica Neue"/>
+              </a:defRPr>
+            </a:pPr>
+            <a:r>
+              <a:t>첫 유료 발주서</a:t>
+            </a:r>
+          </a:p>
+          <a:p xmlns:a="http://schemas.openxmlformats.org/drawingml/2006/main">
+            <a:pPr algn="l">
+              <a:buNone/>
+              <a:defRPr sz="2400">
+                <a:solidFill>
+                  <a:srgbClr val="000000"/>
+                </a:solidFill>
+                <a:latin typeface="Helvetica Neue"/>
+                <a:ea typeface="Helvetica Neue"/>
+                <a:cs typeface="Helvetica Neue"/>
+              </a:defRPr>
+            </a:pPr>
+            <a:r>
+              <a:t>반복 주문 조건</a:t>
+            </a:r>
+          </a:p>
+          <a:p xmlns:a="http://schemas.openxmlformats.org/drawingml/2006/main">
+            <a:pPr algn="l">
+              <a:buNone/>
+              <a:defRPr sz="2400">
+                <a:solidFill>
+                  <a:srgbClr val="000000"/>
+                </a:solidFill>
+                <a:latin typeface="Helvetica Neue"/>
+                <a:ea typeface="Helvetica Neue"/>
+                <a:cs typeface="Helvetica Neue"/>
+              </a:defRPr>
+            </a:pPr>
+            <a:r>
+              <a:t>실제 원가로 추진 여부 결정</a:t>
             </a:r>
           </a:p>
         </p:txBody>
@@ -8347,7 +8347,7 @@
               </a:defRPr>
             </a:pPr>
             <a:r>
-              <a:t>4,560만원 집행 전,</a:t>
+              <a:t>4,560만원을 집행하기 전,</a:t>
             </a:r>
           </a:p>
           <a:p xmlns:a="http://schemas.openxmlformats.org/drawingml/2006/main">
@@ -8363,7 +8363,7 @@
               </a:defRPr>
             </a:pPr>
             <a:r>
-              <a:t>네 증빙부터 승인해 주십시오</a:t>
+              <a:t>네 가지 검증 과제를 승인해 주십시오</a:t>
             </a:r>
           </a:p>
         </p:txBody>
@@ -8409,7 +8409,7 @@
               </a:defRPr>
             </a:pPr>
             <a:r>
-              <a:t>① 품목분류·표시 문구 사전검토  ② 제품특이 CoA·안정성·유효용량</a:t>
+              <a:t>① 품목분류·표시 문구 사전검토  ② 제품 CoA·안정성·유효용량</a:t>
             </a:r>
           </a:p>
           <a:p xmlns:a="http://schemas.openxmlformats.org/drawingml/2006/main">
@@ -8425,7 +8425,7 @@
               </a:defRPr>
             </a:pPr>
             <a:r>
-              <a:t>③ OEM 2곳 실견적·QA Agreement  ④ 유료 PoV와 반복 PO 트리거</a:t>
+              <a:t>③ OEM 2곳 실제 견적·품질 협약서  ④ 유료 고객 시험과 반복 주문</a:t>
             </a:r>
           </a:p>
         </p:txBody>
@@ -8471,7 +8471,7 @@
               </a:defRPr>
             </a:pPr>
             <a:r>
-              <a:t>DECISION · VALIDATE, THEN SCALE</a:t>
+              <a:t>승인 요청 · 검증 예산</a:t>
             </a:r>
           </a:p>
         </p:txBody>
@@ -8673,7 +8673,7 @@
               </a:defRPr>
             </a:pPr>
             <a:r>
-              <a:t>APPENDIX · 정의·산식·출처·면책</a:t>
+              <a:t>APPENDIX · 용어·계산식·출처·이용 안내</a:t>
             </a:r>
           </a:p>
         </p:txBody>
@@ -8765,7 +8765,7 @@
               </a:defRPr>
             </a:pPr>
             <a:r>
-              <a:t>PoV=가치검증</a:t>
+              <a:t>PoV=고객 가치 검증</a:t>
             </a:r>
           </a:p>
         </p:txBody>
@@ -8841,23 +8841,23 @@
               </a:defRPr>
             </a:pPr>
             <a:r>
-              <a:t>OEM=주문자상표 생산</a:t>
-            </a:r>
-          </a:p>
-          <a:p xmlns:a="http://schemas.openxmlformats.org/drawingml/2006/main">
-            <a:pPr algn="l">
-              <a:buNone/>
-              <a:defRPr sz="2400">
-                <a:solidFill>
-                  <a:srgbClr val="000000"/>
-                </a:solidFill>
-                <a:latin typeface="Helvetica Neue"/>
-                <a:ea typeface="Helvetica Neue"/>
-                <a:cs typeface="Helvetica Neue"/>
-              </a:defRPr>
-            </a:pPr>
-            <a:r>
-              <a:t>MOQ=최소주문수량</a:t>
+              <a:t>OEM=주문자 상표 부착 생산</a:t>
+            </a:r>
+          </a:p>
+          <a:p xmlns:a="http://schemas.openxmlformats.org/drawingml/2006/main">
+            <a:pPr algn="l">
+              <a:buNone/>
+              <a:defRPr sz="2400">
+                <a:solidFill>
+                  <a:srgbClr val="000000"/>
+                </a:solidFill>
+                <a:latin typeface="Helvetica Neue"/>
+                <a:ea typeface="Helvetica Neue"/>
+                <a:cs typeface="Helvetica Neue"/>
+              </a:defRPr>
+            </a:pPr>
+            <a:r>
+              <a:t>MOQ=최소 주문 수량</a:t>
             </a:r>
           </a:p>
         </p:txBody>
@@ -8997,7 +8997,7 @@
               </a:defRPr>
             </a:pPr>
             <a:r>
-              <a:t>면책</a:t>
+              <a:t>이용 안내</a:t>
             </a:r>
           </a:p>
           <a:p xmlns:a="http://schemas.openxmlformats.org/drawingml/2006/main">
@@ -9029,7 +9029,7 @@
               </a:defRPr>
             </a:pPr>
             <a:r>
-              <a:t>모두 관할기관·시험기관·실견적·</a:t>
+              <a:t>관할기관·시험기관·실제 견적·</a:t>
             </a:r>
           </a:p>
           <a:p xmlns:a="http://schemas.openxmlformats.org/drawingml/2006/main">
@@ -9203,7 +9203,7 @@
               </a:defRPr>
             </a:pPr>
             <a:r>
-              <a:t>재고는 한 SKU만,</a:t>
+              <a:t>재고는 한 종류만,</a:t>
             </a:r>
           </a:p>
           <a:p xmlns:a="http://schemas.openxmlformats.org/drawingml/2006/main">
@@ -9219,7 +9219,7 @@
               </a:defRPr>
             </a:pPr>
             <a:r>
-              <a:t>네 게이트 후 투자한다</a:t>
+              <a:t>네 가지 확인 후 투자한다</a:t>
             </a:r>
           </a:p>
         </p:txBody>
@@ -9311,7 +9311,7 @@
               </a:defRPr>
             </a:pPr>
             <a:r>
-              <a:t>READINESS 41/100 · VALIDATE</a:t>
+              <a:t>준비도 41/100 · 검증 단계</a:t>
             </a:r>
           </a:p>
         </p:txBody>
@@ -9513,7 +9513,7 @@
               </a:defRPr>
             </a:pPr>
             <a:r>
-              <a:t>완제품 네 SKU가 아니라, 검증 가능한 한 SKU를 보유한다</a:t>
+              <a:t>완제품 네 종류 대신, 품질을 확인할 수 있는 마스터만 보유한다</a:t>
             </a:r>
           </a:p>
         </p:txBody>
@@ -9832,7 +9832,7 @@
               </a:defRPr>
             </a:pPr>
             <a:r>
-              <a:t>lot·CoA 관리</a:t>
+              <a:t>로트·CoA 관리</a:t>
             </a:r>
           </a:p>
           <a:p xmlns:a="http://schemas.openxmlformats.org/drawingml/2006/main">
@@ -10036,7 +10036,7 @@
               </a:defRPr>
             </a:pPr>
             <a:r>
-              <a:t>완제품 선재고 0kg</a:t>
+              <a:t>미리 만든 완제품 0kg</a:t>
             </a:r>
           </a:p>
         </p:txBody>
@@ -10238,7 +10238,7 @@
               </a:defRPr>
             </a:pPr>
             <a:r>
-              <a:t>배양액을 표준 마스터로 바꾸고, 주문 규격으로만 확장한다</a:t>
+              <a:t>배양액을 표준 마스터로 만든 뒤, 고객 주문에 맞춰 제품화한다</a:t>
             </a:r>
           </a:p>
         </p:txBody>
@@ -11050,7 +11050,7 @@
               </a:defRPr>
             </a:pPr>
             <a:r>
-              <a:t>1톤 물질수지는 보이지만, 9,240원/kg 원가 브리지는 비어 있다</a:t>
+              <a:t>kg당 9,240원의 세부 원가는 아직 확인되지 않았다</a:t>
             </a:r>
           </a:p>
         </p:txBody>
@@ -11420,7 +11420,7 @@
               </a:defRPr>
             </a:pPr>
             <a:r>
-              <a:t>원본: 1,000L×4,000원/L · ※ 건조·부형제·검사·포장·수율 비용은 아직 연결되지 않음</a:t>
+              <a:t>원본: 1,000L×4,000원/L · ※ 건조·부형제·검사·포장·수율 비용의 반영 여부는 아직 확인되지 않음</a:t>
             </a:r>
           </a:p>
         </p:txBody>
@@ -11622,7 +11622,7 @@
               </a:defRPr>
             </a:pPr>
             <a:r>
-              <a:t>20% 마스터만 재고로 두면 폐기·사양변경 리스크를 격리한다</a:t>
+              <a:t>20% 마스터만 재고로 두면 폐기와 사양 변경 위험을 줄일 수 있다</a:t>
             </a:r>
           </a:p>
         </p:txBody>
@@ -11962,23 +11962,23 @@
               </a:defRPr>
             </a:pPr>
             <a:r>
-              <a:t>PO(구매주문서) 승인</a:t>
-            </a:r>
-          </a:p>
-          <a:p xmlns:a="http://schemas.openxmlformats.org/drawingml/2006/main">
-            <a:pPr algn="l">
-              <a:buNone/>
-              <a:defRPr sz="2400">
-                <a:solidFill>
-                  <a:srgbClr val="000000"/>
-                </a:solidFill>
-                <a:latin typeface="Helvetica Neue"/>
-                <a:ea typeface="Helvetica Neue"/>
-                <a:cs typeface="Helvetica Neue"/>
-              </a:defRPr>
-            </a:pPr>
-            <a:r>
-              <a:t>MOQ·리드타임 잠금</a:t>
+              <a:t>PO(발주서) 승인</a:t>
+            </a:r>
+          </a:p>
+          <a:p xmlns:a="http://schemas.openxmlformats.org/drawingml/2006/main">
+            <a:pPr algn="l">
+              <a:buNone/>
+              <a:defRPr sz="2400">
+                <a:solidFill>
+                  <a:srgbClr val="000000"/>
+                </a:solidFill>
+                <a:latin typeface="Helvetica Neue"/>
+                <a:ea typeface="Helvetica Neue"/>
+                <a:cs typeface="Helvetica Neue"/>
+              </a:defRPr>
+            </a:pPr>
+            <a:r>
+              <a:t>MOQ·납기 확인</a:t>
             </a:r>
           </a:p>
           <a:p xmlns:a="http://schemas.openxmlformats.org/drawingml/2006/main">
@@ -12196,7 +12196,7 @@
               </a:defRPr>
             </a:pPr>
             <a:r>
-              <a:t>주문이 들어오면 규격을 잠그고, 그때 OEM을 가동한다</a:t>
+              <a:t>발주서와 제품 규격을 확인한 뒤 OEM 생산을 시작한다</a:t>
             </a:r>
           </a:p>
         </p:txBody>
@@ -12345,7 +12345,7 @@
               </a:defRPr>
             </a:pPr>
             <a:r>
-              <a:t>PO·규격 잠금</a:t>
+              <a:t>발주서·규격 확정</a:t>
             </a:r>
           </a:p>
         </p:txBody>
@@ -12921,7 +12921,7 @@
               </a:defRPr>
             </a:pPr>
             <a:r>
-              <a:t>첫 계약 전, 품목분류와 공장 QA를 서면으로 잠근다</a:t>
+              <a:t>첫 계약 전에 품목 분류와 공장 품질 체계를 서면으로 확인한다</a:t>
             </a:r>
           </a:p>
         </p:txBody>
@@ -12981,7 +12981,7 @@
               </a:defRPr>
             </a:pPr>
             <a:r>
-              <a:t>원료 명칭·사료공정</a:t>
+              <a:t>원료 명칭·품목 분류</a:t>
             </a:r>
           </a:p>
           <a:p xmlns:a="http://schemas.openxmlformats.org/drawingml/2006/main">
@@ -13089,7 +13089,7 @@
               </a:defRPr>
             </a:pPr>
             <a:r>
-              <a:t>CoA(로트 성적서)</a:t>
+              <a:t>로트별 CoA</a:t>
             </a:r>
           </a:p>
           <a:p xmlns:a="http://schemas.openxmlformats.org/drawingml/2006/main">
@@ -13261,39 +13261,39 @@
               </a:defRPr>
             </a:pPr>
             <a:r>
-              <a:t>lot 추적·리콜</a:t>
-            </a:r>
-          </a:p>
-          <a:p xmlns:a="http://schemas.openxmlformats.org/drawingml/2006/main">
-            <a:pPr algn="l">
-              <a:buNone/>
-              <a:defRPr sz="2400">
-                <a:solidFill>
-                  <a:srgbClr val="000000"/>
-                </a:solidFill>
-                <a:latin typeface="Helvetica Neue"/>
-                <a:ea typeface="Helvetica Neue"/>
-                <a:cs typeface="Helvetica Neue"/>
-              </a:defRPr>
-            </a:pPr>
-            <a:r>
-              <a:t>MOQ(최소주문량)</a:t>
-            </a:r>
-          </a:p>
-          <a:p xmlns:a="http://schemas.openxmlformats.org/drawingml/2006/main">
-            <a:pPr algn="l">
-              <a:buNone/>
-              <a:defRPr sz="2400">
-                <a:solidFill>
-                  <a:srgbClr val="000000"/>
-                </a:solidFill>
-                <a:latin typeface="Helvetica Neue"/>
-                <a:ea typeface="Helvetica Neue"/>
-                <a:cs typeface="Helvetica Neue"/>
-              </a:defRPr>
-            </a:pPr>
-            <a:r>
-              <a:t>리드타임·반품</a:t>
+              <a:t>로트 추적·회수</a:t>
+            </a:r>
+          </a:p>
+          <a:p xmlns:a="http://schemas.openxmlformats.org/drawingml/2006/main">
+            <a:pPr algn="l">
+              <a:buNone/>
+              <a:defRPr sz="2400">
+                <a:solidFill>
+                  <a:srgbClr val="000000"/>
+                </a:solidFill>
+                <a:latin typeface="Helvetica Neue"/>
+                <a:ea typeface="Helvetica Neue"/>
+                <a:cs typeface="Helvetica Neue"/>
+              </a:defRPr>
+            </a:pPr>
+            <a:r>
+              <a:t>MOQ·납기</a:t>
+            </a:r>
+          </a:p>
+          <a:p xmlns:a="http://schemas.openxmlformats.org/drawingml/2006/main">
+            <a:pPr algn="l">
+              <a:buNone/>
+              <a:defRPr sz="2400">
+                <a:solidFill>
+                  <a:srgbClr val="000000"/>
+                </a:solidFill>
+                <a:latin typeface="Helvetica Neue"/>
+                <a:ea typeface="Helvetica Neue"/>
+                <a:cs typeface="Helvetica Neue"/>
+              </a:defRPr>
+            </a:pPr>
+            <a:r>
+              <a:t>반품 조건</a:t>
             </a:r>
           </a:p>
         </p:txBody>
@@ -13968,7 +13968,7 @@
               </a:defRPr>
             </a:pPr>
             <a:r>
-              <a:t>※ RP-GABA=반추위 보호 GABA · 제품특이 PoV 필요</a:t>
+              <a:t>※ RP-GABA=반추위 보호 GABA · 해당 제품을 사용한 고객 시험 필요</a:t>
             </a:r>
           </a:p>
         </p:txBody>

</xml_diff>

<commit_message>
feat: split GABA feed business and add commercialization team
</commit_message>
<xml_diff>
--- a/GABA_Feed_Business_Model_Speech_Deck_v1.pptx
+++ b/GABA_Feed_Business_Model_Speech_Deck_v1.pptx
@@ -2,31 +2,32 @@
 <file path=ppt/presentation.xml><?xml version="1.0" encoding="utf-8"?>
 <p:presentation xmlns:p="http://schemas.openxmlformats.org/presentationml/2006/main">
   <p:sldMasterIdLst>
-    <p:sldMasterId xmlns:r="http://schemas.openxmlformats.org/officeDocument/2006/relationships" id="2147483648" r:id="R0970b38cb1b24455"/>
+    <p:sldMasterId xmlns:r="http://schemas.openxmlformats.org/officeDocument/2006/relationships" id="2147483648" r:id="R23b2f4b2b0bc4d4e"/>
   </p:sldMasterIdLst>
   <p:notesMasterIdLst>
-    <p:notesMasterId xmlns:r="http://schemas.openxmlformats.org/officeDocument/2006/relationships" r:id="R2530760c313c44e4"/>
+    <p:notesMasterId xmlns:r="http://schemas.openxmlformats.org/officeDocument/2006/relationships" r:id="Rd45be563a9784949"/>
   </p:notesMasterIdLst>
   <p:sldIdLst>
-    <p:sldId xmlns:r="http://schemas.openxmlformats.org/officeDocument/2006/relationships" id="256" r:id="R89a4d953b05348a6"/>
-    <p:sldId xmlns:r="http://schemas.openxmlformats.org/officeDocument/2006/relationships" id="257" r:id="R61bc09e86d4c456e"/>
-    <p:sldId xmlns:r="http://schemas.openxmlformats.org/officeDocument/2006/relationships" id="258" r:id="R47c2ab4ec6404465"/>
-    <p:sldId xmlns:r="http://schemas.openxmlformats.org/officeDocument/2006/relationships" id="259" r:id="R58851d4bc81f4bee"/>
-    <p:sldId xmlns:r="http://schemas.openxmlformats.org/officeDocument/2006/relationships" id="260" r:id="Rcf4955f38d5448bd"/>
-    <p:sldId xmlns:r="http://schemas.openxmlformats.org/officeDocument/2006/relationships" id="261" r:id="Rea5ccbdcae3c48a0"/>
-    <p:sldId xmlns:r="http://schemas.openxmlformats.org/officeDocument/2006/relationships" id="262" r:id="R80629fbb99104ced"/>
-    <p:sldId xmlns:r="http://schemas.openxmlformats.org/officeDocument/2006/relationships" id="263" r:id="R45b6d3e9ee3c4c80"/>
-    <p:sldId xmlns:r="http://schemas.openxmlformats.org/officeDocument/2006/relationships" id="264" r:id="R462bf99882e14203"/>
-    <p:sldId xmlns:r="http://schemas.openxmlformats.org/officeDocument/2006/relationships" id="265" r:id="R9c42a96959db4535"/>
-    <p:sldId xmlns:r="http://schemas.openxmlformats.org/officeDocument/2006/relationships" id="266" r:id="R68f782dd53c246df"/>
-    <p:sldId xmlns:r="http://schemas.openxmlformats.org/officeDocument/2006/relationships" id="267" r:id="R78fccbce6e394d90"/>
-    <p:sldId xmlns:r="http://schemas.openxmlformats.org/officeDocument/2006/relationships" id="268" r:id="Re764078bf52c4e72"/>
-    <p:sldId xmlns:r="http://schemas.openxmlformats.org/officeDocument/2006/relationships" id="269" r:id="Refc5d1d76e0b49e7"/>
-    <p:sldId xmlns:r="http://schemas.openxmlformats.org/officeDocument/2006/relationships" id="270" r:id="R4ef7658785c341d1"/>
-    <p:sldId xmlns:r="http://schemas.openxmlformats.org/officeDocument/2006/relationships" id="271" r:id="Ra37f4470a4054d88"/>
-    <p:sldId xmlns:r="http://schemas.openxmlformats.org/officeDocument/2006/relationships" id="272" r:id="R95f1a2ca21f4421b"/>
-    <p:sldId xmlns:r="http://schemas.openxmlformats.org/officeDocument/2006/relationships" id="273" r:id="Rb93f557620e145b3"/>
-    <p:sldId xmlns:r="http://schemas.openxmlformats.org/officeDocument/2006/relationships" id="274" r:id="R857d86fc3438493a"/>
+    <p:sldId xmlns:r="http://schemas.openxmlformats.org/officeDocument/2006/relationships" id="256" r:id="R0771553f57cd47bf"/>
+    <p:sldId xmlns:r="http://schemas.openxmlformats.org/officeDocument/2006/relationships" id="257" r:id="R4789fc1fa3ba45e8"/>
+    <p:sldId xmlns:r="http://schemas.openxmlformats.org/officeDocument/2006/relationships" id="258" r:id="Re167f1bb8a8b485f"/>
+    <p:sldId xmlns:r="http://schemas.openxmlformats.org/officeDocument/2006/relationships" id="259" r:id="Raf0482924f844156"/>
+    <p:sldId xmlns:r="http://schemas.openxmlformats.org/officeDocument/2006/relationships" id="260" r:id="R15544ece48e048b1"/>
+    <p:sldId xmlns:r="http://schemas.openxmlformats.org/officeDocument/2006/relationships" id="261" r:id="R084c648901f34139"/>
+    <p:sldId xmlns:r="http://schemas.openxmlformats.org/officeDocument/2006/relationships" id="262" r:id="R7bb0df0478f4442f"/>
+    <p:sldId xmlns:r="http://schemas.openxmlformats.org/officeDocument/2006/relationships" id="263" r:id="Rf13056fbfdec4fb7"/>
+    <p:sldId xmlns:r="http://schemas.openxmlformats.org/officeDocument/2006/relationships" id="264" r:id="Rfaabb8ad912140b5"/>
+    <p:sldId xmlns:r="http://schemas.openxmlformats.org/officeDocument/2006/relationships" id="265" r:id="R350f45f6bd684f17"/>
+    <p:sldId xmlns:r="http://schemas.openxmlformats.org/officeDocument/2006/relationships" id="266" r:id="R35d054d2b1b84a79"/>
+    <p:sldId xmlns:r="http://schemas.openxmlformats.org/officeDocument/2006/relationships" id="267" r:id="R645c896dfe364a63"/>
+    <p:sldId xmlns:r="http://schemas.openxmlformats.org/officeDocument/2006/relationships" id="268" r:id="Rb346897b1f854083"/>
+    <p:sldId xmlns:r="http://schemas.openxmlformats.org/officeDocument/2006/relationships" id="269" r:id="Rb4243cea195d4637"/>
+    <p:sldId xmlns:r="http://schemas.openxmlformats.org/officeDocument/2006/relationships" id="270" r:id="Rcbfcc3ec0c9341be"/>
+    <p:sldId xmlns:r="http://schemas.openxmlformats.org/officeDocument/2006/relationships" id="271" r:id="R4e463d64aea0489a"/>
+    <p:sldId xmlns:r="http://schemas.openxmlformats.org/officeDocument/2006/relationships" id="272" r:id="Rab76e8785970448a"/>
+    <p:sldId xmlns:r="http://schemas.openxmlformats.org/officeDocument/2006/relationships" id="273" r:id="R4bfc68dc3daa4e0a"/>
+    <p:sldId xmlns:r="http://schemas.openxmlformats.org/officeDocument/2006/relationships" id="274" r:id="R873e928d48834c36"/>
+    <p:sldId xmlns:r="http://schemas.openxmlformats.org/officeDocument/2006/relationships" id="275" r:id="Rd175f4c199a94447"/>
   </p:sldIdLst>
   <p:sldSz cx="12192000" cy="6858000"/>
   <p:notesSz cx="6858000" cy="9144000"/>
@@ -460,7 +461,7 @@
           <a:lstStyle xmlns:a="http://schemas.openxmlformats.org/drawingml/2006/main"/>
           <a:p xmlns:a="http://schemas.openxmlformats.org/drawingml/2006/main">
             <a:r>
-              <a:t>사업 모델의 핵심은 단순합니다. 20% 마스터 한 종류만 재고로 보유하고, 고객이 주문한 규격은 OEM 공장에서 생산합니다. 오늘 요청드리는 것은 대규모 생산 투자가 아니라 네 가지 핵심 조건을 실제 자료로 확인하는 일입니다.</a:t>
+              <a:t>가바사료 사업은 두 부문으로 나눕니다. 가바크루드는 GABA 20% 기준품과 고객 주문에 맞춘 5~20% OEM 원료를 공급합니다. 가바케어믹스는 가바크루드와 미네랄매트릭스를 결합한 배합사료입니다. 두 사업은 품질 기준과 규제·제품 검증 체계를 함께 사용합니다.</a:t>
             </a:r>
           </a:p>
           <a:p xmlns:a="http://schemas.openxmlformats.org/drawingml/2006/main">
@@ -471,6 +472,11 @@
           <a:p xmlns:a="http://schemas.openxmlformats.org/drawingml/2006/main">
             <a:r>
               <a:t>[Sources]</a:t>
+            </a:r>
+          </a:p>
+          <a:p xmlns:a="http://schemas.openxmlformats.org/drawingml/2006/main">
+            <a:r>
+              <a:t>- 사용자 제공 사업화 정보 · 2026-08-03</a:t>
             </a:r>
           </a:p>
           <a:p xmlns:a="http://schemas.openxmlformats.org/drawingml/2006/main">
@@ -985,7 +991,7 @@
           <a:lstStyle xmlns:a="http://schemas.openxmlformats.org/drawingml/2006/main"/>
           <a:p xmlns:a="http://schemas.openxmlformats.org/drawingml/2006/main">
             <a:r>
-              <a:t>원본 기준으로는 첫 반복판매가 브리지 능력의 35.1%를 사용합니다. 다만 활성 GABA의 정의, 수율, OEE와 OEM 병목이 확인되지 않았으므로 확정 공급능력으로 표현하면 안 됩니다. OEE는 설비의 가동·성능·품질을 함께 보는 종합효율입니다.</a:t>
+              <a:t>비전바이오켐의 배양액 생산가능량은 월 20톤, 지에프퍼멘텍은 월 200톤으로 제공됐습니다. 합계는 월 220톤입니다. CAPA는 생산가능량을 뜻합니다. 이 수치는 계약, 실제 가동률, 품질체계, 규격별 수율을 확인한 뒤 공급계획에 반영해야 합니다.</a:t>
             </a:r>
           </a:p>
           <a:p xmlns:a="http://schemas.openxmlformats.org/drawingml/2006/main">
@@ -1000,7 +1006,7 @@
           </a:p>
           <a:p xmlns:a="http://schemas.openxmlformats.org/drawingml/2006/main">
             <a:r>
-              <a:t>- D:/다운로드/GABA_20_Master_Inventory_OEM_Make_to_Order_Business_Model_v5.pptx</a:t>
+              <a:t>- 사용자 제공 사업화 정보 · 2026-08-03</a:t>
             </a:r>
           </a:p>
         </p:txBody>
@@ -1265,7 +1271,7 @@
           <a:lstStyle xmlns:a="http://schemas.openxmlformats.org/drawingml/2006/main"/>
           <a:p xmlns:a="http://schemas.openxmlformats.org/drawingml/2006/main">
             <a:r>
-              <a:t>요청드리는 것은 대규모 설비 투자가 아닙니다. 원본에 제시된 4,560만원의 검증 예산을 네 가지 과제의 완료 시점에 맞춰 단계적으로 집행하는 것입니다. 어느 한 과제에서 기준을 충족하지 못하면 멈추고, 모두 확인되면 고객사와 투자자에게 사업 확대 계획을 다시 제안합니다.</a:t>
+              <a:t>분석기술 전문가는 장순욱 셀핀다 생명과학연구소 부사장으로, 해원바이오 전무와 한국신약 연구소장을 지냈습니다. 분석기술 고문은 구장룡 충남대 농업과학연구소 총괄책임으로, 우성사료 연구소장을 지냈습니다. 정밀발효·정제 전문가는 박지호 셀핀다 생명과학연구소 소장으로, 현대바이오랜드 재직 경력이 있습니다. 박지호 소장의 과거 직책은 제공되지 않아 재직 경력으로만 표기했습니다.</a:t>
             </a:r>
           </a:p>
           <a:p xmlns:a="http://schemas.openxmlformats.org/drawingml/2006/main">
@@ -1280,7 +1286,7 @@
           </a:p>
           <a:p xmlns:a="http://schemas.openxmlformats.org/drawingml/2006/main">
             <a:r>
-              <a:t>- D:/다운로드/GABA_20_Master_Inventory_OEM_Make_to_Order_Business_Model_v5.pptx</a:t>
+              <a:t>- 사용자 제공 사업화 정보 · 2026-08-03</a:t>
             </a:r>
           </a:p>
         </p:txBody>
@@ -1350,7 +1356,7 @@
           <a:lstStyle xmlns:a="http://schemas.openxmlformats.org/drawingml/2006/main"/>
           <a:p xmlns:a="http://schemas.openxmlformats.org/drawingml/2006/main">
             <a:r>
-              <a:t>마지막 장은 어려운 용어와 핵심 가정을 한곳에 모았습니다. 원본의 가격, 원가, 용량, 고객가치는 검증 전 가정입니다. 연구 결과는 축종·제형·용량이 달라 제품 효능을 보장하지 않으며, 법적 분류와 표시·광고 문구는 별도 전문 검토가 필요합니다.</a:t>
+              <a:t>요청드리는 것은 대규모 설비 투자가 아닙니다. 원본에 제시된 4,560만원의 검증 예산을 두 사업이 공통으로 확인해야 할 네 과제에 단계적으로 집행하는 것입니다. 어느 한 과제에서 기준을 충족하지 못하면 멈추고, 모두 확인되면 고객사와 투자자에게 사업 확대 계획을 다시 제안합니다.</a:t>
             </a:r>
           </a:p>
           <a:p xmlns:a="http://schemas.openxmlformats.org/drawingml/2006/main">
@@ -1365,32 +1371,7 @@
           </a:p>
           <a:p xmlns:a="http://schemas.openxmlformats.org/drawingml/2006/main">
             <a:r>
-              <a:t>- https://www.law.go.kr/행정규칙/사료%20등의%20기준%20및%20규격</a:t>
-            </a:r>
-          </a:p>
-          <a:p xmlns:a="http://schemas.openxmlformats.org/drawingml/2006/main">
-            <a:r>
-              <a:t>- https://www.law.go.kr/LSW/admRulInfoP.do?admRulSeq=2100000231582&amp;chrClsCd=010201</a:t>
-            </a:r>
-          </a:p>
-          <a:p xmlns:a="http://schemas.openxmlformats.org/drawingml/2006/main">
-            <a:r>
-              <a:t>- https://www.mafra.go.kr/bbs/home/791/597692/download.do</a:t>
-            </a:r>
-          </a:p>
-          <a:p xmlns:a="http://schemas.openxmlformats.org/drawingml/2006/main">
-            <a:r>
-              <a:t>- https://www.mdpi.com/2076-2615/16/2/262</a:t>
-            </a:r>
-          </a:p>
-          <a:p xmlns:a="http://schemas.openxmlformats.org/drawingml/2006/main">
-            <a:r>
-              <a:t>- https://www.kci.go.kr/kciportal/landing/article.kci?arti_id=ART003036784</a:t>
-            </a:r>
-          </a:p>
-          <a:p xmlns:a="http://schemas.openxmlformats.org/drawingml/2006/main">
-            <a:r>
-              <a:t>- https://www.e-kfas.org/Upload/files/kfas/4.%2058%281%29%2033-45.pdf</a:t>
+              <a:t>- 사용자 제공 사업화 정보 · 2026-08-03</a:t>
             </a:r>
           </a:p>
           <a:p xmlns:a="http://schemas.openxmlformats.org/drawingml/2006/main">
@@ -1465,7 +1446,7 @@
           <a:lstStyle xmlns:a="http://schemas.openxmlformats.org/drawingml/2006/main"/>
           <a:p xmlns:a="http://schemas.openxmlformats.org/drawingml/2006/main">
             <a:r>
-              <a:t>현재 준비도는 41점입니다. 사업 구조는 설계됐지만 품목 분류, 해당 제품의 유효 용량, OEM 실제 견적, 유료 반복 주문은 아직 확인되지 않았습니다. 따라서 지금은 사업 확대보다 검증에 집중해야 합니다.</a:t>
+              <a:t>사업을 나누면 고객과 매출 방식이 분명해집니다. 가바크루드는 원료 영업과 OEM 주문을, 가바케어믹스는 배합사료와 현장 적용을 담당합니다. 현재 준비도는 41점이며 품목 분류, 유효 용량, OEM 실제 견적, 유료 반복 주문은 아직 확인되지 않았습니다.</a:t>
             </a:r>
           </a:p>
           <a:p xmlns:a="http://schemas.openxmlformats.org/drawingml/2006/main">
@@ -1476,6 +1457,131 @@
           <a:p xmlns:a="http://schemas.openxmlformats.org/drawingml/2006/main">
             <a:r>
               <a:t>[Sources]</a:t>
+            </a:r>
+          </a:p>
+          <a:p xmlns:a="http://schemas.openxmlformats.org/drawingml/2006/main">
+            <a:r>
+              <a:t>- 사용자 제공 사업화 정보 · 2026-08-03</a:t>
+            </a:r>
+          </a:p>
+          <a:p xmlns:a="http://schemas.openxmlformats.org/drawingml/2006/main">
+            <a:r>
+              <a:t>- D:/다운로드/GABA_20_Master_Inventory_OEM_Make_to_Order_Business_Model_v5.pptx</a:t>
+            </a:r>
+          </a:p>
+        </p:txBody>
+      </p:sp>
+      <p:sp>
+        <p:nvSpPr>
+          <p:cNvPr id="4" name="Slide Number Placeholder 3"/>
+          <p:cNvSpPr>
+            <a:spLocks xmlns:a="http://schemas.openxmlformats.org/drawingml/2006/main" noGrp="1"/>
+          </p:cNvSpPr>
+          <p:nvPr>
+            <p:ph type="sldNum" idx="5"/>
+          </p:nvPr>
+        </p:nvSpPr>
+        <p:spPr/>
+        <p:txBody>
+          <a:bodyPr xmlns:a="http://schemas.openxmlformats.org/drawingml/2006/main"/>
+          <a:lstStyle xmlns:a="http://schemas.openxmlformats.org/drawingml/2006/main"/>
+          <a:p xmlns:a="http://schemas.openxmlformats.org/drawingml/2006/main"/>
+        </p:txBody>
+      </p:sp>
+    </p:spTree>
+  </p:cSld>
+  <p:clrMapOvr>
+    <a:masterClrMapping xmlns:a="http://schemas.openxmlformats.org/drawingml/2006/main"/>
+  </p:clrMapOvr>
+</p:notes>
+</file>
+
+<file path=ppt/notesSlides/notesSlide20.xml><?xml version="1.0" encoding="utf-8"?>
+<p:notes xmlns:p="http://schemas.openxmlformats.org/presentationml/2006/main">
+  <p:cSld>
+    <p:spTree>
+      <p:nvGrpSpPr>
+        <p:cNvPr id="1" name=""/>
+        <p:cNvGrpSpPr/>
+        <p:nvPr/>
+      </p:nvGrpSpPr>
+      <p:grpSpPr>
+        <a:xfrm xmlns:a="http://schemas.openxmlformats.org/drawingml/2006/main"/>
+      </p:grpSpPr>
+      <p:sp>
+        <p:nvSpPr>
+          <p:cNvPr id="2" name="Slide Image Placeholder 1"/>
+          <p:cNvSpPr>
+            <a:spLocks xmlns:a="http://schemas.openxmlformats.org/drawingml/2006/main" noGrp="1"/>
+          </p:cNvSpPr>
+          <p:nvPr>
+            <p:ph type="sldImg" idx="0"/>
+          </p:nvPr>
+        </p:nvSpPr>
+        <p:spPr/>
+      </p:sp>
+      <p:sp>
+        <p:nvSpPr>
+          <p:cNvPr id="3" name="Notes Placeholder 2"/>
+          <p:cNvSpPr>
+            <a:spLocks xmlns:a="http://schemas.openxmlformats.org/drawingml/2006/main" noGrp="1"/>
+          </p:cNvSpPr>
+          <p:nvPr>
+            <p:ph type="body" idx="1"/>
+          </p:nvPr>
+        </p:nvSpPr>
+        <p:spPr/>
+        <p:txBody>
+          <a:bodyPr xmlns:a="http://schemas.openxmlformats.org/drawingml/2006/main"/>
+          <a:lstStyle xmlns:a="http://schemas.openxmlformats.org/drawingml/2006/main"/>
+          <a:p xmlns:a="http://schemas.openxmlformats.org/drawingml/2006/main">
+            <a:r>
+              <a:t>마지막 장은 두 사업의 정의, 어려운 용어, 핵심 가정과 이용 시 주의사항을 정리했습니다. 핵심 인력과 생산가능량은 사용자 제공 자료입니다. 원본의 가격, 원가, 용량, 고객가치는 검증 전 가정이며, 법적 분류와 표시·광고 문구는 별도 전문 검토가 필요합니다.</a:t>
+            </a:r>
+          </a:p>
+          <a:p xmlns:a="http://schemas.openxmlformats.org/drawingml/2006/main">
+            <a:r>
+              <a:t/>
+            </a:r>
+          </a:p>
+          <a:p xmlns:a="http://schemas.openxmlformats.org/drawingml/2006/main">
+            <a:r>
+              <a:t>[Sources]</a:t>
+            </a:r>
+          </a:p>
+          <a:p xmlns:a="http://schemas.openxmlformats.org/drawingml/2006/main">
+            <a:r>
+              <a:t>- 사용자 제공 사업화 정보 · 2026-08-03</a:t>
+            </a:r>
+          </a:p>
+          <a:p xmlns:a="http://schemas.openxmlformats.org/drawingml/2006/main">
+            <a:r>
+              <a:t>- https://www.law.go.kr/행정규칙/사료%20등의%20기준%20및%20규격</a:t>
+            </a:r>
+          </a:p>
+          <a:p xmlns:a="http://schemas.openxmlformats.org/drawingml/2006/main">
+            <a:r>
+              <a:t>- https://www.law.go.kr/LSW/admRulInfoP.do?admRulSeq=2100000231582&amp;chrClsCd=010201</a:t>
+            </a:r>
+          </a:p>
+          <a:p xmlns:a="http://schemas.openxmlformats.org/drawingml/2006/main">
+            <a:r>
+              <a:t>- https://www.mafra.go.kr/bbs/home/791/597692/download.do</a:t>
+            </a:r>
+          </a:p>
+          <a:p xmlns:a="http://schemas.openxmlformats.org/drawingml/2006/main">
+            <a:r>
+              <a:t>- https://www.mdpi.com/2076-2615/16/2/262</a:t>
+            </a:r>
+          </a:p>
+          <a:p xmlns:a="http://schemas.openxmlformats.org/drawingml/2006/main">
+            <a:r>
+              <a:t>- https://www.kci.go.kr/kciportal/landing/article.kci?arti_id=ART003036784</a:t>
+            </a:r>
+          </a:p>
+          <a:p xmlns:a="http://schemas.openxmlformats.org/drawingml/2006/main">
+            <a:r>
+              <a:t>- https://www.e-kfas.org/Upload/files/kfas/4.%2058%281%29%2033-45.pdf</a:t>
             </a:r>
           </a:p>
           <a:p xmlns:a="http://schemas.openxmlformats.org/drawingml/2006/main">
@@ -1550,7 +1656,7 @@
           <a:lstStyle xmlns:a="http://schemas.openxmlformats.org/drawingml/2006/main"/>
           <a:p xmlns:a="http://schemas.openxmlformats.org/drawingml/2006/main">
             <a:r>
-              <a:t>원배양액 직납은 품질과 물류 변동이 큽니다. 반면 20% 마스터는 한 로트 단위로 시험하고 추적하기 쉽고, 저농도 규격은 고객 PO가 확인된 뒤 만들 수 있습니다. CoA는 로트별 시험성적서, FIFO는 먼저 입고한 재고를 먼저 출고하는 원칙입니다.</a:t>
+              <a:t>가바크루드는 원료 고객에게 기준품과 주문형 농도를 공급합니다. 가바케어믹스는 그 원료에 미네랄매트릭스를 결합해 축종별 배합사료로 확장합니다. CoA는 로트별 시험성적서입니다.</a:t>
             </a:r>
           </a:p>
           <a:p xmlns:a="http://schemas.openxmlformats.org/drawingml/2006/main">
@@ -1561,6 +1667,11 @@
           <a:p xmlns:a="http://schemas.openxmlformats.org/drawingml/2006/main">
             <a:r>
               <a:t>[Sources]</a:t>
+            </a:r>
+          </a:p>
+          <a:p xmlns:a="http://schemas.openxmlformats.org/drawingml/2006/main">
+            <a:r>
+              <a:t>- 사용자 제공 사업화 정보 · 2026-08-03</a:t>
             </a:r>
           </a:p>
           <a:p xmlns:a="http://schemas.openxmlformats.org/drawingml/2006/main">
@@ -1635,7 +1746,7 @@
           <a:lstStyle xmlns:a="http://schemas.openxmlformats.org/drawingml/2006/main"/>
           <a:p xmlns:a="http://schemas.openxmlformats.org/drawingml/2006/main">
             <a:r>
-              <a:t>이 구조의 핵심은 공통 중간물입니다. 모든 규격의 출발점을 20% 마스터로 통일하면 품질기준과 재고기준이 하나가 됩니다. OEM은 주문자상표 부착생산을 뜻하며, 발주자가 규격을 정하고 공장이 생산합니다.</a:t>
+              <a:t>가바크루드는 GABA 20% 기준품을 품질의 기준점으로 삼습니다. 고객이 5~20% 농도를 주문하면 기준품을 바탕으로 OEM 생산합니다. OEM은 주문자 상표 부착 생산을 뜻합니다.</a:t>
             </a:r>
           </a:p>
           <a:p xmlns:a="http://schemas.openxmlformats.org/drawingml/2006/main">
@@ -1646,6 +1757,11 @@
           <a:p xmlns:a="http://schemas.openxmlformats.org/drawingml/2006/main">
             <a:r>
               <a:t>[Sources]</a:t>
+            </a:r>
+          </a:p>
+          <a:p xmlns:a="http://schemas.openxmlformats.org/drawingml/2006/main">
+            <a:r>
+              <a:t>- 사용자 제공 사업화 정보 · 2026-08-03</a:t>
             </a:r>
           </a:p>
           <a:p xmlns:a="http://schemas.openxmlformats.org/drawingml/2006/main">
@@ -2163,7 +2279,7 @@
   </p:cSld>
   <p:clrMap bg1="lt1" tx1="dk1" bg2="lt2" tx2="dk2" accent1="accent1" accent2="accent2" accent3="accent3" accent4="accent4" accent5="accent5" accent6="accent6" hlink="hlink" folHlink="folHlink"/>
   <p:sldLayoutIdLst>
-    <p:sldLayoutId xmlns:r="http://schemas.openxmlformats.org/officeDocument/2006/relationships" id="2147483649" r:id="Rc01a14ba3ea148cd"/>
+    <p:sldLayoutId xmlns:r="http://schemas.openxmlformats.org/officeDocument/2006/relationships" id="2147483649" r:id="R8567dc6f08e2465b"/>
   </p:sldLayoutIdLst>
   <p:txStyles>
     <p:titleStyle>
@@ -2718,42 +2834,36 @@
           </c:marker>
           <c:cat>
             <c:strLit>
-              <c:ptCount val="5"/>
+              <c:ptCount val="4"/>
               <c:pt idx="0">
-                <c:v>첫 모델</c:v>
+                <c:v>비전바이오켐</c:v>
               </c:pt>
               <c:pt idx="1">
-                <c:v/>
+                <c:v>비전바이오켐</c:v>
               </c:pt>
               <c:pt idx="2">
-                <c:v/>
+                <c:v>지에프퍼멘텍</c:v>
               </c:pt>
               <c:pt idx="3">
-                <c:v>브리지</c:v>
-              </c:pt>
-              <c:pt idx="4">
-                <c:v/>
+                <c:v>지에프퍼멘텍</c:v>
               </c:pt>
             </c:strLit>
           </c:cat>
           <c:val>
             <c:numLit>
               <c:formatCode>0.0</c:formatCode>
-              <c:ptCount val="5"/>
+              <c:ptCount val="4"/>
               <c:pt idx="0">
-                <c:v>4.188</c:v>
+                <c:v>20</c:v>
               </c:pt>
               <c:pt idx="1">
-                <c:v>4.188</c:v>
+                <c:v>20</c:v>
               </c:pt>
               <c:pt idx="2">
-                <c:v>4.188</c:v>
+                <c:v>200</c:v>
               </c:pt>
               <c:pt idx="3">
-                <c:v>11.944</c:v>
-              </c:pt>
-              <c:pt idx="4">
-                <c:v>11.944</c:v>
+                <c:v>200</c:v>
               </c:pt>
             </c:numLit>
           </c:val>
@@ -2813,7 +2923,7 @@
         <c:axId val="48672768"/>
         <c:scaling>
           <c:orientation val="minMax"/>
-          <c:max val="14"/>
+          <c:max val="220"/>
           <c:min val="0"/>
         </c:scaling>
         <c:delete val="0"/>
@@ -2828,7 +2938,7 @@
             </a:ln>
           </c:spPr>
         </c:majorGridlines>
-        <c:numFmt formatCode="0.0"/>
+        <c:numFmt formatCode="0"/>
         <c:majorTickMark val="none"/>
         <c:minorTickMark val="none"/>
         <c:spPr>
@@ -2857,7 +2967,7 @@
         </c:txPr>
         <c:crossAx val="48650112"/>
         <c:crossBetween val="between"/>
-        <c:majorUnit val="2"/>
+        <c:majorUnit val="50"/>
       </c:valAx>
       <c:spPr>
         <a:noFill xmlns:a="http://schemas.openxmlformats.org/drawingml/2006/main"/>
@@ -2938,23 +3048,7 @@
               </a:defRPr>
             </a:pPr>
             <a:r>
-              <a:t>한 가지 재고로 시작해,</a:t>
-            </a:r>
-          </a:p>
-          <a:p xmlns:a="http://schemas.openxmlformats.org/drawingml/2006/main">
-            <a:pPr algn="l">
-              <a:buNone/>
-              <a:defRPr sz="6000">
-                <a:solidFill>
-                  <a:srgbClr val="000000"/>
-                </a:solidFill>
-                <a:latin typeface="Helvetica Neue"/>
-                <a:ea typeface="Helvetica Neue"/>
-                <a:cs typeface="Helvetica Neue"/>
-              </a:defRPr>
-            </a:pPr>
-            <a:r>
-              <a:t>주문에 맞춰 네 규격을 만든다</a:t>
+              <a:t>두 사업, 하나의 품질 기준으로 시작한다</a:t>
             </a:r>
           </a:p>
         </p:txBody>
@@ -3000,23 +3094,23 @@
               </a:defRPr>
             </a:pPr>
             <a:r>
-              <a:t>GABA 20% 마스터만 재고 · 5·10·15·20% 제품은 주문 후 OEM 생산</a:t>
-            </a:r>
-          </a:p>
-          <a:p xmlns:a="http://schemas.openxmlformats.org/drawingml/2006/main">
-            <a:pPr algn="l">
-              <a:buNone/>
-              <a:defRPr sz="2400">
-                <a:solidFill>
-                  <a:srgbClr val="000000"/>
-                </a:solidFill>
-                <a:latin typeface="Helvetica Neue"/>
-                <a:ea typeface="Helvetica Neue"/>
-                <a:cs typeface="Helvetica Neue"/>
-              </a:defRPr>
-            </a:pPr>
-            <a:r>
-              <a:t>규제·제품 근거·OEM 조건·반복 주문을 확인한 뒤 확대</a:t>
+              <a:t>가바크루드: GABA 20% 기준품·OEM 5~20% 원료</a:t>
+            </a:r>
+          </a:p>
+          <a:p xmlns:a="http://schemas.openxmlformats.org/drawingml/2006/main">
+            <a:pPr algn="l">
+              <a:buNone/>
+              <a:defRPr sz="2400">
+                <a:solidFill>
+                  <a:srgbClr val="000000"/>
+                </a:solidFill>
+                <a:latin typeface="Helvetica Neue"/>
+                <a:ea typeface="Helvetica Neue"/>
+                <a:cs typeface="Helvetica Neue"/>
+              </a:defRPr>
+            </a:pPr>
+            <a:r>
+              <a:t>가바케어믹스: 가바크루드+미네랄매트릭스 배합사료</a:t>
             </a:r>
           </a:p>
         </p:txBody>
@@ -3062,7 +3156,7 @@
               </a:defRPr>
             </a:pPr>
             <a:r>
-              <a:t>사업 검증 발표자료 · 2026.08</a:t>
+              <a:t>사업화 발표자료 · 2026.08</a:t>
             </a:r>
           </a:p>
         </p:txBody>
@@ -3264,7 +3358,7 @@
               </a:defRPr>
             </a:pPr>
             <a:r>
-              <a:t>첫 고객 시험은 한 축종·한 제형·한 경제효과에 집중한다</a:t>
+              <a:t>가바케어믹스의 첫 고객 시험은 한 축종·한 제형·한 경제효과에 집중한다</a:t>
             </a:r>
           </a:p>
         </p:txBody>
@@ -3726,7 +3820,7 @@
                 <a:ea typeface="Arial"/>
                 <a:cs typeface="Arial"/>
               </a:rPr>
-              <a:t>GABA BUSINESS MODEL | 10 | FIRST BEACHHEAD</a:t>
+              <a:t>GABA BUSINESS MODEL | 10 | GABA CARE MIX POV</a:t>
             </a:r>
           </a:p>
         </p:txBody>
@@ -3925,7 +4019,7 @@
               </a:defRPr>
             </a:pPr>
             <a:r>
-              <a:t>kg당 8,760원의 공헌이익은 실제 견적을 확인해야 성립한다</a:t>
+              <a:t>가바크루드 공헌이익 8,760원/kg은 실제 견적 확인이 필요하다</a:t>
             </a:r>
           </a:p>
         </p:txBody>
@@ -4401,7 +4495,7 @@
                 <a:ea typeface="Arial"/>
                 <a:cs typeface="Arial"/>
               </a:rPr>
-              <a:t>GABA BUSINESS MODEL | 11 | MASTER ECONOMICS</a:t>
+              <a:t>GABA BUSINESS MODEL | 11 | GABA CRUDE ECONOMICS</a:t>
             </a:r>
           </a:p>
         </p:txBody>
@@ -4600,7 +4694,7 @@
               </a:defRPr>
             </a:pPr>
             <a:r>
-              <a:t>사료 1톤당 4,149원의 공헌이익도 투입량과 직접비 확인이 필요하다</a:t>
+              <a:t>가바케어믹스의 사료 1톤당 4,149원 공헌이익도 투입량과 직접비 확인이 필요하다</a:t>
             </a:r>
           </a:p>
         </p:txBody>
@@ -5076,7 +5170,7 @@
                 <a:ea typeface="Arial"/>
                 <a:cs typeface="Arial"/>
               </a:rPr>
-              <a:t>GABA BUSINESS MODEL | 12 | MATRIX ECONOMICS</a:t>
+              <a:t>GABA BUSINESS MODEL | 12 | GABA CARE MIX ECONOMICS</a:t>
             </a:r>
           </a:p>
         </p:txBody>
@@ -5275,7 +5369,7 @@
               </a:defRPr>
             </a:pPr>
             <a:r>
-              <a:t>사료 1톤당 고객 가치 18,000원은 유료 비교시험으로 확인해야 한다</a:t>
+              <a:t>고객 가치 18,000원/사료t은 유료 비교시험으로 확인한다</a:t>
             </a:r>
           </a:p>
         </p:txBody>
@@ -5950,7 +6044,7 @@
               </a:defRPr>
             </a:pPr>
             <a:r>
-              <a:t>반복 주문 가정대로라면 매출 6.60억원, 공헌이익 3.83억원이다</a:t>
+              <a:t>두 사업의 반복 주문 가정대로라면 매출 6.60억원, 공헌이익 3.83억원이다</a:t>
             </a:r>
           </a:p>
         </p:txBody>
@@ -5996,7 +6090,7 @@
               </a:defRPr>
             </a:pPr>
             <a:r>
-              <a:t>20% 마스터</a:t>
+              <a:t>가바크루드</a:t>
             </a:r>
           </a:p>
           <a:p xmlns:a="http://schemas.openxmlformats.org/drawingml/2006/main">
@@ -6120,7 +6214,7 @@
               </a:defRPr>
             </a:pPr>
             <a:r>
-              <a:t>매트릭스</a:t>
+              <a:t>가바케어믹스</a:t>
             </a:r>
           </a:p>
           <a:p xmlns:a="http://schemas.openxmlformats.org/drawingml/2006/main">
@@ -6320,7 +6414,7 @@
               </a:defRPr>
             </a:pPr>
             <a:r>
-              <a:t>마스터 매출 3.60억 + 매트릭스 매출 3.00억</a:t>
+              <a:t>가바크루드 매출 3.60억 + 가바케어믹스 매출 3.00억</a:t>
             </a:r>
           </a:p>
           <a:p xmlns:a="http://schemas.openxmlformats.org/drawingml/2006/main">
@@ -6336,7 +6430,7 @@
               </a:defRPr>
             </a:pPr>
             <a:r>
-              <a:t>※ 실제 PO가 아닌 반복주문 가정 시나리오</a:t>
+              <a:t>※ 실제 PO가 아닌 반복 주문 가정 시나리오</a:t>
             </a:r>
           </a:p>
         </p:txBody>
@@ -6538,7 +6632,7 @@
               </a:defRPr>
             </a:pPr>
             <a:r>
-              <a:t>첫 반복 주문 물량은 추정 생산능력의 35%에 해당한다</a:t>
+              <a:t>두 생산 파트너의 배양액 CAPA는 사용자 제공 자료 기준 월 220톤이다</a:t>
             </a:r>
           </a:p>
         </p:txBody>
@@ -6613,7 +6707,7 @@
               </a:defRPr>
             </a:pPr>
             <a:r>
-              <a:t>4.19t</a:t>
+              <a:t>월 20톤</a:t>
             </a:r>
           </a:p>
         </p:txBody>
@@ -6659,23 +6753,23 @@
               </a:defRPr>
             </a:pPr>
             <a:r>
-              <a:t>첫 모델 필요</a:t>
-            </a:r>
-          </a:p>
-          <a:p xmlns:a="http://schemas.openxmlformats.org/drawingml/2006/main">
-            <a:pPr algn="l">
-              <a:buNone/>
-              <a:defRPr sz="2400">
-                <a:solidFill>
-                  <a:srgbClr val="000000"/>
-                </a:solidFill>
-                <a:latin typeface="Helvetica Neue"/>
-                <a:ea typeface="Helvetica Neue"/>
-                <a:cs typeface="Helvetica Neue"/>
-              </a:defRPr>
-            </a:pPr>
-            <a:r>
-              <a:t>활성 GABA/년</a:t>
+              <a:t>비전바이오켐</a:t>
+            </a:r>
+          </a:p>
+          <a:p xmlns:a="http://schemas.openxmlformats.org/drawingml/2006/main">
+            <a:pPr algn="l">
+              <a:buNone/>
+              <a:defRPr sz="2400">
+                <a:solidFill>
+                  <a:srgbClr val="000000"/>
+                </a:solidFill>
+                <a:latin typeface="Helvetica Neue"/>
+                <a:ea typeface="Helvetica Neue"/>
+                <a:cs typeface="Helvetica Neue"/>
+              </a:defRPr>
+            </a:pPr>
+            <a:r>
+              <a:t>배양액 CAPA</a:t>
             </a:r>
           </a:p>
         </p:txBody>
@@ -6750,7 +6844,7 @@
               </a:defRPr>
             </a:pPr>
             <a:r>
-              <a:t>11.94t</a:t>
+              <a:t>월 200톤</a:t>
             </a:r>
           </a:p>
         </p:txBody>
@@ -6796,23 +6890,23 @@
               </a:defRPr>
             </a:pPr>
             <a:r>
-              <a:t>추정 생산능력</a:t>
-            </a:r>
-          </a:p>
-          <a:p xmlns:a="http://schemas.openxmlformats.org/drawingml/2006/main">
-            <a:pPr algn="l">
-              <a:buNone/>
-              <a:defRPr sz="2400">
-                <a:solidFill>
-                  <a:srgbClr val="000000"/>
-                </a:solidFill>
-                <a:latin typeface="Helvetica Neue"/>
-                <a:ea typeface="Helvetica Neue"/>
-                <a:cs typeface="Helvetica Neue"/>
-              </a:defRPr>
-            </a:pPr>
-            <a:r>
-              <a:t>활성 GABA/년</a:t>
+              <a:t>지에프퍼멘텍</a:t>
+            </a:r>
+          </a:p>
+          <a:p xmlns:a="http://schemas.openxmlformats.org/drawingml/2006/main">
+            <a:pPr algn="l">
+              <a:buNone/>
+              <a:defRPr sz="2400">
+                <a:solidFill>
+                  <a:srgbClr val="000000"/>
+                </a:solidFill>
+                <a:latin typeface="Helvetica Neue"/>
+                <a:ea typeface="Helvetica Neue"/>
+                <a:cs typeface="Helvetica Neue"/>
+              </a:defRPr>
+            </a:pPr>
+            <a:r>
+              <a:t>배양액 CAPA</a:t>
             </a:r>
           </a:p>
         </p:txBody>
@@ -6858,23 +6952,23 @@
               </a:defRPr>
             </a:pPr>
             <a:r>
-              <a:t>4.19÷11.94=35.1% · 여유 7.76t</a:t>
-            </a:r>
-          </a:p>
-          <a:p xmlns:a="http://schemas.openxmlformats.org/drawingml/2006/main">
-            <a:pPr algn="l">
-              <a:buNone/>
-              <a:defRPr sz="2400">
-                <a:solidFill>
-                  <a:srgbClr val="000000"/>
-                </a:solidFill>
-                <a:latin typeface="Helvetica Neue"/>
-                <a:ea typeface="Helvetica Neue"/>
-                <a:cs typeface="Helvetica Neue"/>
-              </a:defRPr>
-            </a:pPr>
-            <a:r>
-              <a:t>※ ‘활성 GABA’ 정의·수율·OEE·OEM 능력 확인 전 공급보장 금지</a:t>
+              <a:t>사용자 제공 자료 합계 월 220톤</a:t>
+            </a:r>
+          </a:p>
+          <a:p xmlns:a="http://schemas.openxmlformats.org/drawingml/2006/main">
+            <a:pPr algn="l">
+              <a:buNone/>
+              <a:defRPr sz="2400">
+                <a:solidFill>
+                  <a:srgbClr val="000000"/>
+                </a:solidFill>
+                <a:latin typeface="Helvetica Neue"/>
+                <a:ea typeface="Helvetica Neue"/>
+                <a:cs typeface="Helvetica Neue"/>
+              </a:defRPr>
+            </a:pPr>
+            <a:r>
+              <a:t>※ 계약·실가동·품질체계 확인 후 공급계획에 반영</a:t>
             </a:r>
           </a:p>
         </p:txBody>
@@ -6891,7 +6985,7 @@
         </p:xfrm>
         <a:graphic xmlns:a="http://schemas.openxmlformats.org/drawingml/2006/main">
           <a:graphicData uri="http://schemas.openxmlformats.org/drawingml/2006/chart">
-            <c:chart xmlns:r="http://schemas.openxmlformats.org/officeDocument/2006/relationships" xmlns:c="http://schemas.openxmlformats.org/drawingml/2006/chart" r:id="Rc3a332c1e26f4225"/>
+            <c:chart xmlns:r="http://schemas.openxmlformats.org/officeDocument/2006/relationships" xmlns:c="http://schemas.openxmlformats.org/drawingml/2006/chart" r:id="R151c71a12c7c4cea"/>
           </a:graphicData>
         </a:graphic>
       </p:graphicFrame>
@@ -6980,7 +7074,7 @@
                 <a:ea typeface="Arial"/>
                 <a:cs typeface="Arial"/>
               </a:rPr>
-              <a:t>GABA BUSINESS MODEL | 15 | CAPACITY DISCIPLINE</a:t>
+              <a:t>GABA BUSINESS MODEL | 15 | PRODUCTION PARTNERS</a:t>
             </a:r>
           </a:p>
         </p:txBody>
@@ -7092,7 +7186,7 @@
               </a:defRPr>
             </a:pPr>
             <a:r>
-              <a:t>네 가지 중 하나라도 확인되지 않으면 사업을 확대하지 않는다</a:t>
+              <a:t>사업 확대는 네 가지를 모두 확인한 뒤 결정한다</a:t>
             </a:r>
           </a:p>
         </p:txBody>
@@ -7554,7 +7648,7 @@
                 <a:ea typeface="Arial"/>
                 <a:cs typeface="Arial"/>
               </a:rPr>
-              <a:t>GABA BUSINESS MODEL | 16 | EXPANSION CHECKS</a:t>
+              <a:t>GABA BUSINESS MODEL | 16 | EXPANSION CRITERIA</a:t>
             </a:r>
           </a:p>
         </p:txBody>
@@ -7666,7 +7760,7 @@
               </a:defRPr>
             </a:pPr>
             <a:r>
-              <a:t>앞으로 90일 동안 네 가지 핵심 검증을 순서대로 마친다</a:t>
+              <a:t>90일 안에 두 사업의 공통 검증과 첫 유료 주문을 확인한다</a:t>
             </a:r>
           </a:p>
         </p:txBody>
@@ -8308,22 +8402,337 @@
       </p:grpSpPr>
       <p:sp>
         <p:nvSpPr>
-          <p:cNvPr id="6" name="Title-3-1">
-            <a:extLst xmlns:a="http://schemas.openxmlformats.org/drawingml/2006/main">
-              <a:ext uri="{FF2B5EF4-FFF2-40B4-BE49-F238E27FC236}">
-                <a16:creationId xmlns:a16="http://schemas.microsoft.com/office/drawing/2014/main" id="{93582F7D-404D-46AB-80D1-FE06EE84CD39}"/>
-              </a:ext>
-            </a:extLst>
-          </p:cNvPr>
-          <p:cNvSpPr>
-            <a:spLocks xmlns:a="http://schemas.openxmlformats.org/drawingml/2006/main" noGrp="1"/>
-          </p:cNvSpPr>
-          <p:nvPr/>
-        </p:nvSpPr>
-        <p:spPr>
-          <a:xfrm xmlns:a="http://schemas.openxmlformats.org/drawingml/2006/main">
-            <a:off x="393668" y="1738789"/>
-            <a:ext cx="9448800" cy="2491454"/>
+          <p:cNvPr id="15" name="Rounded-Rectangle-5-1">
+            <a:extLst xmlns:a="http://schemas.openxmlformats.org/drawingml/2006/main">
+              <a:ext uri="{FF2B5EF4-FFF2-40B4-BE49-F238E27FC236}">
+                <a16:creationId xmlns:a16="http://schemas.microsoft.com/office/drawing/2014/main" id="{E16F1EE6-E756-45C0-8617-BB78BF867B63}"/>
+              </a:ext>
+            </a:extLst>
+          </p:cNvPr>
+          <p:cNvSpPr>
+            <a:spLocks xmlns:a="http://schemas.openxmlformats.org/drawingml/2006/main" noGrp="1"/>
+          </p:cNvSpPr>
+          <p:nvPr/>
+        </p:nvSpPr>
+        <p:spPr>
+          <a:xfrm xmlns:a="http://schemas.openxmlformats.org/drawingml/2006/main">
+            <a:off x="393668" y="3022568"/>
+            <a:ext cx="3568732" cy="2971800"/>
+          </a:xfrm>
+          <a:prstGeom xmlns:a="http://schemas.openxmlformats.org/drawingml/2006/main" prst="roundRect">
+            <a:avLst>
+              <a:gd name="adj" fmla="val 2564"/>
+            </a:avLst>
+          </a:prstGeom>
+          <a:solidFill xmlns:a="http://schemas.openxmlformats.org/drawingml/2006/main">
+            <a:srgbClr val="F2F2F2"/>
+          </a:solidFill>
+        </p:spPr>
+      </p:sp>
+      <p:sp>
+        <p:nvSpPr>
+          <p:cNvPr id="2" name="Rounded-Rectangle-6-2">
+            <a:extLst xmlns:a="http://schemas.openxmlformats.org/drawingml/2006/main">
+              <a:ext uri="{FF2B5EF4-FFF2-40B4-BE49-F238E27FC236}">
+                <a16:creationId xmlns:a16="http://schemas.microsoft.com/office/drawing/2014/main" id="{D4C87DE3-EBAE-4928-8F13-9D57644F80E9}"/>
+              </a:ext>
+            </a:extLst>
+          </p:cNvPr>
+          <p:cNvSpPr>
+            <a:spLocks xmlns:a="http://schemas.openxmlformats.org/drawingml/2006/main" noGrp="1"/>
+          </p:cNvSpPr>
+          <p:nvPr/>
+        </p:nvSpPr>
+        <p:spPr>
+          <a:xfrm xmlns:a="http://schemas.openxmlformats.org/drawingml/2006/main">
+            <a:off x="4311682" y="3022568"/>
+            <a:ext cx="3568732" cy="2971800"/>
+          </a:xfrm>
+          <a:prstGeom xmlns:a="http://schemas.openxmlformats.org/drawingml/2006/main" prst="roundRect">
+            <a:avLst>
+              <a:gd name="adj" fmla="val 2564"/>
+            </a:avLst>
+          </a:prstGeom>
+          <a:solidFill xmlns:a="http://schemas.openxmlformats.org/drawingml/2006/main">
+            <a:srgbClr val="F2F2F2"/>
+          </a:solidFill>
+        </p:spPr>
+      </p:sp>
+      <p:sp>
+        <p:nvSpPr>
+          <p:cNvPr id="3" name="Rounded-Rectangle-7-3">
+            <a:extLst xmlns:a="http://schemas.openxmlformats.org/drawingml/2006/main">
+              <a:ext uri="{FF2B5EF4-FFF2-40B4-BE49-F238E27FC236}">
+                <a16:creationId xmlns:a16="http://schemas.microsoft.com/office/drawing/2014/main" id="{B8FB0289-E741-4BA8-94D1-677C5EF213D1}"/>
+              </a:ext>
+            </a:extLst>
+          </p:cNvPr>
+          <p:cNvSpPr>
+            <a:spLocks xmlns:a="http://schemas.openxmlformats.org/drawingml/2006/main" noGrp="1"/>
+          </p:cNvSpPr>
+          <p:nvPr/>
+        </p:nvSpPr>
+        <p:spPr>
+          <a:xfrm xmlns:a="http://schemas.openxmlformats.org/drawingml/2006/main">
+            <a:off x="8232267" y="3022568"/>
+            <a:ext cx="3568732" cy="2971800"/>
+          </a:xfrm>
+          <a:prstGeom xmlns:a="http://schemas.openxmlformats.org/drawingml/2006/main" prst="roundRect">
+            <a:avLst>
+              <a:gd name="adj" fmla="val 2564"/>
+            </a:avLst>
+          </a:prstGeom>
+          <a:solidFill xmlns:a="http://schemas.openxmlformats.org/drawingml/2006/main">
+            <a:srgbClr val="F2F2F2"/>
+          </a:solidFill>
+        </p:spPr>
+      </p:sp>
+      <p:sp>
+        <p:nvSpPr>
+          <p:cNvPr id="4" name="Slide-Number-Placeholder-1-4">
+            <a:extLst xmlns:a="http://schemas.openxmlformats.org/drawingml/2006/main">
+              <a:ext uri="{FF2B5EF4-FFF2-40B4-BE49-F238E27FC236}">
+                <a16:creationId xmlns:a16="http://schemas.microsoft.com/office/drawing/2014/main" id="{83969B42-BFA8-448C-8026-85E52F042B13}"/>
+              </a:ext>
+            </a:extLst>
+          </p:cNvPr>
+          <p:cNvSpPr>
+            <a:spLocks xmlns:a="http://schemas.openxmlformats.org/drawingml/2006/main" noGrp="1"/>
+          </p:cNvSpPr>
+          <p:nvPr/>
+        </p:nvSpPr>
+        <p:spPr>
+          <a:xfrm xmlns:a="http://schemas.openxmlformats.org/drawingml/2006/main">
+            <a:off x="11279315" y="6279261"/>
+            <a:ext cx="518922" cy="241268"/>
+          </a:xfrm>
+          <a:prstGeom xmlns:a="http://schemas.openxmlformats.org/drawingml/2006/main" prst="rect">
+            <a:avLst/>
+          </a:prstGeom>
+        </p:spPr>
+        <p:txBody>
+          <a:bodyPr xmlns:a="http://schemas.openxmlformats.org/drawingml/2006/main" lIns="0" tIns="0" rIns="0" bIns="0" anchor="b"/>
+          <a:lstStyle xmlns:a="http://schemas.openxmlformats.org/drawingml/2006/main"/>
+          <a:p xmlns:a="http://schemas.openxmlformats.org/drawingml/2006/main">
+            <a:pPr algn="r">
+              <a:buNone/>
+              <a:defRPr sz="1000">
+                <a:solidFill>
+                  <a:srgbClr val="000000"/>
+                </a:solidFill>
+                <a:latin typeface="Helvetica Neue"/>
+                <a:ea typeface="Helvetica Neue"/>
+                <a:cs typeface="Helvetica Neue"/>
+              </a:defRPr>
+            </a:pPr>
+            <a:r>
+              <a:t>18</a:t>
+            </a:r>
+          </a:p>
+        </p:txBody>
+      </p:sp>
+      <p:sp>
+        <p:nvSpPr>
+          <p:cNvPr id="5" name="Title-2-5">
+            <a:extLst xmlns:a="http://schemas.openxmlformats.org/drawingml/2006/main">
+              <a:ext uri="{FF2B5EF4-FFF2-40B4-BE49-F238E27FC236}">
+                <a16:creationId xmlns:a16="http://schemas.microsoft.com/office/drawing/2014/main" id="{DCF1A8D5-0AB3-4E51-AEDC-9EBECE5A4517}"/>
+              </a:ext>
+            </a:extLst>
+          </p:cNvPr>
+          <p:cNvSpPr>
+            <a:spLocks xmlns:a="http://schemas.openxmlformats.org/drawingml/2006/main" noGrp="1"/>
+          </p:cNvSpPr>
+          <p:nvPr/>
+        </p:nvSpPr>
+        <p:spPr>
+          <a:xfrm xmlns:a="http://schemas.openxmlformats.org/drawingml/2006/main">
+            <a:off x="393668" y="344043"/>
+            <a:ext cx="11404568" cy="1047464"/>
+          </a:xfrm>
+          <a:prstGeom xmlns:a="http://schemas.openxmlformats.org/drawingml/2006/main" prst="rect">
+            <a:avLst/>
+          </a:prstGeom>
+        </p:spPr>
+        <p:txBody>
+          <a:bodyPr xmlns:a="http://schemas.openxmlformats.org/drawingml/2006/main" lIns="0" tIns="0" rIns="0" bIns="0" anchor="t">
+            <a:normAutofit fontScale="100000"/>
+          </a:bodyPr>
+          <a:lstStyle xmlns:a="http://schemas.openxmlformats.org/drawingml/2006/main"/>
+          <a:p xmlns:a="http://schemas.openxmlformats.org/drawingml/2006/main">
+            <a:pPr algn="l">
+              <a:buNone/>
+              <a:defRPr sz="2900">
+                <a:solidFill>
+                  <a:srgbClr val="000000"/>
+                </a:solidFill>
+                <a:latin typeface="Helvetica Neue"/>
+                <a:ea typeface="Helvetica Neue"/>
+                <a:cs typeface="Helvetica Neue"/>
+              </a:defRPr>
+            </a:pPr>
+            <a:r>
+              <a:t>핵심 인력은 분석·사료·정밀발효 경험을 함께 갖췄다</a:t>
+            </a:r>
+          </a:p>
+        </p:txBody>
+      </p:sp>
+      <p:sp>
+        <p:nvSpPr>
+          <p:cNvPr id="6" name="Content-Placeholder-9-6">
+            <a:extLst xmlns:a="http://schemas.openxmlformats.org/drawingml/2006/main">
+              <a:ext uri="{FF2B5EF4-FFF2-40B4-BE49-F238E27FC236}">
+                <a16:creationId xmlns:a16="http://schemas.microsoft.com/office/drawing/2014/main" id="{3E72F593-79F2-43AE-A593-E6DB7B4B4FC0}"/>
+              </a:ext>
+            </a:extLst>
+          </p:cNvPr>
+          <p:cNvSpPr>
+            <a:spLocks xmlns:a="http://schemas.openxmlformats.org/drawingml/2006/main" noGrp="1"/>
+          </p:cNvSpPr>
+          <p:nvPr/>
+        </p:nvSpPr>
+        <p:spPr>
+          <a:xfrm xmlns:a="http://schemas.openxmlformats.org/drawingml/2006/main">
+            <a:off x="702374" y="4900613"/>
+            <a:ext cx="2949607" cy="819150"/>
+          </a:xfrm>
+          <a:prstGeom xmlns:a="http://schemas.openxmlformats.org/drawingml/2006/main" prst="rect">
+            <a:avLst/>
+          </a:prstGeom>
+        </p:spPr>
+        <p:txBody>
+          <a:bodyPr xmlns:a="http://schemas.openxmlformats.org/drawingml/2006/main" lIns="91440" tIns="45720" rIns="91440" bIns="45720">
+            <a:normAutofit fontScale="100000"/>
+          </a:bodyPr>
+          <a:lstStyle xmlns:a="http://schemas.openxmlformats.org/drawingml/2006/main"/>
+          <a:p xmlns:a="http://schemas.openxmlformats.org/drawingml/2006/main">
+            <a:pPr algn="l">
+              <a:buNone/>
+              <a:defRPr sz="2400">
+                <a:solidFill>
+                  <a:srgbClr val="000000"/>
+                </a:solidFill>
+                <a:latin typeface="Helvetica Neue"/>
+                <a:ea typeface="Helvetica Neue"/>
+                <a:cs typeface="Helvetica Neue"/>
+              </a:defRPr>
+            </a:pPr>
+            <a:r>
+              <a:t>분석기술 전문가</a:t>
+            </a:r>
+          </a:p>
+        </p:txBody>
+      </p:sp>
+      <p:sp>
+        <p:nvSpPr>
+          <p:cNvPr id="7" name="Content-Placeholder-10-7">
+            <a:extLst xmlns:a="http://schemas.openxmlformats.org/drawingml/2006/main">
+              <a:ext uri="{FF2B5EF4-FFF2-40B4-BE49-F238E27FC236}">
+                <a16:creationId xmlns:a16="http://schemas.microsoft.com/office/drawing/2014/main" id="{F70819C6-E100-46F1-A253-8C7B6596CAA2}"/>
+              </a:ext>
+            </a:extLst>
+          </p:cNvPr>
+          <p:cNvSpPr>
+            <a:spLocks xmlns:a="http://schemas.openxmlformats.org/drawingml/2006/main" noGrp="1"/>
+          </p:cNvSpPr>
+          <p:nvPr/>
+        </p:nvSpPr>
+        <p:spPr>
+          <a:xfrm xmlns:a="http://schemas.openxmlformats.org/drawingml/2006/main">
+            <a:off x="8541830" y="4900613"/>
+            <a:ext cx="2949607" cy="819150"/>
+          </a:xfrm>
+          <a:prstGeom xmlns:a="http://schemas.openxmlformats.org/drawingml/2006/main" prst="rect">
+            <a:avLst/>
+          </a:prstGeom>
+        </p:spPr>
+        <p:txBody>
+          <a:bodyPr xmlns:a="http://schemas.openxmlformats.org/drawingml/2006/main" lIns="91440" tIns="45720" rIns="91440" bIns="45720">
+            <a:normAutofit fontScale="99479"/>
+          </a:bodyPr>
+          <a:lstStyle xmlns:a="http://schemas.openxmlformats.org/drawingml/2006/main"/>
+          <a:p xmlns:a="http://schemas.openxmlformats.org/drawingml/2006/main">
+            <a:pPr algn="l">
+              <a:buNone/>
+              <a:defRPr sz="2400">
+                <a:solidFill>
+                  <a:srgbClr val="000000"/>
+                </a:solidFill>
+                <a:latin typeface="Helvetica Neue"/>
+                <a:ea typeface="Helvetica Neue"/>
+                <a:cs typeface="Helvetica Neue"/>
+              </a:defRPr>
+            </a:pPr>
+            <a:r>
+              <a:t>정밀발효·정제 전문가</a:t>
+            </a:r>
+          </a:p>
+        </p:txBody>
+      </p:sp>
+      <p:sp>
+        <p:nvSpPr>
+          <p:cNvPr id="8" name="Content-Placeholder-11-8">
+            <a:extLst xmlns:a="http://schemas.openxmlformats.org/drawingml/2006/main">
+              <a:ext uri="{FF2B5EF4-FFF2-40B4-BE49-F238E27FC236}">
+                <a16:creationId xmlns:a16="http://schemas.microsoft.com/office/drawing/2014/main" id="{7A05743D-C63F-4B00-B533-D7ECE388EBC1}"/>
+              </a:ext>
+            </a:extLst>
+          </p:cNvPr>
+          <p:cNvSpPr>
+            <a:spLocks xmlns:a="http://schemas.openxmlformats.org/drawingml/2006/main" noGrp="1"/>
+          </p:cNvSpPr>
+          <p:nvPr/>
+        </p:nvSpPr>
+        <p:spPr>
+          <a:xfrm xmlns:a="http://schemas.openxmlformats.org/drawingml/2006/main">
+            <a:off x="4621244" y="4900613"/>
+            <a:ext cx="2949607" cy="819150"/>
+          </a:xfrm>
+          <a:prstGeom xmlns:a="http://schemas.openxmlformats.org/drawingml/2006/main" prst="rect">
+            <a:avLst/>
+          </a:prstGeom>
+        </p:spPr>
+        <p:txBody>
+          <a:bodyPr xmlns:a="http://schemas.openxmlformats.org/drawingml/2006/main" lIns="91440" tIns="45720" rIns="91440" bIns="45720">
+            <a:normAutofit fontScale="100000"/>
+          </a:bodyPr>
+          <a:lstStyle xmlns:a="http://schemas.openxmlformats.org/drawingml/2006/main"/>
+          <a:p xmlns:a="http://schemas.openxmlformats.org/drawingml/2006/main">
+            <a:pPr algn="l">
+              <a:buNone/>
+              <a:defRPr sz="2400">
+                <a:solidFill>
+                  <a:srgbClr val="000000"/>
+                </a:solidFill>
+                <a:latin typeface="Helvetica Neue"/>
+                <a:ea typeface="Helvetica Neue"/>
+                <a:cs typeface="Helvetica Neue"/>
+              </a:defRPr>
+            </a:pPr>
+            <a:r>
+              <a:t>분석기술 고문</a:t>
+            </a:r>
+          </a:p>
+        </p:txBody>
+      </p:sp>
+      <p:sp>
+        <p:nvSpPr>
+          <p:cNvPr id="9" name="Content-Placeholder-9-9">
+            <a:extLst xmlns:a="http://schemas.openxmlformats.org/drawingml/2006/main">
+              <a:ext uri="{FF2B5EF4-FFF2-40B4-BE49-F238E27FC236}">
+                <a16:creationId xmlns:a16="http://schemas.microsoft.com/office/drawing/2014/main" id="{6B6DF3F5-8239-45F8-9E70-2B3E7F1DB3FF}"/>
+              </a:ext>
+            </a:extLst>
+          </p:cNvPr>
+          <p:cNvSpPr>
+            <a:spLocks xmlns:a="http://schemas.openxmlformats.org/drawingml/2006/main" noGrp="1"/>
+          </p:cNvSpPr>
+          <p:nvPr/>
+        </p:nvSpPr>
+        <p:spPr>
+          <a:xfrm xmlns:a="http://schemas.openxmlformats.org/drawingml/2006/main">
+            <a:off x="702374" y="3429000"/>
+            <a:ext cx="2940082" cy="1359313"/>
           </a:xfrm>
           <a:prstGeom xmlns:a="http://schemas.openxmlformats.org/drawingml/2006/main" prst="rect">
             <a:avLst/>
@@ -8331,61 +8740,137 @@
         </p:spPr>
         <p:txBody>
           <a:bodyPr xmlns:a="http://schemas.openxmlformats.org/drawingml/2006/main" lIns="0" tIns="0" rIns="0" bIns="0" anchor="b">
-            <a:noAutofit/>
+            <a:normAutofit fontScale="100000"/>
           </a:bodyPr>
           <a:lstStyle xmlns:a="http://schemas.openxmlformats.org/drawingml/2006/main"/>
           <a:p xmlns:a="http://schemas.openxmlformats.org/drawingml/2006/main">
             <a:pPr algn="l">
               <a:buNone/>
-              <a:defRPr sz="6000">
-                <a:solidFill>
-                  <a:srgbClr val="000000"/>
-                </a:solidFill>
-                <a:latin typeface="Helvetica Neue"/>
-                <a:ea typeface="Helvetica Neue"/>
-                <a:cs typeface="Helvetica Neue"/>
-              </a:defRPr>
-            </a:pPr>
-            <a:r>
-              <a:t>4,560만원을 집행하기 전,</a:t>
-            </a:r>
-          </a:p>
-          <a:p xmlns:a="http://schemas.openxmlformats.org/drawingml/2006/main">
-            <a:pPr algn="l">
-              <a:buNone/>
-              <a:defRPr sz="6000">
-                <a:solidFill>
-                  <a:srgbClr val="000000"/>
-                </a:solidFill>
-                <a:latin typeface="Helvetica Neue"/>
-                <a:ea typeface="Helvetica Neue"/>
-                <a:cs typeface="Helvetica Neue"/>
-              </a:defRPr>
-            </a:pPr>
-            <a:r>
-              <a:t>네 가지 검증 과제를 승인해 주십시오</a:t>
-            </a:r>
-          </a:p>
-        </p:txBody>
-      </p:sp>
-      <p:sp>
-        <p:nvSpPr>
-          <p:cNvPr id="2" name="Subtitle-4-2">
-            <a:extLst xmlns:a="http://schemas.openxmlformats.org/drawingml/2006/main">
-              <a:ext uri="{FF2B5EF4-FFF2-40B4-BE49-F238E27FC236}">
-                <a16:creationId xmlns:a16="http://schemas.microsoft.com/office/drawing/2014/main" id="{6DBE01A0-2CC5-41DA-85B6-ED57A07E76EC}"/>
-              </a:ext>
-            </a:extLst>
-          </p:cNvPr>
-          <p:cNvSpPr>
-            <a:spLocks xmlns:a="http://schemas.openxmlformats.org/drawingml/2006/main" noGrp="1"/>
-          </p:cNvSpPr>
-          <p:nvPr/>
-        </p:nvSpPr>
-        <p:spPr>
-          <a:xfrm xmlns:a="http://schemas.openxmlformats.org/drawingml/2006/main">
-            <a:off x="393668" y="4973288"/>
-            <a:ext cx="10953750" cy="1080230"/>
+              <a:defRPr sz="2400">
+                <a:solidFill>
+                  <a:srgbClr val="000000"/>
+                </a:solidFill>
+                <a:latin typeface="Helvetica Neue"/>
+                <a:ea typeface="Helvetica Neue"/>
+                <a:cs typeface="Helvetica Neue"/>
+              </a:defRPr>
+            </a:pPr>
+            <a:r>
+              <a:t>장순욱</a:t>
+            </a:r>
+          </a:p>
+        </p:txBody>
+      </p:sp>
+      <p:sp>
+        <p:nvSpPr>
+          <p:cNvPr id="10" name="Content-Placeholder-9-10">
+            <a:extLst xmlns:a="http://schemas.openxmlformats.org/drawingml/2006/main">
+              <a:ext uri="{FF2B5EF4-FFF2-40B4-BE49-F238E27FC236}">
+                <a16:creationId xmlns:a16="http://schemas.microsoft.com/office/drawing/2014/main" id="{CE72FAEF-F255-4F90-AEDE-480E5F8C5F47}"/>
+              </a:ext>
+            </a:extLst>
+          </p:cNvPr>
+          <p:cNvSpPr>
+            <a:spLocks xmlns:a="http://schemas.openxmlformats.org/drawingml/2006/main" noGrp="1"/>
+          </p:cNvSpPr>
+          <p:nvPr/>
+        </p:nvSpPr>
+        <p:spPr>
+          <a:xfrm xmlns:a="http://schemas.openxmlformats.org/drawingml/2006/main">
+            <a:off x="4612958" y="3429000"/>
+            <a:ext cx="2940082" cy="1359313"/>
+          </a:xfrm>
+          <a:prstGeom xmlns:a="http://schemas.openxmlformats.org/drawingml/2006/main" prst="rect">
+            <a:avLst/>
+          </a:prstGeom>
+        </p:spPr>
+        <p:txBody>
+          <a:bodyPr xmlns:a="http://schemas.openxmlformats.org/drawingml/2006/main" lIns="0" tIns="0" rIns="0" bIns="0" anchor="b">
+            <a:normAutofit fontScale="100000"/>
+          </a:bodyPr>
+          <a:lstStyle xmlns:a="http://schemas.openxmlformats.org/drawingml/2006/main"/>
+          <a:p xmlns:a="http://schemas.openxmlformats.org/drawingml/2006/main">
+            <a:pPr algn="l">
+              <a:buNone/>
+              <a:defRPr sz="2400">
+                <a:solidFill>
+                  <a:srgbClr val="000000"/>
+                </a:solidFill>
+                <a:latin typeface="Helvetica Neue"/>
+                <a:ea typeface="Helvetica Neue"/>
+                <a:cs typeface="Helvetica Neue"/>
+              </a:defRPr>
+            </a:pPr>
+            <a:r>
+              <a:t>구장룡</a:t>
+            </a:r>
+          </a:p>
+        </p:txBody>
+      </p:sp>
+      <p:sp>
+        <p:nvSpPr>
+          <p:cNvPr id="11" name="Content-Placeholder-9-11">
+            <a:extLst xmlns:a="http://schemas.openxmlformats.org/drawingml/2006/main">
+              <a:ext uri="{FF2B5EF4-FFF2-40B4-BE49-F238E27FC236}">
+                <a16:creationId xmlns:a16="http://schemas.microsoft.com/office/drawing/2014/main" id="{70DD8D92-9021-4372-B7E8-35A09E99E87D}"/>
+              </a:ext>
+            </a:extLst>
+          </p:cNvPr>
+          <p:cNvSpPr>
+            <a:spLocks xmlns:a="http://schemas.openxmlformats.org/drawingml/2006/main" noGrp="1"/>
+          </p:cNvSpPr>
+          <p:nvPr/>
+        </p:nvSpPr>
+        <p:spPr>
+          <a:xfrm xmlns:a="http://schemas.openxmlformats.org/drawingml/2006/main">
+            <a:off x="8562404" y="3429000"/>
+            <a:ext cx="2940082" cy="1359313"/>
+          </a:xfrm>
+          <a:prstGeom xmlns:a="http://schemas.openxmlformats.org/drawingml/2006/main" prst="rect">
+            <a:avLst/>
+          </a:prstGeom>
+        </p:spPr>
+        <p:txBody>
+          <a:bodyPr xmlns:a="http://schemas.openxmlformats.org/drawingml/2006/main" lIns="0" tIns="0" rIns="0" bIns="0" anchor="b">
+            <a:normAutofit fontScale="100000"/>
+          </a:bodyPr>
+          <a:lstStyle xmlns:a="http://schemas.openxmlformats.org/drawingml/2006/main"/>
+          <a:p xmlns:a="http://schemas.openxmlformats.org/drawingml/2006/main">
+            <a:pPr algn="l">
+              <a:buNone/>
+              <a:defRPr sz="2400">
+                <a:solidFill>
+                  <a:srgbClr val="000000"/>
+                </a:solidFill>
+                <a:latin typeface="Helvetica Neue"/>
+                <a:ea typeface="Helvetica Neue"/>
+                <a:cs typeface="Helvetica Neue"/>
+              </a:defRPr>
+            </a:pPr>
+            <a:r>
+              <a:t>박지호</a:t>
+            </a:r>
+          </a:p>
+        </p:txBody>
+      </p:sp>
+      <p:sp>
+        <p:nvSpPr>
+          <p:cNvPr id="12" name="Content-Placeholder-15-12">
+            <a:extLst xmlns:a="http://schemas.openxmlformats.org/drawingml/2006/main">
+              <a:ext uri="{FF2B5EF4-FFF2-40B4-BE49-F238E27FC236}">
+                <a16:creationId xmlns:a16="http://schemas.microsoft.com/office/drawing/2014/main" id="{E1FBB930-6AF2-4B7D-84BA-8E934D069C6B}"/>
+              </a:ext>
+            </a:extLst>
+          </p:cNvPr>
+          <p:cNvSpPr>
+            <a:spLocks xmlns:a="http://schemas.openxmlformats.org/drawingml/2006/main" noGrp="1"/>
+          </p:cNvSpPr>
+          <p:nvPr/>
+        </p:nvSpPr>
+        <p:spPr>
+          <a:xfrm xmlns:a="http://schemas.openxmlformats.org/drawingml/2006/main">
+            <a:off x="393668" y="1138333"/>
+            <a:ext cx="11404568" cy="1599438"/>
           </a:xfrm>
           <a:prstGeom xmlns:a="http://schemas.openxmlformats.org/drawingml/2006/main" prst="rect">
             <a:avLst/>
@@ -8399,89 +8884,59 @@
           <a:p xmlns:a="http://schemas.openxmlformats.org/drawingml/2006/main">
             <a:pPr algn="l">
               <a:buNone/>
-              <a:defRPr sz="2100">
-                <a:solidFill>
-                  <a:srgbClr val="000000"/>
-                </a:solidFill>
-                <a:latin typeface="Helvetica Neue"/>
-                <a:ea typeface="Helvetica Neue"/>
-                <a:cs typeface="Helvetica Neue"/>
-              </a:defRPr>
-            </a:pPr>
-            <a:r>
-              <a:t>① 품목분류·표시 문구 사전검토  ② 제품 CoA·안정성·유효용량</a:t>
-            </a:r>
-          </a:p>
-          <a:p xmlns:a="http://schemas.openxmlformats.org/drawingml/2006/main">
-            <a:pPr algn="l">
-              <a:buNone/>
-              <a:defRPr sz="2100">
-                <a:solidFill>
-                  <a:srgbClr val="000000"/>
-                </a:solidFill>
-                <a:latin typeface="Helvetica Neue"/>
-                <a:ea typeface="Helvetica Neue"/>
-                <a:cs typeface="Helvetica Neue"/>
-              </a:defRPr>
-            </a:pPr>
-            <a:r>
-              <a:t>③ OEM 2곳 실제 견적·품질 협약서  ④ 유료 고객 시험과 반복 주문</a:t>
-            </a:r>
-          </a:p>
-        </p:txBody>
-      </p:sp>
-      <p:sp>
-        <p:nvSpPr>
-          <p:cNvPr id="3" name="Subtitle-4-3">
-            <a:extLst xmlns:a="http://schemas.openxmlformats.org/drawingml/2006/main">
-              <a:ext uri="{FF2B5EF4-FFF2-40B4-BE49-F238E27FC236}">
-                <a16:creationId xmlns:a16="http://schemas.microsoft.com/office/drawing/2014/main" id="{83CFF434-0D8D-452B-9588-51118CD257D7}"/>
-              </a:ext>
-            </a:extLst>
-          </p:cNvPr>
-          <p:cNvSpPr>
-            <a:spLocks xmlns:a="http://schemas.openxmlformats.org/drawingml/2006/main" noGrp="1"/>
-          </p:cNvSpPr>
-          <p:nvPr/>
-        </p:nvSpPr>
-        <p:spPr>
-          <a:xfrm xmlns:a="http://schemas.openxmlformats.org/drawingml/2006/main">
-            <a:off x="393668" y="392240"/>
-            <a:ext cx="1612868" cy="649129"/>
-          </a:xfrm>
-          <a:prstGeom xmlns:a="http://schemas.openxmlformats.org/drawingml/2006/main" prst="rect">
-            <a:avLst/>
-          </a:prstGeom>
-        </p:spPr>
-        <p:txBody>
-          <a:bodyPr xmlns:a="http://schemas.openxmlformats.org/drawingml/2006/main" lIns="0" tIns="0" rIns="0" bIns="0">
-            <a:noAutofit/>
-          </a:bodyPr>
-          <a:lstStyle xmlns:a="http://schemas.openxmlformats.org/drawingml/2006/main"/>
-          <a:p xmlns:a="http://schemas.openxmlformats.org/drawingml/2006/main">
-            <a:pPr algn="l">
-              <a:buNone/>
-              <a:defRPr sz="2400">
-                <a:solidFill>
-                  <a:srgbClr val="000000"/>
-                </a:solidFill>
-                <a:latin typeface="Helvetica Neue"/>
-                <a:ea typeface="Helvetica Neue"/>
-                <a:cs typeface="Helvetica Neue"/>
-              </a:defRPr>
-            </a:pPr>
-            <a:r>
-              <a:t>승인 요청 · 검증 예산</a:t>
-            </a:r>
-          </a:p>
-        </p:txBody>
-      </p:sp>
-      <p:sp>
-        <p:nvSpPr>
-          <p:cNvPr id="4" name="brand-rule-19">
-            <a:extLst xmlns:a="http://schemas.openxmlformats.org/drawingml/2006/main">
-              <a:ext uri="{FF2B5EF4-FFF2-40B4-BE49-F238E27FC236}">
-                <a16:creationId xmlns:a16="http://schemas.microsoft.com/office/drawing/2014/main" id="{7AAF7002-EC9D-469C-84D7-2EC7F0804319}"/>
+              <a:defRPr sz="1600">
+                <a:solidFill>
+                  <a:srgbClr val="000000"/>
+                </a:solidFill>
+                <a:latin typeface="Helvetica Neue"/>
+                <a:ea typeface="Helvetica Neue"/>
+                <a:cs typeface="Helvetica Neue"/>
+              </a:defRPr>
+            </a:pPr>
+            <a:r>
+              <a:t>장순욱 | 현 셀핀다 생명과학연구소 부사장 · 전 해원바이오 전무 · 전 한국신약 연구소장</a:t>
+            </a:r>
+          </a:p>
+          <a:p xmlns:a="http://schemas.openxmlformats.org/drawingml/2006/main">
+            <a:pPr algn="l">
+              <a:buNone/>
+              <a:defRPr sz="1600">
+                <a:solidFill>
+                  <a:srgbClr val="000000"/>
+                </a:solidFill>
+                <a:latin typeface="Helvetica Neue"/>
+                <a:ea typeface="Helvetica Neue"/>
+                <a:cs typeface="Helvetica Neue"/>
+              </a:defRPr>
+            </a:pPr>
+            <a:r>
+              <a:t>구장룡 | 현 충남대 농업과학연구소 총괄책임 · 전 우성사료 연구소장</a:t>
+            </a:r>
+          </a:p>
+          <a:p xmlns:a="http://schemas.openxmlformats.org/drawingml/2006/main">
+            <a:pPr algn="l">
+              <a:buNone/>
+              <a:defRPr sz="1600">
+                <a:solidFill>
+                  <a:srgbClr val="000000"/>
+                </a:solidFill>
+                <a:latin typeface="Helvetica Neue"/>
+                <a:ea typeface="Helvetica Neue"/>
+                <a:cs typeface="Helvetica Neue"/>
+              </a:defRPr>
+            </a:pPr>
+            <a:r>
+              <a:t>박지호 | 현 셀핀다 생명과학연구소 소장 · 전 현대바이오랜드 재직</a:t>
+            </a:r>
+          </a:p>
+        </p:txBody>
+      </p:sp>
+      <p:sp>
+        <p:nvSpPr>
+          <p:cNvPr id="13" name="brand-rule-3">
+            <a:extLst xmlns:a="http://schemas.openxmlformats.org/drawingml/2006/main">
+              <a:ext uri="{FF2B5EF4-FFF2-40B4-BE49-F238E27FC236}">
+                <a16:creationId xmlns:a16="http://schemas.microsoft.com/office/drawing/2014/main" id="{CF26F2E1-309A-4854-AE35-3CF8D1E0B7DE}"/>
               </a:ext>
             </a:extLst>
           </p:cNvPr>
@@ -8511,10 +8966,10 @@
       </p:sp>
       <p:sp>
         <p:nvSpPr>
-          <p:cNvPr id="5" name="brand-footer-19">
-            <a:extLst xmlns:a="http://schemas.openxmlformats.org/drawingml/2006/main">
-              <a:ext uri="{FF2B5EF4-FFF2-40B4-BE49-F238E27FC236}">
-                <a16:creationId xmlns:a16="http://schemas.microsoft.com/office/drawing/2014/main" id="{5673E306-1329-4C06-B385-21CE77F2D44C}"/>
+          <p:cNvPr id="14" name="brand-footer-3">
+            <a:extLst xmlns:a="http://schemas.openxmlformats.org/drawingml/2006/main">
+              <a:ext uri="{FF2B5EF4-FFF2-40B4-BE49-F238E27FC236}">
+                <a16:creationId xmlns:a16="http://schemas.microsoft.com/office/drawing/2014/main" id="{67FA2FB3-A9A5-4AF6-A336-B21A6025C47A}"/>
               </a:ext>
             </a:extLst>
           </p:cNvPr>
@@ -8561,7 +9016,7 @@
                 <a:ea typeface="Arial"/>
                 <a:cs typeface="Arial"/>
               </a:rPr>
-              <a:t>18 | DECISION ASK</a:t>
+              <a:t>GABA BUSINESS MODEL | 18 | COMMERCIALIZATION TEAM</a:t>
             </a:r>
           </a:p>
         </p:txBody>
@@ -8569,7 +9024,7 @@
     </p:spTree>
     <p:extLst>
       <p:ext uri="{BB962C8B-B14F-4D97-AF65-F5344CB8AC3E}">
-        <p14:creationId xmlns:p14="http://schemas.microsoft.com/office/powerpoint/2010/main" val="1951378401"/>
+        <p14:creationId xmlns:p14="http://schemas.microsoft.com/office/powerpoint/2010/main" val="1364317174"/>
       </p:ext>
     </p:extLst>
   </p:cSld>
@@ -8590,296 +9045,84 @@
       </p:grpSpPr>
       <p:sp>
         <p:nvSpPr>
-          <p:cNvPr id="9" name="Slide-Number-Placeholder-1-2">
-            <a:extLst xmlns:a="http://schemas.openxmlformats.org/drawingml/2006/main">
-              <a:ext uri="{FF2B5EF4-FFF2-40B4-BE49-F238E27FC236}">
-                <a16:creationId xmlns:a16="http://schemas.microsoft.com/office/drawing/2014/main" id="{899BFBB6-2B10-416C-B0B8-D3DCD3722082}"/>
-              </a:ext>
-            </a:extLst>
-          </p:cNvPr>
-          <p:cNvSpPr>
-            <a:spLocks xmlns:a="http://schemas.openxmlformats.org/drawingml/2006/main" noGrp="1"/>
-          </p:cNvSpPr>
-          <p:nvPr/>
-        </p:nvSpPr>
-        <p:spPr>
-          <a:xfrm xmlns:a="http://schemas.openxmlformats.org/drawingml/2006/main">
-            <a:off x="11279219" y="6278594"/>
-            <a:ext cx="519113" cy="241268"/>
-          </a:xfrm>
-          <a:prstGeom xmlns:a="http://schemas.openxmlformats.org/drawingml/2006/main" prst="rect">
-            <a:avLst/>
-          </a:prstGeom>
-        </p:spPr>
-        <p:txBody>
-          <a:bodyPr xmlns:a="http://schemas.openxmlformats.org/drawingml/2006/main" lIns="0" tIns="0" rIns="0" bIns="0" anchor="b"/>
-          <a:lstStyle xmlns:a="http://schemas.openxmlformats.org/drawingml/2006/main"/>
-          <a:p xmlns:a="http://schemas.openxmlformats.org/drawingml/2006/main">
-            <a:pPr algn="r">
-              <a:buNone/>
-              <a:defRPr sz="1000">
-                <a:solidFill>
-                  <a:srgbClr val="000000"/>
-                </a:solidFill>
-                <a:latin typeface="Helvetica Neue"/>
-                <a:ea typeface="Helvetica Neue"/>
-                <a:cs typeface="Helvetica Neue"/>
-              </a:defRPr>
-            </a:pPr>
-            <a:r>
-              <a:t>19</a:t>
-            </a:r>
-          </a:p>
-        </p:txBody>
-      </p:sp>
-      <p:sp>
-        <p:nvSpPr>
-          <p:cNvPr id="2" name="Title-2-3">
-            <a:extLst xmlns:a="http://schemas.openxmlformats.org/drawingml/2006/main">
-              <a:ext uri="{FF2B5EF4-FFF2-40B4-BE49-F238E27FC236}">
-                <a16:creationId xmlns:a16="http://schemas.microsoft.com/office/drawing/2014/main" id="{5CFAC748-585C-4584-8553-0EC8E67AB075}"/>
-              </a:ext>
-            </a:extLst>
-          </p:cNvPr>
-          <p:cNvSpPr>
-            <a:spLocks xmlns:a="http://schemas.openxmlformats.org/drawingml/2006/main" noGrp="1"/>
-          </p:cNvSpPr>
-          <p:nvPr/>
-        </p:nvSpPr>
-        <p:spPr>
-          <a:xfrm xmlns:a="http://schemas.openxmlformats.org/drawingml/2006/main">
-            <a:off x="393668" y="344043"/>
-            <a:ext cx="11404568" cy="1047464"/>
-          </a:xfrm>
-          <a:prstGeom xmlns:a="http://schemas.openxmlformats.org/drawingml/2006/main" prst="rect">
-            <a:avLst/>
-          </a:prstGeom>
-        </p:spPr>
-        <p:txBody>
-          <a:bodyPr xmlns:a="http://schemas.openxmlformats.org/drawingml/2006/main" lIns="0" tIns="0" rIns="0" bIns="0" anchor="t">
-            <a:normAutofit fontScale="100000"/>
+          <p:cNvPr id="6" name="Title-3-1">
+            <a:extLst xmlns:a="http://schemas.openxmlformats.org/drawingml/2006/main">
+              <a:ext uri="{FF2B5EF4-FFF2-40B4-BE49-F238E27FC236}">
+                <a16:creationId xmlns:a16="http://schemas.microsoft.com/office/drawing/2014/main" id="{93582F7D-404D-46AB-80D1-FE06EE84CD39}"/>
+              </a:ext>
+            </a:extLst>
+          </p:cNvPr>
+          <p:cNvSpPr>
+            <a:spLocks xmlns:a="http://schemas.openxmlformats.org/drawingml/2006/main" noGrp="1"/>
+          </p:cNvSpPr>
+          <p:nvPr/>
+        </p:nvSpPr>
+        <p:spPr>
+          <a:xfrm xmlns:a="http://schemas.openxmlformats.org/drawingml/2006/main">
+            <a:off x="393668" y="1738789"/>
+            <a:ext cx="9448800" cy="2491454"/>
+          </a:xfrm>
+          <a:prstGeom xmlns:a="http://schemas.openxmlformats.org/drawingml/2006/main" prst="rect">
+            <a:avLst/>
+          </a:prstGeom>
+        </p:spPr>
+        <p:txBody>
+          <a:bodyPr xmlns:a="http://schemas.openxmlformats.org/drawingml/2006/main" lIns="0" tIns="0" rIns="0" bIns="0" anchor="b">
+            <a:noAutofit/>
           </a:bodyPr>
           <a:lstStyle xmlns:a="http://schemas.openxmlformats.org/drawingml/2006/main"/>
           <a:p xmlns:a="http://schemas.openxmlformats.org/drawingml/2006/main">
             <a:pPr algn="l">
               <a:buNone/>
-              <a:defRPr sz="2900">
-                <a:solidFill>
-                  <a:srgbClr val="000000"/>
-                </a:solidFill>
-                <a:latin typeface="Helvetica Neue"/>
-                <a:ea typeface="Helvetica Neue"/>
-                <a:cs typeface="Helvetica Neue"/>
-              </a:defRPr>
-            </a:pPr>
-            <a:r>
-              <a:t>APPENDIX · 용어·계산식·출처·이용 안내</a:t>
-            </a:r>
-          </a:p>
-        </p:txBody>
-      </p:sp>
-      <p:sp>
-        <p:nvSpPr>
-          <p:cNvPr id="3" name="Content-Placeholder-9-4">
-            <a:extLst xmlns:a="http://schemas.openxmlformats.org/drawingml/2006/main">
-              <a:ext uri="{FF2B5EF4-FFF2-40B4-BE49-F238E27FC236}">
-                <a16:creationId xmlns:a16="http://schemas.microsoft.com/office/drawing/2014/main" id="{34DB5DEF-8114-43EB-BCF8-0B628E7C364A}"/>
-              </a:ext>
-            </a:extLst>
-          </p:cNvPr>
-          <p:cNvSpPr>
-            <a:spLocks xmlns:a="http://schemas.openxmlformats.org/drawingml/2006/main" noGrp="1"/>
-          </p:cNvSpPr>
-          <p:nvPr/>
-        </p:nvSpPr>
-        <p:spPr>
-          <a:xfrm xmlns:a="http://schemas.openxmlformats.org/drawingml/2006/main">
-            <a:off x="393668" y="2031968"/>
-            <a:ext cx="5537168" cy="1643063"/>
-          </a:xfrm>
-          <a:prstGeom xmlns:a="http://schemas.openxmlformats.org/drawingml/2006/main" prst="rect">
-            <a:avLst/>
-          </a:prstGeom>
-        </p:spPr>
-        <p:txBody>
-          <a:bodyPr xmlns:a="http://schemas.openxmlformats.org/drawingml/2006/main" lIns="91440" tIns="45720" rIns="91440" bIns="45720"/>
-          <a:lstStyle xmlns:a="http://schemas.openxmlformats.org/drawingml/2006/main"/>
-          <a:p xmlns:a="http://schemas.openxmlformats.org/drawingml/2006/main">
-            <a:pPr algn="l">
-              <a:buNone/>
-              <a:defRPr sz="2400">
-                <a:solidFill>
-                  <a:srgbClr val="000000"/>
-                </a:solidFill>
-                <a:latin typeface="Helvetica Neue"/>
-                <a:ea typeface="Helvetica Neue"/>
-                <a:cs typeface="Helvetica Neue"/>
-              </a:defRPr>
-            </a:pPr>
-            <a:r>
-              <a:t>용어</a:t>
-            </a:r>
-          </a:p>
-          <a:p xmlns:a="http://schemas.openxmlformats.org/drawingml/2006/main">
-            <a:pPr algn="l">
-              <a:buNone/>
-              <a:defRPr sz="2400">
-                <a:solidFill>
-                  <a:srgbClr val="000000"/>
-                </a:solidFill>
-                <a:latin typeface="Helvetica Neue"/>
-                <a:ea typeface="Helvetica Neue"/>
-                <a:cs typeface="Helvetica Neue"/>
-              </a:defRPr>
-            </a:pPr>
-            <a:r>
-              <a:t>GABA=감마아미노부티르산</a:t>
-            </a:r>
-          </a:p>
-          <a:p xmlns:a="http://schemas.openxmlformats.org/drawingml/2006/main">
-            <a:pPr algn="l">
-              <a:buNone/>
-              <a:defRPr sz="2400">
-                <a:solidFill>
-                  <a:srgbClr val="000000"/>
-                </a:solidFill>
-                <a:latin typeface="Helvetica Neue"/>
-                <a:ea typeface="Helvetica Neue"/>
-                <a:cs typeface="Helvetica Neue"/>
-              </a:defRPr>
-            </a:pPr>
-            <a:r>
-              <a:t>CoA=로트 성적서</a:t>
-            </a:r>
-          </a:p>
-          <a:p xmlns:a="http://schemas.openxmlformats.org/drawingml/2006/main">
-            <a:pPr algn="l">
-              <a:buNone/>
-              <a:defRPr sz="2400">
-                <a:solidFill>
-                  <a:srgbClr val="000000"/>
-                </a:solidFill>
-                <a:latin typeface="Helvetica Neue"/>
-                <a:ea typeface="Helvetica Neue"/>
-                <a:cs typeface="Helvetica Neue"/>
-              </a:defRPr>
-            </a:pPr>
-            <a:r>
-              <a:t>PoV=고객 가치 검증</a:t>
-            </a:r>
-          </a:p>
-        </p:txBody>
-      </p:sp>
-      <p:sp>
-        <p:nvSpPr>
-          <p:cNvPr id="4" name="Content-Placeholder-10-5">
-            <a:extLst xmlns:a="http://schemas.openxmlformats.org/drawingml/2006/main">
-              <a:ext uri="{FF2B5EF4-FFF2-40B4-BE49-F238E27FC236}">
-                <a16:creationId xmlns:a16="http://schemas.microsoft.com/office/drawing/2014/main" id="{EFACA7CB-B804-47CA-AB1B-80FE7DDA4BA7}"/>
-              </a:ext>
-            </a:extLst>
-          </p:cNvPr>
-          <p:cNvSpPr>
-            <a:spLocks xmlns:a="http://schemas.openxmlformats.org/drawingml/2006/main" noGrp="1"/>
-          </p:cNvSpPr>
-          <p:nvPr/>
-        </p:nvSpPr>
-        <p:spPr>
-          <a:xfrm xmlns:a="http://schemas.openxmlformats.org/drawingml/2006/main">
-            <a:off x="6256592" y="2031968"/>
-            <a:ext cx="5537168" cy="1643063"/>
-          </a:xfrm>
-          <a:prstGeom xmlns:a="http://schemas.openxmlformats.org/drawingml/2006/main" prst="rect">
-            <a:avLst/>
-          </a:prstGeom>
-        </p:spPr>
-        <p:txBody>
-          <a:bodyPr xmlns:a="http://schemas.openxmlformats.org/drawingml/2006/main" lIns="91440" tIns="45720" rIns="91440" bIns="45720"/>
-          <a:lstStyle xmlns:a="http://schemas.openxmlformats.org/drawingml/2006/main"/>
-          <a:p xmlns:a="http://schemas.openxmlformats.org/drawingml/2006/main">
-            <a:pPr algn="l">
-              <a:buNone/>
-              <a:defRPr sz="2400">
-                <a:solidFill>
-                  <a:srgbClr val="000000"/>
-                </a:solidFill>
-                <a:latin typeface="Helvetica Neue"/>
-                <a:ea typeface="Helvetica Neue"/>
-                <a:cs typeface="Helvetica Neue"/>
-              </a:defRPr>
-            </a:pPr>
-            <a:r>
-              <a:t>운영</a:t>
-            </a:r>
-          </a:p>
-          <a:p xmlns:a="http://schemas.openxmlformats.org/drawingml/2006/main">
-            <a:pPr algn="l">
-              <a:buNone/>
-              <a:defRPr sz="2400">
-                <a:solidFill>
-                  <a:srgbClr val="000000"/>
-                </a:solidFill>
-                <a:latin typeface="Helvetica Neue"/>
-                <a:ea typeface="Helvetica Neue"/>
-                <a:cs typeface="Helvetica Neue"/>
-              </a:defRPr>
-            </a:pPr>
-            <a:r>
-              <a:t>마스터배치=고농축 중간재</a:t>
-            </a:r>
-          </a:p>
-          <a:p xmlns:a="http://schemas.openxmlformats.org/drawingml/2006/main">
-            <a:pPr algn="l">
-              <a:buNone/>
-              <a:defRPr sz="2400">
-                <a:solidFill>
-                  <a:srgbClr val="000000"/>
-                </a:solidFill>
-                <a:latin typeface="Helvetica Neue"/>
-                <a:ea typeface="Helvetica Neue"/>
-                <a:cs typeface="Helvetica Neue"/>
-              </a:defRPr>
-            </a:pPr>
-            <a:r>
-              <a:t>OEM=주문자 상표 부착 생산</a:t>
-            </a:r>
-          </a:p>
-          <a:p xmlns:a="http://schemas.openxmlformats.org/drawingml/2006/main">
-            <a:pPr algn="l">
-              <a:buNone/>
-              <a:defRPr sz="2400">
-                <a:solidFill>
-                  <a:srgbClr val="000000"/>
-                </a:solidFill>
-                <a:latin typeface="Helvetica Neue"/>
-                <a:ea typeface="Helvetica Neue"/>
-                <a:cs typeface="Helvetica Neue"/>
-              </a:defRPr>
-            </a:pPr>
-            <a:r>
-              <a:t>MOQ=최소 주문 수량</a:t>
-            </a:r>
-          </a:p>
-        </p:txBody>
-      </p:sp>
-      <p:sp>
-        <p:nvSpPr>
-          <p:cNvPr id="5" name="Content-Placeholder-9-6">
-            <a:extLst xmlns:a="http://schemas.openxmlformats.org/drawingml/2006/main">
-              <a:ext uri="{FF2B5EF4-FFF2-40B4-BE49-F238E27FC236}">
-                <a16:creationId xmlns:a16="http://schemas.microsoft.com/office/drawing/2014/main" id="{234C9D70-A9C5-49B5-8918-C361BF8A333B}"/>
-              </a:ext>
-            </a:extLst>
-          </p:cNvPr>
-          <p:cNvSpPr>
-            <a:spLocks xmlns:a="http://schemas.openxmlformats.org/drawingml/2006/main" noGrp="1"/>
-          </p:cNvSpPr>
-          <p:nvPr/>
-        </p:nvSpPr>
-        <p:spPr>
-          <a:xfrm xmlns:a="http://schemas.openxmlformats.org/drawingml/2006/main">
-            <a:off x="393668" y="4016978"/>
-            <a:ext cx="5537168" cy="1643158"/>
+              <a:defRPr sz="6000">
+                <a:solidFill>
+                  <a:srgbClr val="000000"/>
+                </a:solidFill>
+                <a:latin typeface="Helvetica Neue"/>
+                <a:ea typeface="Helvetica Neue"/>
+                <a:cs typeface="Helvetica Neue"/>
+              </a:defRPr>
+            </a:pPr>
+            <a:r>
+              <a:t>4,560만원을 집행하기 전,</a:t>
+            </a:r>
+          </a:p>
+          <a:p xmlns:a="http://schemas.openxmlformats.org/drawingml/2006/main">
+            <a:pPr algn="l">
+              <a:buNone/>
+              <a:defRPr sz="6000">
+                <a:solidFill>
+                  <a:srgbClr val="000000"/>
+                </a:solidFill>
+                <a:latin typeface="Helvetica Neue"/>
+                <a:ea typeface="Helvetica Neue"/>
+                <a:cs typeface="Helvetica Neue"/>
+              </a:defRPr>
+            </a:pPr>
+            <a:r>
+              <a:t>두 사업의 공통 검증을 승인해 주십시오</a:t>
+            </a:r>
+          </a:p>
+        </p:txBody>
+      </p:sp>
+      <p:sp>
+        <p:nvSpPr>
+          <p:cNvPr id="2" name="Subtitle-4-2">
+            <a:extLst xmlns:a="http://schemas.openxmlformats.org/drawingml/2006/main">
+              <a:ext uri="{FF2B5EF4-FFF2-40B4-BE49-F238E27FC236}">
+                <a16:creationId xmlns:a16="http://schemas.microsoft.com/office/drawing/2014/main" id="{6DBE01A0-2CC5-41DA-85B6-ED57A07E76EC}"/>
+              </a:ext>
+            </a:extLst>
+          </p:cNvPr>
+          <p:cNvSpPr>
+            <a:spLocks xmlns:a="http://schemas.openxmlformats.org/drawingml/2006/main" noGrp="1"/>
+          </p:cNvSpPr>
+          <p:nvPr/>
+        </p:nvSpPr>
+        <p:spPr>
+          <a:xfrm xmlns:a="http://schemas.openxmlformats.org/drawingml/2006/main">
+            <a:off x="393668" y="4973288"/>
+            <a:ext cx="10953750" cy="1080230"/>
           </a:xfrm>
           <a:prstGeom xmlns:a="http://schemas.openxmlformats.org/drawingml/2006/main" prst="rect">
             <a:avLst/>
@@ -8887,93 +9130,61 @@
         </p:spPr>
         <p:txBody>
           <a:bodyPr xmlns:a="http://schemas.openxmlformats.org/drawingml/2006/main" lIns="0" tIns="0" rIns="0" bIns="0">
-            <a:normAutofit fontScale="100000"/>
+            <a:noAutofit/>
           </a:bodyPr>
           <a:lstStyle xmlns:a="http://schemas.openxmlformats.org/drawingml/2006/main"/>
           <a:p xmlns:a="http://schemas.openxmlformats.org/drawingml/2006/main">
             <a:pPr algn="l">
               <a:buNone/>
-              <a:defRPr sz="2400">
-                <a:solidFill>
-                  <a:srgbClr val="000000"/>
-                </a:solidFill>
-                <a:latin typeface="Helvetica Neue"/>
-                <a:ea typeface="Helvetica Neue"/>
-                <a:cs typeface="Helvetica Neue"/>
-              </a:defRPr>
-            </a:pPr>
-            <a:r>
-              <a:t>핵심 가정</a:t>
-            </a:r>
-          </a:p>
-          <a:p xmlns:a="http://schemas.openxmlformats.org/drawingml/2006/main">
-            <a:pPr algn="l">
-              <a:buNone/>
-              <a:defRPr sz="2400">
-                <a:solidFill>
-                  <a:srgbClr val="000000"/>
-                </a:solidFill>
-                <a:latin typeface="Helvetica Neue"/>
-                <a:ea typeface="Helvetica Neue"/>
-                <a:cs typeface="Helvetica Neue"/>
-              </a:defRPr>
-            </a:pPr>
-            <a:r>
-              <a:t>18,000원/kg·9,240원/kg</a:t>
-            </a:r>
-          </a:p>
-          <a:p xmlns:a="http://schemas.openxmlformats.org/drawingml/2006/main">
-            <a:pPr algn="l">
-              <a:buNone/>
-              <a:defRPr sz="2400">
-                <a:solidFill>
-                  <a:srgbClr val="000000"/>
-                </a:solidFill>
-                <a:latin typeface="Helvetica Neue"/>
-                <a:ea typeface="Helvetica Neue"/>
-                <a:cs typeface="Helvetica Neue"/>
-              </a:defRPr>
-            </a:pPr>
-            <a:r>
-              <a:t>75g/사료t·4,681.8원/kg</a:t>
-            </a:r>
-          </a:p>
-          <a:p xmlns:a="http://schemas.openxmlformats.org/drawingml/2006/main">
-            <a:pPr algn="l">
-              <a:buNone/>
-              <a:defRPr sz="2400">
-                <a:solidFill>
-                  <a:srgbClr val="000000"/>
-                </a:solidFill>
-                <a:latin typeface="Helvetica Neue"/>
-                <a:ea typeface="Helvetica Neue"/>
-                <a:cs typeface="Helvetica Neue"/>
-              </a:defRPr>
-            </a:pPr>
-            <a:r>
-              <a:t>고객가치 18,000원/t</a:t>
-            </a:r>
-          </a:p>
-        </p:txBody>
-      </p:sp>
-      <p:sp>
-        <p:nvSpPr>
-          <p:cNvPr id="6" name="Content-Placeholder-10-7">
-            <a:extLst xmlns:a="http://schemas.openxmlformats.org/drawingml/2006/main">
-              <a:ext uri="{FF2B5EF4-FFF2-40B4-BE49-F238E27FC236}">
-                <a16:creationId xmlns:a16="http://schemas.microsoft.com/office/drawing/2014/main" id="{1A34C16A-8F7A-4B12-BA58-172260CF0F97}"/>
-              </a:ext>
-            </a:extLst>
-          </p:cNvPr>
-          <p:cNvSpPr>
-            <a:spLocks xmlns:a="http://schemas.openxmlformats.org/drawingml/2006/main" noGrp="1"/>
-          </p:cNvSpPr>
-          <p:nvPr/>
-        </p:nvSpPr>
-        <p:spPr>
-          <a:xfrm xmlns:a="http://schemas.openxmlformats.org/drawingml/2006/main">
-            <a:off x="6256592" y="4016978"/>
-            <a:ext cx="5537168" cy="1643158"/>
+              <a:defRPr sz="2100">
+                <a:solidFill>
+                  <a:srgbClr val="000000"/>
+                </a:solidFill>
+                <a:latin typeface="Helvetica Neue"/>
+                <a:ea typeface="Helvetica Neue"/>
+                <a:cs typeface="Helvetica Neue"/>
+              </a:defRPr>
+            </a:pPr>
+            <a:r>
+              <a:t>① 품목분류·표시 문구  ② 제품 CoA·안정성·유효용량</a:t>
+            </a:r>
+          </a:p>
+          <a:p xmlns:a="http://schemas.openxmlformats.org/drawingml/2006/main">
+            <a:pPr algn="l">
+              <a:buNone/>
+              <a:defRPr sz="2100">
+                <a:solidFill>
+                  <a:srgbClr val="000000"/>
+                </a:solidFill>
+                <a:latin typeface="Helvetica Neue"/>
+                <a:ea typeface="Helvetica Neue"/>
+                <a:cs typeface="Helvetica Neue"/>
+              </a:defRPr>
+            </a:pPr>
+            <a:r>
+              <a:t>③ 생산 파트너 실사·실제 견적  ④ 유료 고객 시험과 반복 주문</a:t>
+            </a:r>
+          </a:p>
+        </p:txBody>
+      </p:sp>
+      <p:sp>
+        <p:nvSpPr>
+          <p:cNvPr id="3" name="Subtitle-4-3">
+            <a:extLst xmlns:a="http://schemas.openxmlformats.org/drawingml/2006/main">
+              <a:ext uri="{FF2B5EF4-FFF2-40B4-BE49-F238E27FC236}">
+                <a16:creationId xmlns:a16="http://schemas.microsoft.com/office/drawing/2014/main" id="{83CFF434-0D8D-452B-9588-51118CD257D7}"/>
+              </a:ext>
+            </a:extLst>
+          </p:cNvPr>
+          <p:cNvSpPr>
+            <a:spLocks xmlns:a="http://schemas.openxmlformats.org/drawingml/2006/main" noGrp="1"/>
+          </p:cNvSpPr>
+          <p:nvPr/>
+        </p:nvSpPr>
+        <p:spPr>
+          <a:xfrm xmlns:a="http://schemas.openxmlformats.org/drawingml/2006/main">
+            <a:off x="393668" y="392240"/>
+            <a:ext cx="1612868" cy="649129"/>
           </a:xfrm>
           <a:prstGeom xmlns:a="http://schemas.openxmlformats.org/drawingml/2006/main" prst="rect">
             <a:avLst/>
@@ -8981,7 +9192,7 @@
         </p:spPr>
         <p:txBody>
           <a:bodyPr xmlns:a="http://schemas.openxmlformats.org/drawingml/2006/main" lIns="0" tIns="0" rIns="0" bIns="0">
-            <a:normAutofit fontScale="100000"/>
+            <a:noAutofit/>
           </a:bodyPr>
           <a:lstStyle xmlns:a="http://schemas.openxmlformats.org/drawingml/2006/main"/>
           <a:p xmlns:a="http://schemas.openxmlformats.org/drawingml/2006/main">
@@ -8997,65 +9208,17 @@
               </a:defRPr>
             </a:pPr>
             <a:r>
-              <a:t>이용 안내</a:t>
-            </a:r>
-          </a:p>
-          <a:p xmlns:a="http://schemas.openxmlformats.org/drawingml/2006/main">
-            <a:pPr algn="l">
-              <a:buNone/>
-              <a:defRPr sz="2400">
-                <a:solidFill>
-                  <a:srgbClr val="000000"/>
-                </a:solidFill>
-                <a:latin typeface="Helvetica Neue"/>
-                <a:ea typeface="Helvetica Neue"/>
-                <a:cs typeface="Helvetica Neue"/>
-              </a:defRPr>
-            </a:pPr>
-            <a:r>
-              <a:t>법적 분류·효능·공장 적합성·원가</a:t>
-            </a:r>
-          </a:p>
-          <a:p xmlns:a="http://schemas.openxmlformats.org/drawingml/2006/main">
-            <a:pPr algn="l">
-              <a:buNone/>
-              <a:defRPr sz="2400">
-                <a:solidFill>
-                  <a:srgbClr val="000000"/>
-                </a:solidFill>
-                <a:latin typeface="Helvetica Neue"/>
-                <a:ea typeface="Helvetica Neue"/>
-                <a:cs typeface="Helvetica Neue"/>
-              </a:defRPr>
-            </a:pPr>
-            <a:r>
-              <a:t>관할기관·시험기관·실제 견적·</a:t>
-            </a:r>
-          </a:p>
-          <a:p xmlns:a="http://schemas.openxmlformats.org/drawingml/2006/main">
-            <a:pPr algn="l">
-              <a:buNone/>
-              <a:defRPr sz="2400">
-                <a:solidFill>
-                  <a:srgbClr val="000000"/>
-                </a:solidFill>
-                <a:latin typeface="Helvetica Neue"/>
-                <a:ea typeface="Helvetica Neue"/>
-                <a:cs typeface="Helvetica Neue"/>
-              </a:defRPr>
-            </a:pPr>
-            <a:r>
-              <a:t>고객 현장에서 별도 확인</a:t>
-            </a:r>
-          </a:p>
-        </p:txBody>
-      </p:sp>
-      <p:sp>
-        <p:nvSpPr>
-          <p:cNvPr id="7" name="brand-rule-16">
-            <a:extLst xmlns:a="http://schemas.openxmlformats.org/drawingml/2006/main">
-              <a:ext uri="{FF2B5EF4-FFF2-40B4-BE49-F238E27FC236}">
-                <a16:creationId xmlns:a16="http://schemas.microsoft.com/office/drawing/2014/main" id="{55BD5789-824C-4804-8B5F-C81E993C9E53}"/>
+              <a:t>승인 요청 · 검증 예산</a:t>
+            </a:r>
+          </a:p>
+        </p:txBody>
+      </p:sp>
+      <p:sp>
+        <p:nvSpPr>
+          <p:cNvPr id="4" name="brand-rule-19">
+            <a:extLst xmlns:a="http://schemas.openxmlformats.org/drawingml/2006/main">
+              <a:ext uri="{FF2B5EF4-FFF2-40B4-BE49-F238E27FC236}">
+                <a16:creationId xmlns:a16="http://schemas.microsoft.com/office/drawing/2014/main" id="{7AAF7002-EC9D-469C-84D7-2EC7F0804319}"/>
               </a:ext>
             </a:extLst>
           </p:cNvPr>
@@ -9085,10 +9248,10 @@
       </p:sp>
       <p:sp>
         <p:nvSpPr>
-          <p:cNvPr id="8" name="brand-footer-16">
-            <a:extLst xmlns:a="http://schemas.openxmlformats.org/drawingml/2006/main">
-              <a:ext uri="{FF2B5EF4-FFF2-40B4-BE49-F238E27FC236}">
-                <a16:creationId xmlns:a16="http://schemas.microsoft.com/office/drawing/2014/main" id="{B551CBFC-E8C9-4FAA-B5CF-AB153853215C}"/>
+          <p:cNvPr id="5" name="brand-footer-19">
+            <a:extLst xmlns:a="http://schemas.openxmlformats.org/drawingml/2006/main">
+              <a:ext uri="{FF2B5EF4-FFF2-40B4-BE49-F238E27FC236}">
+                <a16:creationId xmlns:a16="http://schemas.microsoft.com/office/drawing/2014/main" id="{5673E306-1329-4C06-B385-21CE77F2D44C}"/>
               </a:ext>
             </a:extLst>
           </p:cNvPr>
@@ -9135,7 +9298,7 @@
                 <a:ea typeface="Arial"/>
                 <a:cs typeface="Arial"/>
               </a:rPr>
-              <a:t>GABA BUSINESS MODEL | 19 | APPENDIX</a:t>
+              <a:t>19 | DECISION ASK</a:t>
             </a:r>
           </a:p>
         </p:txBody>
@@ -9143,7 +9306,7 @@
     </p:spTree>
     <p:extLst>
       <p:ext uri="{BB962C8B-B14F-4D97-AF65-F5344CB8AC3E}">
-        <p14:creationId xmlns:p14="http://schemas.microsoft.com/office/powerpoint/2010/main" val="1604558683"/>
+        <p14:creationId xmlns:p14="http://schemas.microsoft.com/office/powerpoint/2010/main" val="1951378401"/>
       </p:ext>
     </p:extLst>
   </p:cSld>
@@ -9203,7 +9366,7 @@
               </a:defRPr>
             </a:pPr>
             <a:r>
-              <a:t>재고는 한 종류만,</a:t>
+              <a:t>원료와 배합사료를 나누고,</a:t>
             </a:r>
           </a:p>
           <a:p xmlns:a="http://schemas.openxmlformats.org/drawingml/2006/main">
@@ -9219,7 +9382,7 @@
               </a:defRPr>
             </a:pPr>
             <a:r>
-              <a:t>네 가지 확인 후 투자한다</a:t>
+              <a:t>검증 기준은 함께 관리한다</a:t>
             </a:r>
           </a:p>
         </p:txBody>
@@ -9265,7 +9428,7 @@
               </a:defRPr>
             </a:pPr>
             <a:r>
-              <a:t>20% MASTER + MAKE-TO-ORDER OEM</a:t>
+              <a:t>GABA CRUDE + GABA CARE MIX</a:t>
             </a:r>
           </a:p>
         </p:txBody>
@@ -9410,6 +9573,580 @@
     <p:extLst>
       <p:ext uri="{BB962C8B-B14F-4D97-AF65-F5344CB8AC3E}">
         <p14:creationId xmlns:p14="http://schemas.microsoft.com/office/powerpoint/2010/main" val="50483475"/>
+      </p:ext>
+    </p:extLst>
+  </p:cSld>
+</p:sld>
+</file>
+
+<file path=ppt/slides/slide20.xml><?xml version="1.0" encoding="utf-8"?>
+<p:sld xmlns:p="http://schemas.openxmlformats.org/presentationml/2006/main">
+  <p:cSld>
+    <p:spTree>
+      <p:nvGrpSpPr>
+        <p:cNvPr id="1" name=""/>
+        <p:cNvGrpSpPr/>
+        <p:nvPr/>
+      </p:nvGrpSpPr>
+      <p:grpSpPr>
+        <a:xfrm xmlns:a="http://schemas.openxmlformats.org/drawingml/2006/main"/>
+      </p:grpSpPr>
+      <p:sp>
+        <p:nvSpPr>
+          <p:cNvPr id="9" name="Slide-Number-Placeholder-1-2">
+            <a:extLst xmlns:a="http://schemas.openxmlformats.org/drawingml/2006/main">
+              <a:ext uri="{FF2B5EF4-FFF2-40B4-BE49-F238E27FC236}">
+                <a16:creationId xmlns:a16="http://schemas.microsoft.com/office/drawing/2014/main" id="{899BFBB6-2B10-416C-B0B8-D3DCD3722082}"/>
+              </a:ext>
+            </a:extLst>
+          </p:cNvPr>
+          <p:cNvSpPr>
+            <a:spLocks xmlns:a="http://schemas.openxmlformats.org/drawingml/2006/main" noGrp="1"/>
+          </p:cNvSpPr>
+          <p:nvPr/>
+        </p:nvSpPr>
+        <p:spPr>
+          <a:xfrm xmlns:a="http://schemas.openxmlformats.org/drawingml/2006/main">
+            <a:off x="11279219" y="6278594"/>
+            <a:ext cx="519113" cy="241268"/>
+          </a:xfrm>
+          <a:prstGeom xmlns:a="http://schemas.openxmlformats.org/drawingml/2006/main" prst="rect">
+            <a:avLst/>
+          </a:prstGeom>
+        </p:spPr>
+        <p:txBody>
+          <a:bodyPr xmlns:a="http://schemas.openxmlformats.org/drawingml/2006/main" lIns="0" tIns="0" rIns="0" bIns="0" anchor="b"/>
+          <a:lstStyle xmlns:a="http://schemas.openxmlformats.org/drawingml/2006/main"/>
+          <a:p xmlns:a="http://schemas.openxmlformats.org/drawingml/2006/main">
+            <a:pPr algn="r">
+              <a:buNone/>
+              <a:defRPr sz="1000">
+                <a:solidFill>
+                  <a:srgbClr val="000000"/>
+                </a:solidFill>
+                <a:latin typeface="Helvetica Neue"/>
+                <a:ea typeface="Helvetica Neue"/>
+                <a:cs typeface="Helvetica Neue"/>
+              </a:defRPr>
+            </a:pPr>
+            <a:r>
+              <a:t>20</a:t>
+            </a:r>
+          </a:p>
+        </p:txBody>
+      </p:sp>
+      <p:sp>
+        <p:nvSpPr>
+          <p:cNvPr id="2" name="Title-2-3">
+            <a:extLst xmlns:a="http://schemas.openxmlformats.org/drawingml/2006/main">
+              <a:ext uri="{FF2B5EF4-FFF2-40B4-BE49-F238E27FC236}">
+                <a16:creationId xmlns:a16="http://schemas.microsoft.com/office/drawing/2014/main" id="{5CFAC748-585C-4584-8553-0EC8E67AB075}"/>
+              </a:ext>
+            </a:extLst>
+          </p:cNvPr>
+          <p:cNvSpPr>
+            <a:spLocks xmlns:a="http://schemas.openxmlformats.org/drawingml/2006/main" noGrp="1"/>
+          </p:cNvSpPr>
+          <p:nvPr/>
+        </p:nvSpPr>
+        <p:spPr>
+          <a:xfrm xmlns:a="http://schemas.openxmlformats.org/drawingml/2006/main">
+            <a:off x="393668" y="344043"/>
+            <a:ext cx="11404568" cy="1047464"/>
+          </a:xfrm>
+          <a:prstGeom xmlns:a="http://schemas.openxmlformats.org/drawingml/2006/main" prst="rect">
+            <a:avLst/>
+          </a:prstGeom>
+        </p:spPr>
+        <p:txBody>
+          <a:bodyPr xmlns:a="http://schemas.openxmlformats.org/drawingml/2006/main" lIns="0" tIns="0" rIns="0" bIns="0" anchor="t">
+            <a:normAutofit fontScale="100000"/>
+          </a:bodyPr>
+          <a:lstStyle xmlns:a="http://schemas.openxmlformats.org/drawingml/2006/main"/>
+          <a:p xmlns:a="http://schemas.openxmlformats.org/drawingml/2006/main">
+            <a:pPr algn="l">
+              <a:buNone/>
+              <a:defRPr sz="2900">
+                <a:solidFill>
+                  <a:srgbClr val="000000"/>
+                </a:solidFill>
+                <a:latin typeface="Helvetica Neue"/>
+                <a:ea typeface="Helvetica Neue"/>
+                <a:cs typeface="Helvetica Neue"/>
+              </a:defRPr>
+            </a:pPr>
+            <a:r>
+              <a:t>APPENDIX · 사업 정의·용어·가정·이용 안내</a:t>
+            </a:r>
+          </a:p>
+        </p:txBody>
+      </p:sp>
+      <p:sp>
+        <p:nvSpPr>
+          <p:cNvPr id="3" name="Content-Placeholder-9-4">
+            <a:extLst xmlns:a="http://schemas.openxmlformats.org/drawingml/2006/main">
+              <a:ext uri="{FF2B5EF4-FFF2-40B4-BE49-F238E27FC236}">
+                <a16:creationId xmlns:a16="http://schemas.microsoft.com/office/drawing/2014/main" id="{34DB5DEF-8114-43EB-BCF8-0B628E7C364A}"/>
+              </a:ext>
+            </a:extLst>
+          </p:cNvPr>
+          <p:cNvSpPr>
+            <a:spLocks xmlns:a="http://schemas.openxmlformats.org/drawingml/2006/main" noGrp="1"/>
+          </p:cNvSpPr>
+          <p:nvPr/>
+        </p:nvSpPr>
+        <p:spPr>
+          <a:xfrm xmlns:a="http://schemas.openxmlformats.org/drawingml/2006/main">
+            <a:off x="393668" y="2031968"/>
+            <a:ext cx="5537168" cy="1643063"/>
+          </a:xfrm>
+          <a:prstGeom xmlns:a="http://schemas.openxmlformats.org/drawingml/2006/main" prst="rect">
+            <a:avLst/>
+          </a:prstGeom>
+        </p:spPr>
+        <p:txBody>
+          <a:bodyPr xmlns:a="http://schemas.openxmlformats.org/drawingml/2006/main" lIns="91440" tIns="45720" rIns="91440" bIns="45720"/>
+          <a:lstStyle xmlns:a="http://schemas.openxmlformats.org/drawingml/2006/main"/>
+          <a:p xmlns:a="http://schemas.openxmlformats.org/drawingml/2006/main">
+            <a:pPr algn="l">
+              <a:buNone/>
+              <a:defRPr sz="2400">
+                <a:solidFill>
+                  <a:srgbClr val="000000"/>
+                </a:solidFill>
+                <a:latin typeface="Helvetica Neue"/>
+                <a:ea typeface="Helvetica Neue"/>
+                <a:cs typeface="Helvetica Neue"/>
+              </a:defRPr>
+            </a:pPr>
+            <a:r>
+              <a:t>사업</a:t>
+            </a:r>
+          </a:p>
+          <a:p xmlns:a="http://schemas.openxmlformats.org/drawingml/2006/main">
+            <a:pPr algn="l">
+              <a:buNone/>
+              <a:defRPr sz="2400">
+                <a:solidFill>
+                  <a:srgbClr val="000000"/>
+                </a:solidFill>
+                <a:latin typeface="Helvetica Neue"/>
+                <a:ea typeface="Helvetica Neue"/>
+                <a:cs typeface="Helvetica Neue"/>
+              </a:defRPr>
+            </a:pPr>
+            <a:r>
+              <a:t>가바크루드=GABA 원료</a:t>
+            </a:r>
+          </a:p>
+          <a:p xmlns:a="http://schemas.openxmlformats.org/drawingml/2006/main">
+            <a:pPr algn="l">
+              <a:buNone/>
+              <a:defRPr sz="2400">
+                <a:solidFill>
+                  <a:srgbClr val="000000"/>
+                </a:solidFill>
+                <a:latin typeface="Helvetica Neue"/>
+                <a:ea typeface="Helvetica Neue"/>
+                <a:cs typeface="Helvetica Neue"/>
+              </a:defRPr>
+            </a:pPr>
+            <a:r>
+              <a:t>가바케어믹스=배합사료</a:t>
+            </a:r>
+          </a:p>
+          <a:p xmlns:a="http://schemas.openxmlformats.org/drawingml/2006/main">
+            <a:pPr algn="l">
+              <a:buNone/>
+              <a:defRPr sz="2400">
+                <a:solidFill>
+                  <a:srgbClr val="000000"/>
+                </a:solidFill>
+                <a:latin typeface="Helvetica Neue"/>
+                <a:ea typeface="Helvetica Neue"/>
+                <a:cs typeface="Helvetica Neue"/>
+              </a:defRPr>
+            </a:pPr>
+            <a:r>
+              <a:t>CAPA=생산가능량</a:t>
+            </a:r>
+          </a:p>
+        </p:txBody>
+      </p:sp>
+      <p:sp>
+        <p:nvSpPr>
+          <p:cNvPr id="4" name="Content-Placeholder-10-5">
+            <a:extLst xmlns:a="http://schemas.openxmlformats.org/drawingml/2006/main">
+              <a:ext uri="{FF2B5EF4-FFF2-40B4-BE49-F238E27FC236}">
+                <a16:creationId xmlns:a16="http://schemas.microsoft.com/office/drawing/2014/main" id="{EFACA7CB-B804-47CA-AB1B-80FE7DDA4BA7}"/>
+              </a:ext>
+            </a:extLst>
+          </p:cNvPr>
+          <p:cNvSpPr>
+            <a:spLocks xmlns:a="http://schemas.openxmlformats.org/drawingml/2006/main" noGrp="1"/>
+          </p:cNvSpPr>
+          <p:nvPr/>
+        </p:nvSpPr>
+        <p:spPr>
+          <a:xfrm xmlns:a="http://schemas.openxmlformats.org/drawingml/2006/main">
+            <a:off x="6256592" y="2031968"/>
+            <a:ext cx="5537168" cy="1643063"/>
+          </a:xfrm>
+          <a:prstGeom xmlns:a="http://schemas.openxmlformats.org/drawingml/2006/main" prst="rect">
+            <a:avLst/>
+          </a:prstGeom>
+        </p:spPr>
+        <p:txBody>
+          <a:bodyPr xmlns:a="http://schemas.openxmlformats.org/drawingml/2006/main" lIns="91440" tIns="45720" rIns="91440" bIns="45720"/>
+          <a:lstStyle xmlns:a="http://schemas.openxmlformats.org/drawingml/2006/main"/>
+          <a:p xmlns:a="http://schemas.openxmlformats.org/drawingml/2006/main">
+            <a:pPr algn="l">
+              <a:buNone/>
+              <a:defRPr sz="2400">
+                <a:solidFill>
+                  <a:srgbClr val="000000"/>
+                </a:solidFill>
+                <a:latin typeface="Helvetica Neue"/>
+                <a:ea typeface="Helvetica Neue"/>
+                <a:cs typeface="Helvetica Neue"/>
+              </a:defRPr>
+            </a:pPr>
+            <a:r>
+              <a:t>용어</a:t>
+            </a:r>
+          </a:p>
+          <a:p xmlns:a="http://schemas.openxmlformats.org/drawingml/2006/main">
+            <a:pPr algn="l">
+              <a:buNone/>
+              <a:defRPr sz="2400">
+                <a:solidFill>
+                  <a:srgbClr val="000000"/>
+                </a:solidFill>
+                <a:latin typeface="Helvetica Neue"/>
+                <a:ea typeface="Helvetica Neue"/>
+                <a:cs typeface="Helvetica Neue"/>
+              </a:defRPr>
+            </a:pPr>
+            <a:r>
+              <a:t>CoA=로트 성적서</a:t>
+            </a:r>
+          </a:p>
+          <a:p xmlns:a="http://schemas.openxmlformats.org/drawingml/2006/main">
+            <a:pPr algn="l">
+              <a:buNone/>
+              <a:defRPr sz="2400">
+                <a:solidFill>
+                  <a:srgbClr val="000000"/>
+                </a:solidFill>
+                <a:latin typeface="Helvetica Neue"/>
+                <a:ea typeface="Helvetica Neue"/>
+                <a:cs typeface="Helvetica Neue"/>
+              </a:defRPr>
+            </a:pPr>
+            <a:r>
+              <a:t>OEM=주문자 상표 부착 생산</a:t>
+            </a:r>
+          </a:p>
+          <a:p xmlns:a="http://schemas.openxmlformats.org/drawingml/2006/main">
+            <a:pPr algn="l">
+              <a:buNone/>
+              <a:defRPr sz="2400">
+                <a:solidFill>
+                  <a:srgbClr val="000000"/>
+                </a:solidFill>
+                <a:latin typeface="Helvetica Neue"/>
+                <a:ea typeface="Helvetica Neue"/>
+                <a:cs typeface="Helvetica Neue"/>
+              </a:defRPr>
+            </a:pPr>
+            <a:r>
+              <a:t>PoV=고객 가치 검증</a:t>
+            </a:r>
+          </a:p>
+        </p:txBody>
+      </p:sp>
+      <p:sp>
+        <p:nvSpPr>
+          <p:cNvPr id="5" name="Content-Placeholder-9-6">
+            <a:extLst xmlns:a="http://schemas.openxmlformats.org/drawingml/2006/main">
+              <a:ext uri="{FF2B5EF4-FFF2-40B4-BE49-F238E27FC236}">
+                <a16:creationId xmlns:a16="http://schemas.microsoft.com/office/drawing/2014/main" id="{234C9D70-A9C5-49B5-8918-C361BF8A333B}"/>
+              </a:ext>
+            </a:extLst>
+          </p:cNvPr>
+          <p:cNvSpPr>
+            <a:spLocks xmlns:a="http://schemas.openxmlformats.org/drawingml/2006/main" noGrp="1"/>
+          </p:cNvSpPr>
+          <p:nvPr/>
+        </p:nvSpPr>
+        <p:spPr>
+          <a:xfrm xmlns:a="http://schemas.openxmlformats.org/drawingml/2006/main">
+            <a:off x="393668" y="4016978"/>
+            <a:ext cx="5537168" cy="1643158"/>
+          </a:xfrm>
+          <a:prstGeom xmlns:a="http://schemas.openxmlformats.org/drawingml/2006/main" prst="rect">
+            <a:avLst/>
+          </a:prstGeom>
+        </p:spPr>
+        <p:txBody>
+          <a:bodyPr xmlns:a="http://schemas.openxmlformats.org/drawingml/2006/main" lIns="0" tIns="0" rIns="0" bIns="0">
+            <a:normAutofit fontScale="100000"/>
+          </a:bodyPr>
+          <a:lstStyle xmlns:a="http://schemas.openxmlformats.org/drawingml/2006/main"/>
+          <a:p xmlns:a="http://schemas.openxmlformats.org/drawingml/2006/main">
+            <a:pPr algn="l">
+              <a:buNone/>
+              <a:defRPr sz="2400">
+                <a:solidFill>
+                  <a:srgbClr val="000000"/>
+                </a:solidFill>
+                <a:latin typeface="Helvetica Neue"/>
+                <a:ea typeface="Helvetica Neue"/>
+                <a:cs typeface="Helvetica Neue"/>
+              </a:defRPr>
+            </a:pPr>
+            <a:r>
+              <a:t>핵심 가정</a:t>
+            </a:r>
+          </a:p>
+          <a:p xmlns:a="http://schemas.openxmlformats.org/drawingml/2006/main">
+            <a:pPr algn="l">
+              <a:buNone/>
+              <a:defRPr sz="2400">
+                <a:solidFill>
+                  <a:srgbClr val="000000"/>
+                </a:solidFill>
+                <a:latin typeface="Helvetica Neue"/>
+                <a:ea typeface="Helvetica Neue"/>
+                <a:cs typeface="Helvetica Neue"/>
+              </a:defRPr>
+            </a:pPr>
+            <a:r>
+              <a:t>18,000원/kg·9,240원/kg</a:t>
+            </a:r>
+          </a:p>
+          <a:p xmlns:a="http://schemas.openxmlformats.org/drawingml/2006/main">
+            <a:pPr algn="l">
+              <a:buNone/>
+              <a:defRPr sz="2400">
+                <a:solidFill>
+                  <a:srgbClr val="000000"/>
+                </a:solidFill>
+                <a:latin typeface="Helvetica Neue"/>
+                <a:ea typeface="Helvetica Neue"/>
+                <a:cs typeface="Helvetica Neue"/>
+              </a:defRPr>
+            </a:pPr>
+            <a:r>
+              <a:t>75g/사료t·4,681.8원/kg</a:t>
+            </a:r>
+          </a:p>
+          <a:p xmlns:a="http://schemas.openxmlformats.org/drawingml/2006/main">
+            <a:pPr algn="l">
+              <a:buNone/>
+              <a:defRPr sz="2400">
+                <a:solidFill>
+                  <a:srgbClr val="000000"/>
+                </a:solidFill>
+                <a:latin typeface="Helvetica Neue"/>
+                <a:ea typeface="Helvetica Neue"/>
+                <a:cs typeface="Helvetica Neue"/>
+              </a:defRPr>
+            </a:pPr>
+            <a:r>
+              <a:t>고객가치 18,000원/t</a:t>
+            </a:r>
+          </a:p>
+        </p:txBody>
+      </p:sp>
+      <p:sp>
+        <p:nvSpPr>
+          <p:cNvPr id="6" name="Content-Placeholder-10-7">
+            <a:extLst xmlns:a="http://schemas.openxmlformats.org/drawingml/2006/main">
+              <a:ext uri="{FF2B5EF4-FFF2-40B4-BE49-F238E27FC236}">
+                <a16:creationId xmlns:a16="http://schemas.microsoft.com/office/drawing/2014/main" id="{1A34C16A-8F7A-4B12-BA58-172260CF0F97}"/>
+              </a:ext>
+            </a:extLst>
+          </p:cNvPr>
+          <p:cNvSpPr>
+            <a:spLocks xmlns:a="http://schemas.openxmlformats.org/drawingml/2006/main" noGrp="1"/>
+          </p:cNvSpPr>
+          <p:nvPr/>
+        </p:nvSpPr>
+        <p:spPr>
+          <a:xfrm xmlns:a="http://schemas.openxmlformats.org/drawingml/2006/main">
+            <a:off x="6256592" y="4016978"/>
+            <a:ext cx="5537168" cy="1643158"/>
+          </a:xfrm>
+          <a:prstGeom xmlns:a="http://schemas.openxmlformats.org/drawingml/2006/main" prst="rect">
+            <a:avLst/>
+          </a:prstGeom>
+        </p:spPr>
+        <p:txBody>
+          <a:bodyPr xmlns:a="http://schemas.openxmlformats.org/drawingml/2006/main" lIns="0" tIns="0" rIns="0" bIns="0">
+            <a:normAutofit fontScale="100000"/>
+          </a:bodyPr>
+          <a:lstStyle xmlns:a="http://schemas.openxmlformats.org/drawingml/2006/main"/>
+          <a:p xmlns:a="http://schemas.openxmlformats.org/drawingml/2006/main">
+            <a:pPr algn="l">
+              <a:buNone/>
+              <a:defRPr sz="2400">
+                <a:solidFill>
+                  <a:srgbClr val="000000"/>
+                </a:solidFill>
+                <a:latin typeface="Helvetica Neue"/>
+                <a:ea typeface="Helvetica Neue"/>
+                <a:cs typeface="Helvetica Neue"/>
+              </a:defRPr>
+            </a:pPr>
+            <a:r>
+              <a:t>이용 안내</a:t>
+            </a:r>
+          </a:p>
+          <a:p xmlns:a="http://schemas.openxmlformats.org/drawingml/2006/main">
+            <a:pPr algn="l">
+              <a:buNone/>
+              <a:defRPr sz="2400">
+                <a:solidFill>
+                  <a:srgbClr val="000000"/>
+                </a:solidFill>
+                <a:latin typeface="Helvetica Neue"/>
+                <a:ea typeface="Helvetica Neue"/>
+                <a:cs typeface="Helvetica Neue"/>
+              </a:defRPr>
+            </a:pPr>
+            <a:r>
+              <a:t>인력·CAPA=사용자 제공 자료</a:t>
+            </a:r>
+          </a:p>
+          <a:p xmlns:a="http://schemas.openxmlformats.org/drawingml/2006/main">
+            <a:pPr algn="l">
+              <a:buNone/>
+              <a:defRPr sz="2400">
+                <a:solidFill>
+                  <a:srgbClr val="000000"/>
+                </a:solidFill>
+                <a:latin typeface="Helvetica Neue"/>
+                <a:ea typeface="Helvetica Neue"/>
+                <a:cs typeface="Helvetica Neue"/>
+              </a:defRPr>
+            </a:pPr>
+            <a:r>
+              <a:t>법적 분류·효능·공장 적합성·원가</a:t>
+            </a:r>
+          </a:p>
+          <a:p xmlns:a="http://schemas.openxmlformats.org/drawingml/2006/main">
+            <a:pPr algn="l">
+              <a:buNone/>
+              <a:defRPr sz="2400">
+                <a:solidFill>
+                  <a:srgbClr val="000000"/>
+                </a:solidFill>
+                <a:latin typeface="Helvetica Neue"/>
+                <a:ea typeface="Helvetica Neue"/>
+                <a:cs typeface="Helvetica Neue"/>
+              </a:defRPr>
+            </a:pPr>
+            <a:r>
+              <a:t>관할기관·시험기관·실제 견적 확인</a:t>
+            </a:r>
+          </a:p>
+        </p:txBody>
+      </p:sp>
+      <p:sp>
+        <p:nvSpPr>
+          <p:cNvPr id="7" name="brand-rule-16">
+            <a:extLst xmlns:a="http://schemas.openxmlformats.org/drawingml/2006/main">
+              <a:ext uri="{FF2B5EF4-FFF2-40B4-BE49-F238E27FC236}">
+                <a16:creationId xmlns:a16="http://schemas.microsoft.com/office/drawing/2014/main" id="{55BD5789-824C-4804-8B5F-C81E993C9E53}"/>
+              </a:ext>
+            </a:extLst>
+          </p:cNvPr>
+          <p:cNvSpPr>
+            <a:spLocks xmlns:a="http://schemas.openxmlformats.org/drawingml/2006/main" noGrp="1"/>
+          </p:cNvSpPr>
+          <p:nvPr/>
+        </p:nvSpPr>
+        <p:spPr>
+          <a:xfrm xmlns:a="http://schemas.openxmlformats.org/drawingml/2006/main">
+            <a:off x="0" y="0"/>
+            <a:ext cx="12192000" cy="66675"/>
+          </a:xfrm>
+          <a:prstGeom xmlns:a="http://schemas.openxmlformats.org/drawingml/2006/main" prst="rect">
+            <a:avLst/>
+          </a:prstGeom>
+          <a:solidFill xmlns:a="http://schemas.openxmlformats.org/drawingml/2006/main">
+            <a:srgbClr val="00A878"/>
+          </a:solidFill>
+          <a:ln xmlns:a="http://schemas.openxmlformats.org/drawingml/2006/main" w="0">
+            <a:solidFill>
+              <a:srgbClr val="00A878"/>
+            </a:solidFill>
+            <a:prstDash val="solid"/>
+          </a:ln>
+        </p:spPr>
+      </p:sp>
+      <p:sp>
+        <p:nvSpPr>
+          <p:cNvPr id="8" name="brand-footer-16">
+            <a:extLst xmlns:a="http://schemas.openxmlformats.org/drawingml/2006/main">
+              <a:ext uri="{FF2B5EF4-FFF2-40B4-BE49-F238E27FC236}">
+                <a16:creationId xmlns:a16="http://schemas.microsoft.com/office/drawing/2014/main" id="{B551CBFC-E8C9-4FAA-B5CF-AB153853215C}"/>
+              </a:ext>
+            </a:extLst>
+          </p:cNvPr>
+          <p:cNvSpPr>
+            <a:spLocks xmlns:a="http://schemas.openxmlformats.org/drawingml/2006/main" noGrp="1"/>
+          </p:cNvSpPr>
+          <p:nvPr/>
+        </p:nvSpPr>
+        <p:spPr>
+          <a:xfrm xmlns:a="http://schemas.openxmlformats.org/drawingml/2006/main">
+            <a:off x="393668" y="6272213"/>
+            <a:ext cx="4953000" cy="238125"/>
+          </a:xfrm>
+          <a:prstGeom xmlns:a="http://schemas.openxmlformats.org/drawingml/2006/main" prst="rect">
+            <a:avLst/>
+          </a:prstGeom>
+          <a:noFill xmlns:a="http://schemas.openxmlformats.org/drawingml/2006/main"/>
+          <a:ln xmlns:a="http://schemas.openxmlformats.org/drawingml/2006/main" w="0">
+            <a:noFill/>
+            <a:prstDash val="solid"/>
+          </a:ln>
+        </p:spPr>
+        <p:txBody>
+          <a:bodyPr xmlns:a="http://schemas.openxmlformats.org/drawingml/2006/main"/>
+          <a:lstStyle xmlns:a="http://schemas.openxmlformats.org/drawingml/2006/main"/>
+          <a:p xmlns:a="http://schemas.openxmlformats.org/drawingml/2006/main">
+            <a:pPr>
+              <a:buNone/>
+              <a:defRPr sz="1000" b="1">
+                <a:solidFill>
+                  <a:srgbClr val="667085"/>
+                </a:solidFill>
+                <a:latin typeface="Arial"/>
+                <a:ea typeface="Arial"/>
+                <a:cs typeface="Arial"/>
+              </a:defRPr>
+            </a:pPr>
+            <a:r>
+              <a:rPr sz="1000" b="1">
+                <a:solidFill>
+                  <a:srgbClr val="667085"/>
+                </a:solidFill>
+                <a:latin typeface="Arial"/>
+                <a:ea typeface="Arial"/>
+                <a:cs typeface="Arial"/>
+              </a:rPr>
+              <a:t>GABA BUSINESS MODEL | 20 | APPENDIX</a:t>
+            </a:r>
+          </a:p>
+        </p:txBody>
+      </p:sp>
+    </p:spTree>
+    <p:extLst>
+      <p:ext uri="{BB962C8B-B14F-4D97-AF65-F5344CB8AC3E}">
+        <p14:creationId xmlns:p14="http://schemas.microsoft.com/office/powerpoint/2010/main" val="1604558683"/>
       </p:ext>
     </p:extLst>
   </p:cSld>
@@ -9513,7 +10250,7 @@
               </a:defRPr>
             </a:pPr>
             <a:r>
-              <a:t>완제품 네 종류 대신, 품질을 확인할 수 있는 마스터만 보유한다</a:t>
+              <a:t>가바크루드가 원료 매출을 만들고, 가바케어믹스가 고객 현장으로 확장한다</a:t>
             </a:r>
           </a:p>
         </p:txBody>
@@ -9662,7 +10399,7 @@
               </a:defRPr>
             </a:pPr>
             <a:r>
-              <a:t>원배양액</a:t>
+              <a:t>기준 원료</a:t>
             </a:r>
           </a:p>
         </p:txBody>
@@ -9708,7 +10445,7 @@
               </a:defRPr>
             </a:pPr>
             <a:r>
-              <a:t>20% 마스터</a:t>
+              <a:t>맞춤 원료</a:t>
             </a:r>
           </a:p>
         </p:txBody>
@@ -9754,7 +10491,7 @@
               </a:defRPr>
             </a:pPr>
             <a:r>
-              <a:t>주문형 제품</a:t>
+              <a:t>배합사료</a:t>
             </a:r>
           </a:p>
         </p:txBody>
@@ -9800,55 +10537,39 @@
               </a:defRPr>
             </a:pPr>
             <a:r>
-              <a:t>기본 재고</a:t>
-            </a:r>
-          </a:p>
-          <a:p xmlns:a="http://schemas.openxmlformats.org/drawingml/2006/main">
-            <a:pPr algn="l">
-              <a:buNone/>
-              <a:defRPr sz="2400">
-                <a:solidFill>
-                  <a:srgbClr val="000000"/>
-                </a:solidFill>
-                <a:latin typeface="Helvetica Neue"/>
-                <a:ea typeface="Helvetica Neue"/>
-                <a:cs typeface="Helvetica Neue"/>
-              </a:defRPr>
-            </a:pPr>
-            <a:r>
-              <a:t>500kg/배치</a:t>
-            </a:r>
-          </a:p>
-          <a:p xmlns:a="http://schemas.openxmlformats.org/drawingml/2006/main">
-            <a:pPr algn="l">
-              <a:buNone/>
-              <a:defRPr sz="2400">
-                <a:solidFill>
-                  <a:srgbClr val="000000"/>
-                </a:solidFill>
-                <a:latin typeface="Helvetica Neue"/>
-                <a:ea typeface="Helvetica Neue"/>
-                <a:cs typeface="Helvetica Neue"/>
-              </a:defRPr>
-            </a:pPr>
-            <a:r>
-              <a:t>로트·CoA 관리</a:t>
-            </a:r>
-          </a:p>
-          <a:p xmlns:a="http://schemas.openxmlformats.org/drawingml/2006/main">
-            <a:pPr algn="l">
-              <a:buNone/>
-              <a:defRPr sz="2400">
-                <a:solidFill>
-                  <a:srgbClr val="000000"/>
-                </a:solidFill>
-                <a:latin typeface="Helvetica Neue"/>
-                <a:ea typeface="Helvetica Neue"/>
-                <a:cs typeface="Helvetica Neue"/>
-              </a:defRPr>
-            </a:pPr>
-            <a:r>
-              <a:t>FIFO 출고</a:t>
+              <a:t>GABA 20% 기준품</a:t>
+            </a:r>
+          </a:p>
+          <a:p xmlns:a="http://schemas.openxmlformats.org/drawingml/2006/main">
+            <a:pPr algn="l">
+              <a:buNone/>
+              <a:defRPr sz="2400">
+                <a:solidFill>
+                  <a:srgbClr val="000000"/>
+                </a:solidFill>
+                <a:latin typeface="Helvetica Neue"/>
+                <a:ea typeface="Helvetica Neue"/>
+                <a:cs typeface="Helvetica Neue"/>
+              </a:defRPr>
+            </a:pPr>
+            <a:r>
+              <a:t>품질·출하 기준</a:t>
+            </a:r>
+          </a:p>
+          <a:p xmlns:a="http://schemas.openxmlformats.org/drawingml/2006/main">
+            <a:pPr algn="l">
+              <a:buNone/>
+              <a:defRPr sz="2400">
+                <a:solidFill>
+                  <a:srgbClr val="000000"/>
+                </a:solidFill>
+                <a:latin typeface="Helvetica Neue"/>
+                <a:ea typeface="Helvetica Neue"/>
+                <a:cs typeface="Helvetica Neue"/>
+              </a:defRPr>
+            </a:pPr>
+            <a:r>
+              <a:t>로트별 CoA</a:t>
             </a:r>
           </a:p>
         </p:txBody>
@@ -9894,55 +10615,39 @@
               </a:defRPr>
             </a:pPr>
             <a:r>
-              <a:t>보류</a:t>
-            </a:r>
-          </a:p>
-          <a:p xmlns:a="http://schemas.openxmlformats.org/drawingml/2006/main">
-            <a:pPr algn="l">
-              <a:buNone/>
-              <a:defRPr sz="2400">
-                <a:solidFill>
-                  <a:srgbClr val="000000"/>
-                </a:solidFill>
-                <a:latin typeface="Helvetica Neue"/>
-                <a:ea typeface="Helvetica Neue"/>
-                <a:cs typeface="Helvetica Neue"/>
-              </a:defRPr>
-            </a:pPr>
-            <a:r>
-              <a:t>역가·미생물 변동</a:t>
-            </a:r>
-          </a:p>
-          <a:p xmlns:a="http://schemas.openxmlformats.org/drawingml/2006/main">
-            <a:pPr algn="l">
-              <a:buNone/>
-              <a:defRPr sz="2400">
-                <a:solidFill>
-                  <a:srgbClr val="000000"/>
-                </a:solidFill>
-                <a:latin typeface="Helvetica Neue"/>
-                <a:ea typeface="Helvetica Neue"/>
-                <a:cs typeface="Helvetica Neue"/>
-              </a:defRPr>
-            </a:pPr>
-            <a:r>
-              <a:t>보존·운송 불확실</a:t>
-            </a:r>
-          </a:p>
-          <a:p xmlns:a="http://schemas.openxmlformats.org/drawingml/2006/main">
-            <a:pPr algn="l">
-              <a:buNone/>
-              <a:defRPr sz="2400">
-                <a:solidFill>
-                  <a:srgbClr val="000000"/>
-                </a:solidFill>
-                <a:latin typeface="Helvetica Neue"/>
-                <a:ea typeface="Helvetica Neue"/>
-                <a:cs typeface="Helvetica Neue"/>
-              </a:defRPr>
-            </a:pPr>
-            <a:r>
-              <a:t>직납 기본안 아님</a:t>
+              <a:t>OEM 5~20%</a:t>
+            </a:r>
+          </a:p>
+          <a:p xmlns:a="http://schemas.openxmlformats.org/drawingml/2006/main">
+            <a:pPr algn="l">
+              <a:buNone/>
+              <a:defRPr sz="2400">
+                <a:solidFill>
+                  <a:srgbClr val="000000"/>
+                </a:solidFill>
+                <a:latin typeface="Helvetica Neue"/>
+                <a:ea typeface="Helvetica Neue"/>
+                <a:cs typeface="Helvetica Neue"/>
+              </a:defRPr>
+            </a:pPr>
+            <a:r>
+              <a:t>고객 주문 후 생산</a:t>
+            </a:r>
+          </a:p>
+          <a:p xmlns:a="http://schemas.openxmlformats.org/drawingml/2006/main">
+            <a:pPr algn="l">
+              <a:buNone/>
+              <a:defRPr sz="2400">
+                <a:solidFill>
+                  <a:srgbClr val="000000"/>
+                </a:solidFill>
+                <a:latin typeface="Helvetica Neue"/>
+                <a:ea typeface="Helvetica Neue"/>
+                <a:cs typeface="Helvetica Neue"/>
+              </a:defRPr>
+            </a:pPr>
+            <a:r>
+              <a:t>농도·포장 맞춤</a:t>
             </a:r>
           </a:p>
         </p:txBody>
@@ -9988,55 +10693,39 @@
               </a:defRPr>
             </a:pPr>
             <a:r>
-              <a:t>PO 후 생산</a:t>
-            </a:r>
-          </a:p>
-          <a:p xmlns:a="http://schemas.openxmlformats.org/drawingml/2006/main">
-            <a:pPr algn="l">
-              <a:buNone/>
-              <a:defRPr sz="2400">
-                <a:solidFill>
-                  <a:srgbClr val="000000"/>
-                </a:solidFill>
-                <a:latin typeface="Helvetica Neue"/>
-                <a:ea typeface="Helvetica Neue"/>
-                <a:cs typeface="Helvetica Neue"/>
-              </a:defRPr>
-            </a:pPr>
-            <a:r>
-              <a:t>5·10·15·20%</a:t>
-            </a:r>
-          </a:p>
-          <a:p xmlns:a="http://schemas.openxmlformats.org/drawingml/2006/main">
-            <a:pPr algn="l">
-              <a:buNone/>
-              <a:defRPr sz="2400">
-                <a:solidFill>
-                  <a:srgbClr val="000000"/>
-                </a:solidFill>
-                <a:latin typeface="Helvetica Neue"/>
-                <a:ea typeface="Helvetica Neue"/>
-                <a:cs typeface="Helvetica Neue"/>
-              </a:defRPr>
-            </a:pPr>
-            <a:r>
-              <a:t>OEM 혼합·포장</a:t>
-            </a:r>
-          </a:p>
-          <a:p xmlns:a="http://schemas.openxmlformats.org/drawingml/2006/main">
-            <a:pPr algn="l">
-              <a:buNone/>
-              <a:defRPr sz="2400">
-                <a:solidFill>
-                  <a:srgbClr val="000000"/>
-                </a:solidFill>
-                <a:latin typeface="Helvetica Neue"/>
-                <a:ea typeface="Helvetica Neue"/>
-                <a:cs typeface="Helvetica Neue"/>
-              </a:defRPr>
-            </a:pPr>
-            <a:r>
-              <a:t>미리 만든 완제품 0kg</a:t>
+              <a:t>가바크루드+</a:t>
+            </a:r>
+          </a:p>
+          <a:p xmlns:a="http://schemas.openxmlformats.org/drawingml/2006/main">
+            <a:pPr algn="l">
+              <a:buNone/>
+              <a:defRPr sz="2400">
+                <a:solidFill>
+                  <a:srgbClr val="000000"/>
+                </a:solidFill>
+                <a:latin typeface="Helvetica Neue"/>
+                <a:ea typeface="Helvetica Neue"/>
+                <a:cs typeface="Helvetica Neue"/>
+              </a:defRPr>
+            </a:pPr>
+            <a:r>
+              <a:t>미네랄매트릭스</a:t>
+            </a:r>
+          </a:p>
+          <a:p xmlns:a="http://schemas.openxmlformats.org/drawingml/2006/main">
+            <a:pPr algn="l">
+              <a:buNone/>
+              <a:defRPr sz="2400">
+                <a:solidFill>
+                  <a:srgbClr val="000000"/>
+                </a:solidFill>
+                <a:latin typeface="Helvetica Neue"/>
+                <a:ea typeface="Helvetica Neue"/>
+                <a:cs typeface="Helvetica Neue"/>
+              </a:defRPr>
+            </a:pPr>
+            <a:r>
+              <a:t>축종별 맞춤 배합</a:t>
             </a:r>
           </a:p>
         </p:txBody>
@@ -10126,7 +10815,7 @@
                 <a:ea typeface="Arial"/>
                 <a:cs typeface="Arial"/>
               </a:rPr>
-              <a:t>GABA BUSINESS MODEL | 03 | INVENTORY ANSWER</a:t>
+              <a:t>GABA BUSINESS MODEL | 03 | TWO BUSINESS TRACKS</a:t>
             </a:r>
           </a:p>
         </p:txBody>
@@ -10238,7 +10927,7 @@
               </a:defRPr>
             </a:pPr>
             <a:r>
-              <a:t>배양액을 표준 마스터로 만든 뒤, 고객 주문에 맞춰 제품화한다</a:t>
+              <a:t>가바크루드는 GABA 20% 기준품을 축으로 주문 농도까지 확장한다</a:t>
             </a:r>
           </a:p>
         </p:txBody>
@@ -10387,7 +11076,7 @@
               </a:defRPr>
             </a:pPr>
             <a:r>
-              <a:t>공통 중간물</a:t>
+              <a:t>원료의 출발점</a:t>
             </a:r>
           </a:p>
         </p:txBody>
@@ -10479,7 +11168,7 @@
               </a:defRPr>
             </a:pPr>
             <a:r>
-              <a:t>주문형 매출</a:t>
+              <a:t>주문형 원료</a:t>
             </a:r>
           </a:p>
         </p:txBody>
@@ -10525,55 +11214,55 @@
               </a:defRPr>
             </a:pPr>
             <a:r>
-              <a:t>20% 마스터</a:t>
-            </a:r>
-          </a:p>
-          <a:p xmlns:a="http://schemas.openxmlformats.org/drawingml/2006/main">
-            <a:pPr algn="l">
-              <a:buNone/>
-              <a:defRPr sz="2400">
-                <a:solidFill>
-                  <a:srgbClr val="000000"/>
-                </a:solidFill>
-                <a:latin typeface="Helvetica Neue"/>
-                <a:ea typeface="Helvetica Neue"/>
-                <a:cs typeface="Helvetica Neue"/>
-              </a:defRPr>
-            </a:pPr>
-            <a:r>
-              <a:t>500kg/배치</a:t>
-            </a:r>
-          </a:p>
-          <a:p xmlns:a="http://schemas.openxmlformats.org/drawingml/2006/main">
-            <a:pPr algn="l">
-              <a:buNone/>
-              <a:defRPr sz="2400">
-                <a:solidFill>
-                  <a:srgbClr val="000000"/>
-                </a:solidFill>
-                <a:latin typeface="Helvetica Neue"/>
-                <a:ea typeface="Helvetica Neue"/>
-                <a:cs typeface="Helvetica Neue"/>
-              </a:defRPr>
-            </a:pPr>
-            <a:r>
-              <a:t>내부 생산·보관</a:t>
-            </a:r>
-          </a:p>
-          <a:p xmlns:a="http://schemas.openxmlformats.org/drawingml/2006/main">
-            <a:pPr algn="l">
-              <a:buNone/>
-              <a:defRPr sz="2400">
-                <a:solidFill>
-                  <a:srgbClr val="000000"/>
-                </a:solidFill>
-                <a:latin typeface="Helvetica Neue"/>
-                <a:ea typeface="Helvetica Neue"/>
-                <a:cs typeface="Helvetica Neue"/>
-              </a:defRPr>
-            </a:pPr>
-            <a:r>
-              <a:t>규격의 기준점</a:t>
+              <a:t>GABA 20% 기준품</a:t>
+            </a:r>
+          </a:p>
+          <a:p xmlns:a="http://schemas.openxmlformats.org/drawingml/2006/main">
+            <a:pPr algn="l">
+              <a:buNone/>
+              <a:defRPr sz="2400">
+                <a:solidFill>
+                  <a:srgbClr val="000000"/>
+                </a:solidFill>
+                <a:latin typeface="Helvetica Neue"/>
+                <a:ea typeface="Helvetica Neue"/>
+                <a:cs typeface="Helvetica Neue"/>
+              </a:defRPr>
+            </a:pPr>
+            <a:r>
+              <a:t>로트·CoA 관리</a:t>
+            </a:r>
+          </a:p>
+          <a:p xmlns:a="http://schemas.openxmlformats.org/drawingml/2006/main">
+            <a:pPr algn="l">
+              <a:buNone/>
+              <a:defRPr sz="2400">
+                <a:solidFill>
+                  <a:srgbClr val="000000"/>
+                </a:solidFill>
+                <a:latin typeface="Helvetica Neue"/>
+                <a:ea typeface="Helvetica Neue"/>
+                <a:cs typeface="Helvetica Neue"/>
+              </a:defRPr>
+            </a:pPr>
+            <a:r>
+              <a:t>품질·출하 기준</a:t>
+            </a:r>
+          </a:p>
+          <a:p xmlns:a="http://schemas.openxmlformats.org/drawingml/2006/main">
+            <a:pPr algn="l">
+              <a:buNone/>
+              <a:defRPr sz="2400">
+                <a:solidFill>
+                  <a:srgbClr val="000000"/>
+                </a:solidFill>
+                <a:latin typeface="Helvetica Neue"/>
+                <a:ea typeface="Helvetica Neue"/>
+                <a:cs typeface="Helvetica Neue"/>
+              </a:defRPr>
+            </a:pPr>
+            <a:r>
+              <a:t>재고 집중</a:t>
             </a:r>
           </a:p>
         </p:txBody>
@@ -10635,7 +11324,7 @@
               </a:defRPr>
             </a:pPr>
             <a:r>
-              <a:t>GABA·고형분 생성</a:t>
+              <a:t>정밀발효·정제</a:t>
             </a:r>
           </a:p>
           <a:p xmlns:a="http://schemas.openxmlformats.org/drawingml/2006/main">
@@ -10667,7 +11356,7 @@
               </a:defRPr>
             </a:pPr>
             <a:r>
-              <a:t>직접 판매는 보류</a:t>
+              <a:t>기준품 원료</a:t>
             </a:r>
           </a:p>
         </p:txBody>
@@ -10713,55 +11402,55 @@
               </a:defRPr>
             </a:pPr>
             <a:r>
-              <a:t>OEM 완제품</a:t>
-            </a:r>
-          </a:p>
-          <a:p xmlns:a="http://schemas.openxmlformats.org/drawingml/2006/main">
-            <a:pPr algn="l">
-              <a:buNone/>
-              <a:defRPr sz="2400">
-                <a:solidFill>
-                  <a:srgbClr val="000000"/>
-                </a:solidFill>
-                <a:latin typeface="Helvetica Neue"/>
-                <a:ea typeface="Helvetica Neue"/>
-                <a:cs typeface="Helvetica Neue"/>
-              </a:defRPr>
-            </a:pPr>
-            <a:r>
-              <a:t>5·10·15·20%</a:t>
-            </a:r>
-          </a:p>
-          <a:p xmlns:a="http://schemas.openxmlformats.org/drawingml/2006/main">
-            <a:pPr algn="l">
-              <a:buNone/>
-              <a:defRPr sz="2400">
-                <a:solidFill>
-                  <a:srgbClr val="000000"/>
-                </a:solidFill>
-                <a:latin typeface="Helvetica Neue"/>
-                <a:ea typeface="Helvetica Neue"/>
-                <a:cs typeface="Helvetica Neue"/>
-              </a:defRPr>
-            </a:pPr>
-            <a:r>
-              <a:t>담체·포장 맞춤</a:t>
-            </a:r>
-          </a:p>
-          <a:p xmlns:a="http://schemas.openxmlformats.org/drawingml/2006/main">
-            <a:pPr algn="l">
-              <a:buNone/>
-              <a:defRPr sz="2400">
-                <a:solidFill>
-                  <a:srgbClr val="000000"/>
-                </a:solidFill>
-                <a:latin typeface="Helvetica Neue"/>
-                <a:ea typeface="Helvetica Neue"/>
-                <a:cs typeface="Helvetica Neue"/>
-              </a:defRPr>
-            </a:pPr>
-            <a:r>
-              <a:t>고객 PO 후 생산</a:t>
+              <a:t>OEM 5~20%</a:t>
+            </a:r>
+          </a:p>
+          <a:p xmlns:a="http://schemas.openxmlformats.org/drawingml/2006/main">
+            <a:pPr algn="l">
+              <a:buNone/>
+              <a:defRPr sz="2400">
+                <a:solidFill>
+                  <a:srgbClr val="000000"/>
+                </a:solidFill>
+                <a:latin typeface="Helvetica Neue"/>
+                <a:ea typeface="Helvetica Neue"/>
+                <a:cs typeface="Helvetica Neue"/>
+              </a:defRPr>
+            </a:pPr>
+            <a:r>
+              <a:t>농도·포장 맞춤</a:t>
+            </a:r>
+          </a:p>
+          <a:p xmlns:a="http://schemas.openxmlformats.org/drawingml/2006/main">
+            <a:pPr algn="l">
+              <a:buNone/>
+              <a:defRPr sz="2400">
+                <a:solidFill>
+                  <a:srgbClr val="000000"/>
+                </a:solidFill>
+                <a:latin typeface="Helvetica Neue"/>
+                <a:ea typeface="Helvetica Neue"/>
+                <a:cs typeface="Helvetica Neue"/>
+              </a:defRPr>
+            </a:pPr>
+            <a:r>
+              <a:t>고객 발주 후 생산</a:t>
+            </a:r>
+          </a:p>
+          <a:p xmlns:a="http://schemas.openxmlformats.org/drawingml/2006/main">
+            <a:pPr algn="l">
+              <a:buNone/>
+              <a:defRPr sz="2400">
+                <a:solidFill>
+                  <a:srgbClr val="000000"/>
+                </a:solidFill>
+                <a:latin typeface="Helvetica Neue"/>
+                <a:ea typeface="Helvetica Neue"/>
+                <a:cs typeface="Helvetica Neue"/>
+              </a:defRPr>
+            </a:pPr>
+            <a:r>
+              <a:t>원료 매출</a:t>
             </a:r>
           </a:p>
         </p:txBody>
@@ -10851,7 +11540,7 @@
                 <a:ea typeface="Arial"/>
                 <a:cs typeface="Arial"/>
               </a:rPr>
-              <a:t>GABA BUSINESS MODEL | 04 | MASTER-TO-ORDER</a:t>
+              <a:t>GABA BUSINESS MODEL | 04 | GABA CRUDE</a:t>
             </a:r>
           </a:p>
         </p:txBody>
@@ -11050,7 +11739,7 @@
               </a:defRPr>
             </a:pPr>
             <a:r>
-              <a:t>kg당 9,240원의 세부 원가는 아직 확인되지 않았다</a:t>
+              <a:t>가바크루드 기준품의 kg당 9,240원 원가는 세부 내역 확인이 필요하다</a:t>
             </a:r>
           </a:p>
         </p:txBody>
@@ -11510,7 +12199,7 @@
                 <a:ea typeface="Arial"/>
                 <a:cs typeface="Arial"/>
               </a:rPr>
-              <a:t>GABA BUSINESS MODEL | 05 | COST BRIDGE</a:t>
+              <a:t>GABA BUSINESS MODEL | 05 | GABA CRUDE COST</a:t>
             </a:r>
           </a:p>
         </p:txBody>
@@ -11622,7 +12311,7 @@
               </a:defRPr>
             </a:pPr>
             <a:r>
-              <a:t>20% 마스터만 재고로 두면 폐기와 사양 변경 위험을 줄일 수 있다</a:t>
+              <a:t>가바크루드 20% 기준품에 재고를 집중하면 폐기와 사양 변경 위험이 줄어든다</a:t>
             </a:r>
           </a:p>
         </p:txBody>
@@ -11682,7 +12371,7 @@
               </a:defRPr>
             </a:pPr>
             <a:r>
-              <a:t>배양액→20% 마스터</a:t>
+              <a:t>배양액→가바크루드</a:t>
             </a:r>
           </a:p>
           <a:p xmlns:a="http://schemas.openxmlformats.org/drawingml/2006/main">
@@ -12084,7 +12773,7 @@
                 <a:ea typeface="Arial"/>
                 <a:cs typeface="Arial"/>
               </a:rPr>
-              <a:t>GABA BUSINESS MODEL | 06 | SINGLE-SKU POLICY</a:t>
+              <a:t>GABA BUSINESS MODEL | 06 | GABA CRUDE INVENTORY</a:t>
             </a:r>
           </a:p>
         </p:txBody>
@@ -12196,7 +12885,7 @@
               </a:defRPr>
             </a:pPr>
             <a:r>
-              <a:t>발주서와 제품 규격을 확인한 뒤 OEM 생산을 시작한다</a:t>
+              <a:t>가바크루드 주문 농도와 발주서를 확인한 뒤 OEM 생산을 시작한다</a:t>
             </a:r>
           </a:p>
         </p:txBody>
@@ -12809,7 +13498,7 @@
                 <a:ea typeface="Arial"/>
                 <a:cs typeface="Arial"/>
               </a:rPr>
-              <a:t>GABA BUSINESS MODEL | 07 | MAKE-TO-ORDER FLOW</a:t>
+              <a:t>GABA BUSINESS MODEL | 07 | GABA CRUDE OEM FLOW</a:t>
             </a:r>
           </a:p>
         </p:txBody>
@@ -12921,7 +13610,7 @@
               </a:defRPr>
             </a:pPr>
             <a:r>
-              <a:t>첫 계약 전에 품목 분류와 공장 품질 체계를 서면으로 확인한다</a:t>
+              <a:t>두 사업 모두 첫 계약 전에 품목 분류와 공장 품질 체계를 서면으로 확인한다</a:t>
             </a:r>
           </a:p>
         </p:txBody>
@@ -13383,7 +14072,7 @@
                 <a:ea typeface="Arial"/>
                 <a:cs typeface="Arial"/>
               </a:rPr>
-              <a:t>GABA BUSINESS MODEL | 08 | REGULATORY &amp; QA GATES</a:t>
+              <a:t>GABA BUSINESS MODEL | 08 | REGULATORY &amp; QA CHECKS</a:t>
             </a:r>
           </a:p>
         </p:txBody>
@@ -13582,7 +14271,7 @@
               </a:defRPr>
             </a:pPr>
             <a:r>
-              <a:t>GABA 가능성은 보이지만, 효과는 축종·제형·용량마다 달랐다</a:t>
+              <a:t>가바케어믹스의 현장 가치는 축종·제형·용량을 정한 시험에서 확인해야 한다</a:t>
             </a:r>
           </a:p>
         </p:txBody>
@@ -14058,7 +14747,7 @@
                 <a:ea typeface="Arial"/>
                 <a:cs typeface="Arial"/>
               </a:rPr>
-              <a:t>GABA BUSINESS MODEL | 09 | EVIDENCE REALITY</a:t>
+              <a:t>GABA BUSINESS MODEL | 09 | GABA CARE MIX EVIDENCE</a:t>
             </a:r>
           </a:p>
         </p:txBody>

</xml_diff>

<commit_message>
feat: advance CareMix for branded Hanwoo validation
</commit_message>
<xml_diff>
--- a/GABA_Feed_Business_Model_Speech_Deck_v1.pptx
+++ b/GABA_Feed_Business_Model_Speech_Deck_v1.pptx
@@ -2,32 +2,32 @@
 <file path=ppt/presentation.xml><?xml version="1.0" encoding="utf-8"?>
 <p:presentation xmlns:p="http://schemas.openxmlformats.org/presentationml/2006/main">
   <p:sldMasterIdLst>
-    <p:sldMasterId xmlns:r="http://schemas.openxmlformats.org/officeDocument/2006/relationships" id="2147483648" r:id="R23b2f4b2b0bc4d4e"/>
+    <p:sldMasterId xmlns:r="http://schemas.openxmlformats.org/officeDocument/2006/relationships" id="2147483648" r:id="R2771d6ecf9194c5b"/>
   </p:sldMasterIdLst>
   <p:notesMasterIdLst>
-    <p:notesMasterId xmlns:r="http://schemas.openxmlformats.org/officeDocument/2006/relationships" r:id="Rd45be563a9784949"/>
+    <p:notesMasterId xmlns:r="http://schemas.openxmlformats.org/officeDocument/2006/relationships" r:id="R9cfbc2d8790d4810"/>
   </p:notesMasterIdLst>
   <p:sldIdLst>
-    <p:sldId xmlns:r="http://schemas.openxmlformats.org/officeDocument/2006/relationships" id="256" r:id="R0771553f57cd47bf"/>
-    <p:sldId xmlns:r="http://schemas.openxmlformats.org/officeDocument/2006/relationships" id="257" r:id="R4789fc1fa3ba45e8"/>
-    <p:sldId xmlns:r="http://schemas.openxmlformats.org/officeDocument/2006/relationships" id="258" r:id="Re167f1bb8a8b485f"/>
-    <p:sldId xmlns:r="http://schemas.openxmlformats.org/officeDocument/2006/relationships" id="259" r:id="Raf0482924f844156"/>
-    <p:sldId xmlns:r="http://schemas.openxmlformats.org/officeDocument/2006/relationships" id="260" r:id="R15544ece48e048b1"/>
-    <p:sldId xmlns:r="http://schemas.openxmlformats.org/officeDocument/2006/relationships" id="261" r:id="R084c648901f34139"/>
-    <p:sldId xmlns:r="http://schemas.openxmlformats.org/officeDocument/2006/relationships" id="262" r:id="R7bb0df0478f4442f"/>
-    <p:sldId xmlns:r="http://schemas.openxmlformats.org/officeDocument/2006/relationships" id="263" r:id="Rf13056fbfdec4fb7"/>
-    <p:sldId xmlns:r="http://schemas.openxmlformats.org/officeDocument/2006/relationships" id="264" r:id="Rfaabb8ad912140b5"/>
-    <p:sldId xmlns:r="http://schemas.openxmlformats.org/officeDocument/2006/relationships" id="265" r:id="R350f45f6bd684f17"/>
-    <p:sldId xmlns:r="http://schemas.openxmlformats.org/officeDocument/2006/relationships" id="266" r:id="R35d054d2b1b84a79"/>
-    <p:sldId xmlns:r="http://schemas.openxmlformats.org/officeDocument/2006/relationships" id="267" r:id="R645c896dfe364a63"/>
-    <p:sldId xmlns:r="http://schemas.openxmlformats.org/officeDocument/2006/relationships" id="268" r:id="Rb346897b1f854083"/>
-    <p:sldId xmlns:r="http://schemas.openxmlformats.org/officeDocument/2006/relationships" id="269" r:id="Rb4243cea195d4637"/>
-    <p:sldId xmlns:r="http://schemas.openxmlformats.org/officeDocument/2006/relationships" id="270" r:id="Rcbfcc3ec0c9341be"/>
-    <p:sldId xmlns:r="http://schemas.openxmlformats.org/officeDocument/2006/relationships" id="271" r:id="R4e463d64aea0489a"/>
-    <p:sldId xmlns:r="http://schemas.openxmlformats.org/officeDocument/2006/relationships" id="272" r:id="Rab76e8785970448a"/>
-    <p:sldId xmlns:r="http://schemas.openxmlformats.org/officeDocument/2006/relationships" id="273" r:id="R4bfc68dc3daa4e0a"/>
-    <p:sldId xmlns:r="http://schemas.openxmlformats.org/officeDocument/2006/relationships" id="274" r:id="R873e928d48834c36"/>
-    <p:sldId xmlns:r="http://schemas.openxmlformats.org/officeDocument/2006/relationships" id="275" r:id="Rd175f4c199a94447"/>
+    <p:sldId xmlns:r="http://schemas.openxmlformats.org/officeDocument/2006/relationships" id="256" r:id="R56f6f5e5d5c3485f"/>
+    <p:sldId xmlns:r="http://schemas.openxmlformats.org/officeDocument/2006/relationships" id="257" r:id="R4d78884ac22e4785"/>
+    <p:sldId xmlns:r="http://schemas.openxmlformats.org/officeDocument/2006/relationships" id="258" r:id="R891c0b33d9804bd7"/>
+    <p:sldId xmlns:r="http://schemas.openxmlformats.org/officeDocument/2006/relationships" id="259" r:id="Ra7ab92d1e40144bc"/>
+    <p:sldId xmlns:r="http://schemas.openxmlformats.org/officeDocument/2006/relationships" id="260" r:id="R655397d7018f4f40"/>
+    <p:sldId xmlns:r="http://schemas.openxmlformats.org/officeDocument/2006/relationships" id="261" r:id="R1bf43133737c4481"/>
+    <p:sldId xmlns:r="http://schemas.openxmlformats.org/officeDocument/2006/relationships" id="262" r:id="R7322ca95164d456d"/>
+    <p:sldId xmlns:r="http://schemas.openxmlformats.org/officeDocument/2006/relationships" id="263" r:id="Ra03a1c3a4622450f"/>
+    <p:sldId xmlns:r="http://schemas.openxmlformats.org/officeDocument/2006/relationships" id="264" r:id="Rf5562a501deb4036"/>
+    <p:sldId xmlns:r="http://schemas.openxmlformats.org/officeDocument/2006/relationships" id="265" r:id="Recea583a17c7496c"/>
+    <p:sldId xmlns:r="http://schemas.openxmlformats.org/officeDocument/2006/relationships" id="266" r:id="Rf7ed6daba89d46b0"/>
+    <p:sldId xmlns:r="http://schemas.openxmlformats.org/officeDocument/2006/relationships" id="267" r:id="Ref190450f9304125"/>
+    <p:sldId xmlns:r="http://schemas.openxmlformats.org/officeDocument/2006/relationships" id="268" r:id="R5f0f40a700ad41b0"/>
+    <p:sldId xmlns:r="http://schemas.openxmlformats.org/officeDocument/2006/relationships" id="269" r:id="Rf8dc14d3b36c45a1"/>
+    <p:sldId xmlns:r="http://schemas.openxmlformats.org/officeDocument/2006/relationships" id="270" r:id="R061501480be64796"/>
+    <p:sldId xmlns:r="http://schemas.openxmlformats.org/officeDocument/2006/relationships" id="271" r:id="R65a0463ede3f4a6f"/>
+    <p:sldId xmlns:r="http://schemas.openxmlformats.org/officeDocument/2006/relationships" id="272" r:id="Rf12f69dfa4b643e5"/>
+    <p:sldId xmlns:r="http://schemas.openxmlformats.org/officeDocument/2006/relationships" id="273" r:id="Rc42eda7159994d09"/>
+    <p:sldId xmlns:r="http://schemas.openxmlformats.org/officeDocument/2006/relationships" id="274" r:id="R7a17c83c7de14550"/>
+    <p:sldId xmlns:r="http://schemas.openxmlformats.org/officeDocument/2006/relationships" id="275" r:id="R4e502fd6528a42b2"/>
   </p:sldIdLst>
   <p:sldSz cx="12192000" cy="6858000"/>
   <p:notesSz cx="6858000" cy="9144000"/>
@@ -461,7 +461,7 @@
           <a:lstStyle xmlns:a="http://schemas.openxmlformats.org/drawingml/2006/main"/>
           <a:p xmlns:a="http://schemas.openxmlformats.org/drawingml/2006/main">
             <a:r>
-              <a:t>가바사료 사업은 두 부문으로 나눕니다. 가바크루드는 GABA 20% 기준품과 고객 주문에 맞춘 5~20% OEM 원료를 공급합니다. 가바케어믹스는 가바크루드와 미네랄매트릭스를 결합한 배합사료입니다. 두 사업은 품질 기준과 규제·제품 검증 체계를 함께 사용합니다.</a:t>
+              <a:t>가바사료 사업은 두 부문으로 나눕니다. 가바크루드는 GABA 20% 기준품과 고객 주문에 맞춘 5~20% OEM 원료를 공급합니다. 가바케어믹스는 가바크루드와 미네랄매트릭스를 결합한 비육 한우 브랜드 축산용 배합사료로 고도화합니다. 목표는 육질 개선과 생산성 향상이지만, 실제 효과는 대조군 시험과 출하 성적으로 확인합니다.</a:t>
             </a:r>
           </a:p>
           <a:p xmlns:a="http://schemas.openxmlformats.org/drawingml/2006/main">
@@ -551,7 +551,7 @@
           <a:lstStyle xmlns:a="http://schemas.openxmlformats.org/drawingml/2006/main"/>
           <a:p xmlns:a="http://schemas.openxmlformats.org/drawingml/2006/main">
             <a:r>
-              <a:t>첫 시험은 넓게 하면 학습이 흐려집니다. 반추위 보호 제형, 열스트레스 상황, 고객군 하나, 1차 지표 하나로 좁히고 시작 전에 성공·중단 기준을 합의합니다. PoV는 실제 고객 환경에서 경제적 가치를 확인하는 가치검증입니다.</a:t>
+              <a:t>첫 시험은 비육 한우로 좁힙니다. 같은 사육 조건에서 가바케어믹스 급여군과 대조군을 비교하고, 제품 활성함량과 배합 조건을 고정합니다. 생산성은 ADG, FCR, kg 증체당 사료비로 보고, 육질은 도체중, 등심단면적, 근내지방도, 육질등급, 등지방두께로 판단합니다. ADG는 일당증체량, FCR은 체중 1kg 증가에 필요한 사료량입니다.</a:t>
             </a:r>
           </a:p>
           <a:p xmlns:a="http://schemas.openxmlformats.org/drawingml/2006/main">
@@ -566,7 +566,7 @@
           </a:p>
           <a:p xmlns:a="http://schemas.openxmlformats.org/drawingml/2006/main">
             <a:r>
-              <a:t>- https://www.mdpi.com/2076-2615/16/2/262</a:t>
+              <a:t>- 사용자 제공 사업화 정보 · 2026-08-03</a:t>
             </a:r>
           </a:p>
           <a:p xmlns:a="http://schemas.openxmlformats.org/drawingml/2006/main">
@@ -1076,7 +1076,7 @@
           <a:lstStyle xmlns:a="http://schemas.openxmlformats.org/drawingml/2006/main"/>
           <a:p xmlns:a="http://schemas.openxmlformats.org/drawingml/2006/main">
             <a:r>
-              <a:t>사업 확대는 네 가지 검증을 모두 마친 뒤 결정합니다. 규제와 표시 문구는 서면 검토 결과로, 제품 근거는 해당 제품의 시험 결과로 확인합니다. OEM 조건은 공장 실사와 품질 협약서로, 상업성은 유료 고객 시험과 반복 주문으로 확인합니다. 품질 협약서는 발주자와 제조자가 시험, 변경, 일탈, 회수 책임을 합의한 문서입니다.</a:t>
+              <a:t>30일은 제품과 사업 준비의 시간입니다. 이 기간에 제품 규격, 품목·표시 문구, 시험생산, 실제 원가와 유료 농장 계약을 확인합니다. 90일은 생산성의 조기 신호를 보는 기간이며, 육질은 출하 성적으로 최종 판정합니다. 이상반응, 지속적인 섭취 저하, kg 증체당 비용 악화, 제품 규격 미달이 확인되면 시험을 중단하거나 확대를 보류합니다.</a:t>
             </a:r>
           </a:p>
           <a:p xmlns:a="http://schemas.openxmlformats.org/drawingml/2006/main">
@@ -1091,22 +1091,17 @@
           </a:p>
           <a:p xmlns:a="http://schemas.openxmlformats.org/drawingml/2006/main">
             <a:r>
+              <a:t>- 사용자 제공 사업화 정보 · 2026-08-03</a:t>
+            </a:r>
+          </a:p>
+          <a:p xmlns:a="http://schemas.openxmlformats.org/drawingml/2006/main">
+            <a:r>
               <a:t>- https://www.law.go.kr/행정규칙/사료%20등의%20기준%20및%20규격</a:t>
             </a:r>
           </a:p>
           <a:p xmlns:a="http://schemas.openxmlformats.org/drawingml/2006/main">
             <a:r>
               <a:t>- https://www.law.go.kr/LSW/admRulInfoP.do?admRulSeq=2100000231582&amp;chrClsCd=010201</a:t>
-            </a:r>
-          </a:p>
-          <a:p xmlns:a="http://schemas.openxmlformats.org/drawingml/2006/main">
-            <a:r>
-              <a:t>- https://www.mafra.go.kr/bbs/home/792/577302/artclView.do</a:t>
-            </a:r>
-          </a:p>
-          <a:p xmlns:a="http://schemas.openxmlformats.org/drawingml/2006/main">
-            <a:r>
-              <a:t>- D:/다운로드/GABA_20_Master_Inventory_OEM_Make_to_Order_Business_Model_v5.pptx</a:t>
             </a:r>
           </a:p>
         </p:txBody>
@@ -1176,7 +1171,7 @@
           <a:lstStyle xmlns:a="http://schemas.openxmlformats.org/drawingml/2006/main"/>
           <a:p xmlns:a="http://schemas.openxmlformats.org/drawingml/2006/main">
             <a:r>
-              <a:t>첫 30일에는 규제 경로와 제품 조건을 확인합니다. 다음 30일에는 시험 생산을 진행하고 고객 시험계획을 확정합니다. 마지막 30일에는 첫 유료 발주서와 반복 주문 조건을 확보한 뒤 실제 원가를 기준으로 계속 추진할지 결정합니다. RFI는 잠재 제조사에 필요한 정보와 조건을 요청하는 문서입니다.</a:t>
+              <a:t>0일에서 7일 사이에는 제품 규격, 품목·표시 문구와 비육 한우 대조군 시험계획을 확정합니다. 8일에서 21일 사이에는 시험생산 한 번과 3지점 시료로 재현성을 확인하고 실제 원가를 계산합니다. 22일에서 30일 사이에는 유료 농장 한 곳과 발주서 한 건을 확보해 실증을 시작합니다. 이후 90일까지 생산성 조기 신호를 보고, 육질은 출하 시점에 최종 판단합니다.</a:t>
             </a:r>
           </a:p>
           <a:p xmlns:a="http://schemas.openxmlformats.org/drawingml/2006/main">
@@ -1191,17 +1186,17 @@
           </a:p>
           <a:p xmlns:a="http://schemas.openxmlformats.org/drawingml/2006/main">
             <a:r>
+              <a:t>- 사용자 제공 사업화 정보 · 2026-08-03</a:t>
+            </a:r>
+          </a:p>
+          <a:p xmlns:a="http://schemas.openxmlformats.org/drawingml/2006/main">
+            <a:r>
               <a:t>- https://www.law.go.kr/행정규칙/사료%20등의%20기준%20및%20규격</a:t>
             </a:r>
           </a:p>
           <a:p xmlns:a="http://schemas.openxmlformats.org/drawingml/2006/main">
             <a:r>
               <a:t>- https://www.law.go.kr/LSW/admRulInfoP.do?admRulSeq=2100000231582&amp;chrClsCd=010201</a:t>
-            </a:r>
-          </a:p>
-          <a:p xmlns:a="http://schemas.openxmlformats.org/drawingml/2006/main">
-            <a:r>
-              <a:t>- D:/다운로드/GABA_20_Master_Inventory_OEM_Make_to_Order_Business_Model_v5.pptx</a:t>
             </a:r>
           </a:p>
         </p:txBody>
@@ -1271,7 +1266,7 @@
           <a:lstStyle xmlns:a="http://schemas.openxmlformats.org/drawingml/2006/main"/>
           <a:p xmlns:a="http://schemas.openxmlformats.org/drawingml/2006/main">
             <a:r>
-              <a:t>분석기술 전문가는 장순욱 셀핀다 생명과학연구소 부사장으로, 해원바이오 전무와 한국신약 연구소장을 지냈습니다. 분석기술 고문은 구장룡 충남대 농업과학연구소 총괄책임으로, 우성사료 연구소장을 지냈습니다. 정밀발효·정제 전문가는 박지호 셀핀다 생명과학연구소 소장으로, 현대바이오랜드 재직 경력이 있습니다. 박지호 소장의 과거 직책은 제공되지 않아 재직 경력으로만 표기했습니다.</a:t>
+              <a:t>분석기술 전문가는 장순욱 셀핀다 생명과학연구소 부사장으로, 해원바이오 전무와 한국신약 연구소장을 지냈습니다. 분석기술 고문은 구자룡 충남대 농업과학연구소 총괄책임으로, 우성사료 연구소장을 지냈습니다. 정밀발효·정제 전문가는 박지호 셀핀다 생명과학연구소 소장으로, 현대바이오랜드 재직 경력이 있습니다. 박지호 소장의 과거 직책은 제공되지 않아 재직 경력으로만 표기했습니다.</a:t>
             </a:r>
           </a:p>
           <a:p xmlns:a="http://schemas.openxmlformats.org/drawingml/2006/main">
@@ -1356,7 +1351,7 @@
           <a:lstStyle xmlns:a="http://schemas.openxmlformats.org/drawingml/2006/main"/>
           <a:p xmlns:a="http://schemas.openxmlformats.org/drawingml/2006/main">
             <a:r>
-              <a:t>요청드리는 것은 대규모 설비 투자가 아닙니다. 원본에 제시된 4,560만원의 검증 예산을 두 사업이 공통으로 확인해야 할 네 과제에 단계적으로 집행하는 것입니다. 어느 한 과제에서 기준을 충족하지 못하면 멈추고, 모두 확인되면 고객사와 투자자에게 사업 확대 계획을 다시 제안합니다.</a:t>
+              <a:t>요청드리는 것은 대규모 설비 투자가 아닙니다. 원본에 제시된 4,560만원의 검증 예산으로 30일 안에 제품 규격과 시험생산, 실제 원가를 확인하고 비육 한우 유료 실증을 시작하는 것입니다. 90일 생산성 신호와 출하 육질 결과는 별도 판정 시점으로 관리하며, 규격·안전·경제성 기준을 충족하지 못하면 확대를 보류합니다.</a:t>
             </a:r>
           </a:p>
           <a:p xmlns:a="http://schemas.openxmlformats.org/drawingml/2006/main">
@@ -1446,7 +1441,7 @@
           <a:lstStyle xmlns:a="http://schemas.openxmlformats.org/drawingml/2006/main"/>
           <a:p xmlns:a="http://schemas.openxmlformats.org/drawingml/2006/main">
             <a:r>
-              <a:t>사업을 나누면 고객과 매출 방식이 분명해집니다. 가바크루드는 원료 영업과 OEM 주문을, 가바케어믹스는 배합사료와 현장 적용을 담당합니다. 현재 준비도는 41점이며 품목 분류, 유효 용량, OEM 실제 견적, 유료 반복 주문은 아직 확인되지 않았습니다.</a:t>
+              <a:t>속도를 높이되 검증 기간을 왜곡하지 않습니다. 30일 안에 제품 규격, 시험생산, 실제 원가와 유료 농장 실증을 준비합니다. 90일에는 일당증체량과 사료요구율 같은 생산성 조기 신호를 확인하고, 육질은 개체 식별이 연결된 출하 성적으로 최종 판단합니다.</a:t>
             </a:r>
           </a:p>
           <a:p xmlns:a="http://schemas.openxmlformats.org/drawingml/2006/main">
@@ -1536,7 +1531,7 @@
           <a:lstStyle xmlns:a="http://schemas.openxmlformats.org/drawingml/2006/main"/>
           <a:p xmlns:a="http://schemas.openxmlformats.org/drawingml/2006/main">
             <a:r>
-              <a:t>마지막 장은 두 사업의 정의, 어려운 용어, 핵심 가정과 이용 시 주의사항을 정리했습니다. 핵심 인력과 생산가능량은 사용자 제공 자료입니다. 원본의 가격, 원가, 용량, 고객가치는 검증 전 가정이며, 법적 분류와 표시·광고 문구는 별도 전문 검토가 필요합니다.</a:t>
+              <a:t>마지막 장은 두 사업의 정의, 측정 용어, 검증 일정과 이용 시 주의사항을 정리했습니다. 30일은 제품과 사업 준비를 마치고 유료 실증을 시작하는 목표이며, 육질 개선 효능을 확정하는 시점이 아닙니다. 생산성은 90일 조기 신호와 출하 누적 결과를 함께 보고, 육질은 출하 성적으로 최종 판단합니다. 법적 분류와 표시·광고 문구는 별도 전문 검토가 필요합니다.</a:t>
             </a:r>
           </a:p>
           <a:p xmlns:a="http://schemas.openxmlformats.org/drawingml/2006/main">
@@ -1656,7 +1651,7 @@
           <a:lstStyle xmlns:a="http://schemas.openxmlformats.org/drawingml/2006/main"/>
           <a:p xmlns:a="http://schemas.openxmlformats.org/drawingml/2006/main">
             <a:r>
-              <a:t>가바크루드는 원료 고객에게 기준품과 주문형 농도를 공급합니다. 가바케어믹스는 그 원료에 미네랄매트릭스를 결합해 축종별 배합사료로 확장합니다. CoA는 로트별 시험성적서입니다.</a:t>
+              <a:t>가바크루드는 원료 고객에게 기준품과 주문형 농도를 공급합니다. 가바케어믹스는 그 원료에 미네랄매트릭스를 결합해 비육 한우 브랜드 축산용 배합사료로 확장합니다. 두 사업의 공통 기준은 활성 GABA 함량과 로트별 시험성적서입니다.</a:t>
             </a:r>
           </a:p>
           <a:p xmlns:a="http://schemas.openxmlformats.org/drawingml/2006/main">
@@ -2186,7 +2181,7 @@
           <a:lstStyle xmlns:a="http://schemas.openxmlformats.org/drawingml/2006/main"/>
           <a:p xmlns:a="http://schemas.openxmlformats.org/drawingml/2006/main">
             <a:r>
-              <a:t>세 연구의 결과는 일관되지 않습니다. 2026년 젖소 연구에서는 산유량 차이가 통계적으로 유의하지 않았고 일부 유성분만 유의했습니다. 2023년 한우 연구는 초기 증체에서 가능성을 보였지만 도체 지표는 유의하지 않았습니다. 2025년 넙치 연구에서도 성장 개선이 확인되지 않았습니다. 따라서 한 축종, 한 제형, 한 용량으로 조건을 좁혀 해당 제품의 고객 시험을 진행해야 합니다.</a:t>
+              <a:t>세 연구의 결과는 일관되지 않습니다. 2026년 젖소 연구에서는 산유량 차이가 통계적으로 유의하지 않았고 일부 유성분만 유의했습니다. 2023년 한우 연구는 초기 증체에서 가능성을 보였지만 도체 지표는 유의하지 않았습니다. 2025년 넙치 연구에서도 성장 개선이 확인되지 않았습니다. 따라서 기존 연구를 효능 주장으로 사용하지 않고, 비육 한우와 해당 제품에 맞춘 대조군 시험을 새로 설계합니다.</a:t>
             </a:r>
           </a:p>
           <a:p xmlns:a="http://schemas.openxmlformats.org/drawingml/2006/main">
@@ -2279,7 +2274,7 @@
   </p:cSld>
   <p:clrMap bg1="lt1" tx1="dk1" bg2="lt2" tx2="dk2" accent1="accent1" accent2="accent2" accent3="accent3" accent4="accent4" accent5="accent5" accent6="accent6" hlink="hlink" folHlink="folHlink"/>
   <p:sldLayoutIdLst>
-    <p:sldLayoutId xmlns:r="http://schemas.openxmlformats.org/officeDocument/2006/relationships" id="2147483649" r:id="R8567dc6f08e2465b"/>
+    <p:sldLayoutId xmlns:r="http://schemas.openxmlformats.org/officeDocument/2006/relationships" id="2147483649" r:id="Rc56d9dfb53c649ba"/>
   </p:sldLayoutIdLst>
   <p:txStyles>
     <p:titleStyle>
@@ -3048,7 +3043,7 @@
               </a:defRPr>
             </a:pPr>
             <a:r>
-              <a:t>두 사업, 하나의 품질 기준으로 시작한다</a:t>
+              <a:t>육질과 생산성을 함께 검증하는 가바케어믹스로 고도화한다</a:t>
             </a:r>
           </a:p>
         </p:txBody>
@@ -3110,7 +3105,7 @@
               </a:defRPr>
             </a:pPr>
             <a:r>
-              <a:t>가바케어믹스: 가바크루드+미네랄매트릭스 배합사료</a:t>
+              <a:t>가바케어믹스: 비육 한우 브랜드 축산용 배합사료</a:t>
             </a:r>
           </a:p>
         </p:txBody>
@@ -3358,7 +3353,7 @@
               </a:defRPr>
             </a:pPr>
             <a:r>
-              <a:t>가바케어믹스의 첫 고객 시험은 한 축종·한 제형·한 경제효과에 집중한다</a:t>
+              <a:t>가바케어믹스의 첫 검증은 비육 한우 한 축종에 집중한다</a:t>
             </a:r>
           </a:p>
         </p:txBody>
@@ -3402,55 +3397,55 @@
               </a:defRPr>
             </a:pPr>
             <a:r>
-              <a:t>축종</a:t>
-            </a:r>
-          </a:p>
-          <a:p xmlns:a="http://schemas.openxmlformats.org/drawingml/2006/main">
-            <a:pPr algn="l">
-              <a:buNone/>
-              <a:defRPr sz="2400">
-                <a:solidFill>
-                  <a:srgbClr val="000000"/>
-                </a:solidFill>
-                <a:latin typeface="Helvetica Neue"/>
-                <a:ea typeface="Helvetica Neue"/>
-                <a:cs typeface="Helvetica Neue"/>
-              </a:defRPr>
-            </a:pPr>
-            <a:r>
-              <a:t>반추동물 1군</a:t>
-            </a:r>
-          </a:p>
-          <a:p xmlns:a="http://schemas.openxmlformats.org/drawingml/2006/main">
-            <a:pPr algn="l">
-              <a:buNone/>
-              <a:defRPr sz="2400">
-                <a:solidFill>
-                  <a:srgbClr val="000000"/>
-                </a:solidFill>
-                <a:latin typeface="Helvetica Neue"/>
-                <a:ea typeface="Helvetica Neue"/>
-                <a:cs typeface="Helvetica Neue"/>
-              </a:defRPr>
-            </a:pPr>
-            <a:r>
-              <a:t>열스트레스 상황</a:t>
-            </a:r>
-          </a:p>
-          <a:p xmlns:a="http://schemas.openxmlformats.org/drawingml/2006/main">
-            <a:pPr algn="l">
-              <a:buNone/>
-              <a:defRPr sz="2400">
-                <a:solidFill>
-                  <a:srgbClr val="000000"/>
-                </a:solidFill>
-                <a:latin typeface="Helvetica Neue"/>
-                <a:ea typeface="Helvetica Neue"/>
-                <a:cs typeface="Helvetica Neue"/>
-              </a:defRPr>
-            </a:pPr>
-            <a:r>
-              <a:t>고객군 1개</a:t>
+              <a:t>시험 대상</a:t>
+            </a:r>
+          </a:p>
+          <a:p xmlns:a="http://schemas.openxmlformats.org/drawingml/2006/main">
+            <a:pPr algn="l">
+              <a:buNone/>
+              <a:defRPr sz="2400">
+                <a:solidFill>
+                  <a:srgbClr val="000000"/>
+                </a:solidFill>
+                <a:latin typeface="Helvetica Neue"/>
+                <a:ea typeface="Helvetica Neue"/>
+                <a:cs typeface="Helvetica Neue"/>
+              </a:defRPr>
+            </a:pPr>
+            <a:r>
+              <a:t>비육 한우</a:t>
+            </a:r>
+          </a:p>
+          <a:p xmlns:a="http://schemas.openxmlformats.org/drawingml/2006/main">
+            <a:pPr algn="l">
+              <a:buNone/>
+              <a:defRPr sz="2400">
+                <a:solidFill>
+                  <a:srgbClr val="000000"/>
+                </a:solidFill>
+                <a:latin typeface="Helvetica Neue"/>
+                <a:ea typeface="Helvetica Neue"/>
+                <a:cs typeface="Helvetica Neue"/>
+              </a:defRPr>
+            </a:pPr>
+            <a:r>
+              <a:t>동일 사육조건</a:t>
+            </a:r>
+          </a:p>
+          <a:p xmlns:a="http://schemas.openxmlformats.org/drawingml/2006/main">
+            <a:pPr algn="l">
+              <a:buNone/>
+              <a:defRPr sz="2400">
+                <a:solidFill>
+                  <a:srgbClr val="000000"/>
+                </a:solidFill>
+                <a:latin typeface="Helvetica Neue"/>
+                <a:ea typeface="Helvetica Neue"/>
+                <a:cs typeface="Helvetica Neue"/>
+              </a:defRPr>
+            </a:pPr>
+            <a:r>
+              <a:t>가바케어믹스·대조군</a:t>
             </a:r>
           </a:p>
         </p:txBody>
@@ -3494,23 +3489,7 @@
               </a:defRPr>
             </a:pPr>
             <a:r>
-              <a:t>제형</a:t>
-            </a:r>
-          </a:p>
-          <a:p xmlns:a="http://schemas.openxmlformats.org/drawingml/2006/main">
-            <a:pPr algn="l">
-              <a:buNone/>
-              <a:defRPr sz="2400">
-                <a:solidFill>
-                  <a:srgbClr val="000000"/>
-                </a:solidFill>
-                <a:latin typeface="Helvetica Neue"/>
-                <a:ea typeface="Helvetica Neue"/>
-                <a:cs typeface="Helvetica Neue"/>
-              </a:defRPr>
-            </a:pPr>
-            <a:r>
-              <a:t>RP-GABA 우선</a:t>
+              <a:t>제품 기준</a:t>
             </a:r>
           </a:p>
           <a:p xmlns:a="http://schemas.openxmlformats.org/drawingml/2006/main">
@@ -3527,6 +3506,22 @@
             </a:pPr>
             <a:r>
               <a:t>활성함량 고정</a:t>
+            </a:r>
+          </a:p>
+          <a:p xmlns:a="http://schemas.openxmlformats.org/drawingml/2006/main">
+            <a:pPr algn="l">
+              <a:buNone/>
+              <a:defRPr sz="2400">
+                <a:solidFill>
+                  <a:srgbClr val="000000"/>
+                </a:solidFill>
+                <a:latin typeface="Helvetica Neue"/>
+                <a:ea typeface="Helvetica Neue"/>
+                <a:cs typeface="Helvetica Neue"/>
+              </a:defRPr>
+            </a:pPr>
+            <a:r>
+              <a:t>배합 균일도</a:t>
             </a:r>
           </a:p>
           <a:p xmlns:a="http://schemas.openxmlformats.org/drawingml/2006/main">
@@ -3588,55 +3583,55 @@
               </a:defRPr>
             </a:pPr>
             <a:r>
-              <a:t>성과</a:t>
-            </a:r>
-          </a:p>
-          <a:p xmlns:a="http://schemas.openxmlformats.org/drawingml/2006/main">
-            <a:pPr algn="l">
-              <a:buNone/>
-              <a:defRPr sz="2400">
-                <a:solidFill>
-                  <a:srgbClr val="000000"/>
-                </a:solidFill>
-                <a:latin typeface="Helvetica Neue"/>
-                <a:ea typeface="Helvetica Neue"/>
-                <a:cs typeface="Helvetica Neue"/>
-              </a:defRPr>
-            </a:pPr>
-            <a:r>
-              <a:t>사료섭취·유성분 중</a:t>
-            </a:r>
-          </a:p>
-          <a:p xmlns:a="http://schemas.openxmlformats.org/drawingml/2006/main">
-            <a:pPr algn="l">
-              <a:buNone/>
-              <a:defRPr sz="2400">
-                <a:solidFill>
-                  <a:srgbClr val="000000"/>
-                </a:solidFill>
-                <a:latin typeface="Helvetica Neue"/>
-                <a:ea typeface="Helvetica Neue"/>
-                <a:cs typeface="Helvetica Neue"/>
-              </a:defRPr>
-            </a:pPr>
-            <a:r>
-              <a:t>1차 지표 1개</a:t>
-            </a:r>
-          </a:p>
-          <a:p xmlns:a="http://schemas.openxmlformats.org/drawingml/2006/main">
-            <a:pPr algn="l">
-              <a:buNone/>
-              <a:defRPr sz="2400">
-                <a:solidFill>
-                  <a:srgbClr val="000000"/>
-                </a:solidFill>
-                <a:latin typeface="Helvetica Neue"/>
-                <a:ea typeface="Helvetica Neue"/>
-                <a:cs typeface="Helvetica Neue"/>
-              </a:defRPr>
-            </a:pPr>
-            <a:r>
-              <a:t>사전 판정기준</a:t>
+              <a:t>생산성</a:t>
+            </a:r>
+          </a:p>
+          <a:p xmlns:a="http://schemas.openxmlformats.org/drawingml/2006/main">
+            <a:pPr algn="l">
+              <a:buNone/>
+              <a:defRPr sz="2400">
+                <a:solidFill>
+                  <a:srgbClr val="000000"/>
+                </a:solidFill>
+                <a:latin typeface="Helvetica Neue"/>
+                <a:ea typeface="Helvetica Neue"/>
+                <a:cs typeface="Helvetica Neue"/>
+              </a:defRPr>
+            </a:pPr>
+            <a:r>
+              <a:t>일당증체량 ADG</a:t>
+            </a:r>
+          </a:p>
+          <a:p xmlns:a="http://schemas.openxmlformats.org/drawingml/2006/main">
+            <a:pPr algn="l">
+              <a:buNone/>
+              <a:defRPr sz="2400">
+                <a:solidFill>
+                  <a:srgbClr val="000000"/>
+                </a:solidFill>
+                <a:latin typeface="Helvetica Neue"/>
+                <a:ea typeface="Helvetica Neue"/>
+                <a:cs typeface="Helvetica Neue"/>
+              </a:defRPr>
+            </a:pPr>
+            <a:r>
+              <a:t>사료요구율 FCR</a:t>
+            </a:r>
+          </a:p>
+          <a:p xmlns:a="http://schemas.openxmlformats.org/drawingml/2006/main">
+            <a:pPr algn="l">
+              <a:buNone/>
+              <a:defRPr sz="2400">
+                <a:solidFill>
+                  <a:srgbClr val="000000"/>
+                </a:solidFill>
+                <a:latin typeface="Helvetica Neue"/>
+                <a:ea typeface="Helvetica Neue"/>
+                <a:cs typeface="Helvetica Neue"/>
+              </a:defRPr>
+            </a:pPr>
+            <a:r>
+              <a:t>kg 증체당 사료비</a:t>
             </a:r>
           </a:p>
         </p:txBody>
@@ -3682,55 +3677,55 @@
               </a:defRPr>
             </a:pPr>
             <a:r>
-              <a:t>상업 조건</a:t>
-            </a:r>
-          </a:p>
-          <a:p xmlns:a="http://schemas.openxmlformats.org/drawingml/2006/main">
-            <a:pPr algn="l">
-              <a:buNone/>
-              <a:defRPr sz="2400">
-                <a:solidFill>
-                  <a:srgbClr val="000000"/>
-                </a:solidFill>
-                <a:latin typeface="Helvetica Neue"/>
-                <a:ea typeface="Helvetica Neue"/>
-                <a:cs typeface="Helvetica Neue"/>
-              </a:defRPr>
-            </a:pPr>
-            <a:r>
-              <a:t>유료 고객 시험</a:t>
-            </a:r>
-          </a:p>
-          <a:p xmlns:a="http://schemas.openxmlformats.org/drawingml/2006/main">
-            <a:pPr algn="l">
-              <a:buNone/>
-              <a:defRPr sz="2400">
-                <a:solidFill>
-                  <a:srgbClr val="000000"/>
-                </a:solidFill>
-                <a:latin typeface="Helvetica Neue"/>
-                <a:ea typeface="Helvetica Neue"/>
-                <a:cs typeface="Helvetica Neue"/>
-              </a:defRPr>
-            </a:pPr>
-            <a:r>
-              <a:t>가격·중단 기준</a:t>
-            </a:r>
-          </a:p>
-          <a:p xmlns:a="http://schemas.openxmlformats.org/drawingml/2006/main">
-            <a:pPr algn="l">
-              <a:buNone/>
-              <a:defRPr sz="2400">
-                <a:solidFill>
-                  <a:srgbClr val="000000"/>
-                </a:solidFill>
-                <a:latin typeface="Helvetica Neue"/>
-                <a:ea typeface="Helvetica Neue"/>
-                <a:cs typeface="Helvetica Neue"/>
-              </a:defRPr>
-            </a:pPr>
-            <a:r>
-              <a:t>반복 주문 조건</a:t>
+              <a:t>육질</a:t>
+            </a:r>
+          </a:p>
+          <a:p xmlns:a="http://schemas.openxmlformats.org/drawingml/2006/main">
+            <a:pPr algn="l">
+              <a:buNone/>
+              <a:defRPr sz="2400">
+                <a:solidFill>
+                  <a:srgbClr val="000000"/>
+                </a:solidFill>
+                <a:latin typeface="Helvetica Neue"/>
+                <a:ea typeface="Helvetica Neue"/>
+                <a:cs typeface="Helvetica Neue"/>
+              </a:defRPr>
+            </a:pPr>
+            <a:r>
+              <a:t>도체중·등심단면적</a:t>
+            </a:r>
+          </a:p>
+          <a:p xmlns:a="http://schemas.openxmlformats.org/drawingml/2006/main">
+            <a:pPr algn="l">
+              <a:buNone/>
+              <a:defRPr sz="2400">
+                <a:solidFill>
+                  <a:srgbClr val="000000"/>
+                </a:solidFill>
+                <a:latin typeface="Helvetica Neue"/>
+                <a:ea typeface="Helvetica Neue"/>
+                <a:cs typeface="Helvetica Neue"/>
+              </a:defRPr>
+            </a:pPr>
+            <a:r>
+              <a:t>근내지방도·육질등급</a:t>
+            </a:r>
+          </a:p>
+          <a:p xmlns:a="http://schemas.openxmlformats.org/drawingml/2006/main">
+            <a:pPr algn="l">
+              <a:buNone/>
+              <a:defRPr sz="2400">
+                <a:solidFill>
+                  <a:srgbClr val="000000"/>
+                </a:solidFill>
+                <a:latin typeface="Helvetica Neue"/>
+                <a:ea typeface="Helvetica Neue"/>
+                <a:cs typeface="Helvetica Neue"/>
+              </a:defRPr>
+            </a:pPr>
+            <a:r>
+              <a:t>등지방두께</a:t>
             </a:r>
           </a:p>
         </p:txBody>
@@ -4694,7 +4689,7 @@
               </a:defRPr>
             </a:pPr>
             <a:r>
-              <a:t>가바케어믹스의 사료 1톤당 4,149원 공헌이익도 투입량과 직접비 확인이 필요하다</a:t>
+              <a:t>가바케어믹스 공헌이익 4,149원/t은 아직 가정이다</a:t>
             </a:r>
           </a:p>
         </p:txBody>
@@ -6044,7 +6039,7 @@
               </a:defRPr>
             </a:pPr>
             <a:r>
-              <a:t>두 사업의 반복 주문 가정대로라면 매출 6.60억원, 공헌이익 3.83억원이다</a:t>
+              <a:t>반복 주문 가정 매출은 6.60억원, 공헌이익은 3.83억원이다</a:t>
             </a:r>
           </a:p>
         </p:txBody>
@@ -6632,7 +6627,7 @@
               </a:defRPr>
             </a:pPr>
             <a:r>
-              <a:t>두 생산 파트너의 배양액 CAPA는 사용자 제공 자료 기준 월 220톤이다</a:t>
+              <a:t>제공된 배양액 CAPA 합계는 월 220톤이다</a:t>
             </a:r>
           </a:p>
         </p:txBody>
@@ -6985,7 +6980,7 @@
         </p:xfrm>
         <a:graphic xmlns:a="http://schemas.openxmlformats.org/drawingml/2006/main">
           <a:graphicData uri="http://schemas.openxmlformats.org/drawingml/2006/chart">
-            <c:chart xmlns:r="http://schemas.openxmlformats.org/officeDocument/2006/relationships" xmlns:c="http://schemas.openxmlformats.org/drawingml/2006/chart" r:id="R151c71a12c7c4cea"/>
+            <c:chart xmlns:r="http://schemas.openxmlformats.org/officeDocument/2006/relationships" xmlns:c="http://schemas.openxmlformats.org/drawingml/2006/chart" r:id="R53f6c218a0474b8d"/>
           </a:graphicData>
         </a:graphic>
       </p:graphicFrame>
@@ -7186,7 +7181,7 @@
               </a:defRPr>
             </a:pPr>
             <a:r>
-              <a:t>사업 확대는 네 가지를 모두 확인한 뒤 결정한다</a:t>
+              <a:t>검증 속도는 높이되, 육질 판정 시점은 출하에 맞춘다</a:t>
             </a:r>
           </a:p>
         </p:txBody>
@@ -7230,55 +7225,55 @@
               </a:defRPr>
             </a:pPr>
             <a:r>
-              <a:t>규제</a:t>
-            </a:r>
-          </a:p>
-          <a:p xmlns:a="http://schemas.openxmlformats.org/drawingml/2006/main">
-            <a:pPr algn="l">
-              <a:buNone/>
-              <a:defRPr sz="2400">
-                <a:solidFill>
-                  <a:srgbClr val="000000"/>
-                </a:solidFill>
-                <a:latin typeface="Helvetica Neue"/>
-                <a:ea typeface="Helvetica Neue"/>
-                <a:cs typeface="Helvetica Neue"/>
-              </a:defRPr>
-            </a:pPr>
-            <a:r>
-              <a:t>품목분류·등록경로</a:t>
-            </a:r>
-          </a:p>
-          <a:p xmlns:a="http://schemas.openxmlformats.org/drawingml/2006/main">
-            <a:pPr algn="l">
-              <a:buNone/>
-              <a:defRPr sz="2400">
-                <a:solidFill>
-                  <a:srgbClr val="000000"/>
-                </a:solidFill>
-                <a:latin typeface="Helvetica Neue"/>
-                <a:ea typeface="Helvetica Neue"/>
-                <a:cs typeface="Helvetica Neue"/>
-              </a:defRPr>
-            </a:pPr>
-            <a:r>
-              <a:t>표시 가능 문구</a:t>
-            </a:r>
-          </a:p>
-          <a:p xmlns:a="http://schemas.openxmlformats.org/drawingml/2006/main">
-            <a:pPr algn="l">
-              <a:buNone/>
-              <a:defRPr sz="2400">
-                <a:solidFill>
-                  <a:srgbClr val="000000"/>
-                </a:solidFill>
-                <a:latin typeface="Helvetica Neue"/>
-                <a:ea typeface="Helvetica Neue"/>
-                <a:cs typeface="Helvetica Neue"/>
-              </a:defRPr>
-            </a:pPr>
-            <a:r>
-              <a:t>확인 전 외부 홍보 중단</a:t>
+              <a:t>30일</a:t>
+            </a:r>
+          </a:p>
+          <a:p xmlns:a="http://schemas.openxmlformats.org/drawingml/2006/main">
+            <a:pPr algn="l">
+              <a:buNone/>
+              <a:defRPr sz="2400">
+                <a:solidFill>
+                  <a:srgbClr val="000000"/>
+                </a:solidFill>
+                <a:latin typeface="Helvetica Neue"/>
+                <a:ea typeface="Helvetica Neue"/>
+                <a:cs typeface="Helvetica Neue"/>
+              </a:defRPr>
+            </a:pPr>
+            <a:r>
+              <a:t>규격·품목 검토</a:t>
+            </a:r>
+          </a:p>
+          <a:p xmlns:a="http://schemas.openxmlformats.org/drawingml/2006/main">
+            <a:pPr algn="l">
+              <a:buNone/>
+              <a:defRPr sz="2400">
+                <a:solidFill>
+                  <a:srgbClr val="000000"/>
+                </a:solidFill>
+                <a:latin typeface="Helvetica Neue"/>
+                <a:ea typeface="Helvetica Neue"/>
+                <a:cs typeface="Helvetica Neue"/>
+              </a:defRPr>
+            </a:pPr>
+            <a:r>
+              <a:t>시험생산·실제 원가</a:t>
+            </a:r>
+          </a:p>
+          <a:p xmlns:a="http://schemas.openxmlformats.org/drawingml/2006/main">
+            <a:pPr algn="l">
+              <a:buNone/>
+              <a:defRPr sz="2400">
+                <a:solidFill>
+                  <a:srgbClr val="000000"/>
+                </a:solidFill>
+                <a:latin typeface="Helvetica Neue"/>
+                <a:ea typeface="Helvetica Neue"/>
+                <a:cs typeface="Helvetica Neue"/>
+              </a:defRPr>
+            </a:pPr>
+            <a:r>
+              <a:t>유료 실증 착수</a:t>
             </a:r>
           </a:p>
         </p:txBody>
@@ -7322,55 +7317,55 @@
               </a:defRPr>
             </a:pPr>
             <a:r>
-              <a:t>제품 근거</a:t>
-            </a:r>
-          </a:p>
-          <a:p xmlns:a="http://schemas.openxmlformats.org/drawingml/2006/main">
-            <a:pPr algn="l">
-              <a:buNone/>
-              <a:defRPr sz="2400">
-                <a:solidFill>
-                  <a:srgbClr val="000000"/>
-                </a:solidFill>
-                <a:latin typeface="Helvetica Neue"/>
-                <a:ea typeface="Helvetica Neue"/>
-                <a:cs typeface="Helvetica Neue"/>
-              </a:defRPr>
-            </a:pPr>
-            <a:r>
-              <a:t>활성함량·안정성</a:t>
-            </a:r>
-          </a:p>
-          <a:p xmlns:a="http://schemas.openxmlformats.org/drawingml/2006/main">
-            <a:pPr algn="l">
-              <a:buNone/>
-              <a:defRPr sz="2400">
-                <a:solidFill>
-                  <a:srgbClr val="000000"/>
-                </a:solidFill>
-                <a:latin typeface="Helvetica Neue"/>
-                <a:ea typeface="Helvetica Neue"/>
-                <a:cs typeface="Helvetica Neue"/>
-              </a:defRPr>
-            </a:pPr>
-            <a:r>
-              <a:t>축종별 유효용량</a:t>
-            </a:r>
-          </a:p>
-          <a:p xmlns:a="http://schemas.openxmlformats.org/drawingml/2006/main">
-            <a:pPr algn="l">
-              <a:buNone/>
-              <a:defRPr sz="2400">
-                <a:solidFill>
-                  <a:srgbClr val="000000"/>
-                </a:solidFill>
-                <a:latin typeface="Helvetica Neue"/>
-                <a:ea typeface="Helvetica Neue"/>
-                <a:cs typeface="Helvetica Neue"/>
-              </a:defRPr>
-            </a:pPr>
-            <a:r>
-              <a:t>확인 전 확대 보류</a:t>
+              <a:t>90일</a:t>
+            </a:r>
+          </a:p>
+          <a:p xmlns:a="http://schemas.openxmlformats.org/drawingml/2006/main">
+            <a:pPr algn="l">
+              <a:buNone/>
+              <a:defRPr sz="2400">
+                <a:solidFill>
+                  <a:srgbClr val="000000"/>
+                </a:solidFill>
+                <a:latin typeface="Helvetica Neue"/>
+                <a:ea typeface="Helvetica Neue"/>
+                <a:cs typeface="Helvetica Neue"/>
+              </a:defRPr>
+            </a:pPr>
+            <a:r>
+              <a:t>섭취량·ADG</a:t>
+            </a:r>
+          </a:p>
+          <a:p xmlns:a="http://schemas.openxmlformats.org/drawingml/2006/main">
+            <a:pPr algn="l">
+              <a:buNone/>
+              <a:defRPr sz="2400">
+                <a:solidFill>
+                  <a:srgbClr val="000000"/>
+                </a:solidFill>
+                <a:latin typeface="Helvetica Neue"/>
+                <a:ea typeface="Helvetica Neue"/>
+                <a:cs typeface="Helvetica Neue"/>
+              </a:defRPr>
+            </a:pPr>
+            <a:r>
+              <a:t>FCR·kg 증체당 비용</a:t>
+            </a:r>
+          </a:p>
+          <a:p xmlns:a="http://schemas.openxmlformats.org/drawingml/2006/main">
+            <a:pPr algn="l">
+              <a:buNone/>
+              <a:defRPr sz="2400">
+                <a:solidFill>
+                  <a:srgbClr val="000000"/>
+                </a:solidFill>
+                <a:latin typeface="Helvetica Neue"/>
+                <a:ea typeface="Helvetica Neue"/>
+                <a:cs typeface="Helvetica Neue"/>
+              </a:defRPr>
+            </a:pPr>
+            <a:r>
+              <a:t>생산성 조기 신호</a:t>
             </a:r>
           </a:p>
         </p:txBody>
@@ -7416,55 +7411,55 @@
               </a:defRPr>
             </a:pPr>
             <a:r>
-              <a:t>OEM·품질</a:t>
-            </a:r>
-          </a:p>
-          <a:p xmlns:a="http://schemas.openxmlformats.org/drawingml/2006/main">
-            <a:pPr algn="l">
-              <a:buNone/>
-              <a:defRPr sz="2400">
-                <a:solidFill>
-                  <a:srgbClr val="000000"/>
-                </a:solidFill>
-                <a:latin typeface="Helvetica Neue"/>
-                <a:ea typeface="Helvetica Neue"/>
-                <a:cs typeface="Helvetica Neue"/>
-              </a:defRPr>
-            </a:pPr>
-            <a:r>
-              <a:t>실제 견적·MOQ·납기</a:t>
-            </a:r>
-          </a:p>
-          <a:p xmlns:a="http://schemas.openxmlformats.org/drawingml/2006/main">
-            <a:pPr algn="l">
-              <a:buNone/>
-              <a:defRPr sz="2400">
-                <a:solidFill>
-                  <a:srgbClr val="000000"/>
-                </a:solidFill>
-                <a:latin typeface="Helvetica Neue"/>
-                <a:ea typeface="Helvetica Neue"/>
-                <a:cs typeface="Helvetica Neue"/>
-              </a:defRPr>
-            </a:pPr>
-            <a:r>
-              <a:t>품질 협약서</a:t>
-            </a:r>
-          </a:p>
-          <a:p xmlns:a="http://schemas.openxmlformats.org/drawingml/2006/main">
-            <a:pPr algn="l">
-              <a:buNone/>
-              <a:defRPr sz="2400">
-                <a:solidFill>
-                  <a:srgbClr val="000000"/>
-                </a:solidFill>
-                <a:latin typeface="Helvetica Neue"/>
-                <a:ea typeface="Helvetica Neue"/>
-                <a:cs typeface="Helvetica Neue"/>
-              </a:defRPr>
-            </a:pPr>
-            <a:r>
-              <a:t>합의 전 납기 약속 보류</a:t>
+              <a:t>출하 시</a:t>
+            </a:r>
+          </a:p>
+          <a:p xmlns:a="http://schemas.openxmlformats.org/drawingml/2006/main">
+            <a:pPr algn="l">
+              <a:buNone/>
+              <a:defRPr sz="2400">
+                <a:solidFill>
+                  <a:srgbClr val="000000"/>
+                </a:solidFill>
+                <a:latin typeface="Helvetica Neue"/>
+                <a:ea typeface="Helvetica Neue"/>
+                <a:cs typeface="Helvetica Neue"/>
+              </a:defRPr>
+            </a:pPr>
+            <a:r>
+              <a:t>도체중·등심단면적</a:t>
+            </a:r>
+          </a:p>
+          <a:p xmlns:a="http://schemas.openxmlformats.org/drawingml/2006/main">
+            <a:pPr algn="l">
+              <a:buNone/>
+              <a:defRPr sz="2400">
+                <a:solidFill>
+                  <a:srgbClr val="000000"/>
+                </a:solidFill>
+                <a:latin typeface="Helvetica Neue"/>
+                <a:ea typeface="Helvetica Neue"/>
+                <a:cs typeface="Helvetica Neue"/>
+              </a:defRPr>
+            </a:pPr>
+            <a:r>
+              <a:t>근내지방도·육질등급</a:t>
+            </a:r>
+          </a:p>
+          <a:p xmlns:a="http://schemas.openxmlformats.org/drawingml/2006/main">
+            <a:pPr algn="l">
+              <a:buNone/>
+              <a:defRPr sz="2400">
+                <a:solidFill>
+                  <a:srgbClr val="000000"/>
+                </a:solidFill>
+                <a:latin typeface="Helvetica Neue"/>
+                <a:ea typeface="Helvetica Neue"/>
+                <a:cs typeface="Helvetica Neue"/>
+              </a:defRPr>
+            </a:pPr>
+            <a:r>
+              <a:t>육질 최종 평가</a:t>
             </a:r>
           </a:p>
         </p:txBody>
@@ -7510,55 +7505,55 @@
               </a:defRPr>
             </a:pPr>
             <a:r>
-              <a:t>상업성</a:t>
-            </a:r>
-          </a:p>
-          <a:p xmlns:a="http://schemas.openxmlformats.org/drawingml/2006/main">
-            <a:pPr algn="l">
-              <a:buNone/>
-              <a:defRPr sz="2400">
-                <a:solidFill>
-                  <a:srgbClr val="000000"/>
-                </a:solidFill>
-                <a:latin typeface="Helvetica Neue"/>
-                <a:ea typeface="Helvetica Neue"/>
-                <a:cs typeface="Helvetica Neue"/>
-              </a:defRPr>
-            </a:pPr>
-            <a:r>
-              <a:t>유료 고객 시험 2건</a:t>
-            </a:r>
-          </a:p>
-          <a:p xmlns:a="http://schemas.openxmlformats.org/drawingml/2006/main">
-            <a:pPr algn="l">
-              <a:buNone/>
-              <a:defRPr sz="2400">
-                <a:solidFill>
-                  <a:srgbClr val="000000"/>
-                </a:solidFill>
-                <a:latin typeface="Helvetica Neue"/>
-                <a:ea typeface="Helvetica Neue"/>
-                <a:cs typeface="Helvetica Neue"/>
-              </a:defRPr>
-            </a:pPr>
-            <a:r>
-              <a:t>반복 주문 자료</a:t>
-            </a:r>
-          </a:p>
-          <a:p xmlns:a="http://schemas.openxmlformats.org/drawingml/2006/main">
-            <a:pPr algn="l">
-              <a:buNone/>
-              <a:defRPr sz="2400">
-                <a:solidFill>
-                  <a:srgbClr val="000000"/>
-                </a:solidFill>
-                <a:latin typeface="Helvetica Neue"/>
-                <a:ea typeface="Helvetica Neue"/>
-                <a:cs typeface="Helvetica Neue"/>
-              </a:defRPr>
-            </a:pPr>
-            <a:r>
-              <a:t>미확인 시 투자 확대 중단</a:t>
+              <a:t>중단·보류</a:t>
+            </a:r>
+          </a:p>
+          <a:p xmlns:a="http://schemas.openxmlformats.org/drawingml/2006/main">
+            <a:pPr algn="l">
+              <a:buNone/>
+              <a:defRPr sz="2400">
+                <a:solidFill>
+                  <a:srgbClr val="000000"/>
+                </a:solidFill>
+                <a:latin typeface="Helvetica Neue"/>
+                <a:ea typeface="Helvetica Neue"/>
+                <a:cs typeface="Helvetica Neue"/>
+              </a:defRPr>
+            </a:pPr>
+            <a:r>
+              <a:t>이상반응·섭취 저하</a:t>
+            </a:r>
+          </a:p>
+          <a:p xmlns:a="http://schemas.openxmlformats.org/drawingml/2006/main">
+            <a:pPr algn="l">
+              <a:buNone/>
+              <a:defRPr sz="2400">
+                <a:solidFill>
+                  <a:srgbClr val="000000"/>
+                </a:solidFill>
+                <a:latin typeface="Helvetica Neue"/>
+                <a:ea typeface="Helvetica Neue"/>
+                <a:cs typeface="Helvetica Neue"/>
+              </a:defRPr>
+            </a:pPr>
+            <a:r>
+              <a:t>비용 개선 없음</a:t>
+            </a:r>
+          </a:p>
+          <a:p xmlns:a="http://schemas.openxmlformats.org/drawingml/2006/main">
+            <a:pPr algn="l">
+              <a:buNone/>
+              <a:defRPr sz="2400">
+                <a:solidFill>
+                  <a:srgbClr val="000000"/>
+                </a:solidFill>
+                <a:latin typeface="Helvetica Neue"/>
+                <a:ea typeface="Helvetica Neue"/>
+                <a:cs typeface="Helvetica Neue"/>
+              </a:defRPr>
+            </a:pPr>
+            <a:r>
+              <a:t>규격 미달·표시 미확정</a:t>
             </a:r>
           </a:p>
         </p:txBody>
@@ -7760,7 +7755,7 @@
               </a:defRPr>
             </a:pPr>
             <a:r>
-              <a:t>90일 안에 두 사업의 공통 검증과 첫 유료 주문을 확인한다</a:t>
+              <a:t>첫 30일은 7일·21일·30일 세 번의 결정을 만든다</a:t>
             </a:r>
           </a:p>
         </p:txBody>
@@ -7909,7 +7904,7 @@
               </a:defRPr>
             </a:pPr>
             <a:r>
-              <a:t>0–30일</a:t>
+              <a:t>0–7일</a:t>
             </a:r>
           </a:p>
         </p:txBody>
@@ -7955,7 +7950,7 @@
               </a:defRPr>
             </a:pPr>
             <a:r>
-              <a:t>31–60일</a:t>
+              <a:t>8–21일</a:t>
             </a:r>
           </a:p>
         </p:txBody>
@@ -8001,7 +7996,7 @@
               </a:defRPr>
             </a:pPr>
             <a:r>
-              <a:t>61–90일</a:t>
+              <a:t>22–30일</a:t>
             </a:r>
           </a:p>
         </p:txBody>
@@ -8047,55 +8042,55 @@
               </a:defRPr>
             </a:pPr>
             <a:r>
-              <a:t>제품·공급 조건 확인</a:t>
-            </a:r>
-          </a:p>
-          <a:p xmlns:a="http://schemas.openxmlformats.org/drawingml/2006/main">
-            <a:pPr algn="l">
-              <a:buNone/>
-              <a:defRPr sz="2400">
-                <a:solidFill>
-                  <a:srgbClr val="000000"/>
-                </a:solidFill>
-                <a:latin typeface="Helvetica Neue"/>
-                <a:ea typeface="Helvetica Neue"/>
-                <a:cs typeface="Helvetica Neue"/>
-              </a:defRPr>
-            </a:pPr>
-            <a:r>
-              <a:t>시험생산·균일도</a:t>
-            </a:r>
-          </a:p>
-          <a:p xmlns:a="http://schemas.openxmlformats.org/drawingml/2006/main">
-            <a:pPr algn="l">
-              <a:buNone/>
-              <a:defRPr sz="2400">
-                <a:solidFill>
-                  <a:srgbClr val="000000"/>
-                </a:solidFill>
-                <a:latin typeface="Helvetica Neue"/>
-                <a:ea typeface="Helvetica Neue"/>
-                <a:cs typeface="Helvetica Neue"/>
-              </a:defRPr>
-            </a:pPr>
-            <a:r>
-              <a:t>안정성·CoA</a:t>
-            </a:r>
-          </a:p>
-          <a:p xmlns:a="http://schemas.openxmlformats.org/drawingml/2006/main">
-            <a:pPr algn="l">
-              <a:buNone/>
-              <a:defRPr sz="2400">
-                <a:solidFill>
-                  <a:srgbClr val="000000"/>
-                </a:solidFill>
-                <a:latin typeface="Helvetica Neue"/>
-                <a:ea typeface="Helvetica Neue"/>
-                <a:cs typeface="Helvetica Neue"/>
-              </a:defRPr>
-            </a:pPr>
-            <a:r>
-              <a:t>유료 고객 시험계획</a:t>
+              <a:t>규격·시험 설계</a:t>
+            </a:r>
+          </a:p>
+          <a:p xmlns:a="http://schemas.openxmlformats.org/drawingml/2006/main">
+            <a:pPr algn="l">
+              <a:buNone/>
+              <a:defRPr sz="2400">
+                <a:solidFill>
+                  <a:srgbClr val="000000"/>
+                </a:solidFill>
+                <a:latin typeface="Helvetica Neue"/>
+                <a:ea typeface="Helvetica Neue"/>
+                <a:cs typeface="Helvetica Neue"/>
+              </a:defRPr>
+            </a:pPr>
+            <a:r>
+              <a:t>제품 규격서</a:t>
+            </a:r>
+          </a:p>
+          <a:p xmlns:a="http://schemas.openxmlformats.org/drawingml/2006/main">
+            <a:pPr algn="l">
+              <a:buNone/>
+              <a:defRPr sz="2400">
+                <a:solidFill>
+                  <a:srgbClr val="000000"/>
+                </a:solidFill>
+                <a:latin typeface="Helvetica Neue"/>
+                <a:ea typeface="Helvetica Neue"/>
+                <a:cs typeface="Helvetica Neue"/>
+              </a:defRPr>
+            </a:pPr>
+            <a:r>
+              <a:t>품목·표시 사전검토</a:t>
+            </a:r>
+          </a:p>
+          <a:p xmlns:a="http://schemas.openxmlformats.org/drawingml/2006/main">
+            <a:pPr algn="l">
+              <a:buNone/>
+              <a:defRPr sz="2400">
+                <a:solidFill>
+                  <a:srgbClr val="000000"/>
+                </a:solidFill>
+                <a:latin typeface="Helvetica Neue"/>
+                <a:ea typeface="Helvetica Neue"/>
+                <a:cs typeface="Helvetica Neue"/>
+              </a:defRPr>
+            </a:pPr>
+            <a:r>
+              <a:t>비육 한우 대조군 계획</a:t>
             </a:r>
           </a:p>
         </p:txBody>
@@ -8141,55 +8136,55 @@
               </a:defRPr>
             </a:pPr>
             <a:r>
-              <a:t>규제 경로 확인</a:t>
-            </a:r>
-          </a:p>
-          <a:p xmlns:a="http://schemas.openxmlformats.org/drawingml/2006/main">
-            <a:pPr algn="l">
-              <a:buNone/>
-              <a:defRPr sz="2400">
-                <a:solidFill>
-                  <a:srgbClr val="000000"/>
-                </a:solidFill>
-                <a:latin typeface="Helvetica Neue"/>
-                <a:ea typeface="Helvetica Neue"/>
-                <a:cs typeface="Helvetica Neue"/>
-              </a:defRPr>
-            </a:pPr>
-            <a:r>
-              <a:t>품목분류 사전검토</a:t>
-            </a:r>
-          </a:p>
-          <a:p xmlns:a="http://schemas.openxmlformats.org/drawingml/2006/main">
-            <a:pPr algn="l">
-              <a:buNone/>
-              <a:defRPr sz="2400">
-                <a:solidFill>
-                  <a:srgbClr val="000000"/>
-                </a:solidFill>
-                <a:latin typeface="Helvetica Neue"/>
-                <a:ea typeface="Helvetica Neue"/>
-                <a:cs typeface="Helvetica Neue"/>
-              </a:defRPr>
-            </a:pPr>
-            <a:r>
-              <a:t>활성함량·제형 확정</a:t>
-            </a:r>
-          </a:p>
-          <a:p xmlns:a="http://schemas.openxmlformats.org/drawingml/2006/main">
-            <a:pPr algn="l">
-              <a:buNone/>
-              <a:defRPr sz="2400">
-                <a:solidFill>
-                  <a:srgbClr val="000000"/>
-                </a:solidFill>
-                <a:latin typeface="Helvetica Neue"/>
-                <a:ea typeface="Helvetica Neue"/>
-                <a:cs typeface="Helvetica Neue"/>
-              </a:defRPr>
-            </a:pPr>
-            <a:r>
-              <a:t>OEM 2곳 RFI</a:t>
+              <a:t>제품 재현성</a:t>
+            </a:r>
+          </a:p>
+          <a:p xmlns:a="http://schemas.openxmlformats.org/drawingml/2006/main">
+            <a:pPr algn="l">
+              <a:buNone/>
+              <a:defRPr sz="2400">
+                <a:solidFill>
+                  <a:srgbClr val="000000"/>
+                </a:solidFill>
+                <a:latin typeface="Helvetica Neue"/>
+                <a:ea typeface="Helvetica Neue"/>
+                <a:cs typeface="Helvetica Neue"/>
+              </a:defRPr>
+            </a:pPr>
+            <a:r>
+              <a:t>시험생산 1회</a:t>
+            </a:r>
+          </a:p>
+          <a:p xmlns:a="http://schemas.openxmlformats.org/drawingml/2006/main">
+            <a:pPr algn="l">
+              <a:buNone/>
+              <a:defRPr sz="2400">
+                <a:solidFill>
+                  <a:srgbClr val="000000"/>
+                </a:solidFill>
+                <a:latin typeface="Helvetica Neue"/>
+                <a:ea typeface="Helvetica Neue"/>
+                <a:cs typeface="Helvetica Neue"/>
+              </a:defRPr>
+            </a:pPr>
+            <a:r>
+              <a:t>3지점 시료·균일도</a:t>
+            </a:r>
+          </a:p>
+          <a:p xmlns:a="http://schemas.openxmlformats.org/drawingml/2006/main">
+            <a:pPr algn="l">
+              <a:buNone/>
+              <a:defRPr sz="2400">
+                <a:solidFill>
+                  <a:srgbClr val="000000"/>
+                </a:solidFill>
+                <a:latin typeface="Helvetica Neue"/>
+                <a:ea typeface="Helvetica Neue"/>
+                <a:cs typeface="Helvetica Neue"/>
+              </a:defRPr>
+            </a:pPr>
+            <a:r>
+              <a:t>실제 견적·원가</a:t>
             </a:r>
           </a:p>
         </p:txBody>
@@ -8235,55 +8230,55 @@
               </a:defRPr>
             </a:pPr>
             <a:r>
-              <a:t>상업성 확인</a:t>
-            </a:r>
-          </a:p>
-          <a:p xmlns:a="http://schemas.openxmlformats.org/drawingml/2006/main">
-            <a:pPr algn="l">
-              <a:buNone/>
-              <a:defRPr sz="2400">
-                <a:solidFill>
-                  <a:srgbClr val="000000"/>
-                </a:solidFill>
-                <a:latin typeface="Helvetica Neue"/>
-                <a:ea typeface="Helvetica Neue"/>
-                <a:cs typeface="Helvetica Neue"/>
-              </a:defRPr>
-            </a:pPr>
-            <a:r>
-              <a:t>첫 유료 발주서</a:t>
-            </a:r>
-          </a:p>
-          <a:p xmlns:a="http://schemas.openxmlformats.org/drawingml/2006/main">
-            <a:pPr algn="l">
-              <a:buNone/>
-              <a:defRPr sz="2400">
-                <a:solidFill>
-                  <a:srgbClr val="000000"/>
-                </a:solidFill>
-                <a:latin typeface="Helvetica Neue"/>
-                <a:ea typeface="Helvetica Neue"/>
-                <a:cs typeface="Helvetica Neue"/>
-              </a:defRPr>
-            </a:pPr>
-            <a:r>
-              <a:t>반복 주문 조건</a:t>
-            </a:r>
-          </a:p>
-          <a:p xmlns:a="http://schemas.openxmlformats.org/drawingml/2006/main">
-            <a:pPr algn="l">
-              <a:buNone/>
-              <a:defRPr sz="2400">
-                <a:solidFill>
-                  <a:srgbClr val="000000"/>
-                </a:solidFill>
-                <a:latin typeface="Helvetica Neue"/>
-                <a:ea typeface="Helvetica Neue"/>
-                <a:cs typeface="Helvetica Neue"/>
-              </a:defRPr>
-            </a:pPr>
-            <a:r>
-              <a:t>실제 원가로 추진 여부 결정</a:t>
+              <a:t>유료 실증 착수</a:t>
+            </a:r>
+          </a:p>
+          <a:p xmlns:a="http://schemas.openxmlformats.org/drawingml/2006/main">
+            <a:pPr algn="l">
+              <a:buNone/>
+              <a:defRPr sz="2400">
+                <a:solidFill>
+                  <a:srgbClr val="000000"/>
+                </a:solidFill>
+                <a:latin typeface="Helvetica Neue"/>
+                <a:ea typeface="Helvetica Neue"/>
+                <a:cs typeface="Helvetica Neue"/>
+              </a:defRPr>
+            </a:pPr>
+            <a:r>
+              <a:t>농장 1곳·발주서 1건</a:t>
+            </a:r>
+          </a:p>
+          <a:p xmlns:a="http://schemas.openxmlformats.org/drawingml/2006/main">
+            <a:pPr algn="l">
+              <a:buNone/>
+              <a:defRPr sz="2400">
+                <a:solidFill>
+                  <a:srgbClr val="000000"/>
+                </a:solidFill>
+                <a:latin typeface="Helvetica Neue"/>
+                <a:ea typeface="Helvetica Neue"/>
+                <a:cs typeface="Helvetica Neue"/>
+              </a:defRPr>
+            </a:pPr>
+            <a:r>
+              <a:t>기초 체중·섭취량</a:t>
+            </a:r>
+          </a:p>
+          <a:p xmlns:a="http://schemas.openxmlformats.org/drawingml/2006/main">
+            <a:pPr algn="l">
+              <a:buNone/>
+              <a:defRPr sz="2400">
+                <a:solidFill>
+                  <a:srgbClr val="000000"/>
+                </a:solidFill>
+                <a:latin typeface="Helvetica Neue"/>
+                <a:ea typeface="Helvetica Neue"/>
+                <a:cs typeface="Helvetica Neue"/>
+              </a:defRPr>
+            </a:pPr>
+            <a:r>
+              <a:t>개체·출하 성적 연결</a:t>
             </a:r>
           </a:p>
         </p:txBody>
@@ -8802,7 +8797,7 @@
               </a:defRPr>
             </a:pPr>
             <a:r>
-              <a:t>구장룡</a:t>
+              <a:t>구자룡</a:t>
             </a:r>
           </a:p>
         </p:txBody>
@@ -8910,7 +8905,7 @@
               </a:defRPr>
             </a:pPr>
             <a:r>
-              <a:t>구장룡 | 현 충남대 농업과학연구소 총괄책임 · 전 우성사료 연구소장</a:t>
+              <a:t>구자룡 | 현 충남대 농업과학연구소 총괄책임 · 전 우성사료 연구소장</a:t>
             </a:r>
           </a:p>
           <a:p xmlns:a="http://schemas.openxmlformats.org/drawingml/2006/main">
@@ -9084,7 +9079,7 @@
               </a:defRPr>
             </a:pPr>
             <a:r>
-              <a:t>4,560만원을 집행하기 전,</a:t>
+              <a:t>30일 제품 검증과</a:t>
             </a:r>
           </a:p>
           <a:p xmlns:a="http://schemas.openxmlformats.org/drawingml/2006/main">
@@ -9100,7 +9095,23 @@
               </a:defRPr>
             </a:pPr>
             <a:r>
-              <a:t>두 사업의 공통 검증을 승인해 주십시오</a:t>
+              <a:t>비육 한우 유료 실증을</a:t>
+            </a:r>
+          </a:p>
+          <a:p xmlns:a="http://schemas.openxmlformats.org/drawingml/2006/main">
+            <a:pPr algn="l">
+              <a:buNone/>
+              <a:defRPr sz="6000">
+                <a:solidFill>
+                  <a:srgbClr val="000000"/>
+                </a:solidFill>
+                <a:latin typeface="Helvetica Neue"/>
+                <a:ea typeface="Helvetica Neue"/>
+                <a:cs typeface="Helvetica Neue"/>
+              </a:defRPr>
+            </a:pPr>
+            <a:r>
+              <a:t>승인해 주십시오</a:t>
             </a:r>
           </a:p>
         </p:txBody>
@@ -9146,7 +9157,7 @@
               </a:defRPr>
             </a:pPr>
             <a:r>
-              <a:t>① 품목분류·표시 문구  ② 제품 CoA·안정성·유효용량</a:t>
+              <a:t>① 규격·품목·표시 검토  ② 시험생산·3지점 시료·실제 원가</a:t>
             </a:r>
           </a:p>
           <a:p xmlns:a="http://schemas.openxmlformats.org/drawingml/2006/main">
@@ -9162,7 +9173,7 @@
               </a:defRPr>
             </a:pPr>
             <a:r>
-              <a:t>③ 생산 파트너 실사·실제 견적  ④ 유료 고객 시험과 반복 주문</a:t>
+              <a:t>③ 유료 농장 1곳·발주서 1건  ④ 90일 생산성·출하 육질 측정</a:t>
             </a:r>
           </a:p>
         </p:txBody>
@@ -9208,7 +9219,7 @@
               </a:defRPr>
             </a:pPr>
             <a:r>
-              <a:t>승인 요청 · 검증 예산</a:t>
+              <a:t>승인 요청 · 검증 예산 4,560만원</a:t>
             </a:r>
           </a:p>
         </p:txBody>
@@ -9366,7 +9377,7 @@
               </a:defRPr>
             </a:pPr>
             <a:r>
-              <a:t>원료와 배합사료를 나누고,</a:t>
+              <a:t>30일 안에 준비하고,</a:t>
             </a:r>
           </a:p>
           <a:p xmlns:a="http://schemas.openxmlformats.org/drawingml/2006/main">
@@ -9382,7 +9393,7 @@
               </a:defRPr>
             </a:pPr>
             <a:r>
-              <a:t>검증 기준은 함께 관리한다</a:t>
+              <a:t>육질은 출하 시 판정한다</a:t>
             </a:r>
           </a:p>
         </p:txBody>
@@ -9428,7 +9439,7 @@
               </a:defRPr>
             </a:pPr>
             <a:r>
-              <a:t>GABA CRUDE + GABA CARE MIX</a:t>
+              <a:t>GABA CARE MIX | BRANDED HANWOO</a:t>
             </a:r>
           </a:p>
         </p:txBody>
@@ -9474,7 +9485,7 @@
               </a:defRPr>
             </a:pPr>
             <a:r>
-              <a:t>준비도 41/100 · 검증 단계</a:t>
+              <a:t>30일 실증 착수 · 90일 생산성 신호</a:t>
             </a:r>
           </a:p>
         </p:txBody>
@@ -9676,7 +9687,7 @@
               </a:defRPr>
             </a:pPr>
             <a:r>
-              <a:t>APPENDIX · 사업 정의·용어·가정·이용 안내</a:t>
+              <a:t>APPENDIX · 사업 정의·측정 용어·검증 일정</a:t>
             </a:r>
           </a:p>
         </p:txBody>
@@ -9752,23 +9763,23 @@
               </a:defRPr>
             </a:pPr>
             <a:r>
-              <a:t>가바케어믹스=배합사료</a:t>
-            </a:r>
-          </a:p>
-          <a:p xmlns:a="http://schemas.openxmlformats.org/drawingml/2006/main">
-            <a:pPr algn="l">
-              <a:buNone/>
-              <a:defRPr sz="2400">
-                <a:solidFill>
-                  <a:srgbClr val="000000"/>
-                </a:solidFill>
-                <a:latin typeface="Helvetica Neue"/>
-                <a:ea typeface="Helvetica Neue"/>
-                <a:cs typeface="Helvetica Neue"/>
-              </a:defRPr>
-            </a:pPr>
-            <a:r>
-              <a:t>CAPA=생산가능량</a:t>
+              <a:t>가바케어믹스=비육 한우 배합사료</a:t>
+            </a:r>
+          </a:p>
+          <a:p xmlns:a="http://schemas.openxmlformats.org/drawingml/2006/main">
+            <a:pPr algn="l">
+              <a:buNone/>
+              <a:defRPr sz="2400">
+                <a:solidFill>
+                  <a:srgbClr val="000000"/>
+                </a:solidFill>
+                <a:latin typeface="Helvetica Neue"/>
+                <a:ea typeface="Helvetica Neue"/>
+                <a:cs typeface="Helvetica Neue"/>
+              </a:defRPr>
+            </a:pPr>
+            <a:r>
+              <a:t>CAPA=배양액 생산가능량</a:t>
             </a:r>
           </a:p>
         </p:txBody>
@@ -9812,55 +9823,55 @@
               </a:defRPr>
             </a:pPr>
             <a:r>
-              <a:t>용어</a:t>
-            </a:r>
-          </a:p>
-          <a:p xmlns:a="http://schemas.openxmlformats.org/drawingml/2006/main">
-            <a:pPr algn="l">
-              <a:buNone/>
-              <a:defRPr sz="2400">
-                <a:solidFill>
-                  <a:srgbClr val="000000"/>
-                </a:solidFill>
-                <a:latin typeface="Helvetica Neue"/>
-                <a:ea typeface="Helvetica Neue"/>
-                <a:cs typeface="Helvetica Neue"/>
-              </a:defRPr>
-            </a:pPr>
-            <a:r>
-              <a:t>CoA=로트 성적서</a:t>
-            </a:r>
-          </a:p>
-          <a:p xmlns:a="http://schemas.openxmlformats.org/drawingml/2006/main">
-            <a:pPr algn="l">
-              <a:buNone/>
-              <a:defRPr sz="2400">
-                <a:solidFill>
-                  <a:srgbClr val="000000"/>
-                </a:solidFill>
-                <a:latin typeface="Helvetica Neue"/>
-                <a:ea typeface="Helvetica Neue"/>
-                <a:cs typeface="Helvetica Neue"/>
-              </a:defRPr>
-            </a:pPr>
-            <a:r>
-              <a:t>OEM=주문자 상표 부착 생산</a:t>
-            </a:r>
-          </a:p>
-          <a:p xmlns:a="http://schemas.openxmlformats.org/drawingml/2006/main">
-            <a:pPr algn="l">
-              <a:buNone/>
-              <a:defRPr sz="2400">
-                <a:solidFill>
-                  <a:srgbClr val="000000"/>
-                </a:solidFill>
-                <a:latin typeface="Helvetica Neue"/>
-                <a:ea typeface="Helvetica Neue"/>
-                <a:cs typeface="Helvetica Neue"/>
-              </a:defRPr>
-            </a:pPr>
-            <a:r>
-              <a:t>PoV=고객 가치 검증</a:t>
+              <a:t>측정 용어</a:t>
+            </a:r>
+          </a:p>
+          <a:p xmlns:a="http://schemas.openxmlformats.org/drawingml/2006/main">
+            <a:pPr algn="l">
+              <a:buNone/>
+              <a:defRPr sz="2400">
+                <a:solidFill>
+                  <a:srgbClr val="000000"/>
+                </a:solidFill>
+                <a:latin typeface="Helvetica Neue"/>
+                <a:ea typeface="Helvetica Neue"/>
+                <a:cs typeface="Helvetica Neue"/>
+              </a:defRPr>
+            </a:pPr>
+            <a:r>
+              <a:t>ADG=일당증체량</a:t>
+            </a:r>
+          </a:p>
+          <a:p xmlns:a="http://schemas.openxmlformats.org/drawingml/2006/main">
+            <a:pPr algn="l">
+              <a:buNone/>
+              <a:defRPr sz="2400">
+                <a:solidFill>
+                  <a:srgbClr val="000000"/>
+                </a:solidFill>
+                <a:latin typeface="Helvetica Neue"/>
+                <a:ea typeface="Helvetica Neue"/>
+                <a:cs typeface="Helvetica Neue"/>
+              </a:defRPr>
+            </a:pPr>
+            <a:r>
+              <a:t>FCR=사료요구율</a:t>
+            </a:r>
+          </a:p>
+          <a:p xmlns:a="http://schemas.openxmlformats.org/drawingml/2006/main">
+            <a:pPr algn="l">
+              <a:buNone/>
+              <a:defRPr sz="2400">
+                <a:solidFill>
+                  <a:srgbClr val="000000"/>
+                </a:solidFill>
+                <a:latin typeface="Helvetica Neue"/>
+                <a:ea typeface="Helvetica Neue"/>
+                <a:cs typeface="Helvetica Neue"/>
+              </a:defRPr>
+            </a:pPr>
+            <a:r>
+              <a:t>대조군=비교 기준 집단</a:t>
             </a:r>
           </a:p>
         </p:txBody>
@@ -9906,55 +9917,55 @@
               </a:defRPr>
             </a:pPr>
             <a:r>
-              <a:t>핵심 가정</a:t>
-            </a:r>
-          </a:p>
-          <a:p xmlns:a="http://schemas.openxmlformats.org/drawingml/2006/main">
-            <a:pPr algn="l">
-              <a:buNone/>
-              <a:defRPr sz="2400">
-                <a:solidFill>
-                  <a:srgbClr val="000000"/>
-                </a:solidFill>
-                <a:latin typeface="Helvetica Neue"/>
-                <a:ea typeface="Helvetica Neue"/>
-                <a:cs typeface="Helvetica Neue"/>
-              </a:defRPr>
-            </a:pPr>
-            <a:r>
-              <a:t>18,000원/kg·9,240원/kg</a:t>
-            </a:r>
-          </a:p>
-          <a:p xmlns:a="http://schemas.openxmlformats.org/drawingml/2006/main">
-            <a:pPr algn="l">
-              <a:buNone/>
-              <a:defRPr sz="2400">
-                <a:solidFill>
-                  <a:srgbClr val="000000"/>
-                </a:solidFill>
-                <a:latin typeface="Helvetica Neue"/>
-                <a:ea typeface="Helvetica Neue"/>
-                <a:cs typeface="Helvetica Neue"/>
-              </a:defRPr>
-            </a:pPr>
-            <a:r>
-              <a:t>75g/사료t·4,681.8원/kg</a:t>
-            </a:r>
-          </a:p>
-          <a:p xmlns:a="http://schemas.openxmlformats.org/drawingml/2006/main">
-            <a:pPr algn="l">
-              <a:buNone/>
-              <a:defRPr sz="2400">
-                <a:solidFill>
-                  <a:srgbClr val="000000"/>
-                </a:solidFill>
-                <a:latin typeface="Helvetica Neue"/>
-                <a:ea typeface="Helvetica Neue"/>
-                <a:cs typeface="Helvetica Neue"/>
-              </a:defRPr>
-            </a:pPr>
-            <a:r>
-              <a:t>고객가치 18,000원/t</a:t>
+              <a:t>검증 일정</a:t>
+            </a:r>
+          </a:p>
+          <a:p xmlns:a="http://schemas.openxmlformats.org/drawingml/2006/main">
+            <a:pPr algn="l">
+              <a:buNone/>
+              <a:defRPr sz="2400">
+                <a:solidFill>
+                  <a:srgbClr val="000000"/>
+                </a:solidFill>
+                <a:latin typeface="Helvetica Neue"/>
+                <a:ea typeface="Helvetica Neue"/>
+                <a:cs typeface="Helvetica Neue"/>
+              </a:defRPr>
+            </a:pPr>
+            <a:r>
+              <a:t>30일=착수</a:t>
+            </a:r>
+          </a:p>
+          <a:p xmlns:a="http://schemas.openxmlformats.org/drawingml/2006/main">
+            <a:pPr algn="l">
+              <a:buNone/>
+              <a:defRPr sz="2400">
+                <a:solidFill>
+                  <a:srgbClr val="000000"/>
+                </a:solidFill>
+                <a:latin typeface="Helvetica Neue"/>
+                <a:ea typeface="Helvetica Neue"/>
+                <a:cs typeface="Helvetica Neue"/>
+              </a:defRPr>
+            </a:pPr>
+            <a:r>
+              <a:t>90일=신호</a:t>
+            </a:r>
+          </a:p>
+          <a:p xmlns:a="http://schemas.openxmlformats.org/drawingml/2006/main">
+            <a:pPr algn="l">
+              <a:buNone/>
+              <a:defRPr sz="2400">
+                <a:solidFill>
+                  <a:srgbClr val="000000"/>
+                </a:solidFill>
+                <a:latin typeface="Helvetica Neue"/>
+                <a:ea typeface="Helvetica Neue"/>
+                <a:cs typeface="Helvetica Neue"/>
+              </a:defRPr>
+            </a:pPr>
+            <a:r>
+              <a:t>출하=육질</a:t>
             </a:r>
           </a:p>
         </p:txBody>
@@ -10016,39 +10027,39 @@
               </a:defRPr>
             </a:pPr>
             <a:r>
-              <a:t>인력·CAPA=사용자 제공 자료</a:t>
-            </a:r>
-          </a:p>
-          <a:p xmlns:a="http://schemas.openxmlformats.org/drawingml/2006/main">
-            <a:pPr algn="l">
-              <a:buNone/>
-              <a:defRPr sz="2400">
-                <a:solidFill>
-                  <a:srgbClr val="000000"/>
-                </a:solidFill>
-                <a:latin typeface="Helvetica Neue"/>
-                <a:ea typeface="Helvetica Neue"/>
-                <a:cs typeface="Helvetica Neue"/>
-              </a:defRPr>
-            </a:pPr>
-            <a:r>
-              <a:t>법적 분류·효능·공장 적합성·원가</a:t>
-            </a:r>
-          </a:p>
-          <a:p xmlns:a="http://schemas.openxmlformats.org/drawingml/2006/main">
-            <a:pPr algn="l">
-              <a:buNone/>
-              <a:defRPr sz="2400">
-                <a:solidFill>
-                  <a:srgbClr val="000000"/>
-                </a:solidFill>
-                <a:latin typeface="Helvetica Neue"/>
-                <a:ea typeface="Helvetica Neue"/>
-                <a:cs typeface="Helvetica Neue"/>
-              </a:defRPr>
-            </a:pPr>
-            <a:r>
-              <a:t>관할기관·시험기관·실제 견적 확인</a:t>
+              <a:t>30일은 효능 확정 시점이 아님</a:t>
+            </a:r>
+          </a:p>
+          <a:p xmlns:a="http://schemas.openxmlformats.org/drawingml/2006/main">
+            <a:pPr algn="l">
+              <a:buNone/>
+              <a:defRPr sz="2400">
+                <a:solidFill>
+                  <a:srgbClr val="000000"/>
+                </a:solidFill>
+                <a:latin typeface="Helvetica Neue"/>
+                <a:ea typeface="Helvetica Neue"/>
+                <a:cs typeface="Helvetica Neue"/>
+              </a:defRPr>
+            </a:pPr>
+            <a:r>
+              <a:t>법적 분류·표시·효능·원가</a:t>
+            </a:r>
+          </a:p>
+          <a:p xmlns:a="http://schemas.openxmlformats.org/drawingml/2006/main">
+            <a:pPr algn="l">
+              <a:buNone/>
+              <a:defRPr sz="2400">
+                <a:solidFill>
+                  <a:srgbClr val="000000"/>
+                </a:solidFill>
+                <a:latin typeface="Helvetica Neue"/>
+                <a:ea typeface="Helvetica Neue"/>
+                <a:cs typeface="Helvetica Neue"/>
+              </a:defRPr>
+            </a:pPr>
+            <a:r>
+              <a:t>전문 검토·시험·실제 견적 확인</a:t>
             </a:r>
           </a:p>
         </p:txBody>
@@ -10250,7 +10261,7 @@
               </a:defRPr>
             </a:pPr>
             <a:r>
-              <a:t>가바크루드가 원료 매출을 만들고, 가바케어믹스가 고객 현장으로 확장한다</a:t>
+              <a:t>가바크루드가 원료를 공급하고, 가바케어믹스가 브랜드 한우 성과를 검증한다</a:t>
             </a:r>
           </a:p>
         </p:txBody>
@@ -10491,7 +10502,7 @@
               </a:defRPr>
             </a:pPr>
             <a:r>
-              <a:t>배합사료</a:t>
+              <a:t>브랜드 축산</a:t>
             </a:r>
           </a:p>
         </p:txBody>
@@ -10537,39 +10548,39 @@
               </a:defRPr>
             </a:pPr>
             <a:r>
-              <a:t>GABA 20% 기준품</a:t>
-            </a:r>
-          </a:p>
-          <a:p xmlns:a="http://schemas.openxmlformats.org/drawingml/2006/main">
-            <a:pPr algn="l">
-              <a:buNone/>
-              <a:defRPr sz="2400">
-                <a:solidFill>
-                  <a:srgbClr val="000000"/>
-                </a:solidFill>
-                <a:latin typeface="Helvetica Neue"/>
-                <a:ea typeface="Helvetica Neue"/>
-                <a:cs typeface="Helvetica Neue"/>
-              </a:defRPr>
-            </a:pPr>
-            <a:r>
-              <a:t>품질·출하 기준</a:t>
-            </a:r>
-          </a:p>
-          <a:p xmlns:a="http://schemas.openxmlformats.org/drawingml/2006/main">
-            <a:pPr algn="l">
-              <a:buNone/>
-              <a:defRPr sz="2400">
-                <a:solidFill>
-                  <a:srgbClr val="000000"/>
-                </a:solidFill>
-                <a:latin typeface="Helvetica Neue"/>
-                <a:ea typeface="Helvetica Neue"/>
-                <a:cs typeface="Helvetica Neue"/>
-              </a:defRPr>
-            </a:pPr>
-            <a:r>
-              <a:t>로트별 CoA</a:t>
+              <a:t>OEM 5~20%</a:t>
+            </a:r>
+          </a:p>
+          <a:p xmlns:a="http://schemas.openxmlformats.org/drawingml/2006/main">
+            <a:pPr algn="l">
+              <a:buNone/>
+              <a:defRPr sz="2400">
+                <a:solidFill>
+                  <a:srgbClr val="000000"/>
+                </a:solidFill>
+                <a:latin typeface="Helvetica Neue"/>
+                <a:ea typeface="Helvetica Neue"/>
+                <a:cs typeface="Helvetica Neue"/>
+              </a:defRPr>
+            </a:pPr>
+            <a:r>
+              <a:t>고객 주문 후 생산</a:t>
+            </a:r>
+          </a:p>
+          <a:p xmlns:a="http://schemas.openxmlformats.org/drawingml/2006/main">
+            <a:pPr algn="l">
+              <a:buNone/>
+              <a:defRPr sz="2400">
+                <a:solidFill>
+                  <a:srgbClr val="000000"/>
+                </a:solidFill>
+                <a:latin typeface="Helvetica Neue"/>
+                <a:ea typeface="Helvetica Neue"/>
+                <a:cs typeface="Helvetica Neue"/>
+              </a:defRPr>
+            </a:pPr>
+            <a:r>
+              <a:t>농도·포장 맞춤</a:t>
             </a:r>
           </a:p>
         </p:txBody>
@@ -10615,39 +10626,39 @@
               </a:defRPr>
             </a:pPr>
             <a:r>
-              <a:t>OEM 5~20%</a:t>
-            </a:r>
-          </a:p>
-          <a:p xmlns:a="http://schemas.openxmlformats.org/drawingml/2006/main">
-            <a:pPr algn="l">
-              <a:buNone/>
-              <a:defRPr sz="2400">
-                <a:solidFill>
-                  <a:srgbClr val="000000"/>
-                </a:solidFill>
-                <a:latin typeface="Helvetica Neue"/>
-                <a:ea typeface="Helvetica Neue"/>
-                <a:cs typeface="Helvetica Neue"/>
-              </a:defRPr>
-            </a:pPr>
-            <a:r>
-              <a:t>고객 주문 후 생산</a:t>
-            </a:r>
-          </a:p>
-          <a:p xmlns:a="http://schemas.openxmlformats.org/drawingml/2006/main">
-            <a:pPr algn="l">
-              <a:buNone/>
-              <a:defRPr sz="2400">
-                <a:solidFill>
-                  <a:srgbClr val="000000"/>
-                </a:solidFill>
-                <a:latin typeface="Helvetica Neue"/>
-                <a:ea typeface="Helvetica Neue"/>
-                <a:cs typeface="Helvetica Neue"/>
-              </a:defRPr>
-            </a:pPr>
-            <a:r>
-              <a:t>농도·포장 맞춤</a:t>
+              <a:t>GABA 20% 기준품</a:t>
+            </a:r>
+          </a:p>
+          <a:p xmlns:a="http://schemas.openxmlformats.org/drawingml/2006/main">
+            <a:pPr algn="l">
+              <a:buNone/>
+              <a:defRPr sz="2400">
+                <a:solidFill>
+                  <a:srgbClr val="000000"/>
+                </a:solidFill>
+                <a:latin typeface="Helvetica Neue"/>
+                <a:ea typeface="Helvetica Neue"/>
+                <a:cs typeface="Helvetica Neue"/>
+              </a:defRPr>
+            </a:pPr>
+            <a:r>
+              <a:t>품질·출하 기준</a:t>
+            </a:r>
+          </a:p>
+          <a:p xmlns:a="http://schemas.openxmlformats.org/drawingml/2006/main">
+            <a:pPr algn="l">
+              <a:buNone/>
+              <a:defRPr sz="2400">
+                <a:solidFill>
+                  <a:srgbClr val="000000"/>
+                </a:solidFill>
+                <a:latin typeface="Helvetica Neue"/>
+                <a:ea typeface="Helvetica Neue"/>
+                <a:cs typeface="Helvetica Neue"/>
+              </a:defRPr>
+            </a:pPr>
+            <a:r>
+              <a:t>로트별 CoA</a:t>
             </a:r>
           </a:p>
         </p:txBody>
@@ -10725,7 +10736,7 @@
               </a:defRPr>
             </a:pPr>
             <a:r>
-              <a:t>축종별 맞춤 배합</a:t>
+              <a:t>비육 한우 배합</a:t>
             </a:r>
           </a:p>
         </p:txBody>
@@ -10927,7 +10938,7 @@
               </a:defRPr>
             </a:pPr>
             <a:r>
-              <a:t>가바크루드는 GABA 20% 기준품을 축으로 주문 농도까지 확장한다</a:t>
+              <a:t>GABA 20% 기준품으로 주문 농도까지 확장한다</a:t>
             </a:r>
           </a:p>
         </p:txBody>
@@ -12311,7 +12322,7 @@
               </a:defRPr>
             </a:pPr>
             <a:r>
-              <a:t>가바크루드 20% 기준품에 재고를 집중하면 폐기와 사양 변경 위험이 줄어든다</a:t>
+              <a:t>기준품 재고에 집중한다</a:t>
             </a:r>
           </a:p>
         </p:txBody>
@@ -14271,7 +14282,7 @@
               </a:defRPr>
             </a:pPr>
             <a:r>
-              <a:t>가바케어믹스의 현장 가치는 축종·제형·용량을 정한 시험에서 확인해야 한다</a:t>
+              <a:t>기존 연구만으로 브랜드 한우의 육질 개선을 증명할 수 없다</a:t>
             </a:r>
           </a:p>
         </p:txBody>
@@ -14641,7 +14652,7 @@
               </a:defRPr>
             </a:pPr>
             <a:r>
-              <a:t>젖소: 일부 유성분 유의 · 한우: 도체지표 비유의 · 넙치: 성장·삼투조절 비유의</a:t>
+              <a:t>젖소: 일부 유성분 유의 · 한우: 초기 증체 유의, 도체지표 비유의 · 넙치: 성장 비유의</a:t>
             </a:r>
           </a:p>
           <a:p xmlns:a="http://schemas.openxmlformats.org/drawingml/2006/main">
@@ -14657,7 +14668,7 @@
               </a:defRPr>
             </a:pPr>
             <a:r>
-              <a:t>※ RP-GABA=반추위 보호 GABA · 해당 제품을 사용한 고객 시험 필요</a:t>
+              <a:t>※ 해당 제품·대조군·사전 판정기준으로 다시 확인 필요</a:t>
             </a:r>
           </a:p>
         </p:txBody>

</xml_diff>

<commit_message>
feat: correct GABA economics and add commercialization timeline
</commit_message>
<xml_diff>
--- a/GABA_Feed_Business_Model_Speech_Deck_v1.pptx
+++ b/GABA_Feed_Business_Model_Speech_Deck_v1.pptx
@@ -2,32 +2,32 @@
 <file path=ppt/presentation.xml><?xml version="1.0" encoding="utf-8"?>
 <p:presentation xmlns:p="http://schemas.openxmlformats.org/presentationml/2006/main">
   <p:sldMasterIdLst>
-    <p:sldMasterId xmlns:r="http://schemas.openxmlformats.org/officeDocument/2006/relationships" id="2147483648" r:id="R2771d6ecf9194c5b"/>
+    <p:sldMasterId xmlns:r="http://schemas.openxmlformats.org/officeDocument/2006/relationships" id="2147483648" r:id="R6bdd412e7a9f4e72"/>
   </p:sldMasterIdLst>
   <p:notesMasterIdLst>
-    <p:notesMasterId xmlns:r="http://schemas.openxmlformats.org/officeDocument/2006/relationships" r:id="R9cfbc2d8790d4810"/>
+    <p:notesMasterId xmlns:r="http://schemas.openxmlformats.org/officeDocument/2006/relationships" r:id="R4f36e2ff82324f69"/>
   </p:notesMasterIdLst>
   <p:sldIdLst>
-    <p:sldId xmlns:r="http://schemas.openxmlformats.org/officeDocument/2006/relationships" id="256" r:id="R56f6f5e5d5c3485f"/>
-    <p:sldId xmlns:r="http://schemas.openxmlformats.org/officeDocument/2006/relationships" id="257" r:id="R4d78884ac22e4785"/>
-    <p:sldId xmlns:r="http://schemas.openxmlformats.org/officeDocument/2006/relationships" id="258" r:id="R891c0b33d9804bd7"/>
-    <p:sldId xmlns:r="http://schemas.openxmlformats.org/officeDocument/2006/relationships" id="259" r:id="Ra7ab92d1e40144bc"/>
-    <p:sldId xmlns:r="http://schemas.openxmlformats.org/officeDocument/2006/relationships" id="260" r:id="R655397d7018f4f40"/>
-    <p:sldId xmlns:r="http://schemas.openxmlformats.org/officeDocument/2006/relationships" id="261" r:id="R1bf43133737c4481"/>
-    <p:sldId xmlns:r="http://schemas.openxmlformats.org/officeDocument/2006/relationships" id="262" r:id="R7322ca95164d456d"/>
-    <p:sldId xmlns:r="http://schemas.openxmlformats.org/officeDocument/2006/relationships" id="263" r:id="Ra03a1c3a4622450f"/>
-    <p:sldId xmlns:r="http://schemas.openxmlformats.org/officeDocument/2006/relationships" id="264" r:id="Rf5562a501deb4036"/>
-    <p:sldId xmlns:r="http://schemas.openxmlformats.org/officeDocument/2006/relationships" id="265" r:id="Recea583a17c7496c"/>
-    <p:sldId xmlns:r="http://schemas.openxmlformats.org/officeDocument/2006/relationships" id="266" r:id="Rf7ed6daba89d46b0"/>
-    <p:sldId xmlns:r="http://schemas.openxmlformats.org/officeDocument/2006/relationships" id="267" r:id="Ref190450f9304125"/>
-    <p:sldId xmlns:r="http://schemas.openxmlformats.org/officeDocument/2006/relationships" id="268" r:id="R5f0f40a700ad41b0"/>
-    <p:sldId xmlns:r="http://schemas.openxmlformats.org/officeDocument/2006/relationships" id="269" r:id="Rf8dc14d3b36c45a1"/>
-    <p:sldId xmlns:r="http://schemas.openxmlformats.org/officeDocument/2006/relationships" id="270" r:id="R061501480be64796"/>
-    <p:sldId xmlns:r="http://schemas.openxmlformats.org/officeDocument/2006/relationships" id="271" r:id="R65a0463ede3f4a6f"/>
-    <p:sldId xmlns:r="http://schemas.openxmlformats.org/officeDocument/2006/relationships" id="272" r:id="Rf12f69dfa4b643e5"/>
-    <p:sldId xmlns:r="http://schemas.openxmlformats.org/officeDocument/2006/relationships" id="273" r:id="Rc42eda7159994d09"/>
-    <p:sldId xmlns:r="http://schemas.openxmlformats.org/officeDocument/2006/relationships" id="274" r:id="R7a17c83c7de14550"/>
-    <p:sldId xmlns:r="http://schemas.openxmlformats.org/officeDocument/2006/relationships" id="275" r:id="R4e502fd6528a42b2"/>
+    <p:sldId xmlns:r="http://schemas.openxmlformats.org/officeDocument/2006/relationships" id="256" r:id="R76380bddf2e34336"/>
+    <p:sldId xmlns:r="http://schemas.openxmlformats.org/officeDocument/2006/relationships" id="257" r:id="R1572a907091240d0"/>
+    <p:sldId xmlns:r="http://schemas.openxmlformats.org/officeDocument/2006/relationships" id="258" r:id="R7d85d906a9364159"/>
+    <p:sldId xmlns:r="http://schemas.openxmlformats.org/officeDocument/2006/relationships" id="259" r:id="R934c41cd54c9418f"/>
+    <p:sldId xmlns:r="http://schemas.openxmlformats.org/officeDocument/2006/relationships" id="260" r:id="Rfe07d0686b5444fc"/>
+    <p:sldId xmlns:r="http://schemas.openxmlformats.org/officeDocument/2006/relationships" id="261" r:id="R7a1c8f652de84c3d"/>
+    <p:sldId xmlns:r="http://schemas.openxmlformats.org/officeDocument/2006/relationships" id="262" r:id="R8987b41f775b4805"/>
+    <p:sldId xmlns:r="http://schemas.openxmlformats.org/officeDocument/2006/relationships" id="263" r:id="R9f0c5684735c4823"/>
+    <p:sldId xmlns:r="http://schemas.openxmlformats.org/officeDocument/2006/relationships" id="264" r:id="R233252fb3b5a4c18"/>
+    <p:sldId xmlns:r="http://schemas.openxmlformats.org/officeDocument/2006/relationships" id="265" r:id="R24d5c7d2a88d4b87"/>
+    <p:sldId xmlns:r="http://schemas.openxmlformats.org/officeDocument/2006/relationships" id="266" r:id="R3259f03865dd4775"/>
+    <p:sldId xmlns:r="http://schemas.openxmlformats.org/officeDocument/2006/relationships" id="267" r:id="R9af845fd5a864863"/>
+    <p:sldId xmlns:r="http://schemas.openxmlformats.org/officeDocument/2006/relationships" id="268" r:id="Rf5c46a48d74b4101"/>
+    <p:sldId xmlns:r="http://schemas.openxmlformats.org/officeDocument/2006/relationships" id="269" r:id="R2807a459173d4daa"/>
+    <p:sldId xmlns:r="http://schemas.openxmlformats.org/officeDocument/2006/relationships" id="270" r:id="R0797ca28ea1d44a6"/>
+    <p:sldId xmlns:r="http://schemas.openxmlformats.org/officeDocument/2006/relationships" id="271" r:id="Rf40e2e06bf674979"/>
+    <p:sldId xmlns:r="http://schemas.openxmlformats.org/officeDocument/2006/relationships" id="272" r:id="R2b5aaa056c1f46ef"/>
+    <p:sldId xmlns:r="http://schemas.openxmlformats.org/officeDocument/2006/relationships" id="273" r:id="Rb61a1ebb9f134d81"/>
+    <p:sldId xmlns:r="http://schemas.openxmlformats.org/officeDocument/2006/relationships" id="274" r:id="R17948ed7fae74a73"/>
+    <p:sldId xmlns:r="http://schemas.openxmlformats.org/officeDocument/2006/relationships" id="275" r:id="R31c58a7c9db94cf2"/>
   </p:sldIdLst>
   <p:sldSz cx="12192000" cy="6858000"/>
   <p:notesSz cx="6858000" cy="9144000"/>
@@ -641,7 +641,7 @@
           <a:lstStyle xmlns:a="http://schemas.openxmlformats.org/drawingml/2006/main"/>
           <a:p xmlns:a="http://schemas.openxmlformats.org/drawingml/2006/main">
             <a:r>
-              <a:t>단위당 공헌이익은 판매가에서 제품 원가와 직접 변동비를 뺀 금액입니다. 원본 계산에서는 kg당 8,760원이 남지만, 예상 원가의 세부 항목을 확인하지 못했습니다. 투자자에게는 확정 수익이 아니라 검증해야 할 목표로 설명해야 합니다.</a:t>
+              <a:t>배양액 원가만 반영한 확인 가능 원가 하한은 kg당 4,000원입니다. 최종 매출원가는 배양액 400만원에 말토덱스트린 700kg의 실제 단가와 건조·검사·포장비를 더한 뒤 가바크루드 1,000kg으로 나눠 계산합니다. 따라서 14,000원은 추가 원가를 반영하기 전 매출총이익 상한이며 확정 이익이 아닙니다.</a:t>
             </a:r>
           </a:p>
           <a:p xmlns:a="http://schemas.openxmlformats.org/drawingml/2006/main">
@@ -652,6 +652,11 @@
           <a:p xmlns:a="http://schemas.openxmlformats.org/drawingml/2006/main">
             <a:r>
               <a:t>[Sources]</a:t>
+            </a:r>
+          </a:p>
+          <a:p xmlns:a="http://schemas.openxmlformats.org/drawingml/2006/main">
+            <a:r>
+              <a:t>- 사용자 제공 배양액 조성·원가 정보 · 2026-08-03</a:t>
             </a:r>
           </a:p>
           <a:p xmlns:a="http://schemas.openxmlformats.org/drawingml/2006/main">
@@ -726,7 +731,7 @@
           <a:lstStyle xmlns:a="http://schemas.openxmlformats.org/drawingml/2006/main"/>
           <a:p xmlns:a="http://schemas.openxmlformats.org/drawingml/2006/main">
             <a:r>
-              <a:t>원본은 사료 1톤당 매트릭스 75g과 kg당 제품 원가 4,681.8원을 사용합니다. 그러나 제품의 활성 함량과 제형이 연구의 투여량과 연결되지 않아 유효한 투입량으로 확정할 수 없습니다. 실제 공헌이익은 투입량, OEM 견적, 채널비, 현장비를 확인한 뒤 다시 계산해야 합니다.</a:t>
+              <a:t>매출액 6,000원에서 제품 매출원가 351원을 빼면 매출총이익은 사료 1톤당 5,649원입니다. 판매·현장 변동비 1,500원을 추가로 차감한 손익분기 기준이익은 4,149원입니다. 기존 모델의 제품 투입량 75g/사료t과 제품원가 4,681.8원/kg은 아직 유효용량과 실제 견적으로 확인해야 합니다.</a:t>
             </a:r>
           </a:p>
           <a:p xmlns:a="http://schemas.openxmlformats.org/drawingml/2006/main">
@@ -906,7 +911,7 @@
           <a:lstStyle xmlns:a="http://schemas.openxmlformats.org/drawingml/2006/main"/>
           <a:p xmlns:a="http://schemas.openxmlformats.org/drawingml/2006/main">
             <a:r>
-              <a:t>이 페이지는 잠재 규모를 보여주는 시나리오이지 매출 예측이 아닙니다. 마스터 20톤과 매트릭스 5만 사료톤이 실제 반복주문으로 확인될 때만 경제성이 실현됩니다. 숫자를 사용하려면 반드시 실제 PO와 실현 원가를 함께 제시해야 합니다.</a:t>
+              <a:t>이 페이지는 잠재 매출 규모를 보여주는 시나리오이지 매출 예측이 아닙니다. 가바크루드 20톤과 가바케어믹스 5만 사료톤이 실제 반복주문으로 확인될 때 총매출액은 6.60억원입니다. 매출총이익은 가바크루드의 말토덱스트린·건조·검사·포장 원가를 입력한 뒤 계산해야 합니다.</a:t>
             </a:r>
           </a:p>
           <a:p xmlns:a="http://schemas.openxmlformats.org/drawingml/2006/main">
@@ -917,6 +922,11 @@
           <a:p xmlns:a="http://schemas.openxmlformats.org/drawingml/2006/main">
             <a:r>
               <a:t>[Sources]</a:t>
+            </a:r>
+          </a:p>
+          <a:p xmlns:a="http://schemas.openxmlformats.org/drawingml/2006/main">
+            <a:r>
+              <a:t>- 사용자 제공 배양액 조성·원가 정보 · 2026-08-03</a:t>
             </a:r>
           </a:p>
           <a:p xmlns:a="http://schemas.openxmlformats.org/drawingml/2006/main">
@@ -991,7 +1001,7 @@
           <a:lstStyle xmlns:a="http://schemas.openxmlformats.org/drawingml/2006/main"/>
           <a:p xmlns:a="http://schemas.openxmlformats.org/drawingml/2006/main">
             <a:r>
-              <a:t>비전바이오켐의 배양액 생산가능량은 월 20톤, 지에프퍼멘텍은 월 200톤으로 제공됐습니다. 합계는 월 220톤입니다. CAPA는 생산가능량을 뜻합니다. 이 수치는 계약, 실제 가동률, 품질체계, 규격별 수율을 확인한 뒤 공급계획에 반영해야 합니다.</a:t>
+              <a:t>비전바이오켐의 배양액 생산가능량은 월 20톤, 지에프퍼멘텍은 월 200톤으로 제공됐습니다. 합계는 월 220톤입니다. 배양액 1톤당 이론상 가바크루드 1톤이므로 월 220톤 생산이 가능하며 말토덱스트린은 월 154톤이 필요합니다. CAPA는 생산가능량을 뜻하며 계약, 실제 가동률, 품질체계와 공정수율을 확인한 뒤 공급계획에 반영해야 합니다.</a:t>
             </a:r>
           </a:p>
           <a:p xmlns:a="http://schemas.openxmlformats.org/drawingml/2006/main">
@@ -1007,6 +1017,11 @@
           <a:p xmlns:a="http://schemas.openxmlformats.org/drawingml/2006/main">
             <a:r>
               <a:t>- 사용자 제공 사업화 정보 · 2026-08-03</a:t>
+            </a:r>
+          </a:p>
+          <a:p xmlns:a="http://schemas.openxmlformats.org/drawingml/2006/main">
+            <a:r>
+              <a:t>- 사용자 제공 배양액 조성·원가 정보 · 2026-08-03</a:t>
             </a:r>
           </a:p>
         </p:txBody>
@@ -1351,7 +1366,7 @@
           <a:lstStyle xmlns:a="http://schemas.openxmlformats.org/drawingml/2006/main"/>
           <a:p xmlns:a="http://schemas.openxmlformats.org/drawingml/2006/main">
             <a:r>
-              <a:t>요청드리는 것은 대규모 설비 투자가 아닙니다. 원본에 제시된 4,560만원의 검증 예산으로 30일 안에 제품 규격과 시험생산, 실제 원가를 확인하고 비육 한우 유료 실증을 시작하는 것입니다. 90일 생산성 신호와 출하 육질 결과는 별도 판정 시점으로 관리하며, 규격·안전·경제성 기준을 충족하지 못하면 확대를 보류합니다.</a:t>
+              <a:t>사업화 일정은 세 단계입니다. 2026년 8월에는 생산 파트너를 활용한 파일럿 생산으로 공정수율, 제품 규격, 시험성적서와 실제 매출원가를 확인합니다. 2027년 상반기에는 유료 반복 주문과 납기·품질·매출총이익 조건을 통과한 범위에서 양산을 가동합니다. 2028년 하반기에는 확정 수요, 가동률, 투자 회수, 인허가와 자금조달을 확인한 뒤 5톤·10톤·50톤급 발효조 구성을 비교해 자체 공장 설립을 추진합니다. 지금의 승인 요청은 대규모 설비 투자가 아니라 30일 검증 예산 4,560만원입니다.</a:t>
             </a:r>
           </a:p>
           <a:p xmlns:a="http://schemas.openxmlformats.org/drawingml/2006/main">
@@ -1531,7 +1546,7 @@
           <a:lstStyle xmlns:a="http://schemas.openxmlformats.org/drawingml/2006/main"/>
           <a:p xmlns:a="http://schemas.openxmlformats.org/drawingml/2006/main">
             <a:r>
-              <a:t>마지막 장은 두 사업의 정의, 측정 용어, 검증 일정과 이용 시 주의사항을 정리했습니다. 30일은 제품과 사업 준비를 마치고 유료 실증을 시작하는 목표이며, 육질 개선 효능을 확정하는 시점이 아닙니다. 생산성은 90일 조기 신호와 출하 누적 결과를 함께 보고, 육질은 출하 성적으로 최종 판단합니다. 법적 분류와 표시·광고 문구는 별도 전문 검토가 필요합니다.</a:t>
+              <a:t>마지막 장은 두 사업의 정의, 통상적인 손익 용어, 주요 사업화 일정과 이용 시 주의사항을 정리했습니다. 매출총이익은 매출액에서 매출원가를 뺀 금액이며 판매관리비와 고정비를 차감하기 전 값입니다. 2026년 8월 파일럿 생산, 2027년 상반기 양산 가동, 2028년 하반기 자체 공장 설립은 목표 일정이며 단계별 승인 조건을 통과해야 합니다. 30일은 제품과 사업 준비를 마치고 유료 실증을 시작하는 목표이며, 육질 개선 효능을 확정하는 시점이 아닙니다. 법적 분류와 표시·광고 문구는 별도 전문 검토가 필요합니다.</a:t>
             </a:r>
           </a:p>
           <a:p xmlns:a="http://schemas.openxmlformats.org/drawingml/2006/main">
@@ -1547,6 +1562,11 @@
           <a:p xmlns:a="http://schemas.openxmlformats.org/drawingml/2006/main">
             <a:r>
               <a:t>- 사용자 제공 사업화 정보 · 2026-08-03</a:t>
+            </a:r>
+          </a:p>
+          <a:p xmlns:a="http://schemas.openxmlformats.org/drawingml/2006/main">
+            <a:r>
+              <a:t>- 사용자 제공 배양액 조성·원가 정보 · 2026-08-03</a:t>
             </a:r>
           </a:p>
           <a:p xmlns:a="http://schemas.openxmlformats.org/drawingml/2006/main">
@@ -1831,7 +1851,7 @@
           <a:lstStyle xmlns:a="http://schemas.openxmlformats.org/drawingml/2006/main"/>
           <a:p xmlns:a="http://schemas.openxmlformats.org/drawingml/2006/main">
             <a:r>
-              <a:t>원본은 배양액 1톤의 원가와 산출량을 제시합니다. 그러나 이 정보만으로는 20% 마스터의 kg당 원가 9,240원을 다시 계산할 수 없습니다. 건조, 부형제, 시험, 포장, 수율에 드는 비용을 항목별로 확인해야 합니다.</a:t>
+              <a:t>배양액 1톤은 1,000L이며 원가는 400만원입니다. 고형분 30%는 300kg이고, GABA와 기타 고형분이 2대 1이므로 GABA 200kg과 기타 고형분 100kg으로 구성됩니다. 최종 가바크루드의 GABA 함량을 20%로 맞추면 총생산량은 200kg÷20%=1,000kg입니다. 따라서 말토덱스트린은 1,000kg-300kg=700kg이 필요합니다. 실제 공정손실은 시험생산 수율로 보정해야 합니다.</a:t>
             </a:r>
           </a:p>
           <a:p xmlns:a="http://schemas.openxmlformats.org/drawingml/2006/main">
@@ -1846,7 +1866,7 @@
           </a:p>
           <a:p xmlns:a="http://schemas.openxmlformats.org/drawingml/2006/main">
             <a:r>
-              <a:t>- D:/다운로드/GABA_20_Master_Inventory_OEM_Make_to_Order_Business_Model_v5.pptx</a:t>
+              <a:t>- 사용자 제공 배양액 조성·원가 정보 · 2026-08-03</a:t>
             </a:r>
           </a:p>
         </p:txBody>
@@ -1916,7 +1936,7 @@
           <a:lstStyle xmlns:a="http://schemas.openxmlformats.org/drawingml/2006/main"/>
           <a:p xmlns:a="http://schemas.openxmlformats.org/drawingml/2006/main">
             <a:r>
-              <a:t>재고정책은 단순합니다. 20% 마스터만 안전재고와 재주문점을 관리하고, 완제품은 선생산하지 않습니다. MOQ는 최소주문수량, 리드타임은 주문부터 납품까지 걸리는 시간입니다.</a:t>
+              <a:t>재고정책은 단순합니다. 배양액 1톤당 GABA 20% 가바크루드 1,000kg을 이론 생산량으로 관리하고, 실제 생산량은 시험생산 수율로 보정합니다. 20% 기준품만 안전재고와 재주문점을 관리하고 완제품은 선생산하지 않습니다. MOQ는 최소주문수량, 리드타임은 주문부터 납품까지 걸리는 시간입니다.</a:t>
             </a:r>
           </a:p>
           <a:p xmlns:a="http://schemas.openxmlformats.org/drawingml/2006/main">
@@ -1927,6 +1947,11 @@
           <a:p xmlns:a="http://schemas.openxmlformats.org/drawingml/2006/main">
             <a:r>
               <a:t>[Sources]</a:t>
+            </a:r>
+          </a:p>
+          <a:p xmlns:a="http://schemas.openxmlformats.org/drawingml/2006/main">
+            <a:r>
+              <a:t>- 사용자 제공 배양액 조성·원가 정보 · 2026-08-03</a:t>
             </a:r>
           </a:p>
           <a:p xmlns:a="http://schemas.openxmlformats.org/drawingml/2006/main">
@@ -2274,7 +2299,7 @@
   </p:cSld>
   <p:clrMap bg1="lt1" tx1="dk1" bg2="lt2" tx2="dk2" accent1="accent1" accent2="accent2" accent3="accent3" accent4="accent4" accent5="accent5" accent6="accent6" hlink="hlink" folHlink="folHlink"/>
   <p:sldLayoutIdLst>
-    <p:sldLayoutId xmlns:r="http://schemas.openxmlformats.org/officeDocument/2006/relationships" id="2147483649" r:id="Rc56d9dfb53c649ba"/>
+    <p:sldLayoutId xmlns:r="http://schemas.openxmlformats.org/officeDocument/2006/relationships" id="2147483649" r:id="R9e9b18afb5214a2b"/>
   </p:sldLayoutIdLst>
   <p:txStyles>
     <p:titleStyle>
@@ -4014,7 +4039,7 @@
               </a:defRPr>
             </a:pPr>
             <a:r>
-              <a:t>가바크루드 공헌이익 8,760원/kg은 실제 견적 확인이 필요하다</a:t>
+              <a:t>가바크루드 매출원가는 kg당 4,000원에서 시작한다</a:t>
             </a:r>
           </a:p>
         </p:txBody>
@@ -4060,7 +4085,7 @@
               </a:defRPr>
             </a:pPr>
             <a:r>
-              <a:t>목표 판매가</a:t>
+              <a:t>판매가격</a:t>
             </a:r>
           </a:p>
           <a:p xmlns:a="http://schemas.openxmlformats.org/drawingml/2006/main">
@@ -4122,7 +4147,7 @@
               </a:defRPr>
             </a:pPr>
             <a:r>
-              <a:t>단위당 공헌이익</a:t>
+              <a:t>매출총이익 상한</a:t>
             </a:r>
           </a:p>
           <a:p xmlns:a="http://schemas.openxmlformats.org/drawingml/2006/main">
@@ -4184,7 +4209,7 @@
               </a:defRPr>
             </a:pPr>
             <a:r>
-              <a:t>예상 원가</a:t>
+              <a:t>확인된 원가 하한</a:t>
             </a:r>
           </a:p>
           <a:p xmlns:a="http://schemas.openxmlformats.org/drawingml/2006/main">
@@ -4292,7 +4317,7 @@
               </a:defRPr>
             </a:pPr>
             <a:r>
-              <a:t>9,240</a:t>
+              <a:t>4,000</a:t>
             </a:r>
           </a:p>
         </p:txBody>
@@ -4338,7 +4363,7 @@
               </a:defRPr>
             </a:pPr>
             <a:r>
-              <a:t>+8,760</a:t>
+              <a:t>+14,000</a:t>
             </a:r>
           </a:p>
         </p:txBody>
@@ -4384,7 +4409,7 @@
               </a:defRPr>
             </a:pPr>
             <a:r>
-              <a:t>18,000−9,240=8,760원/kg · 공헌율 48.7%</a:t>
+              <a:t>배양액 400만원÷가바크루드 1,000kg=4,000원/kg</a:t>
             </a:r>
           </a:p>
           <a:p xmlns:a="http://schemas.openxmlformats.org/drawingml/2006/main">
@@ -4400,7 +4425,7 @@
               </a:defRPr>
             </a:pPr>
             <a:r>
-              <a:t>※ 9,240원/kg은 원본 가정이며 세부 원가는 아직 확인되지 않음</a:t>
+              <a:t>※ 말토덱스트린·건조·검사·포장비 반영 후 최종 매출원가와 매출총이익 확정</a:t>
             </a:r>
           </a:p>
         </p:txBody>
@@ -4689,7 +4714,7 @@
               </a:defRPr>
             </a:pPr>
             <a:r>
-              <a:t>가바케어믹스 공헌이익 4,149원/t은 아직 가정이다</a:t>
+              <a:t>가바케어믹스 매출총이익은 5,649원/사료t이다</a:t>
             </a:r>
           </a:p>
         </p:txBody>
@@ -4735,23 +4760,23 @@
               </a:defRPr>
             </a:pPr>
             <a:r>
-              <a:t>판매가</a:t>
-            </a:r>
-          </a:p>
-          <a:p xmlns:a="http://schemas.openxmlformats.org/drawingml/2006/main">
-            <a:pPr algn="l">
-              <a:buNone/>
-              <a:defRPr sz="2400">
-                <a:solidFill>
-                  <a:srgbClr val="000000"/>
-                </a:solidFill>
-                <a:latin typeface="Helvetica Neue"/>
-                <a:ea typeface="Helvetica Neue"/>
-                <a:cs typeface="Helvetica Neue"/>
-              </a:defRPr>
-            </a:pPr>
-            <a:r>
-              <a:t>KRW/t</a:t>
+              <a:t>매출액</a:t>
+            </a:r>
+          </a:p>
+          <a:p xmlns:a="http://schemas.openxmlformats.org/drawingml/2006/main">
+            <a:pPr algn="l">
+              <a:buNone/>
+              <a:defRPr sz="2400">
+                <a:solidFill>
+                  <a:srgbClr val="000000"/>
+                </a:solidFill>
+                <a:latin typeface="Helvetica Neue"/>
+                <a:ea typeface="Helvetica Neue"/>
+                <a:cs typeface="Helvetica Neue"/>
+              </a:defRPr>
+            </a:pPr>
+            <a:r>
+              <a:t>KRW/사료t</a:t>
             </a:r>
           </a:p>
         </p:txBody>
@@ -4797,23 +4822,23 @@
               </a:defRPr>
             </a:pPr>
             <a:r>
-              <a:t>공헌이익</a:t>
-            </a:r>
-          </a:p>
-          <a:p xmlns:a="http://schemas.openxmlformats.org/drawingml/2006/main">
-            <a:pPr algn="l">
-              <a:buNone/>
-              <a:defRPr sz="2400">
-                <a:solidFill>
-                  <a:srgbClr val="000000"/>
-                </a:solidFill>
-                <a:latin typeface="Helvetica Neue"/>
-                <a:ea typeface="Helvetica Neue"/>
-                <a:cs typeface="Helvetica Neue"/>
-              </a:defRPr>
-            </a:pPr>
-            <a:r>
-              <a:t>KRW/t</a:t>
+              <a:t>매출총이익</a:t>
+            </a:r>
+          </a:p>
+          <a:p xmlns:a="http://schemas.openxmlformats.org/drawingml/2006/main">
+            <a:pPr algn="l">
+              <a:buNone/>
+              <a:defRPr sz="2400">
+                <a:solidFill>
+                  <a:srgbClr val="000000"/>
+                </a:solidFill>
+                <a:latin typeface="Helvetica Neue"/>
+                <a:ea typeface="Helvetica Neue"/>
+                <a:cs typeface="Helvetica Neue"/>
+              </a:defRPr>
+            </a:pPr>
+            <a:r>
+              <a:t>KRW/사료t</a:t>
             </a:r>
           </a:p>
         </p:txBody>
@@ -4859,23 +4884,23 @@
               </a:defRPr>
             </a:pPr>
             <a:r>
-              <a:t>직접비</a:t>
-            </a:r>
-          </a:p>
-          <a:p xmlns:a="http://schemas.openxmlformats.org/drawingml/2006/main">
-            <a:pPr algn="l">
-              <a:buNone/>
-              <a:defRPr sz="2400">
-                <a:solidFill>
-                  <a:srgbClr val="000000"/>
-                </a:solidFill>
-                <a:latin typeface="Helvetica Neue"/>
-                <a:ea typeface="Helvetica Neue"/>
-                <a:cs typeface="Helvetica Neue"/>
-              </a:defRPr>
-            </a:pPr>
-            <a:r>
-              <a:t>KRW/t</a:t>
+              <a:t>매출원가</a:t>
+            </a:r>
+          </a:p>
+          <a:p xmlns:a="http://schemas.openxmlformats.org/drawingml/2006/main">
+            <a:pPr algn="l">
+              <a:buNone/>
+              <a:defRPr sz="2400">
+                <a:solidFill>
+                  <a:srgbClr val="000000"/>
+                </a:solidFill>
+                <a:latin typeface="Helvetica Neue"/>
+                <a:ea typeface="Helvetica Neue"/>
+                <a:cs typeface="Helvetica Neue"/>
+              </a:defRPr>
+            </a:pPr>
+            <a:r>
+              <a:t>KRW/사료t</a:t>
             </a:r>
           </a:p>
         </p:txBody>
@@ -4967,7 +4992,7 @@
               </a:defRPr>
             </a:pPr>
             <a:r>
-              <a:t>1,851</a:t>
+              <a:t>351</a:t>
             </a:r>
           </a:p>
         </p:txBody>
@@ -5013,7 +5038,7 @@
               </a:defRPr>
             </a:pPr>
             <a:r>
-              <a:t>+4,149</a:t>
+              <a:t>+5,649</a:t>
             </a:r>
           </a:p>
         </p:txBody>
@@ -5059,7 +5084,7 @@
               </a:defRPr>
             </a:pPr>
             <a:r>
-              <a:t>제품비 351 + 현장·채널비 1,500 = 직접비 1,851원</a:t>
+              <a:t>6,000−351=5,649원 · 판매·현장 변동비 1,500원 차감 후 손익분기 기준이익 4,149원</a:t>
             </a:r>
           </a:p>
           <a:p xmlns:a="http://schemas.openxmlformats.org/drawingml/2006/main">
@@ -5075,7 +5100,7 @@
               </a:defRPr>
             </a:pPr>
             <a:r>
-              <a:t>※ 75g/사료t과 4,681.8원/kg은 원본 가정</a:t>
+              <a:t>※ 75g/사료t과 4,681.8원/kg은 기존 가정</a:t>
             </a:r>
           </a:p>
         </p:txBody>
@@ -6039,7 +6064,7 @@
               </a:defRPr>
             </a:pPr>
             <a:r>
-              <a:t>반복 주문 가정 매출은 6.60억원, 공헌이익은 3.83억원이다</a:t>
+              <a:t>반복 주문 가정 매출액은 6.60억원이다</a:t>
             </a:r>
           </a:p>
         </p:txBody>
@@ -6101,7 +6126,7 @@
               </a:defRPr>
             </a:pPr>
             <a:r>
-              <a:t>공헌이익</a:t>
+              <a:t>매출액</a:t>
             </a:r>
           </a:p>
         </p:txBody>
@@ -6163,7 +6188,7 @@
               </a:defRPr>
             </a:pPr>
             <a:r>
-              <a:t>공헌이익</a:t>
+              <a:t>매출액</a:t>
             </a:r>
           </a:p>
         </p:txBody>
@@ -6225,7 +6250,7 @@
               </a:defRPr>
             </a:pPr>
             <a:r>
-              <a:t>공헌이익</a:t>
+              <a:t>매출액</a:t>
             </a:r>
           </a:p>
         </p:txBody>
@@ -6271,7 +6296,7 @@
               </a:defRPr>
             </a:pPr>
             <a:r>
-              <a:t>1.75억원</a:t>
+              <a:t>3.60억원</a:t>
             </a:r>
           </a:p>
         </p:txBody>
@@ -6317,7 +6342,7 @@
               </a:defRPr>
             </a:pPr>
             <a:r>
-              <a:t>2.07억원</a:t>
+              <a:t>3.00억원</a:t>
             </a:r>
           </a:p>
         </p:txBody>
@@ -6363,7 +6388,7 @@
               </a:defRPr>
             </a:pPr>
             <a:r>
-              <a:t>3.83억원</a:t>
+              <a:t>6.60억원</a:t>
             </a:r>
           </a:p>
         </p:txBody>
@@ -6409,7 +6434,7 @@
               </a:defRPr>
             </a:pPr>
             <a:r>
-              <a:t>가바크루드 매출 3.60억 + 가바케어믹스 매출 3.00억</a:t>
+              <a:t>가바크루드 20톤×18,000원/kg + 가바케어믹스 5만 사료t×6,000원</a:t>
             </a:r>
           </a:p>
           <a:p xmlns:a="http://schemas.openxmlformats.org/drawingml/2006/main">
@@ -6425,7 +6450,7 @@
               </a:defRPr>
             </a:pPr>
             <a:r>
-              <a:t>※ 실제 PO가 아닌 반복 주문 가정 시나리오</a:t>
+              <a:t>※ 매출총이익은 가바크루드 최종 매출원가 확정 후 계산</a:t>
             </a:r>
           </a:p>
         </p:txBody>
@@ -6947,23 +6972,23 @@
               </a:defRPr>
             </a:pPr>
             <a:r>
-              <a:t>사용자 제공 자료 합계 월 220톤</a:t>
-            </a:r>
-          </a:p>
-          <a:p xmlns:a="http://schemas.openxmlformats.org/drawingml/2006/main">
-            <a:pPr algn="l">
-              <a:buNone/>
-              <a:defRPr sz="2400">
-                <a:solidFill>
-                  <a:srgbClr val="000000"/>
-                </a:solidFill>
-                <a:latin typeface="Helvetica Neue"/>
-                <a:ea typeface="Helvetica Neue"/>
-                <a:cs typeface="Helvetica Neue"/>
-              </a:defRPr>
-            </a:pPr>
-            <a:r>
-              <a:t>※ 계약·실가동·품질체계 확인 후 공급계획에 반영</a:t>
+              <a:t>배양액 월 220톤 → 이론상 가바크루드 월 220톤</a:t>
+            </a:r>
+          </a:p>
+          <a:p xmlns:a="http://schemas.openxmlformats.org/drawingml/2006/main">
+            <a:pPr algn="l">
+              <a:buNone/>
+              <a:defRPr sz="2400">
+                <a:solidFill>
+                  <a:srgbClr val="000000"/>
+                </a:solidFill>
+                <a:latin typeface="Helvetica Neue"/>
+                <a:ea typeface="Helvetica Neue"/>
+                <a:cs typeface="Helvetica Neue"/>
+              </a:defRPr>
+            </a:pPr>
+            <a:r>
+              <a:t>필요 말토덱스트린 월 154톤 · 실제 수율은 시험생산으로 보정</a:t>
             </a:r>
           </a:p>
         </p:txBody>
@@ -6980,7 +7005,7 @@
         </p:xfrm>
         <a:graphic xmlns:a="http://schemas.openxmlformats.org/drawingml/2006/main">
           <a:graphicData uri="http://schemas.openxmlformats.org/drawingml/2006/chart">
-            <c:chart xmlns:r="http://schemas.openxmlformats.org/officeDocument/2006/relationships" xmlns:c="http://schemas.openxmlformats.org/drawingml/2006/chart" r:id="R53f6c218a0474b8d"/>
+            <c:chart xmlns:r="http://schemas.openxmlformats.org/officeDocument/2006/relationships" xmlns:c="http://schemas.openxmlformats.org/drawingml/2006/chart" r:id="Rc5149fd3899c4e0a"/>
           </a:graphicData>
         </a:graphic>
       </p:graphicFrame>
@@ -9079,39 +9104,7 @@
               </a:defRPr>
             </a:pPr>
             <a:r>
-              <a:t>30일 제품 검증과</a:t>
-            </a:r>
-          </a:p>
-          <a:p xmlns:a="http://schemas.openxmlformats.org/drawingml/2006/main">
-            <a:pPr algn="l">
-              <a:buNone/>
-              <a:defRPr sz="6000">
-                <a:solidFill>
-                  <a:srgbClr val="000000"/>
-                </a:solidFill>
-                <a:latin typeface="Helvetica Neue"/>
-                <a:ea typeface="Helvetica Neue"/>
-                <a:cs typeface="Helvetica Neue"/>
-              </a:defRPr>
-            </a:pPr>
-            <a:r>
-              <a:t>비육 한우 유료 실증을</a:t>
-            </a:r>
-          </a:p>
-          <a:p xmlns:a="http://schemas.openxmlformats.org/drawingml/2006/main">
-            <a:pPr algn="l">
-              <a:buNone/>
-              <a:defRPr sz="6000">
-                <a:solidFill>
-                  <a:srgbClr val="000000"/>
-                </a:solidFill>
-                <a:latin typeface="Helvetica Neue"/>
-                <a:ea typeface="Helvetica Neue"/>
-                <a:cs typeface="Helvetica Neue"/>
-              </a:defRPr>
-            </a:pPr>
-            <a:r>
-              <a:t>승인해 주십시오</a:t>
+              <a:t>파일럿 생산에서 자체 공장까지 단계적으로 확장한다</a:t>
             </a:r>
           </a:p>
         </p:txBody>
@@ -9157,7 +9150,7 @@
               </a:defRPr>
             </a:pPr>
             <a:r>
-              <a:t>① 규격·품목·표시 검토  ② 시험생산·3지점 시료·실제 원가</a:t>
+              <a:t>2026년 8월 파일럿 생산 · 수율·품질·실제 매출원가 확인</a:t>
             </a:r>
           </a:p>
           <a:p xmlns:a="http://schemas.openxmlformats.org/drawingml/2006/main">
@@ -9173,7 +9166,23 @@
               </a:defRPr>
             </a:pPr>
             <a:r>
-              <a:t>③ 유료 농장 1곳·발주서 1건  ④ 90일 생산성·출하 육질 측정</a:t>
+              <a:t>2027년 상반기 양산 가동 · 반복 주문·납기·매출총이익 검증</a:t>
+            </a:r>
+          </a:p>
+          <a:p xmlns:a="http://schemas.openxmlformats.org/drawingml/2006/main">
+            <a:pPr algn="l">
+              <a:buNone/>
+              <a:defRPr sz="2100">
+                <a:solidFill>
+                  <a:srgbClr val="000000"/>
+                </a:solidFill>
+                <a:latin typeface="Helvetica Neue"/>
+                <a:ea typeface="Helvetica Neue"/>
+                <a:cs typeface="Helvetica Neue"/>
+              </a:defRPr>
+            </a:pPr>
+            <a:r>
+              <a:t>2028년 하반기 자체 공장 · 5·10·50톤급 발효조 구성 검토</a:t>
             </a:r>
           </a:p>
         </p:txBody>
@@ -9219,7 +9228,39 @@
               </a:defRPr>
             </a:pPr>
             <a:r>
-              <a:t>승인 요청 · 검증 예산 4,560만원</a:t>
+              <a:t>지금의 승인</a:t>
+            </a:r>
+          </a:p>
+          <a:p xmlns:a="http://schemas.openxmlformats.org/drawingml/2006/main">
+            <a:pPr algn="l">
+              <a:buNone/>
+              <a:defRPr sz="2400">
+                <a:solidFill>
+                  <a:srgbClr val="000000"/>
+                </a:solidFill>
+                <a:latin typeface="Helvetica Neue"/>
+                <a:ea typeface="Helvetica Neue"/>
+                <a:cs typeface="Helvetica Neue"/>
+              </a:defRPr>
+            </a:pPr>
+            <a:r>
+              <a:t>30일 검증</a:t>
+            </a:r>
+          </a:p>
+          <a:p xmlns:a="http://schemas.openxmlformats.org/drawingml/2006/main">
+            <a:pPr algn="l">
+              <a:buNone/>
+              <a:defRPr sz="2400">
+                <a:solidFill>
+                  <a:srgbClr val="000000"/>
+                </a:solidFill>
+                <a:latin typeface="Helvetica Neue"/>
+                <a:ea typeface="Helvetica Neue"/>
+                <a:cs typeface="Helvetica Neue"/>
+              </a:defRPr>
+            </a:pPr>
+            <a:r>
+              <a:t>4,560만원</a:t>
             </a:r>
           </a:p>
         </p:txBody>
@@ -9309,7 +9350,7 @@
                 <a:ea typeface="Arial"/>
                 <a:cs typeface="Arial"/>
               </a:rPr>
-              <a:t>19 | DECISION ASK</a:t>
+              <a:t>19 | COMMERCIALIZATION TIMELINE</a:t>
             </a:r>
           </a:p>
         </p:txBody>
@@ -9687,7 +9728,7 @@
               </a:defRPr>
             </a:pPr>
             <a:r>
-              <a:t>APPENDIX · 사업 정의·측정 용어·검증 일정</a:t>
+              <a:t>APPENDIX · 사업 정의·손익 용어·주요 일정</a:t>
             </a:r>
           </a:p>
         </p:txBody>
@@ -9823,55 +9864,55 @@
               </a:defRPr>
             </a:pPr>
             <a:r>
-              <a:t>측정 용어</a:t>
-            </a:r>
-          </a:p>
-          <a:p xmlns:a="http://schemas.openxmlformats.org/drawingml/2006/main">
-            <a:pPr algn="l">
-              <a:buNone/>
-              <a:defRPr sz="2400">
-                <a:solidFill>
-                  <a:srgbClr val="000000"/>
-                </a:solidFill>
-                <a:latin typeface="Helvetica Neue"/>
-                <a:ea typeface="Helvetica Neue"/>
-                <a:cs typeface="Helvetica Neue"/>
-              </a:defRPr>
-            </a:pPr>
-            <a:r>
-              <a:t>ADG=일당증체량</a:t>
-            </a:r>
-          </a:p>
-          <a:p xmlns:a="http://schemas.openxmlformats.org/drawingml/2006/main">
-            <a:pPr algn="l">
-              <a:buNone/>
-              <a:defRPr sz="2400">
-                <a:solidFill>
-                  <a:srgbClr val="000000"/>
-                </a:solidFill>
-                <a:latin typeface="Helvetica Neue"/>
-                <a:ea typeface="Helvetica Neue"/>
-                <a:cs typeface="Helvetica Neue"/>
-              </a:defRPr>
-            </a:pPr>
-            <a:r>
-              <a:t>FCR=사료요구율</a:t>
-            </a:r>
-          </a:p>
-          <a:p xmlns:a="http://schemas.openxmlformats.org/drawingml/2006/main">
-            <a:pPr algn="l">
-              <a:buNone/>
-              <a:defRPr sz="2400">
-                <a:solidFill>
-                  <a:srgbClr val="000000"/>
-                </a:solidFill>
-                <a:latin typeface="Helvetica Neue"/>
-                <a:ea typeface="Helvetica Neue"/>
-                <a:cs typeface="Helvetica Neue"/>
-              </a:defRPr>
-            </a:pPr>
-            <a:r>
-              <a:t>대조군=비교 기준 집단</a:t>
+              <a:t>손익 용어</a:t>
+            </a:r>
+          </a:p>
+          <a:p xmlns:a="http://schemas.openxmlformats.org/drawingml/2006/main">
+            <a:pPr algn="l">
+              <a:buNone/>
+              <a:defRPr sz="2400">
+                <a:solidFill>
+                  <a:srgbClr val="000000"/>
+                </a:solidFill>
+                <a:latin typeface="Helvetica Neue"/>
+                <a:ea typeface="Helvetica Neue"/>
+                <a:cs typeface="Helvetica Neue"/>
+              </a:defRPr>
+            </a:pPr>
+            <a:r>
+              <a:t>매출액=판매금액</a:t>
+            </a:r>
+          </a:p>
+          <a:p xmlns:a="http://schemas.openxmlformats.org/drawingml/2006/main">
+            <a:pPr algn="l">
+              <a:buNone/>
+              <a:defRPr sz="2400">
+                <a:solidFill>
+                  <a:srgbClr val="000000"/>
+                </a:solidFill>
+                <a:latin typeface="Helvetica Neue"/>
+                <a:ea typeface="Helvetica Neue"/>
+                <a:cs typeface="Helvetica Neue"/>
+              </a:defRPr>
+            </a:pPr>
+            <a:r>
+              <a:t>매출원가=제품 직접원가</a:t>
+            </a:r>
+          </a:p>
+          <a:p xmlns:a="http://schemas.openxmlformats.org/drawingml/2006/main">
+            <a:pPr algn="l">
+              <a:buNone/>
+              <a:defRPr sz="2400">
+                <a:solidFill>
+                  <a:srgbClr val="000000"/>
+                </a:solidFill>
+                <a:latin typeface="Helvetica Neue"/>
+                <a:ea typeface="Helvetica Neue"/>
+                <a:cs typeface="Helvetica Neue"/>
+              </a:defRPr>
+            </a:pPr>
+            <a:r>
+              <a:t>매출총이익=매출액-매출원가</a:t>
             </a:r>
           </a:p>
         </p:txBody>
@@ -9917,55 +9958,55 @@
               </a:defRPr>
             </a:pPr>
             <a:r>
-              <a:t>검증 일정</a:t>
-            </a:r>
-          </a:p>
-          <a:p xmlns:a="http://schemas.openxmlformats.org/drawingml/2006/main">
-            <a:pPr algn="l">
-              <a:buNone/>
-              <a:defRPr sz="2400">
-                <a:solidFill>
-                  <a:srgbClr val="000000"/>
-                </a:solidFill>
-                <a:latin typeface="Helvetica Neue"/>
-                <a:ea typeface="Helvetica Neue"/>
-                <a:cs typeface="Helvetica Neue"/>
-              </a:defRPr>
-            </a:pPr>
-            <a:r>
-              <a:t>30일=착수</a:t>
-            </a:r>
-          </a:p>
-          <a:p xmlns:a="http://schemas.openxmlformats.org/drawingml/2006/main">
-            <a:pPr algn="l">
-              <a:buNone/>
-              <a:defRPr sz="2400">
-                <a:solidFill>
-                  <a:srgbClr val="000000"/>
-                </a:solidFill>
-                <a:latin typeface="Helvetica Neue"/>
-                <a:ea typeface="Helvetica Neue"/>
-                <a:cs typeface="Helvetica Neue"/>
-              </a:defRPr>
-            </a:pPr>
-            <a:r>
-              <a:t>90일=신호</a:t>
-            </a:r>
-          </a:p>
-          <a:p xmlns:a="http://schemas.openxmlformats.org/drawingml/2006/main">
-            <a:pPr algn="l">
-              <a:buNone/>
-              <a:defRPr sz="2400">
-                <a:solidFill>
-                  <a:srgbClr val="000000"/>
-                </a:solidFill>
-                <a:latin typeface="Helvetica Neue"/>
-                <a:ea typeface="Helvetica Neue"/>
-                <a:cs typeface="Helvetica Neue"/>
-              </a:defRPr>
-            </a:pPr>
-            <a:r>
-              <a:t>출하=육질</a:t>
+              <a:t>주요 일정</a:t>
+            </a:r>
+          </a:p>
+          <a:p xmlns:a="http://schemas.openxmlformats.org/drawingml/2006/main">
+            <a:pPr algn="l">
+              <a:buNone/>
+              <a:defRPr sz="2400">
+                <a:solidFill>
+                  <a:srgbClr val="000000"/>
+                </a:solidFill>
+                <a:latin typeface="Helvetica Neue"/>
+                <a:ea typeface="Helvetica Neue"/>
+                <a:cs typeface="Helvetica Neue"/>
+              </a:defRPr>
+            </a:pPr>
+            <a:r>
+              <a:t>2026.08=파일럿</a:t>
+            </a:r>
+          </a:p>
+          <a:p xmlns:a="http://schemas.openxmlformats.org/drawingml/2006/main">
+            <a:pPr algn="l">
+              <a:buNone/>
+              <a:defRPr sz="2400">
+                <a:solidFill>
+                  <a:srgbClr val="000000"/>
+                </a:solidFill>
+                <a:latin typeface="Helvetica Neue"/>
+                <a:ea typeface="Helvetica Neue"/>
+                <a:cs typeface="Helvetica Neue"/>
+              </a:defRPr>
+            </a:pPr>
+            <a:r>
+              <a:t>2027 상반기=양산</a:t>
+            </a:r>
+          </a:p>
+          <a:p xmlns:a="http://schemas.openxmlformats.org/drawingml/2006/main">
+            <a:pPr algn="l">
+              <a:buNone/>
+              <a:defRPr sz="2400">
+                <a:solidFill>
+                  <a:srgbClr val="000000"/>
+                </a:solidFill>
+                <a:latin typeface="Helvetica Neue"/>
+                <a:ea typeface="Helvetica Neue"/>
+                <a:cs typeface="Helvetica Neue"/>
+              </a:defRPr>
+            </a:pPr>
+            <a:r>
+              <a:t>2028 하반기=자체 공장</a:t>
             </a:r>
           </a:p>
         </p:txBody>
@@ -11335,23 +11376,23 @@
               </a:defRPr>
             </a:pPr>
             <a:r>
-              <a:t>정밀발효·정제</a:t>
-            </a:r>
-          </a:p>
-          <a:p xmlns:a="http://schemas.openxmlformats.org/drawingml/2006/main">
-            <a:pPr algn="l">
-              <a:buNone/>
-              <a:defRPr sz="2400">
-                <a:solidFill>
-                  <a:srgbClr val="000000"/>
-                </a:solidFill>
-                <a:latin typeface="Helvetica Neue"/>
-                <a:ea typeface="Helvetica Neue"/>
-                <a:cs typeface="Helvetica Neue"/>
-              </a:defRPr>
-            </a:pPr>
-            <a:r>
-              <a:t>품질 변동 관리</a:t>
+              <a:t>GABA 20%·고형분 30%</a:t>
+            </a:r>
+          </a:p>
+          <a:p xmlns:a="http://schemas.openxmlformats.org/drawingml/2006/main">
+            <a:pPr algn="l">
+              <a:buNone/>
+              <a:defRPr sz="2400">
+                <a:solidFill>
+                  <a:srgbClr val="000000"/>
+                </a:solidFill>
+                <a:latin typeface="Helvetica Neue"/>
+                <a:ea typeface="Helvetica Neue"/>
+                <a:cs typeface="Helvetica Neue"/>
+              </a:defRPr>
+            </a:pPr>
+            <a:r>
+              <a:t>말토덱스트린 혼합</a:t>
             </a:r>
           </a:p>
           <a:p xmlns:a="http://schemas.openxmlformats.org/drawingml/2006/main">
@@ -11750,7 +11791,7 @@
               </a:defRPr>
             </a:pPr>
             <a:r>
-              <a:t>가바크루드 기준품의 kg당 9,240원 원가는 세부 내역 확인이 필요하다</a:t>
+              <a:t>배양액 1톤은 GABA 20% 가바크루드 1톤으로 전환된다</a:t>
             </a:r>
           </a:p>
         </p:txBody>
@@ -11858,23 +11899,23 @@
               </a:defRPr>
             </a:pPr>
             <a:r>
-              <a:t>GABA 함량</a:t>
-            </a:r>
-          </a:p>
-          <a:p xmlns:a="http://schemas.openxmlformats.org/drawingml/2006/main">
-            <a:pPr algn="l">
-              <a:buNone/>
-              <a:defRPr sz="2400">
-                <a:solidFill>
-                  <a:srgbClr val="000000"/>
-                </a:solidFill>
-                <a:latin typeface="Helvetica Neue"/>
-                <a:ea typeface="Helvetica Neue"/>
-                <a:cs typeface="Helvetica Neue"/>
-              </a:defRPr>
-            </a:pPr>
-            <a:r>
-              <a:t>배양액 1톤</a:t>
+              <a:t>말토덱스트린</a:t>
+            </a:r>
+          </a:p>
+          <a:p xmlns:a="http://schemas.openxmlformats.org/drawingml/2006/main">
+            <a:pPr algn="l">
+              <a:buNone/>
+              <a:defRPr sz="2400">
+                <a:solidFill>
+                  <a:srgbClr val="000000"/>
+                </a:solidFill>
+                <a:latin typeface="Helvetica Neue"/>
+                <a:ea typeface="Helvetica Neue"/>
+                <a:cs typeface="Helvetica Neue"/>
+              </a:defRPr>
+            </a:pPr>
+            <a:r>
+              <a:t>투입량</a:t>
             </a:r>
           </a:p>
         </p:txBody>
@@ -11920,23 +11961,23 @@
               </a:defRPr>
             </a:pPr>
             <a:r>
-              <a:t>건조 고형분</a:t>
-            </a:r>
-          </a:p>
-          <a:p xmlns:a="http://schemas.openxmlformats.org/drawingml/2006/main">
-            <a:pPr algn="l">
-              <a:buNone/>
-              <a:defRPr sz="2400">
-                <a:solidFill>
-                  <a:srgbClr val="000000"/>
-                </a:solidFill>
-                <a:latin typeface="Helvetica Neue"/>
-                <a:ea typeface="Helvetica Neue"/>
-                <a:cs typeface="Helvetica Neue"/>
-              </a:defRPr>
-            </a:pPr>
-            <a:r>
-              <a:t>회수량</a:t>
+              <a:t>고형분 구성</a:t>
+            </a:r>
+          </a:p>
+          <a:p xmlns:a="http://schemas.openxmlformats.org/drawingml/2006/main">
+            <a:pPr algn="l">
+              <a:buNone/>
+              <a:defRPr sz="2400">
+                <a:solidFill>
+                  <a:srgbClr val="000000"/>
+                </a:solidFill>
+                <a:latin typeface="Helvetica Neue"/>
+                <a:ea typeface="Helvetica Neue"/>
+                <a:cs typeface="Helvetica Neue"/>
+              </a:defRPr>
+            </a:pPr>
+            <a:r>
+              <a:t>GABA+기타</a:t>
             </a:r>
           </a:p>
         </p:txBody>
@@ -12028,7 +12069,7 @@
               </a:defRPr>
             </a:pPr>
             <a:r>
-              <a:t>300kg</a:t>
+              <a:t>200kg+100kg</a:t>
             </a:r>
           </a:p>
         </p:txBody>
@@ -12074,7 +12115,7 @@
               </a:defRPr>
             </a:pPr>
             <a:r>
-              <a:t>100kg</a:t>
+              <a:t>700kg</a:t>
             </a:r>
           </a:p>
         </p:txBody>
@@ -12120,7 +12161,7 @@
               </a:defRPr>
             </a:pPr>
             <a:r>
-              <a:t>원본: 1,000L×4,000원/L · ※ 건조·부형제·검사·포장·수율 비용의 반영 여부는 아직 확인되지 않음</a:t>
+              <a:t>GABA 200kg÷목표 함량 20%=가바크루드 1,000kg · 배양액 고형분 300kg+말토덱스트린 700kg</a:t>
             </a:r>
           </a:p>
         </p:txBody>
@@ -12366,55 +12407,55 @@
               </a:defRPr>
             </a:pPr>
             <a:r>
-              <a:t>생산 단위</a:t>
-            </a:r>
-          </a:p>
-          <a:p xmlns:a="http://schemas.openxmlformats.org/drawingml/2006/main">
-            <a:pPr algn="l">
-              <a:buNone/>
-              <a:defRPr sz="2400">
-                <a:solidFill>
-                  <a:srgbClr val="000000"/>
-                </a:solidFill>
-                <a:latin typeface="Helvetica Neue"/>
-                <a:ea typeface="Helvetica Neue"/>
-                <a:cs typeface="Helvetica Neue"/>
-              </a:defRPr>
-            </a:pPr>
-            <a:r>
-              <a:t>배양액→가바크루드</a:t>
-            </a:r>
-          </a:p>
-          <a:p xmlns:a="http://schemas.openxmlformats.org/drawingml/2006/main">
-            <a:pPr algn="l">
-              <a:buNone/>
-              <a:defRPr sz="2400">
-                <a:solidFill>
-                  <a:srgbClr val="000000"/>
-                </a:solidFill>
-                <a:latin typeface="Helvetica Neue"/>
-                <a:ea typeface="Helvetica Neue"/>
-                <a:cs typeface="Helvetica Neue"/>
-              </a:defRPr>
-            </a:pPr>
-            <a:r>
-              <a:t>500kg/배치</a:t>
-            </a:r>
-          </a:p>
-          <a:p xmlns:a="http://schemas.openxmlformats.org/drawingml/2006/main">
-            <a:pPr algn="l">
-              <a:buNone/>
-              <a:defRPr sz="2400">
-                <a:solidFill>
-                  <a:srgbClr val="000000"/>
-                </a:solidFill>
-                <a:latin typeface="Helvetica Neue"/>
-                <a:ea typeface="Helvetica Neue"/>
-                <a:cs typeface="Helvetica Neue"/>
-              </a:defRPr>
-            </a:pPr>
-            <a:r>
-              <a:t>로트별 승인</a:t>
+              <a:t>생산 기준</a:t>
+            </a:r>
+          </a:p>
+          <a:p xmlns:a="http://schemas.openxmlformats.org/drawingml/2006/main">
+            <a:pPr algn="l">
+              <a:buNone/>
+              <a:defRPr sz="2400">
+                <a:solidFill>
+                  <a:srgbClr val="000000"/>
+                </a:solidFill>
+                <a:latin typeface="Helvetica Neue"/>
+                <a:ea typeface="Helvetica Neue"/>
+                <a:cs typeface="Helvetica Neue"/>
+              </a:defRPr>
+            </a:pPr>
+            <a:r>
+              <a:t>배양액 1톤당</a:t>
+            </a:r>
+          </a:p>
+          <a:p xmlns:a="http://schemas.openxmlformats.org/drawingml/2006/main">
+            <a:pPr algn="l">
+              <a:buNone/>
+              <a:defRPr sz="2400">
+                <a:solidFill>
+                  <a:srgbClr val="000000"/>
+                </a:solidFill>
+                <a:latin typeface="Helvetica Neue"/>
+                <a:ea typeface="Helvetica Neue"/>
+                <a:cs typeface="Helvetica Neue"/>
+              </a:defRPr>
+            </a:pPr>
+            <a:r>
+              <a:t>가바크루드 1,000kg</a:t>
+            </a:r>
+          </a:p>
+          <a:p xmlns:a="http://schemas.openxmlformats.org/drawingml/2006/main">
+            <a:pPr algn="l">
+              <a:buNone/>
+              <a:defRPr sz="2400">
+                <a:solidFill>
+                  <a:srgbClr val="000000"/>
+                </a:solidFill>
+                <a:latin typeface="Helvetica Neue"/>
+                <a:ea typeface="Helvetica Neue"/>
+                <a:cs typeface="Helvetica Neue"/>
+              </a:defRPr>
+            </a:pPr>
+            <a:r>
+              <a:t>이론 수율</a:t>
             </a:r>
           </a:p>
         </p:txBody>

</xml_diff>

<commit_message>
feat: add multi-species validation and 100-point evidence plan
</commit_message>
<xml_diff>
--- a/GABA_Feed_Business_Model_Speech_Deck_v1.pptx
+++ b/GABA_Feed_Business_Model_Speech_Deck_v1.pptx
@@ -2,32 +2,32 @@
 <file path=ppt/presentation.xml><?xml version="1.0" encoding="utf-8"?>
 <p:presentation xmlns:p="http://schemas.openxmlformats.org/presentationml/2006/main">
   <p:sldMasterIdLst>
-    <p:sldMasterId xmlns:r="http://schemas.openxmlformats.org/officeDocument/2006/relationships" id="2147483648" r:id="R6bdd412e7a9f4e72"/>
+    <p:sldMasterId xmlns:r="http://schemas.openxmlformats.org/officeDocument/2006/relationships" id="2147483648" r:id="R75038a33079345b6"/>
   </p:sldMasterIdLst>
   <p:notesMasterIdLst>
-    <p:notesMasterId xmlns:r="http://schemas.openxmlformats.org/officeDocument/2006/relationships" r:id="R4f36e2ff82324f69"/>
+    <p:notesMasterId xmlns:r="http://schemas.openxmlformats.org/officeDocument/2006/relationships" r:id="Ra91e2711c8f94f5a"/>
   </p:notesMasterIdLst>
   <p:sldIdLst>
-    <p:sldId xmlns:r="http://schemas.openxmlformats.org/officeDocument/2006/relationships" id="256" r:id="R76380bddf2e34336"/>
-    <p:sldId xmlns:r="http://schemas.openxmlformats.org/officeDocument/2006/relationships" id="257" r:id="R1572a907091240d0"/>
-    <p:sldId xmlns:r="http://schemas.openxmlformats.org/officeDocument/2006/relationships" id="258" r:id="R7d85d906a9364159"/>
-    <p:sldId xmlns:r="http://schemas.openxmlformats.org/officeDocument/2006/relationships" id="259" r:id="R934c41cd54c9418f"/>
-    <p:sldId xmlns:r="http://schemas.openxmlformats.org/officeDocument/2006/relationships" id="260" r:id="Rfe07d0686b5444fc"/>
-    <p:sldId xmlns:r="http://schemas.openxmlformats.org/officeDocument/2006/relationships" id="261" r:id="R7a1c8f652de84c3d"/>
-    <p:sldId xmlns:r="http://schemas.openxmlformats.org/officeDocument/2006/relationships" id="262" r:id="R8987b41f775b4805"/>
-    <p:sldId xmlns:r="http://schemas.openxmlformats.org/officeDocument/2006/relationships" id="263" r:id="R9f0c5684735c4823"/>
-    <p:sldId xmlns:r="http://schemas.openxmlformats.org/officeDocument/2006/relationships" id="264" r:id="R233252fb3b5a4c18"/>
-    <p:sldId xmlns:r="http://schemas.openxmlformats.org/officeDocument/2006/relationships" id="265" r:id="R24d5c7d2a88d4b87"/>
-    <p:sldId xmlns:r="http://schemas.openxmlformats.org/officeDocument/2006/relationships" id="266" r:id="R3259f03865dd4775"/>
-    <p:sldId xmlns:r="http://schemas.openxmlformats.org/officeDocument/2006/relationships" id="267" r:id="R9af845fd5a864863"/>
-    <p:sldId xmlns:r="http://schemas.openxmlformats.org/officeDocument/2006/relationships" id="268" r:id="Rf5c46a48d74b4101"/>
-    <p:sldId xmlns:r="http://schemas.openxmlformats.org/officeDocument/2006/relationships" id="269" r:id="R2807a459173d4daa"/>
-    <p:sldId xmlns:r="http://schemas.openxmlformats.org/officeDocument/2006/relationships" id="270" r:id="R0797ca28ea1d44a6"/>
-    <p:sldId xmlns:r="http://schemas.openxmlformats.org/officeDocument/2006/relationships" id="271" r:id="Rf40e2e06bf674979"/>
-    <p:sldId xmlns:r="http://schemas.openxmlformats.org/officeDocument/2006/relationships" id="272" r:id="R2b5aaa056c1f46ef"/>
-    <p:sldId xmlns:r="http://schemas.openxmlformats.org/officeDocument/2006/relationships" id="273" r:id="Rb61a1ebb9f134d81"/>
-    <p:sldId xmlns:r="http://schemas.openxmlformats.org/officeDocument/2006/relationships" id="274" r:id="R17948ed7fae74a73"/>
-    <p:sldId xmlns:r="http://schemas.openxmlformats.org/officeDocument/2006/relationships" id="275" r:id="R31c58a7c9db94cf2"/>
+    <p:sldId xmlns:r="http://schemas.openxmlformats.org/officeDocument/2006/relationships" id="256" r:id="R6920353e991246f9"/>
+    <p:sldId xmlns:r="http://schemas.openxmlformats.org/officeDocument/2006/relationships" id="257" r:id="Re4277062aee242c5"/>
+    <p:sldId xmlns:r="http://schemas.openxmlformats.org/officeDocument/2006/relationships" id="258" r:id="R5855bd3cbd0f41da"/>
+    <p:sldId xmlns:r="http://schemas.openxmlformats.org/officeDocument/2006/relationships" id="259" r:id="R6635389ef8d84557"/>
+    <p:sldId xmlns:r="http://schemas.openxmlformats.org/officeDocument/2006/relationships" id="260" r:id="Ra6f93f8a0e194da4"/>
+    <p:sldId xmlns:r="http://schemas.openxmlformats.org/officeDocument/2006/relationships" id="261" r:id="Rd9ae9108c6cb41c8"/>
+    <p:sldId xmlns:r="http://schemas.openxmlformats.org/officeDocument/2006/relationships" id="262" r:id="Rd63ed876d1134b8c"/>
+    <p:sldId xmlns:r="http://schemas.openxmlformats.org/officeDocument/2006/relationships" id="263" r:id="R13c4a9880c11449e"/>
+    <p:sldId xmlns:r="http://schemas.openxmlformats.org/officeDocument/2006/relationships" id="264" r:id="Rf76092e2568c4d45"/>
+    <p:sldId xmlns:r="http://schemas.openxmlformats.org/officeDocument/2006/relationships" id="265" r:id="R58b54204c2c24948"/>
+    <p:sldId xmlns:r="http://schemas.openxmlformats.org/officeDocument/2006/relationships" id="266" r:id="Rb3554f05506741b9"/>
+    <p:sldId xmlns:r="http://schemas.openxmlformats.org/officeDocument/2006/relationships" id="267" r:id="R9b22673d38984af0"/>
+    <p:sldId xmlns:r="http://schemas.openxmlformats.org/officeDocument/2006/relationships" id="268" r:id="Rc39f0a9e0c664169"/>
+    <p:sldId xmlns:r="http://schemas.openxmlformats.org/officeDocument/2006/relationships" id="269" r:id="R1c86c23a98144f56"/>
+    <p:sldId xmlns:r="http://schemas.openxmlformats.org/officeDocument/2006/relationships" id="270" r:id="R5c40e130b8c54792"/>
+    <p:sldId xmlns:r="http://schemas.openxmlformats.org/officeDocument/2006/relationships" id="271" r:id="Ra56ef89229d446db"/>
+    <p:sldId xmlns:r="http://schemas.openxmlformats.org/officeDocument/2006/relationships" id="272" r:id="R77c4b63c9e574054"/>
+    <p:sldId xmlns:r="http://schemas.openxmlformats.org/officeDocument/2006/relationships" id="273" r:id="Ra9a01070047646c3"/>
+    <p:sldId xmlns:r="http://schemas.openxmlformats.org/officeDocument/2006/relationships" id="274" r:id="Rbcb7cfe4ec2a4f65"/>
+    <p:sldId xmlns:r="http://schemas.openxmlformats.org/officeDocument/2006/relationships" id="275" r:id="R913ae70b4f484996"/>
   </p:sldIdLst>
   <p:sldSz cx="12192000" cy="6858000"/>
   <p:notesSz cx="6858000" cy="9144000"/>
@@ -461,7 +461,7 @@
           <a:lstStyle xmlns:a="http://schemas.openxmlformats.org/drawingml/2006/main"/>
           <a:p xmlns:a="http://schemas.openxmlformats.org/drawingml/2006/main">
             <a:r>
-              <a:t>가바사료 사업은 두 부문으로 나눕니다. 가바크루드는 GABA 20% 기준품과 고객 주문에 맞춘 5~20% OEM 원료를 공급합니다. 가바케어믹스는 가바크루드와 미네랄매트릭스를 결합한 비육 한우 브랜드 축산용 배합사료로 고도화합니다. 목표는 육질 개선과 생산성 향상이지만, 실제 효과는 대조군 시험과 출하 성적으로 확인합니다.</a:t>
+              <a:t>가바사료 사업은 두 부문으로 나눕니다. 가바크루드는 GABA 20% 기준품과 고객 주문에 맞춘 5~20% OEM 원료를 공급합니다. 가바케어믹스는 가바크루드와 미네랄매트릭스를 결합해 비육우, 젖소, 돼지, 육계, 산란계, 염소와 면양에 적용하는 브랜드 배합사료로 고도화합니다. 목표는 생산성과 축산물 품질의 개선이지만, 실제 효과는 축종별 대조군 시험과 최종 생산물 성적으로 확인합니다.</a:t>
             </a:r>
           </a:p>
           <a:p xmlns:a="http://schemas.openxmlformats.org/drawingml/2006/main">
@@ -551,7 +551,7 @@
           <a:lstStyle xmlns:a="http://schemas.openxmlformats.org/drawingml/2006/main"/>
           <a:p xmlns:a="http://schemas.openxmlformats.org/drawingml/2006/main">
             <a:r>
-              <a:t>첫 시험은 비육 한우로 좁힙니다. 같은 사육 조건에서 가바케어믹스 급여군과 대조군을 비교하고, 제품 활성함량과 배합 조건을 고정합니다. 생산성은 ADG, FCR, kg 증체당 사료비로 보고, 육질은 도체중, 등심단면적, 근내지방도, 육질등급, 등지방두께로 판단합니다. ADG는 일당증체량, FCR은 체중 1kg 증가에 필요한 사료량입니다.</a:t>
+              <a:t>검증 범위는 비육우, 젖소, 돼지, 육계, 산란계, 염소와 면양입니다. 모든 시험에서 제품 활성함량과 배합 조건을 고정하고 대조군을 둡니다. 축종에 따라 증체, 산유, 산란, 사료효율과 단위 생산량당 사료비를 측정하며, 최종 생산물은 도체와 육질, 우유, 계란 품질로 나눠 판단합니다. FCR은 단위 생산량에 필요한 사료량을 뜻합니다.</a:t>
             </a:r>
           </a:p>
           <a:p xmlns:a="http://schemas.openxmlformats.org/drawingml/2006/main">
@@ -571,7 +571,22 @@
           </a:p>
           <a:p xmlns:a="http://schemas.openxmlformats.org/drawingml/2006/main">
             <a:r>
-              <a:t>- https://www.kci.go.kr/kciportal/landing/article.kci?arti_id=ART003036784</a:t>
+              <a:t>- https://eur-lex.europa.eu/eli/reg/2008/429/oj/eng</a:t>
+            </a:r>
+          </a:p>
+          <a:p xmlns:a="http://schemas.openxmlformats.org/drawingml/2006/main">
+            <a:r>
+              <a:t>- https://www.nias.go.kr/front/contview3.do?cmCode=M170106113356833&amp;cntntsNo=202201&amp;mainCategoryCode=</a:t>
+            </a:r>
+          </a:p>
+          <a:p xmlns:a="http://schemas.openxmlformats.org/drawingml/2006/main">
+            <a:r>
+              <a:t>- https://nias.go.kr/front/soboarddown.do?boardSeqNum=3668&amp;cmCode=M090814150850297&amp;fileSeqNum=2744</a:t>
+            </a:r>
+          </a:p>
+          <a:p xmlns:a="http://schemas.openxmlformats.org/drawingml/2006/main">
+            <a:r>
+              <a:t>- https://nias.go.kr/front/soboarddown.do?boardSeqNum=9095&amp;cmCode=M091023194037455&amp;fileSeqNum=5948</a:t>
             </a:r>
           </a:p>
         </p:txBody>
@@ -1091,7 +1106,7 @@
           <a:lstStyle xmlns:a="http://schemas.openxmlformats.org/drawingml/2006/main"/>
           <a:p xmlns:a="http://schemas.openxmlformats.org/drawingml/2006/main">
             <a:r>
-              <a:t>30일은 제품과 사업 준비의 시간입니다. 이 기간에 제품 규격, 품목·표시 문구, 시험생산, 실제 원가와 유료 농장 계약을 확인합니다. 90일은 생산성의 조기 신호를 보는 기간이며, 육질은 출하 성적으로 최종 판정합니다. 이상반응, 지속적인 섭취 저하, kg 증체당 비용 악화, 제품 규격 미달이 확인되면 시험을 중단하거나 확대를 보류합니다.</a:t>
+              <a:t>축종별 기간은 EU 집행규정 429/2008 부속서 IV의 장기 효능시험 최소기간을 사업계획 기준으로 적용했습니다. 비육우 168일 이상, 젖소 84일 이상, 이유자돈 42일, 비육돈 70일 이상, 육계 35일, 산란계 168일, 염소와 면양 56일 이상이며 착유 시험은 84일입니다. 국내 시험기관은 적응기간, 개체수, 반복수, 통계모형과 동물윤리 절차를 최종 확정합니다. 국립축산과학원 자료에서도 이유자돈 6주, 육계 5~6주, 산란계 8주와 같은 연구기간을 확인할 수 있지만, 소재와 목적이 달라 가바케어믹스 효능 근거로 사용하지 않습니다.</a:t>
             </a:r>
           </a:p>
           <a:p xmlns:a="http://schemas.openxmlformats.org/drawingml/2006/main">
@@ -1106,17 +1121,22 @@
           </a:p>
           <a:p xmlns:a="http://schemas.openxmlformats.org/drawingml/2006/main">
             <a:r>
-              <a:t>- 사용자 제공 사업화 정보 · 2026-08-03</a:t>
-            </a:r>
-          </a:p>
-          <a:p xmlns:a="http://schemas.openxmlformats.org/drawingml/2006/main">
-            <a:r>
-              <a:t>- https://www.law.go.kr/행정규칙/사료%20등의%20기준%20및%20규격</a:t>
-            </a:r>
-          </a:p>
-          <a:p xmlns:a="http://schemas.openxmlformats.org/drawingml/2006/main">
-            <a:r>
-              <a:t>- https://www.law.go.kr/LSW/admRulInfoP.do?admRulSeq=2100000231582&amp;chrClsCd=010201</a:t>
+              <a:t>- https://eur-lex.europa.eu/eli/reg/2008/429/oj/eng</a:t>
+            </a:r>
+          </a:p>
+          <a:p xmlns:a="http://schemas.openxmlformats.org/drawingml/2006/main">
+            <a:r>
+              <a:t>- https://www.nias.go.kr/front/contview3.do?cmCode=M170106113356833&amp;cntntsNo=202201&amp;mainCategoryCode=</a:t>
+            </a:r>
+          </a:p>
+          <a:p xmlns:a="http://schemas.openxmlformats.org/drawingml/2006/main">
+            <a:r>
+              <a:t>- https://nias.go.kr/front/soboarddown.do?boardSeqNum=3668&amp;cmCode=M090814150850297&amp;fileSeqNum=2744</a:t>
+            </a:r>
+          </a:p>
+          <a:p xmlns:a="http://schemas.openxmlformats.org/drawingml/2006/main">
+            <a:r>
+              <a:t>- https://nias.go.kr/front/soboarddown.do?boardSeqNum=9095&amp;cmCode=M091023194037455&amp;fileSeqNum=5948</a:t>
             </a:r>
           </a:p>
         </p:txBody>
@@ -1186,7 +1206,7 @@
           <a:lstStyle xmlns:a="http://schemas.openxmlformats.org/drawingml/2006/main"/>
           <a:p xmlns:a="http://schemas.openxmlformats.org/drawingml/2006/main">
             <a:r>
-              <a:t>0일에서 7일 사이에는 제품 규격, 품목·표시 문구와 비육 한우 대조군 시험계획을 확정합니다. 8일에서 21일 사이에는 시험생산 한 번과 3지점 시료로 재현성을 확인하고 실제 원가를 계산합니다. 22일에서 30일 사이에는 유료 농장 한 곳과 발주서 한 건을 확보해 실증을 시작합니다. 이후 90일까지 생산성 조기 신호를 보고, 육질은 출하 시점에 최종 판단합니다.</a:t>
+              <a:t>현재 확인된 준비도는 41점입니다. 100점까지 남은 59점은 규제 14점, 제품 12점, 공급 8점, 단위 경제성 9점, 상업성 16점입니다. 품목 분류와 표시 문구, 제품 규격과 축종별 시험, OEM 품질협약, 실제 견적과 수율, 유료 시험과 반복 주문의 파일 또는 URL에 검토 결론이 연결될 때만 점수를 올립니다. 목표 100점은 실행 목표이지 현재 상태가 아닙니다.</a:t>
             </a:r>
           </a:p>
           <a:p xmlns:a="http://schemas.openxmlformats.org/drawingml/2006/main">
@@ -1212,6 +1232,16 @@
           <a:p xmlns:a="http://schemas.openxmlformats.org/drawingml/2006/main">
             <a:r>
               <a:t>- https://www.law.go.kr/LSW/admRulInfoP.do?admRulSeq=2100000231582&amp;chrClsCd=010201</a:t>
+            </a:r>
+          </a:p>
+          <a:p xmlns:a="http://schemas.openxmlformats.org/drawingml/2006/main">
+            <a:r>
+              <a:t>- https://eur-lex.europa.eu/eli/reg/2008/429/oj/eng</a:t>
+            </a:r>
+          </a:p>
+          <a:p xmlns:a="http://schemas.openxmlformats.org/drawingml/2006/main">
+            <a:r>
+              <a:t>- D:/다운로드/GABA_20_Master_Inventory_OEM_Make_to_Order_Business_Model_v5.pptx</a:t>
             </a:r>
           </a:p>
         </p:txBody>
@@ -1456,7 +1486,7 @@
           <a:lstStyle xmlns:a="http://schemas.openxmlformats.org/drawingml/2006/main"/>
           <a:p xmlns:a="http://schemas.openxmlformats.org/drawingml/2006/main">
             <a:r>
-              <a:t>속도를 높이되 검증 기간을 왜곡하지 않습니다. 30일 안에 제품 규격, 시험생산, 실제 원가와 유료 농장 실증을 준비합니다. 90일에는 일당증체량과 사료요구율 같은 생산성 조기 신호를 확인하고, 육질은 개체 식별이 연결된 출하 성적으로 최종 판단합니다.</a:t>
+              <a:t>30일은 제품 규격, 시험생산, 실제 원가와 유료 시험 계약을 준비하는 기간입니다. 효능은 육계 35일, 이유자돈 42일, 비육돈 70일 이상, 젖소 84일 이상, 비육우와 산란계 168일처럼 축종의 생산주기를 반영해 판정합니다. 현재 확인된 준비도는 41점이며, 100점은 모든 완료 증빙이 검토된 뒤에만 반영합니다.</a:t>
             </a:r>
           </a:p>
           <a:p xmlns:a="http://schemas.openxmlformats.org/drawingml/2006/main">
@@ -1472,6 +1502,11 @@
           <a:p xmlns:a="http://schemas.openxmlformats.org/drawingml/2006/main">
             <a:r>
               <a:t>- 사용자 제공 사업화 정보 · 2026-08-03</a:t>
+            </a:r>
+          </a:p>
+          <a:p xmlns:a="http://schemas.openxmlformats.org/drawingml/2006/main">
+            <a:r>
+              <a:t>- https://eur-lex.europa.eu/eli/reg/2008/429/oj/eng</a:t>
             </a:r>
           </a:p>
           <a:p xmlns:a="http://schemas.openxmlformats.org/drawingml/2006/main">
@@ -1546,7 +1581,7 @@
           <a:lstStyle xmlns:a="http://schemas.openxmlformats.org/drawingml/2006/main"/>
           <a:p xmlns:a="http://schemas.openxmlformats.org/drawingml/2006/main">
             <a:r>
-              <a:t>마지막 장은 두 사업의 정의, 통상적인 손익 용어, 주요 사업화 일정과 이용 시 주의사항을 정리했습니다. 매출총이익은 매출액에서 매출원가를 뺀 금액이며 판매관리비와 고정비를 차감하기 전 값입니다. 2026년 8월 파일럿 생산, 2027년 상반기 양산 가동, 2028년 하반기 자체 공장 설립은 목표 일정이며 단계별 승인 조건을 통과해야 합니다. 30일은 제품과 사업 준비를 마치고 유료 실증을 시작하는 목표이며, 육질 개선 효능을 확정하는 시점이 아닙니다. 법적 분류와 표시·광고 문구는 별도 전문 검토가 필요합니다.</a:t>
+              <a:t>마지막 장은 두 사업의 정의, 통상적인 손익 용어, 주요 사업화 일정과 이용 시 주의사항을 정리했습니다. 매출총이익은 매출액에서 매출원가를 뺀 금액이며 판매관리비와 고정비를 차감하기 전 값입니다. 현재 준비도는 확인된 증빙 기준 41점이고 목표는 100점입니다. 30일은 제품과 사업 준비를 마치고 유료 시험을 시작하는 기간이며, 효능은 축종별 장기 시험이 끝난 뒤 판단합니다. 법적 분류와 표시·광고 문구는 별도 전문 검토가 필요합니다.</a:t>
             </a:r>
           </a:p>
           <a:p xmlns:a="http://schemas.openxmlformats.org/drawingml/2006/main">
@@ -1582,6 +1617,26 @@
           <a:p xmlns:a="http://schemas.openxmlformats.org/drawingml/2006/main">
             <a:r>
               <a:t>- https://www.mafra.go.kr/bbs/home/791/597692/download.do</a:t>
+            </a:r>
+          </a:p>
+          <a:p xmlns:a="http://schemas.openxmlformats.org/drawingml/2006/main">
+            <a:r>
+              <a:t>- https://eur-lex.europa.eu/eli/reg/2008/429/oj/eng</a:t>
+            </a:r>
+          </a:p>
+          <a:p xmlns:a="http://schemas.openxmlformats.org/drawingml/2006/main">
+            <a:r>
+              <a:t>- https://www.nias.go.kr/front/contview3.do?cmCode=M170106113356833&amp;cntntsNo=202201&amp;mainCategoryCode=</a:t>
+            </a:r>
+          </a:p>
+          <a:p xmlns:a="http://schemas.openxmlformats.org/drawingml/2006/main">
+            <a:r>
+              <a:t>- https://nias.go.kr/front/soboarddown.do?boardSeqNum=3668&amp;cmCode=M090814150850297&amp;fileSeqNum=2744</a:t>
+            </a:r>
+          </a:p>
+          <a:p xmlns:a="http://schemas.openxmlformats.org/drawingml/2006/main">
+            <a:r>
+              <a:t>- https://nias.go.kr/front/soboarddown.do?boardSeqNum=9095&amp;cmCode=M091023194037455&amp;fileSeqNum=5948</a:t>
             </a:r>
           </a:p>
           <a:p xmlns:a="http://schemas.openxmlformats.org/drawingml/2006/main">
@@ -1671,7 +1726,7 @@
           <a:lstStyle xmlns:a="http://schemas.openxmlformats.org/drawingml/2006/main"/>
           <a:p xmlns:a="http://schemas.openxmlformats.org/drawingml/2006/main">
             <a:r>
-              <a:t>가바크루드는 원료 고객에게 기준품과 주문형 농도를 공급합니다. 가바케어믹스는 그 원료에 미네랄매트릭스를 결합해 비육 한우 브랜드 축산용 배합사료로 확장합니다. 두 사업의 공통 기준은 활성 GABA 함량과 로트별 시험성적서입니다.</a:t>
+              <a:t>가바크루드는 원료 고객에게 기준품과 주문형 농도를 공급합니다. 가바케어믹스는 그 원료에 미네랄매트릭스를 결합해 축종별 브랜드 배합사료로 확장합니다. 두 사업의 공통 기준은 활성 GABA 함량과 로트별 시험성적서입니다.</a:t>
             </a:r>
           </a:p>
           <a:p xmlns:a="http://schemas.openxmlformats.org/drawingml/2006/main">
@@ -2206,7 +2261,7 @@
           <a:lstStyle xmlns:a="http://schemas.openxmlformats.org/drawingml/2006/main"/>
           <a:p xmlns:a="http://schemas.openxmlformats.org/drawingml/2006/main">
             <a:r>
-              <a:t>세 연구의 결과는 일관되지 않습니다. 2026년 젖소 연구에서는 산유량 차이가 통계적으로 유의하지 않았고 일부 유성분만 유의했습니다. 2023년 한우 연구는 초기 증체에서 가능성을 보였지만 도체 지표는 유의하지 않았습니다. 2025년 넙치 연구에서도 성장 개선이 확인되지 않았습니다. 따라서 기존 연구를 효능 주장으로 사용하지 않고, 비육 한우와 해당 제품에 맞춘 대조군 시험을 새로 설계합니다.</a:t>
+              <a:t>세 연구의 결과는 일관되지 않습니다. 2026년 젖소 연구에서는 산유량 차이가 통계적으로 유의하지 않았고 일부 유성분만 유의했습니다. 2023년 한우 연구는 초기 증체에서 가능성을 보였지만 도체 지표는 유의하지 않았습니다. 2025년 넙치 연구에서도 성장 개선이 확인되지 않았습니다. 따라서 기존 연구를 효능 주장으로 사용하지 않고, 가바케어믹스의 동일 로트와 축종별 대조군을 사용한 새 시험을 설계합니다.</a:t>
             </a:r>
           </a:p>
           <a:p xmlns:a="http://schemas.openxmlformats.org/drawingml/2006/main">
@@ -2299,7 +2354,7 @@
   </p:cSld>
   <p:clrMap bg1="lt1" tx1="dk1" bg2="lt2" tx2="dk2" accent1="accent1" accent2="accent2" accent3="accent3" accent4="accent4" accent5="accent5" accent6="accent6" hlink="hlink" folHlink="folHlink"/>
   <p:sldLayoutIdLst>
-    <p:sldLayoutId xmlns:r="http://schemas.openxmlformats.org/officeDocument/2006/relationships" id="2147483649" r:id="R9e9b18afb5214a2b"/>
+    <p:sldLayoutId xmlns:r="http://schemas.openxmlformats.org/officeDocument/2006/relationships" id="2147483649" r:id="R484251731ecf4b68"/>
   </p:sldLayoutIdLst>
   <p:txStyles>
     <p:titleStyle>
@@ -3068,7 +3123,7 @@
               </a:defRPr>
             </a:pPr>
             <a:r>
-              <a:t>육질과 생산성을 함께 검증하는 가바케어믹스로 고도화한다</a:t>
+              <a:t>생산성과 축산물 품질을 함께 검증하는 가바케어믹스로 고도화한다</a:t>
             </a:r>
           </a:p>
         </p:txBody>
@@ -3130,7 +3185,7 @@
               </a:defRPr>
             </a:pPr>
             <a:r>
-              <a:t>가바케어믹스: 비육 한우 브랜드 축산용 배합사료</a:t>
+              <a:t>가바케어믹스: 주요 가축별 브랜드 배합사료</a:t>
             </a:r>
           </a:p>
         </p:txBody>
@@ -3378,7 +3433,7 @@
               </a:defRPr>
             </a:pPr>
             <a:r>
-              <a:t>가바케어믹스의 첫 검증은 비육 한우 한 축종에 집중한다</a:t>
+              <a:t>가바케어믹스는 같은 제품 기준으로 6개 축종군을 검증한다</a:t>
             </a:r>
           </a:p>
         </p:txBody>
@@ -3438,39 +3493,39 @@
               </a:defRPr>
             </a:pPr>
             <a:r>
-              <a:t>비육 한우</a:t>
-            </a:r>
-          </a:p>
-          <a:p xmlns:a="http://schemas.openxmlformats.org/drawingml/2006/main">
-            <a:pPr algn="l">
-              <a:buNone/>
-              <a:defRPr sz="2400">
-                <a:solidFill>
-                  <a:srgbClr val="000000"/>
-                </a:solidFill>
-                <a:latin typeface="Helvetica Neue"/>
-                <a:ea typeface="Helvetica Neue"/>
-                <a:cs typeface="Helvetica Neue"/>
-              </a:defRPr>
-            </a:pPr>
-            <a:r>
-              <a:t>동일 사육조건</a:t>
-            </a:r>
-          </a:p>
-          <a:p xmlns:a="http://schemas.openxmlformats.org/drawingml/2006/main">
-            <a:pPr algn="l">
-              <a:buNone/>
-              <a:defRPr sz="2400">
-                <a:solidFill>
-                  <a:srgbClr val="000000"/>
-                </a:solidFill>
-                <a:latin typeface="Helvetica Neue"/>
-                <a:ea typeface="Helvetica Neue"/>
-                <a:cs typeface="Helvetica Neue"/>
-              </a:defRPr>
-            </a:pPr>
-            <a:r>
-              <a:t>가바케어믹스·대조군</a:t>
+              <a:t>비육우·젖소·돼지</a:t>
+            </a:r>
+          </a:p>
+          <a:p xmlns:a="http://schemas.openxmlformats.org/drawingml/2006/main">
+            <a:pPr algn="l">
+              <a:buNone/>
+              <a:defRPr sz="2400">
+                <a:solidFill>
+                  <a:srgbClr val="000000"/>
+                </a:solidFill>
+                <a:latin typeface="Helvetica Neue"/>
+                <a:ea typeface="Helvetica Neue"/>
+                <a:cs typeface="Helvetica Neue"/>
+              </a:defRPr>
+            </a:pPr>
+            <a:r>
+              <a:t>육계·산란계</a:t>
+            </a:r>
+          </a:p>
+          <a:p xmlns:a="http://schemas.openxmlformats.org/drawingml/2006/main">
+            <a:pPr algn="l">
+              <a:buNone/>
+              <a:defRPr sz="2400">
+                <a:solidFill>
+                  <a:srgbClr val="000000"/>
+                </a:solidFill>
+                <a:latin typeface="Helvetica Neue"/>
+                <a:ea typeface="Helvetica Neue"/>
+                <a:cs typeface="Helvetica Neue"/>
+              </a:defRPr>
+            </a:pPr>
+            <a:r>
+              <a:t>염소·면양</a:t>
             </a:r>
           </a:p>
         </p:txBody>
@@ -3624,7 +3679,7 @@
               </a:defRPr>
             </a:pPr>
             <a:r>
-              <a:t>일당증체량 ADG</a:t>
+              <a:t>증체·산유·산란</a:t>
             </a:r>
           </a:p>
           <a:p xmlns:a="http://schemas.openxmlformats.org/drawingml/2006/main">
@@ -3656,7 +3711,7 @@
               </a:defRPr>
             </a:pPr>
             <a:r>
-              <a:t>kg 증체당 사료비</a:t>
+              <a:t>단위 생산량당 사료비</a:t>
             </a:r>
           </a:p>
         </p:txBody>
@@ -3702,55 +3757,55 @@
               </a:defRPr>
             </a:pPr>
             <a:r>
-              <a:t>육질</a:t>
-            </a:r>
-          </a:p>
-          <a:p xmlns:a="http://schemas.openxmlformats.org/drawingml/2006/main">
-            <a:pPr algn="l">
-              <a:buNone/>
-              <a:defRPr sz="2400">
-                <a:solidFill>
-                  <a:srgbClr val="000000"/>
-                </a:solidFill>
-                <a:latin typeface="Helvetica Neue"/>
-                <a:ea typeface="Helvetica Neue"/>
-                <a:cs typeface="Helvetica Neue"/>
-              </a:defRPr>
-            </a:pPr>
-            <a:r>
-              <a:t>도체중·등심단면적</a:t>
-            </a:r>
-          </a:p>
-          <a:p xmlns:a="http://schemas.openxmlformats.org/drawingml/2006/main">
-            <a:pPr algn="l">
-              <a:buNone/>
-              <a:defRPr sz="2400">
-                <a:solidFill>
-                  <a:srgbClr val="000000"/>
-                </a:solidFill>
-                <a:latin typeface="Helvetica Neue"/>
-                <a:ea typeface="Helvetica Neue"/>
-                <a:cs typeface="Helvetica Neue"/>
-              </a:defRPr>
-            </a:pPr>
-            <a:r>
-              <a:t>근내지방도·육질등급</a:t>
-            </a:r>
-          </a:p>
-          <a:p xmlns:a="http://schemas.openxmlformats.org/drawingml/2006/main">
-            <a:pPr algn="l">
-              <a:buNone/>
-              <a:defRPr sz="2400">
-                <a:solidFill>
-                  <a:srgbClr val="000000"/>
-                </a:solidFill>
-                <a:latin typeface="Helvetica Neue"/>
-                <a:ea typeface="Helvetica Neue"/>
-                <a:cs typeface="Helvetica Neue"/>
-              </a:defRPr>
-            </a:pPr>
-            <a:r>
-              <a:t>등지방두께</a:t>
+              <a:t>최종 품질</a:t>
+            </a:r>
+          </a:p>
+          <a:p xmlns:a="http://schemas.openxmlformats.org/drawingml/2006/main">
+            <a:pPr algn="l">
+              <a:buNone/>
+              <a:defRPr sz="2400">
+                <a:solidFill>
+                  <a:srgbClr val="000000"/>
+                </a:solidFill>
+                <a:latin typeface="Helvetica Neue"/>
+                <a:ea typeface="Helvetica Neue"/>
+                <a:cs typeface="Helvetica Neue"/>
+              </a:defRPr>
+            </a:pPr>
+            <a:r>
+              <a:t>도체·육질</a:t>
+            </a:r>
+          </a:p>
+          <a:p xmlns:a="http://schemas.openxmlformats.org/drawingml/2006/main">
+            <a:pPr algn="l">
+              <a:buNone/>
+              <a:defRPr sz="2400">
+                <a:solidFill>
+                  <a:srgbClr val="000000"/>
+                </a:solidFill>
+                <a:latin typeface="Helvetica Neue"/>
+                <a:ea typeface="Helvetica Neue"/>
+                <a:cs typeface="Helvetica Neue"/>
+              </a:defRPr>
+            </a:pPr>
+            <a:r>
+              <a:t>유량·유성분</a:t>
+            </a:r>
+          </a:p>
+          <a:p xmlns:a="http://schemas.openxmlformats.org/drawingml/2006/main">
+            <a:pPr algn="l">
+              <a:buNone/>
+              <a:defRPr sz="2400">
+                <a:solidFill>
+                  <a:srgbClr val="000000"/>
+                </a:solidFill>
+                <a:latin typeface="Helvetica Neue"/>
+                <a:ea typeface="Helvetica Neue"/>
+                <a:cs typeface="Helvetica Neue"/>
+              </a:defRPr>
+            </a:pPr>
+            <a:r>
+              <a:t>산란율·난질</a:t>
             </a:r>
           </a:p>
         </p:txBody>
@@ -3840,7 +3895,7 @@
                 <a:ea typeface="Arial"/>
                 <a:cs typeface="Arial"/>
               </a:rPr>
-              <a:t>GABA BUSINESS MODEL | 10 | GABA CARE MIX POV</a:t>
+              <a:t>GABA BUSINESS MODEL | 10 | TARGET SPECIES PROTOCOL</a:t>
             </a:r>
           </a:p>
         </p:txBody>
@@ -7005,7 +7060,7 @@
         </p:xfrm>
         <a:graphic xmlns:a="http://schemas.openxmlformats.org/drawingml/2006/main">
           <a:graphicData uri="http://schemas.openxmlformats.org/drawingml/2006/chart">
-            <c:chart xmlns:r="http://schemas.openxmlformats.org/officeDocument/2006/relationships" xmlns:c="http://schemas.openxmlformats.org/drawingml/2006/chart" r:id="Rc5149fd3899c4e0a"/>
+            <c:chart xmlns:r="http://schemas.openxmlformats.org/officeDocument/2006/relationships" xmlns:c="http://schemas.openxmlformats.org/drawingml/2006/chart" r:id="Reffd6d35d6c94dfb"/>
           </a:graphicData>
         </a:graphic>
       </p:graphicFrame>
@@ -7206,7 +7261,7 @@
               </a:defRPr>
             </a:pPr>
             <a:r>
-              <a:t>검증 속도는 높이되, 육질 판정 시점은 출하에 맞춘다</a:t>
+              <a:t>시험기간은 축종의 생산주기에 맞춘다</a:t>
             </a:r>
           </a:p>
         </p:txBody>
@@ -7250,55 +7305,39 @@
               </a:defRPr>
             </a:pPr>
             <a:r>
-              <a:t>30일</a:t>
-            </a:r>
-          </a:p>
-          <a:p xmlns:a="http://schemas.openxmlformats.org/drawingml/2006/main">
-            <a:pPr algn="l">
-              <a:buNone/>
-              <a:defRPr sz="2400">
-                <a:solidFill>
-                  <a:srgbClr val="000000"/>
-                </a:solidFill>
-                <a:latin typeface="Helvetica Neue"/>
-                <a:ea typeface="Helvetica Neue"/>
-                <a:cs typeface="Helvetica Neue"/>
-              </a:defRPr>
-            </a:pPr>
-            <a:r>
-              <a:t>규격·품목 검토</a:t>
-            </a:r>
-          </a:p>
-          <a:p xmlns:a="http://schemas.openxmlformats.org/drawingml/2006/main">
-            <a:pPr algn="l">
-              <a:buNone/>
-              <a:defRPr sz="2400">
-                <a:solidFill>
-                  <a:srgbClr val="000000"/>
-                </a:solidFill>
-                <a:latin typeface="Helvetica Neue"/>
-                <a:ea typeface="Helvetica Neue"/>
-                <a:cs typeface="Helvetica Neue"/>
-              </a:defRPr>
-            </a:pPr>
-            <a:r>
-              <a:t>시험생산·실제 원가</a:t>
-            </a:r>
-          </a:p>
-          <a:p xmlns:a="http://schemas.openxmlformats.org/drawingml/2006/main">
-            <a:pPr algn="l">
-              <a:buNone/>
-              <a:defRPr sz="2400">
-                <a:solidFill>
-                  <a:srgbClr val="000000"/>
-                </a:solidFill>
-                <a:latin typeface="Helvetica Neue"/>
-                <a:ea typeface="Helvetica Neue"/>
-                <a:cs typeface="Helvetica Neue"/>
-              </a:defRPr>
-            </a:pPr>
-            <a:r>
-              <a:t>유료 실증 착수</a:t>
+              <a:t>비육우 | 168일 이상</a:t>
+            </a:r>
+          </a:p>
+          <a:p xmlns:a="http://schemas.openxmlformats.org/drawingml/2006/main">
+            <a:pPr algn="l">
+              <a:buNone/>
+              <a:defRPr sz="2400">
+                <a:solidFill>
+                  <a:srgbClr val="000000"/>
+                </a:solidFill>
+                <a:latin typeface="Helvetica Neue"/>
+                <a:ea typeface="Helvetica Neue"/>
+                <a:cs typeface="Helvetica Neue"/>
+              </a:defRPr>
+            </a:pPr>
+            <a:r>
+              <a:t>출하·도체·육질</a:t>
+            </a:r>
+          </a:p>
+          <a:p xmlns:a="http://schemas.openxmlformats.org/drawingml/2006/main">
+            <a:pPr algn="l">
+              <a:buNone/>
+              <a:defRPr sz="2400">
+                <a:solidFill>
+                  <a:srgbClr val="000000"/>
+                </a:solidFill>
+                <a:latin typeface="Helvetica Neue"/>
+                <a:ea typeface="Helvetica Neue"/>
+                <a:cs typeface="Helvetica Neue"/>
+              </a:defRPr>
+            </a:pPr>
+            <a:r>
+              <a:t>사료비까지 통합 판정</a:t>
             </a:r>
           </a:p>
         </p:txBody>
@@ -7342,55 +7381,39 @@
               </a:defRPr>
             </a:pPr>
             <a:r>
-              <a:t>90일</a:t>
-            </a:r>
-          </a:p>
-          <a:p xmlns:a="http://schemas.openxmlformats.org/drawingml/2006/main">
-            <a:pPr algn="l">
-              <a:buNone/>
-              <a:defRPr sz="2400">
-                <a:solidFill>
-                  <a:srgbClr val="000000"/>
-                </a:solidFill>
-                <a:latin typeface="Helvetica Neue"/>
-                <a:ea typeface="Helvetica Neue"/>
-                <a:cs typeface="Helvetica Neue"/>
-              </a:defRPr>
-            </a:pPr>
-            <a:r>
-              <a:t>섭취량·ADG</a:t>
-            </a:r>
-          </a:p>
-          <a:p xmlns:a="http://schemas.openxmlformats.org/drawingml/2006/main">
-            <a:pPr algn="l">
-              <a:buNone/>
-              <a:defRPr sz="2400">
-                <a:solidFill>
-                  <a:srgbClr val="000000"/>
-                </a:solidFill>
-                <a:latin typeface="Helvetica Neue"/>
-                <a:ea typeface="Helvetica Neue"/>
-                <a:cs typeface="Helvetica Neue"/>
-              </a:defRPr>
-            </a:pPr>
-            <a:r>
-              <a:t>FCR·kg 증체당 비용</a:t>
-            </a:r>
-          </a:p>
-          <a:p xmlns:a="http://schemas.openxmlformats.org/drawingml/2006/main">
-            <a:pPr algn="l">
-              <a:buNone/>
-              <a:defRPr sz="2400">
-                <a:solidFill>
-                  <a:srgbClr val="000000"/>
-                </a:solidFill>
-                <a:latin typeface="Helvetica Neue"/>
-                <a:ea typeface="Helvetica Neue"/>
-                <a:cs typeface="Helvetica Neue"/>
-              </a:defRPr>
-            </a:pPr>
-            <a:r>
-              <a:t>생산성 조기 신호</a:t>
+              <a:t>젖소 | 84일 이상</a:t>
+            </a:r>
+          </a:p>
+          <a:p xmlns:a="http://schemas.openxmlformats.org/drawingml/2006/main">
+            <a:pPr algn="l">
+              <a:buNone/>
+              <a:defRPr sz="2400">
+                <a:solidFill>
+                  <a:srgbClr val="000000"/>
+                </a:solidFill>
+                <a:latin typeface="Helvetica Neue"/>
+                <a:ea typeface="Helvetica Neue"/>
+                <a:cs typeface="Helvetica Neue"/>
+              </a:defRPr>
+            </a:pPr>
+            <a:r>
+              <a:t>전체 비유기와</a:t>
+            </a:r>
+          </a:p>
+          <a:p xmlns:a="http://schemas.openxmlformats.org/drawingml/2006/main">
+            <a:pPr algn="l">
+              <a:buNone/>
+              <a:defRPr sz="2400">
+                <a:solidFill>
+                  <a:srgbClr val="000000"/>
+                </a:solidFill>
+                <a:latin typeface="Helvetica Neue"/>
+                <a:ea typeface="Helvetica Neue"/>
+                <a:cs typeface="Helvetica Neue"/>
+              </a:defRPr>
+            </a:pPr>
+            <a:r>
+              <a:t>산유량·유성분 보고</a:t>
             </a:r>
           </a:p>
         </p:txBody>
@@ -7436,55 +7459,39 @@
               </a:defRPr>
             </a:pPr>
             <a:r>
-              <a:t>출하 시</a:t>
-            </a:r>
-          </a:p>
-          <a:p xmlns:a="http://schemas.openxmlformats.org/drawingml/2006/main">
-            <a:pPr algn="l">
-              <a:buNone/>
-              <a:defRPr sz="2400">
-                <a:solidFill>
-                  <a:srgbClr val="000000"/>
-                </a:solidFill>
-                <a:latin typeface="Helvetica Neue"/>
-                <a:ea typeface="Helvetica Neue"/>
-                <a:cs typeface="Helvetica Neue"/>
-              </a:defRPr>
-            </a:pPr>
-            <a:r>
-              <a:t>도체중·등심단면적</a:t>
-            </a:r>
-          </a:p>
-          <a:p xmlns:a="http://schemas.openxmlformats.org/drawingml/2006/main">
-            <a:pPr algn="l">
-              <a:buNone/>
-              <a:defRPr sz="2400">
-                <a:solidFill>
-                  <a:srgbClr val="000000"/>
-                </a:solidFill>
-                <a:latin typeface="Helvetica Neue"/>
-                <a:ea typeface="Helvetica Neue"/>
-                <a:cs typeface="Helvetica Neue"/>
-              </a:defRPr>
-            </a:pPr>
-            <a:r>
-              <a:t>근내지방도·육질등급</a:t>
-            </a:r>
-          </a:p>
-          <a:p xmlns:a="http://schemas.openxmlformats.org/drawingml/2006/main">
-            <a:pPr algn="l">
-              <a:buNone/>
-              <a:defRPr sz="2400">
-                <a:solidFill>
-                  <a:srgbClr val="000000"/>
-                </a:solidFill>
-                <a:latin typeface="Helvetica Neue"/>
-                <a:ea typeface="Helvetica Neue"/>
-                <a:cs typeface="Helvetica Neue"/>
-              </a:defRPr>
-            </a:pPr>
-            <a:r>
-              <a:t>육질 최종 평가</a:t>
+              <a:t>돼지 | 단계별 판정</a:t>
+            </a:r>
+          </a:p>
+          <a:p xmlns:a="http://schemas.openxmlformats.org/drawingml/2006/main">
+            <a:pPr algn="l">
+              <a:buNone/>
+              <a:defRPr sz="2400">
+                <a:solidFill>
+                  <a:srgbClr val="000000"/>
+                </a:solidFill>
+                <a:latin typeface="Helvetica Neue"/>
+                <a:ea typeface="Helvetica Neue"/>
+                <a:cs typeface="Helvetica Neue"/>
+              </a:defRPr>
+            </a:pPr>
+            <a:r>
+              <a:t>이유자돈 42일</a:t>
+            </a:r>
+          </a:p>
+          <a:p xmlns:a="http://schemas.openxmlformats.org/drawingml/2006/main">
+            <a:pPr algn="l">
+              <a:buNone/>
+              <a:defRPr sz="2400">
+                <a:solidFill>
+                  <a:srgbClr val="000000"/>
+                </a:solidFill>
+                <a:latin typeface="Helvetica Neue"/>
+                <a:ea typeface="Helvetica Neue"/>
+                <a:cs typeface="Helvetica Neue"/>
+              </a:defRPr>
+            </a:pPr>
+            <a:r>
+              <a:t>비육돈 70일 이상</a:t>
             </a:r>
           </a:p>
         </p:txBody>
@@ -7530,55 +7537,39 @@
               </a:defRPr>
             </a:pPr>
             <a:r>
-              <a:t>중단·보류</a:t>
-            </a:r>
-          </a:p>
-          <a:p xmlns:a="http://schemas.openxmlformats.org/drawingml/2006/main">
-            <a:pPr algn="l">
-              <a:buNone/>
-              <a:defRPr sz="2400">
-                <a:solidFill>
-                  <a:srgbClr val="000000"/>
-                </a:solidFill>
-                <a:latin typeface="Helvetica Neue"/>
-                <a:ea typeface="Helvetica Neue"/>
-                <a:cs typeface="Helvetica Neue"/>
-              </a:defRPr>
-            </a:pPr>
-            <a:r>
-              <a:t>이상반응·섭취 저하</a:t>
-            </a:r>
-          </a:p>
-          <a:p xmlns:a="http://schemas.openxmlformats.org/drawingml/2006/main">
-            <a:pPr algn="l">
-              <a:buNone/>
-              <a:defRPr sz="2400">
-                <a:solidFill>
-                  <a:srgbClr val="000000"/>
-                </a:solidFill>
-                <a:latin typeface="Helvetica Neue"/>
-                <a:ea typeface="Helvetica Neue"/>
-                <a:cs typeface="Helvetica Neue"/>
-              </a:defRPr>
-            </a:pPr>
-            <a:r>
-              <a:t>비용 개선 없음</a:t>
-            </a:r>
-          </a:p>
-          <a:p xmlns:a="http://schemas.openxmlformats.org/drawingml/2006/main">
-            <a:pPr algn="l">
-              <a:buNone/>
-              <a:defRPr sz="2400">
-                <a:solidFill>
-                  <a:srgbClr val="000000"/>
-                </a:solidFill>
-                <a:latin typeface="Helvetica Neue"/>
-                <a:ea typeface="Helvetica Neue"/>
-                <a:cs typeface="Helvetica Neue"/>
-              </a:defRPr>
-            </a:pPr>
-            <a:r>
-              <a:t>규격 미달·표시 미확정</a:t>
+              <a:t>가금·소형반추</a:t>
+            </a:r>
+          </a:p>
+          <a:p xmlns:a="http://schemas.openxmlformats.org/drawingml/2006/main">
+            <a:pPr algn="l">
+              <a:buNone/>
+              <a:defRPr sz="2400">
+                <a:solidFill>
+                  <a:srgbClr val="000000"/>
+                </a:solidFill>
+                <a:latin typeface="Helvetica Neue"/>
+                <a:ea typeface="Helvetica Neue"/>
+                <a:cs typeface="Helvetica Neue"/>
+              </a:defRPr>
+            </a:pPr>
+            <a:r>
+              <a:t>육계 35일·산란계 168일</a:t>
+            </a:r>
+          </a:p>
+          <a:p xmlns:a="http://schemas.openxmlformats.org/drawingml/2006/main">
+            <a:pPr algn="l">
+              <a:buNone/>
+              <a:defRPr sz="2400">
+                <a:solidFill>
+                  <a:srgbClr val="000000"/>
+                </a:solidFill>
+                <a:latin typeface="Helvetica Neue"/>
+                <a:ea typeface="Helvetica Neue"/>
+                <a:cs typeface="Helvetica Neue"/>
+              </a:defRPr>
+            </a:pPr>
+            <a:r>
+              <a:t>염소·면양 56일 이상</a:t>
             </a:r>
           </a:p>
         </p:txBody>
@@ -7668,7 +7659,7 @@
                 <a:ea typeface="Arial"/>
                 <a:cs typeface="Arial"/>
               </a:rPr>
-              <a:t>GABA BUSINESS MODEL | 16 | EXPANSION CRITERIA</a:t>
+              <a:t>GABA BUSINESS MODEL | 16 | SPECIES VALIDATION PERIODS</a:t>
             </a:r>
           </a:p>
         </p:txBody>
@@ -7780,7 +7771,7 @@
               </a:defRPr>
             </a:pPr>
             <a:r>
-              <a:t>첫 30일은 7일·21일·30일 세 번의 결정을 만든다</a:t>
+              <a:t>100점은 선언이 아니라 5개 증빙 묶음으로 달성한다</a:t>
             </a:r>
           </a:p>
         </p:txBody>
@@ -7929,7 +7920,7 @@
               </a:defRPr>
             </a:pPr>
             <a:r>
-              <a:t>0–7일</a:t>
+              <a:t>현재 41점</a:t>
             </a:r>
           </a:p>
         </p:txBody>
@@ -7975,7 +7966,7 @@
               </a:defRPr>
             </a:pPr>
             <a:r>
-              <a:t>8–21일</a:t>
+              <a:t>확인할 59점</a:t>
             </a:r>
           </a:p>
         </p:txBody>
@@ -8021,7 +8012,7 @@
               </a:defRPr>
             </a:pPr>
             <a:r>
-              <a:t>22–30일</a:t>
+              <a:t>목표 100점</a:t>
             </a:r>
           </a:p>
         </p:txBody>
@@ -8067,55 +8058,71 @@
               </a:defRPr>
             </a:pPr>
             <a:r>
-              <a:t>규격·시험 설계</a:t>
-            </a:r>
-          </a:p>
-          <a:p xmlns:a="http://schemas.openxmlformats.org/drawingml/2006/main">
-            <a:pPr algn="l">
-              <a:buNone/>
-              <a:defRPr sz="2400">
-                <a:solidFill>
-                  <a:srgbClr val="000000"/>
-                </a:solidFill>
-                <a:latin typeface="Helvetica Neue"/>
-                <a:ea typeface="Helvetica Neue"/>
-                <a:cs typeface="Helvetica Neue"/>
-              </a:defRPr>
-            </a:pPr>
-            <a:r>
-              <a:t>제품 규격서</a:t>
-            </a:r>
-          </a:p>
-          <a:p xmlns:a="http://schemas.openxmlformats.org/drawingml/2006/main">
-            <a:pPr algn="l">
-              <a:buNone/>
-              <a:defRPr sz="2400">
-                <a:solidFill>
-                  <a:srgbClr val="000000"/>
-                </a:solidFill>
-                <a:latin typeface="Helvetica Neue"/>
-                <a:ea typeface="Helvetica Neue"/>
-                <a:cs typeface="Helvetica Neue"/>
-              </a:defRPr>
-            </a:pPr>
-            <a:r>
-              <a:t>품목·표시 사전검토</a:t>
-            </a:r>
-          </a:p>
-          <a:p xmlns:a="http://schemas.openxmlformats.org/drawingml/2006/main">
-            <a:pPr algn="l">
-              <a:buNone/>
-              <a:defRPr sz="2400">
-                <a:solidFill>
-                  <a:srgbClr val="000000"/>
-                </a:solidFill>
-                <a:latin typeface="Helvetica Neue"/>
-                <a:ea typeface="Helvetica Neue"/>
-                <a:cs typeface="Helvetica Neue"/>
-              </a:defRPr>
-            </a:pPr>
-            <a:r>
-              <a:t>비육 한우 대조군 계획</a:t>
+              <a:t>규제 6/20</a:t>
+            </a:r>
+          </a:p>
+          <a:p xmlns:a="http://schemas.openxmlformats.org/drawingml/2006/main">
+            <a:pPr algn="l">
+              <a:buNone/>
+              <a:defRPr sz="2400">
+                <a:solidFill>
+                  <a:srgbClr val="000000"/>
+                </a:solidFill>
+                <a:latin typeface="Helvetica Neue"/>
+                <a:ea typeface="Helvetica Neue"/>
+                <a:cs typeface="Helvetica Neue"/>
+              </a:defRPr>
+            </a:pPr>
+            <a:r>
+              <a:t>제품 8/20</a:t>
+            </a:r>
+          </a:p>
+          <a:p xmlns:a="http://schemas.openxmlformats.org/drawingml/2006/main">
+            <a:pPr algn="l">
+              <a:buNone/>
+              <a:defRPr sz="2400">
+                <a:solidFill>
+                  <a:srgbClr val="000000"/>
+                </a:solidFill>
+                <a:latin typeface="Helvetica Neue"/>
+                <a:ea typeface="Helvetica Neue"/>
+                <a:cs typeface="Helvetica Neue"/>
+              </a:defRPr>
+            </a:pPr>
+            <a:r>
+              <a:t>공급 12/20</a:t>
+            </a:r>
+          </a:p>
+          <a:p xmlns:a="http://schemas.openxmlformats.org/drawingml/2006/main">
+            <a:pPr algn="l">
+              <a:buNone/>
+              <a:defRPr sz="2400">
+                <a:solidFill>
+                  <a:srgbClr val="000000"/>
+                </a:solidFill>
+                <a:latin typeface="Helvetica Neue"/>
+                <a:ea typeface="Helvetica Neue"/>
+                <a:cs typeface="Helvetica Neue"/>
+              </a:defRPr>
+            </a:pPr>
+            <a:r>
+              <a:t>경제성 11/20</a:t>
+            </a:r>
+          </a:p>
+          <a:p xmlns:a="http://schemas.openxmlformats.org/drawingml/2006/main">
+            <a:pPr algn="l">
+              <a:buNone/>
+              <a:defRPr sz="2400">
+                <a:solidFill>
+                  <a:srgbClr val="000000"/>
+                </a:solidFill>
+                <a:latin typeface="Helvetica Neue"/>
+                <a:ea typeface="Helvetica Neue"/>
+                <a:cs typeface="Helvetica Neue"/>
+              </a:defRPr>
+            </a:pPr>
+            <a:r>
+              <a:t>상업성 4/20</a:t>
             </a:r>
           </a:p>
         </p:txBody>
@@ -8161,55 +8168,55 @@
               </a:defRPr>
             </a:pPr>
             <a:r>
-              <a:t>제품 재현성</a:t>
-            </a:r>
-          </a:p>
-          <a:p xmlns:a="http://schemas.openxmlformats.org/drawingml/2006/main">
-            <a:pPr algn="l">
-              <a:buNone/>
-              <a:defRPr sz="2400">
-                <a:solidFill>
-                  <a:srgbClr val="000000"/>
-                </a:solidFill>
-                <a:latin typeface="Helvetica Neue"/>
-                <a:ea typeface="Helvetica Neue"/>
-                <a:cs typeface="Helvetica Neue"/>
-              </a:defRPr>
-            </a:pPr>
-            <a:r>
-              <a:t>시험생산 1회</a:t>
-            </a:r>
-          </a:p>
-          <a:p xmlns:a="http://schemas.openxmlformats.org/drawingml/2006/main">
-            <a:pPr algn="l">
-              <a:buNone/>
-              <a:defRPr sz="2400">
-                <a:solidFill>
-                  <a:srgbClr val="000000"/>
-                </a:solidFill>
-                <a:latin typeface="Helvetica Neue"/>
-                <a:ea typeface="Helvetica Neue"/>
-                <a:cs typeface="Helvetica Neue"/>
-              </a:defRPr>
-            </a:pPr>
-            <a:r>
-              <a:t>3지점 시료·균일도</a:t>
-            </a:r>
-          </a:p>
-          <a:p xmlns:a="http://schemas.openxmlformats.org/drawingml/2006/main">
-            <a:pPr algn="l">
-              <a:buNone/>
-              <a:defRPr sz="2400">
-                <a:solidFill>
-                  <a:srgbClr val="000000"/>
-                </a:solidFill>
-                <a:latin typeface="Helvetica Neue"/>
-                <a:ea typeface="Helvetica Neue"/>
-                <a:cs typeface="Helvetica Neue"/>
-              </a:defRPr>
-            </a:pPr>
-            <a:r>
-              <a:t>실제 견적·원가</a:t>
+              <a:t>규제 +14·제품 +12</a:t>
+            </a:r>
+          </a:p>
+          <a:p xmlns:a="http://schemas.openxmlformats.org/drawingml/2006/main">
+            <a:pPr algn="l">
+              <a:buNone/>
+              <a:defRPr sz="2400">
+                <a:solidFill>
+                  <a:srgbClr val="000000"/>
+                </a:solidFill>
+                <a:latin typeface="Helvetica Neue"/>
+                <a:ea typeface="Helvetica Neue"/>
+                <a:cs typeface="Helvetica Neue"/>
+              </a:defRPr>
+            </a:pPr>
+            <a:r>
+              <a:t>공급 +8·경제성 +9</a:t>
+            </a:r>
+          </a:p>
+          <a:p xmlns:a="http://schemas.openxmlformats.org/drawingml/2006/main">
+            <a:pPr algn="l">
+              <a:buNone/>
+              <a:defRPr sz="2400">
+                <a:solidFill>
+                  <a:srgbClr val="000000"/>
+                </a:solidFill>
+                <a:latin typeface="Helvetica Neue"/>
+                <a:ea typeface="Helvetica Neue"/>
+                <a:cs typeface="Helvetica Neue"/>
+              </a:defRPr>
+            </a:pPr>
+            <a:r>
+              <a:t>상업성 +16</a:t>
+            </a:r>
+          </a:p>
+          <a:p xmlns:a="http://schemas.openxmlformats.org/drawingml/2006/main">
+            <a:pPr algn="l">
+              <a:buNone/>
+              <a:defRPr sz="2400">
+                <a:solidFill>
+                  <a:srgbClr val="000000"/>
+                </a:solidFill>
+                <a:latin typeface="Helvetica Neue"/>
+                <a:ea typeface="Helvetica Neue"/>
+                <a:cs typeface="Helvetica Neue"/>
+              </a:defRPr>
+            </a:pPr>
+            <a:r>
+              <a:t>파일·URL·결론 연결</a:t>
             </a:r>
           </a:p>
         </p:txBody>
@@ -8255,55 +8262,55 @@
               </a:defRPr>
             </a:pPr>
             <a:r>
-              <a:t>유료 실증 착수</a:t>
-            </a:r>
-          </a:p>
-          <a:p xmlns:a="http://schemas.openxmlformats.org/drawingml/2006/main">
-            <a:pPr algn="l">
-              <a:buNone/>
-              <a:defRPr sz="2400">
-                <a:solidFill>
-                  <a:srgbClr val="000000"/>
-                </a:solidFill>
-                <a:latin typeface="Helvetica Neue"/>
-                <a:ea typeface="Helvetica Neue"/>
-                <a:cs typeface="Helvetica Neue"/>
-              </a:defRPr>
-            </a:pPr>
-            <a:r>
-              <a:t>농장 1곳·발주서 1건</a:t>
-            </a:r>
-          </a:p>
-          <a:p xmlns:a="http://schemas.openxmlformats.org/drawingml/2006/main">
-            <a:pPr algn="l">
-              <a:buNone/>
-              <a:defRPr sz="2400">
-                <a:solidFill>
-                  <a:srgbClr val="000000"/>
-                </a:solidFill>
-                <a:latin typeface="Helvetica Neue"/>
-                <a:ea typeface="Helvetica Neue"/>
-                <a:cs typeface="Helvetica Neue"/>
-              </a:defRPr>
-            </a:pPr>
-            <a:r>
-              <a:t>기초 체중·섭취량</a:t>
-            </a:r>
-          </a:p>
-          <a:p xmlns:a="http://schemas.openxmlformats.org/drawingml/2006/main">
-            <a:pPr algn="l">
-              <a:buNone/>
-              <a:defRPr sz="2400">
-                <a:solidFill>
-                  <a:srgbClr val="000000"/>
-                </a:solidFill>
-                <a:latin typeface="Helvetica Neue"/>
-                <a:ea typeface="Helvetica Neue"/>
-                <a:cs typeface="Helvetica Neue"/>
-              </a:defRPr>
-            </a:pPr>
-            <a:r>
-              <a:t>개체·출하 성적 연결</a:t>
+              <a:t>5개 축 모두 20/20</a:t>
+            </a:r>
+          </a:p>
+          <a:p xmlns:a="http://schemas.openxmlformats.org/drawingml/2006/main">
+            <a:pPr algn="l">
+              <a:buNone/>
+              <a:defRPr sz="2400">
+                <a:solidFill>
+                  <a:srgbClr val="000000"/>
+                </a:solidFill>
+                <a:latin typeface="Helvetica Neue"/>
+                <a:ea typeface="Helvetica Neue"/>
+                <a:cs typeface="Helvetica Neue"/>
+              </a:defRPr>
+            </a:pPr>
+            <a:r>
+              <a:t>축종별 시험 완료</a:t>
+            </a:r>
+          </a:p>
+          <a:p xmlns:a="http://schemas.openxmlformats.org/drawingml/2006/main">
+            <a:pPr algn="l">
+              <a:buNone/>
+              <a:defRPr sz="2400">
+                <a:solidFill>
+                  <a:srgbClr val="000000"/>
+                </a:solidFill>
+                <a:latin typeface="Helvetica Neue"/>
+                <a:ea typeface="Helvetica Neue"/>
+                <a:cs typeface="Helvetica Neue"/>
+              </a:defRPr>
+            </a:pPr>
+            <a:r>
+              <a:t>실제 원가·반복주문</a:t>
+            </a:r>
+          </a:p>
+          <a:p xmlns:a="http://schemas.openxmlformats.org/drawingml/2006/main">
+            <a:pPr algn="l">
+              <a:buNone/>
+              <a:defRPr sz="2400">
+                <a:solidFill>
+                  <a:srgbClr val="000000"/>
+                </a:solidFill>
+                <a:latin typeface="Helvetica Neue"/>
+                <a:ea typeface="Helvetica Neue"/>
+                <a:cs typeface="Helvetica Neue"/>
+              </a:defRPr>
+            </a:pPr>
+            <a:r>
+              <a:t>감사 가능한 자료실</a:t>
             </a:r>
           </a:p>
         </p:txBody>
@@ -8393,7 +8400,7 @@
                 <a:ea typeface="Arial"/>
                 <a:cs typeface="Arial"/>
               </a:rPr>
-              <a:t>GABA BUSINESS MODEL | 17 | 90-DAY VALIDATION</a:t>
+              <a:t>GABA BUSINESS MODEL | 17 | EVIDENCE-GATED READINESS</a:t>
             </a:r>
           </a:p>
         </p:txBody>
@@ -9418,7 +9425,7 @@
               </a:defRPr>
             </a:pPr>
             <a:r>
-              <a:t>30일 안에 준비하고,</a:t>
+              <a:t>30일 안에 시험을 열고,</a:t>
             </a:r>
           </a:p>
           <a:p xmlns:a="http://schemas.openxmlformats.org/drawingml/2006/main">
@@ -9434,7 +9441,7 @@
               </a:defRPr>
             </a:pPr>
             <a:r>
-              <a:t>육질은 출하 시 판정한다</a:t>
+              <a:t>결과는 축종별 주기로 판정한다</a:t>
             </a:r>
           </a:p>
         </p:txBody>
@@ -9480,7 +9487,7 @@
               </a:defRPr>
             </a:pPr>
             <a:r>
-              <a:t>GABA CARE MIX | BRANDED HANWOO</a:t>
+              <a:t>GABA CARE MIX | MULTI-SPECIES</a:t>
             </a:r>
           </a:p>
         </p:txBody>
@@ -9526,7 +9533,7 @@
               </a:defRPr>
             </a:pPr>
             <a:r>
-              <a:t>30일 실증 착수 · 90일 생산성 신호</a:t>
+              <a:t>30일 준비 · 축종별 35~168일 이상 검증</a:t>
             </a:r>
           </a:p>
         </p:txBody>
@@ -9804,7 +9811,7 @@
               </a:defRPr>
             </a:pPr>
             <a:r>
-              <a:t>가바케어믹스=비육 한우 배합사료</a:t>
+              <a:t>가바케어믹스=축종별 배합사료</a:t>
             </a:r>
           </a:p>
           <a:p xmlns:a="http://schemas.openxmlformats.org/drawingml/2006/main">
@@ -10068,39 +10075,39 @@
               </a:defRPr>
             </a:pPr>
             <a:r>
-              <a:t>30일은 효능 확정 시점이 아님</a:t>
-            </a:r>
-          </a:p>
-          <a:p xmlns:a="http://schemas.openxmlformats.org/drawingml/2006/main">
-            <a:pPr algn="l">
-              <a:buNone/>
-              <a:defRPr sz="2400">
-                <a:solidFill>
-                  <a:srgbClr val="000000"/>
-                </a:solidFill>
-                <a:latin typeface="Helvetica Neue"/>
-                <a:ea typeface="Helvetica Neue"/>
-                <a:cs typeface="Helvetica Neue"/>
-              </a:defRPr>
-            </a:pPr>
-            <a:r>
-              <a:t>법적 분류·표시·효능·원가</a:t>
-            </a:r>
-          </a:p>
-          <a:p xmlns:a="http://schemas.openxmlformats.org/drawingml/2006/main">
-            <a:pPr algn="l">
-              <a:buNone/>
-              <a:defRPr sz="2400">
-                <a:solidFill>
-                  <a:srgbClr val="000000"/>
-                </a:solidFill>
-                <a:latin typeface="Helvetica Neue"/>
-                <a:ea typeface="Helvetica Neue"/>
-                <a:cs typeface="Helvetica Neue"/>
-              </a:defRPr>
-            </a:pPr>
-            <a:r>
-              <a:t>전문 검토·시험·실제 견적 확인</a:t>
+              <a:t>현재 41점·목표 100점 분리</a:t>
+            </a:r>
+          </a:p>
+          <a:p xmlns:a="http://schemas.openxmlformats.org/drawingml/2006/main">
+            <a:pPr algn="l">
+              <a:buNone/>
+              <a:defRPr sz="2400">
+                <a:solidFill>
+                  <a:srgbClr val="000000"/>
+                </a:solidFill>
+                <a:latin typeface="Helvetica Neue"/>
+                <a:ea typeface="Helvetica Neue"/>
+                <a:cs typeface="Helvetica Neue"/>
+              </a:defRPr>
+            </a:pPr>
+            <a:r>
+              <a:t>30일은 시험 착수 준비</a:t>
+            </a:r>
+          </a:p>
+          <a:p xmlns:a="http://schemas.openxmlformats.org/drawingml/2006/main">
+            <a:pPr algn="l">
+              <a:buNone/>
+              <a:defRPr sz="2400">
+                <a:solidFill>
+                  <a:srgbClr val="000000"/>
+                </a:solidFill>
+                <a:latin typeface="Helvetica Neue"/>
+                <a:ea typeface="Helvetica Neue"/>
+                <a:cs typeface="Helvetica Neue"/>
+              </a:defRPr>
+            </a:pPr>
+            <a:r>
+              <a:t>효능은 축종별 기간 후 판정</a:t>
             </a:r>
           </a:p>
         </p:txBody>
@@ -10302,7 +10309,7 @@
               </a:defRPr>
             </a:pPr>
             <a:r>
-              <a:t>가바크루드가 원료를 공급하고, 가바케어믹스가 브랜드 한우 성과를 검증한다</a:t>
+              <a:t>가바크루드가 원료를 공급하고, 가바케어믹스가 축종별 성과를 검증한다</a:t>
             </a:r>
           </a:p>
         </p:txBody>
@@ -10777,7 +10784,7 @@
               </a:defRPr>
             </a:pPr>
             <a:r>
-              <a:t>비육 한우 배합</a:t>
+              <a:t>축종별 배합</a:t>
             </a:r>
           </a:p>
         </p:txBody>
@@ -14323,7 +14330,7 @@
               </a:defRPr>
             </a:pPr>
             <a:r>
-              <a:t>기존 연구만으로 브랜드 한우의 육질 개선을 증명할 수 없다</a:t>
+              <a:t>기존 연구만으로 축종별 생산성과 품질 개선을 증명할 수 없다</a:t>
             </a:r>
           </a:p>
         </p:txBody>

</xml_diff>